<commit_message>
Improve library sample dataset and statistics
</commit_message>
<xml_diff>
--- a/ProjectPresentation.pptx
+++ b/ProjectPresentation.pptx
@@ -2,17 +2,17 @@
 <file path=ppt/presentation.xml><?xml version="1.0" encoding="utf-8"?>
 <p:presentation xmlns:p="http://schemas.openxmlformats.org/presentationml/2006/main">
   <p:sldMasterIdLst>
-    <p:sldMasterId xmlns:r="http://schemas.openxmlformats.org/officeDocument/2006/relationships" id="2147483648" r:id="Rf4bb4949ee284391"/>
+    <p:sldMasterId xmlns:r="http://schemas.openxmlformats.org/officeDocument/2006/relationships" id="2147483648" r:id="Rce279dc9bbb74fca"/>
   </p:sldMasterIdLst>
   <p:notesMasterIdLst>
-    <p:notesMasterId xmlns:r="http://schemas.openxmlformats.org/officeDocument/2006/relationships" r:id="Re344f25f3a164983"/>
+    <p:notesMasterId xmlns:r="http://schemas.openxmlformats.org/officeDocument/2006/relationships" r:id="R5174cae511184519"/>
   </p:notesMasterIdLst>
   <p:sldIdLst>
-    <p:sldId xmlns:r="http://schemas.openxmlformats.org/officeDocument/2006/relationships" id="256" r:id="R35777e40d0984c6c"/>
-    <p:sldId xmlns:r="http://schemas.openxmlformats.org/officeDocument/2006/relationships" id="257" r:id="R43d625b8fcdc4d78"/>
-    <p:sldId xmlns:r="http://schemas.openxmlformats.org/officeDocument/2006/relationships" id="258" r:id="R65aea4a32ad24725"/>
-    <p:sldId xmlns:r="http://schemas.openxmlformats.org/officeDocument/2006/relationships" id="259" r:id="R9bfd55a938e14497"/>
-    <p:sldId xmlns:r="http://schemas.openxmlformats.org/officeDocument/2006/relationships" id="260" r:id="R12e973cbd12f4005"/>
+    <p:sldId xmlns:r="http://schemas.openxmlformats.org/officeDocument/2006/relationships" id="256" r:id="R30a17699a4bf4e2c"/>
+    <p:sldId xmlns:r="http://schemas.openxmlformats.org/officeDocument/2006/relationships" id="257" r:id="R457d6575bfa649df"/>
+    <p:sldId xmlns:r="http://schemas.openxmlformats.org/officeDocument/2006/relationships" id="258" r:id="R230d3472cae74759"/>
+    <p:sldId xmlns:r="http://schemas.openxmlformats.org/officeDocument/2006/relationships" id="259" r:id="R369b96a6899d4877"/>
+    <p:sldId xmlns:r="http://schemas.openxmlformats.org/officeDocument/2006/relationships" id="260" r:id="Rd74d799672694d4c"/>
   </p:sldIdLst>
   <p:sldSz cx="12192000" cy="6858000"/>
   <p:notesSz cx="6858000" cy="9144000"/>
@@ -753,7 +753,7 @@
           <p:cNvPr id="3" name="Title">
             <a:extLst xmlns:a="http://schemas.openxmlformats.org/drawingml/2006/main">
               <a:ext uri="{FF2B5EF4-FFF2-40B4-BE49-F238E27FC236}">
-                <a16:creationId xmlns:a16="http://schemas.microsoft.com/office/drawing/2014/main" id="{AD7B1D68-2080-41EC-9270-758B331384F6}"/>
+                <a16:creationId xmlns:a16="http://schemas.microsoft.com/office/drawing/2014/main" id="{A58F1E79-5EE8-45F7-B6DC-BAE875180D50}"/>
               </a:ext>
             </a:extLst>
           </p:cNvPr>
@@ -910,7 +910,7 @@
           <p:cNvPr id="2" name="Subtitle">
             <a:extLst xmlns:a="http://schemas.openxmlformats.org/drawingml/2006/main">
               <a:ext uri="{FF2B5EF4-FFF2-40B4-BE49-F238E27FC236}">
-                <a16:creationId xmlns:a16="http://schemas.microsoft.com/office/drawing/2014/main" id="{47E1F88E-317F-42BE-A17A-9D6C576CA1DE}"/>
+                <a16:creationId xmlns:a16="http://schemas.microsoft.com/office/drawing/2014/main" id="{ACBC1AAF-BADE-48AA-A994-2980EAE8B2F7}"/>
               </a:ext>
             </a:extLst>
           </p:cNvPr>
@@ -1084,7 +1084,7 @@
           <p:cNvPr id="2" name="Section title">
             <a:extLst xmlns:a="http://schemas.openxmlformats.org/drawingml/2006/main">
               <a:ext uri="{FF2B5EF4-FFF2-40B4-BE49-F238E27FC236}">
-                <a16:creationId xmlns:a16="http://schemas.microsoft.com/office/drawing/2014/main" id="{F44A8D96-A75A-4472-BDE4-862170921B16}"/>
+                <a16:creationId xmlns:a16="http://schemas.microsoft.com/office/drawing/2014/main" id="{5F1B5027-64F4-46A0-8124-F45EC485EBCF}"/>
               </a:ext>
             </a:extLst>
           </p:cNvPr>
@@ -1258,7 +1258,7 @@
           <p:cNvPr id="3" name="Title">
             <a:extLst xmlns:a="http://schemas.openxmlformats.org/drawingml/2006/main">
               <a:ext uri="{FF2B5EF4-FFF2-40B4-BE49-F238E27FC236}">
-                <a16:creationId xmlns:a16="http://schemas.microsoft.com/office/drawing/2014/main" id="{D7608CAB-BBC0-4D28-B53D-A2A4ED1A9499}"/>
+                <a16:creationId xmlns:a16="http://schemas.microsoft.com/office/drawing/2014/main" id="{64AD4A9B-6538-40A4-B8D2-4A56F675DB4F}"/>
               </a:ext>
             </a:extLst>
           </p:cNvPr>
@@ -1415,7 +1415,7 @@
           <p:cNvPr id="2" name="Body">
             <a:extLst xmlns:a="http://schemas.openxmlformats.org/drawingml/2006/main">
               <a:ext uri="{FF2B5EF4-FFF2-40B4-BE49-F238E27FC236}">
-                <a16:creationId xmlns:a16="http://schemas.microsoft.com/office/drawing/2014/main" id="{086CE637-4227-4C51-87EC-C49E67EDE69D}"/>
+                <a16:creationId xmlns:a16="http://schemas.microsoft.com/office/drawing/2014/main" id="{1A94D85A-7899-47A6-9200-D36DE7539F85}"/>
               </a:ext>
             </a:extLst>
           </p:cNvPr>
@@ -1589,7 +1589,7 @@
           <p:cNvPr id="4" name="Title">
             <a:extLst xmlns:a="http://schemas.openxmlformats.org/drawingml/2006/main">
               <a:ext uri="{FF2B5EF4-FFF2-40B4-BE49-F238E27FC236}">
-                <a16:creationId xmlns:a16="http://schemas.microsoft.com/office/drawing/2014/main" id="{69E8F938-0D11-42BD-99EC-71596FE5F6A0}"/>
+                <a16:creationId xmlns:a16="http://schemas.microsoft.com/office/drawing/2014/main" id="{83760F92-8774-421A-B838-C5A6D3A1E0B9}"/>
               </a:ext>
             </a:extLst>
           </p:cNvPr>
@@ -1746,7 +1746,7 @@
           <p:cNvPr id="2" name="Left column">
             <a:extLst xmlns:a="http://schemas.openxmlformats.org/drawingml/2006/main">
               <a:ext uri="{FF2B5EF4-FFF2-40B4-BE49-F238E27FC236}">
-                <a16:creationId xmlns:a16="http://schemas.microsoft.com/office/drawing/2014/main" id="{B6C12B86-6086-4328-95CD-B67CD11211FF}"/>
+                <a16:creationId xmlns:a16="http://schemas.microsoft.com/office/drawing/2014/main" id="{B91C1759-E783-4F38-8A09-5658DD52D049}"/>
               </a:ext>
             </a:extLst>
           </p:cNvPr>
@@ -1903,7 +1903,7 @@
           <p:cNvPr id="3" name="Right column">
             <a:extLst xmlns:a="http://schemas.openxmlformats.org/drawingml/2006/main">
               <a:ext uri="{FF2B5EF4-FFF2-40B4-BE49-F238E27FC236}">
-                <a16:creationId xmlns:a16="http://schemas.microsoft.com/office/drawing/2014/main" id="{4F524CF3-E8D7-4D15-81F5-03C4E4E91C35}"/>
+                <a16:creationId xmlns:a16="http://schemas.microsoft.com/office/drawing/2014/main" id="{22DA3DDF-29B2-4E04-9A85-88A02628DAF6}"/>
               </a:ext>
             </a:extLst>
           </p:cNvPr>
@@ -2077,7 +2077,7 @@
           <p:cNvPr id="3" name="Title">
             <a:extLst xmlns:a="http://schemas.openxmlformats.org/drawingml/2006/main">
               <a:ext uri="{FF2B5EF4-FFF2-40B4-BE49-F238E27FC236}">
-                <a16:creationId xmlns:a16="http://schemas.microsoft.com/office/drawing/2014/main" id="{288DA9C7-6B59-4757-9F03-2B945F8ABCC9}"/>
+                <a16:creationId xmlns:a16="http://schemas.microsoft.com/office/drawing/2014/main" id="{9107D1B1-E57D-439B-80E5-E373BABCD365}"/>
               </a:ext>
             </a:extLst>
           </p:cNvPr>
@@ -2234,7 +2234,7 @@
           <p:cNvPr id="2" name="Left column">
             <a:extLst xmlns:a="http://schemas.openxmlformats.org/drawingml/2006/main">
               <a:ext uri="{FF2B5EF4-FFF2-40B4-BE49-F238E27FC236}">
-                <a16:creationId xmlns:a16="http://schemas.microsoft.com/office/drawing/2014/main" id="{29001679-5001-47FF-B6BB-36737A25D5D1}"/>
+                <a16:creationId xmlns:a16="http://schemas.microsoft.com/office/drawing/2014/main" id="{38BA69B6-209B-4153-8A85-1E14E0E23AF3}"/>
               </a:ext>
             </a:extLst>
           </p:cNvPr>
@@ -2429,12 +2429,12 @@
   </p:cSld>
   <p:clrMap bg1="lt1" tx1="dk1" bg2="lt2" tx2="dk2" accent1="accent1" accent2="accent2" accent3="accent3" accent4="accent4" accent5="accent5" accent6="accent6" hlink="hlink" folHlink="folHlink"/>
   <p:sldLayoutIdLst>
-    <p:sldLayoutId xmlns:r="http://schemas.openxmlformats.org/officeDocument/2006/relationships" id="2147483649" r:id="Rb51a7da70e7448cc"/>
-    <p:sldLayoutId xmlns:r="http://schemas.openxmlformats.org/officeDocument/2006/relationships" id="2147483650" r:id="R41d422a163e14273"/>
-    <p:sldLayoutId xmlns:r="http://schemas.openxmlformats.org/officeDocument/2006/relationships" id="2147483651" r:id="R381ce7d7192d466e"/>
-    <p:sldLayoutId xmlns:r="http://schemas.openxmlformats.org/officeDocument/2006/relationships" id="2147483652" r:id="R0636a3e47e4d4a2a"/>
-    <p:sldLayoutId xmlns:r="http://schemas.openxmlformats.org/officeDocument/2006/relationships" id="2147483653" r:id="R81ba3bd864194760"/>
-    <p:sldLayoutId xmlns:r="http://schemas.openxmlformats.org/officeDocument/2006/relationships" id="2147483654" r:id="Re772fb2e6f514f41"/>
+    <p:sldLayoutId xmlns:r="http://schemas.openxmlformats.org/officeDocument/2006/relationships" id="2147483649" r:id="R5d9394d5c7f74b2a"/>
+    <p:sldLayoutId xmlns:r="http://schemas.openxmlformats.org/officeDocument/2006/relationships" id="2147483650" r:id="Redfc73be6e7b4fbd"/>
+    <p:sldLayoutId xmlns:r="http://schemas.openxmlformats.org/officeDocument/2006/relationships" id="2147483651" r:id="R7e7cd8d3aa41403c"/>
+    <p:sldLayoutId xmlns:r="http://schemas.openxmlformats.org/officeDocument/2006/relationships" id="2147483652" r:id="R27b15fac099d4d26"/>
+    <p:sldLayoutId xmlns:r="http://schemas.openxmlformats.org/officeDocument/2006/relationships" id="2147483653" r:id="R72ecdc7863654695"/>
+    <p:sldLayoutId xmlns:r="http://schemas.openxmlformats.org/officeDocument/2006/relationships" id="2147483654" r:id="R43a940e47cde450e"/>
   </p:sldLayoutIdLst>
   <p:txStyles>
     <p:titleStyle>
@@ -2985,7 +2985,7 @@
           <p:cNvPr id="13" name="">
             <a:extLst xmlns:a="http://schemas.openxmlformats.org/drawingml/2006/main">
               <a:ext uri="{FF2B5EF4-FFF2-40B4-BE49-F238E27FC236}">
-                <a16:creationId xmlns:a16="http://schemas.microsoft.com/office/drawing/2014/main" id="{41C87BD8-8A22-4AC9-8F80-E5B3FB020E42}"/>
+                <a16:creationId xmlns:a16="http://schemas.microsoft.com/office/drawing/2014/main" id="{2D3F0C3D-1B93-4630-91DC-72C3F92ACB22}"/>
               </a:ext>
             </a:extLst>
           </p:cNvPr>
@@ -3016,7 +3016,7 @@
           <p:cNvPr id="2" name="">
             <a:extLst xmlns:a="http://schemas.openxmlformats.org/drawingml/2006/main">
               <a:ext uri="{FF2B5EF4-FFF2-40B4-BE49-F238E27FC236}">
-                <a16:creationId xmlns:a16="http://schemas.microsoft.com/office/drawing/2014/main" id="{98A5D614-A980-4C63-BC7A-1A940A769427}"/>
+                <a16:creationId xmlns:a16="http://schemas.microsoft.com/office/drawing/2014/main" id="{7CB85F0F-A835-4F90-960B-3A7C69F4C6C8}"/>
               </a:ext>
             </a:extLst>
           </p:cNvPr>
@@ -3083,7 +3083,7 @@
           <p:cNvPr id="3" name="">
             <a:extLst xmlns:a="http://schemas.openxmlformats.org/drawingml/2006/main">
               <a:ext uri="{FF2B5EF4-FFF2-40B4-BE49-F238E27FC236}">
-                <a16:creationId xmlns:a16="http://schemas.microsoft.com/office/drawing/2014/main" id="{7FF77325-2C6A-4C42-8346-777770772ED7}"/>
+                <a16:creationId xmlns:a16="http://schemas.microsoft.com/office/drawing/2014/main" id="{160C33C0-E712-49ED-B916-89F2531199AC}"/>
               </a:ext>
             </a:extLst>
           </p:cNvPr>
@@ -3173,7 +3173,7 @@
           <p:cNvPr id="4" name="">
             <a:extLst xmlns:a="http://schemas.openxmlformats.org/drawingml/2006/main">
               <a:ext uri="{FF2B5EF4-FFF2-40B4-BE49-F238E27FC236}">
-                <a16:creationId xmlns:a16="http://schemas.microsoft.com/office/drawing/2014/main" id="{4F186EBE-B22C-4238-800D-EDC5D37ABB02}"/>
+                <a16:creationId xmlns:a16="http://schemas.microsoft.com/office/drawing/2014/main" id="{B6608F1D-1261-4ACC-AF07-F7586D91539A}"/>
               </a:ext>
             </a:extLst>
           </p:cNvPr>
@@ -3240,7 +3240,7 @@
           <p:cNvPr id="5" name="">
             <a:extLst xmlns:a="http://schemas.openxmlformats.org/drawingml/2006/main">
               <a:ext uri="{FF2B5EF4-FFF2-40B4-BE49-F238E27FC236}">
-                <a16:creationId xmlns:a16="http://schemas.microsoft.com/office/drawing/2014/main" id="{B8D4CA50-6B2A-4B88-AD23-37F79178DF0E}"/>
+                <a16:creationId xmlns:a16="http://schemas.microsoft.com/office/drawing/2014/main" id="{A1D578A9-F387-4EBA-87D7-8016ABFD9F7B}"/>
               </a:ext>
             </a:extLst>
           </p:cNvPr>
@@ -3307,7 +3307,7 @@
           <p:cNvPr id="6" name="">
             <a:extLst xmlns:a="http://schemas.openxmlformats.org/drawingml/2006/main">
               <a:ext uri="{FF2B5EF4-FFF2-40B4-BE49-F238E27FC236}">
-                <a16:creationId xmlns:a16="http://schemas.microsoft.com/office/drawing/2014/main" id="{25B97583-B7F6-41D1-92E8-299F81539A72}"/>
+                <a16:creationId xmlns:a16="http://schemas.microsoft.com/office/drawing/2014/main" id="{759B4F5E-81F0-4FBF-8A66-3B42993A4D94}"/>
               </a:ext>
             </a:extLst>
           </p:cNvPr>
@@ -3374,7 +3374,7 @@
           <p:cNvPr id="7" name="">
             <a:extLst xmlns:a="http://schemas.openxmlformats.org/drawingml/2006/main">
               <a:ext uri="{FF2B5EF4-FFF2-40B4-BE49-F238E27FC236}">
-                <a16:creationId xmlns:a16="http://schemas.microsoft.com/office/drawing/2014/main" id="{93A1861D-1AFD-4D8A-95CD-346EF27A12A2}"/>
+                <a16:creationId xmlns:a16="http://schemas.microsoft.com/office/drawing/2014/main" id="{55EED3DF-7EB8-4ABA-AC93-F46E311D4003}"/>
               </a:ext>
             </a:extLst>
           </p:cNvPr>
@@ -3407,7 +3407,7 @@
           <p:cNvPr id="8" name="">
             <a:extLst xmlns:a="http://schemas.openxmlformats.org/drawingml/2006/main">
               <a:ext uri="{FF2B5EF4-FFF2-40B4-BE49-F238E27FC236}">
-                <a16:creationId xmlns:a16="http://schemas.microsoft.com/office/drawing/2014/main" id="{E1CB48BB-9464-4E39-9110-0D7A8822AA47}"/>
+                <a16:creationId xmlns:a16="http://schemas.microsoft.com/office/drawing/2014/main" id="{2BD3CAFA-CB1B-470B-8969-0E4FF9186399}"/>
               </a:ext>
             </a:extLst>
           </p:cNvPr>
@@ -3440,7 +3440,7 @@
           <p:cNvPr id="9" name="">
             <a:extLst xmlns:a="http://schemas.openxmlformats.org/drawingml/2006/main">
               <a:ext uri="{FF2B5EF4-FFF2-40B4-BE49-F238E27FC236}">
-                <a16:creationId xmlns:a16="http://schemas.microsoft.com/office/drawing/2014/main" id="{BE156613-D06F-4DA7-A4FB-979938954931}"/>
+                <a16:creationId xmlns:a16="http://schemas.microsoft.com/office/drawing/2014/main" id="{930781DD-D85F-420E-9427-8873BC66B027}"/>
               </a:ext>
             </a:extLst>
           </p:cNvPr>
@@ -3473,7 +3473,7 @@
           <p:cNvPr id="10" name="">
             <a:extLst xmlns:a="http://schemas.openxmlformats.org/drawingml/2006/main">
               <a:ext uri="{FF2B5EF4-FFF2-40B4-BE49-F238E27FC236}">
-                <a16:creationId xmlns:a16="http://schemas.microsoft.com/office/drawing/2014/main" id="{9ABC3203-F586-48AA-9BDC-B83727590795}"/>
+                <a16:creationId xmlns:a16="http://schemas.microsoft.com/office/drawing/2014/main" id="{92258C36-1E83-46B5-983A-C5592EBC1232}"/>
               </a:ext>
             </a:extLst>
           </p:cNvPr>
@@ -3506,7 +3506,7 @@
           <p:cNvPr id="11" name="">
             <a:extLst xmlns:a="http://schemas.openxmlformats.org/drawingml/2006/main">
               <a:ext uri="{FF2B5EF4-FFF2-40B4-BE49-F238E27FC236}">
-                <a16:creationId xmlns:a16="http://schemas.microsoft.com/office/drawing/2014/main" id="{159F6DA3-E04C-4F17-8E55-DED514F56BDD}"/>
+                <a16:creationId xmlns:a16="http://schemas.microsoft.com/office/drawing/2014/main" id="{739B970B-E305-4681-9312-F42129772D3B}"/>
               </a:ext>
             </a:extLst>
           </p:cNvPr>
@@ -3539,7 +3539,7 @@
           <p:cNvPr id="12" name="">
             <a:extLst xmlns:a="http://schemas.openxmlformats.org/drawingml/2006/main">
               <a:ext uri="{FF2B5EF4-FFF2-40B4-BE49-F238E27FC236}">
-                <a16:creationId xmlns:a16="http://schemas.microsoft.com/office/drawing/2014/main" id="{AF0B2A44-D85A-4FDB-B5BE-3F18050D29AF}"/>
+                <a16:creationId xmlns:a16="http://schemas.microsoft.com/office/drawing/2014/main" id="{A432168E-8913-422E-9342-6DDACA09FAAD}"/>
               </a:ext>
             </a:extLst>
           </p:cNvPr>
@@ -3604,7 +3604,7 @@
     </p:spTree>
     <p:extLst>
       <p:ext uri="{BB962C8B-B14F-4D97-AF65-F5344CB8AC3E}">
-        <p14:creationId xmlns:p14="http://schemas.microsoft.com/office/powerpoint/2010/main" val="615642180"/>
+        <p14:creationId xmlns:p14="http://schemas.microsoft.com/office/powerpoint/2010/main" val="1257023167"/>
       </p:ext>
     </p:extLst>
   </p:cSld>
@@ -3635,7 +3635,7 @@
           <p:cNvPr id="26" name="">
             <a:extLst xmlns:a="http://schemas.openxmlformats.org/drawingml/2006/main">
               <a:ext uri="{FF2B5EF4-FFF2-40B4-BE49-F238E27FC236}">
-                <a16:creationId xmlns:a16="http://schemas.microsoft.com/office/drawing/2014/main" id="{B9B2DDA0-86A3-4B29-A899-880445B1A660}"/>
+                <a16:creationId xmlns:a16="http://schemas.microsoft.com/office/drawing/2014/main" id="{DD0E54E7-3806-4DD0-8F8A-4509CA79CE64}"/>
               </a:ext>
             </a:extLst>
           </p:cNvPr>
@@ -3666,7 +3666,7 @@
           <p:cNvPr id="2" name="">
             <a:extLst xmlns:a="http://schemas.openxmlformats.org/drawingml/2006/main">
               <a:ext uri="{FF2B5EF4-FFF2-40B4-BE49-F238E27FC236}">
-                <a16:creationId xmlns:a16="http://schemas.microsoft.com/office/drawing/2014/main" id="{F5DE0F33-0B8F-4D09-979A-A6AFF4160ADE}"/>
+                <a16:creationId xmlns:a16="http://schemas.microsoft.com/office/drawing/2014/main" id="{2E1BD498-81B8-4B73-8812-6783145F15F1}"/>
               </a:ext>
             </a:extLst>
           </p:cNvPr>
@@ -3733,7 +3733,7 @@
           <p:cNvPr id="3" name="">
             <a:extLst xmlns:a="http://schemas.openxmlformats.org/drawingml/2006/main">
               <a:ext uri="{FF2B5EF4-FFF2-40B4-BE49-F238E27FC236}">
-                <a16:creationId xmlns:a16="http://schemas.microsoft.com/office/drawing/2014/main" id="{0CA18DEA-184E-4E9E-9748-447DA4EF22B7}"/>
+                <a16:creationId xmlns:a16="http://schemas.microsoft.com/office/drawing/2014/main" id="{CEB9B8D3-287E-46A4-8C9C-53DB9C4D9B7C}"/>
               </a:ext>
             </a:extLst>
           </p:cNvPr>
@@ -3800,7 +3800,7 @@
           <p:cNvPr id="4" name="">
             <a:extLst xmlns:a="http://schemas.openxmlformats.org/drawingml/2006/main">
               <a:ext uri="{FF2B5EF4-FFF2-40B4-BE49-F238E27FC236}">
-                <a16:creationId xmlns:a16="http://schemas.microsoft.com/office/drawing/2014/main" id="{EF0EA3FA-B22D-4DFA-A7B0-197F68C79174}"/>
+                <a16:creationId xmlns:a16="http://schemas.microsoft.com/office/drawing/2014/main" id="{8E6D0EAF-E723-44F6-B6AA-EBA677BD168C}"/>
               </a:ext>
             </a:extLst>
           </p:cNvPr>
@@ -3831,7 +3831,7 @@
           <p:cNvPr id="5" name="">
             <a:extLst xmlns:a="http://schemas.openxmlformats.org/drawingml/2006/main">
               <a:ext uri="{FF2B5EF4-FFF2-40B4-BE49-F238E27FC236}">
-                <a16:creationId xmlns:a16="http://schemas.microsoft.com/office/drawing/2014/main" id="{C7D252B2-3FC2-41BE-9547-C61E4DB4E346}"/>
+                <a16:creationId xmlns:a16="http://schemas.microsoft.com/office/drawing/2014/main" id="{CF4B98C4-044E-476E-A438-BEC56ED569C8}"/>
               </a:ext>
             </a:extLst>
           </p:cNvPr>
@@ -3898,7 +3898,7 @@
           <p:cNvPr id="6" name="">
             <a:extLst xmlns:a="http://schemas.openxmlformats.org/drawingml/2006/main">
               <a:ext uri="{FF2B5EF4-FFF2-40B4-BE49-F238E27FC236}">
-                <a16:creationId xmlns:a16="http://schemas.microsoft.com/office/drawing/2014/main" id="{BF009A40-D2F9-4CFA-A78D-9B21DD6B0A9C}"/>
+                <a16:creationId xmlns:a16="http://schemas.microsoft.com/office/drawing/2014/main" id="{F3CF8C72-7A1A-488E-9440-A1BE83BF4FA0}"/>
               </a:ext>
             </a:extLst>
           </p:cNvPr>
@@ -3965,7 +3965,7 @@
           <p:cNvPr id="7" name="">
             <a:extLst xmlns:a="http://schemas.openxmlformats.org/drawingml/2006/main">
               <a:ext uri="{FF2B5EF4-FFF2-40B4-BE49-F238E27FC236}">
-                <a16:creationId xmlns:a16="http://schemas.microsoft.com/office/drawing/2014/main" id="{AD00F7F9-7AD8-4853-8E9E-56D1E0F4A4CE}"/>
+                <a16:creationId xmlns:a16="http://schemas.microsoft.com/office/drawing/2014/main" id="{59CB6E8E-6369-46E3-A1D1-12E26C8E26BC}"/>
               </a:ext>
             </a:extLst>
           </p:cNvPr>
@@ -3996,7 +3996,7 @@
           <p:cNvPr id="8" name="">
             <a:extLst xmlns:a="http://schemas.openxmlformats.org/drawingml/2006/main">
               <a:ext uri="{FF2B5EF4-FFF2-40B4-BE49-F238E27FC236}">
-                <a16:creationId xmlns:a16="http://schemas.microsoft.com/office/drawing/2014/main" id="{8A66E236-CDD6-4342-AD15-D753F3B3E1C4}"/>
+                <a16:creationId xmlns:a16="http://schemas.microsoft.com/office/drawing/2014/main" id="{964A13C3-1E9F-49A5-AA9C-4074D69822E5}"/>
               </a:ext>
             </a:extLst>
           </p:cNvPr>
@@ -4063,7 +4063,7 @@
           <p:cNvPr id="9" name="">
             <a:extLst xmlns:a="http://schemas.openxmlformats.org/drawingml/2006/main">
               <a:ext uri="{FF2B5EF4-FFF2-40B4-BE49-F238E27FC236}">
-                <a16:creationId xmlns:a16="http://schemas.microsoft.com/office/drawing/2014/main" id="{FE1D51D4-A0C1-4C5C-99C8-E34C3DC22F33}"/>
+                <a16:creationId xmlns:a16="http://schemas.microsoft.com/office/drawing/2014/main" id="{350D5DC1-E28B-4615-B69D-36A8FDCA46A2}"/>
               </a:ext>
             </a:extLst>
           </p:cNvPr>
@@ -4130,7 +4130,7 @@
           <p:cNvPr id="10" name="">
             <a:extLst xmlns:a="http://schemas.openxmlformats.org/drawingml/2006/main">
               <a:ext uri="{FF2B5EF4-FFF2-40B4-BE49-F238E27FC236}">
-                <a16:creationId xmlns:a16="http://schemas.microsoft.com/office/drawing/2014/main" id="{7B335E48-39B3-4182-8417-26807457A41A}"/>
+                <a16:creationId xmlns:a16="http://schemas.microsoft.com/office/drawing/2014/main" id="{C2C17B66-8246-401B-BAE6-4E24369FFDF1}"/>
               </a:ext>
             </a:extLst>
           </p:cNvPr>
@@ -4161,7 +4161,7 @@
           <p:cNvPr id="11" name="">
             <a:extLst xmlns:a="http://schemas.openxmlformats.org/drawingml/2006/main">
               <a:ext uri="{FF2B5EF4-FFF2-40B4-BE49-F238E27FC236}">
-                <a16:creationId xmlns:a16="http://schemas.microsoft.com/office/drawing/2014/main" id="{B7B81B36-4193-47D3-9700-E8DF76C2DD92}"/>
+                <a16:creationId xmlns:a16="http://schemas.microsoft.com/office/drawing/2014/main" id="{6E08885D-C6B7-4725-843C-5A652746F838}"/>
               </a:ext>
             </a:extLst>
           </p:cNvPr>
@@ -4228,7 +4228,7 @@
           <p:cNvPr id="12" name="">
             <a:extLst xmlns:a="http://schemas.openxmlformats.org/drawingml/2006/main">
               <a:ext uri="{FF2B5EF4-FFF2-40B4-BE49-F238E27FC236}">
-                <a16:creationId xmlns:a16="http://schemas.microsoft.com/office/drawing/2014/main" id="{89A22FAC-EA58-4B43-8276-4D01D34636F1}"/>
+                <a16:creationId xmlns:a16="http://schemas.microsoft.com/office/drawing/2014/main" id="{BBAB91D2-C64F-40B7-897B-7646423DD913}"/>
               </a:ext>
             </a:extLst>
           </p:cNvPr>
@@ -4295,7 +4295,7 @@
           <p:cNvPr id="13" name="">
             <a:extLst xmlns:a="http://schemas.openxmlformats.org/drawingml/2006/main">
               <a:ext uri="{FF2B5EF4-FFF2-40B4-BE49-F238E27FC236}">
-                <a16:creationId xmlns:a16="http://schemas.microsoft.com/office/drawing/2014/main" id="{71245069-3C10-4DEC-9D22-D955263DC3C4}"/>
+                <a16:creationId xmlns:a16="http://schemas.microsoft.com/office/drawing/2014/main" id="{9C3922EB-0EDF-41F3-B8F7-4D3FCC9109B1}"/>
               </a:ext>
             </a:extLst>
           </p:cNvPr>
@@ -4326,7 +4326,7 @@
           <p:cNvPr id="14" name="">
             <a:extLst xmlns:a="http://schemas.openxmlformats.org/drawingml/2006/main">
               <a:ext uri="{FF2B5EF4-FFF2-40B4-BE49-F238E27FC236}">
-                <a16:creationId xmlns:a16="http://schemas.microsoft.com/office/drawing/2014/main" id="{10F03031-B0D1-4928-AE6E-471A5EC57A2A}"/>
+                <a16:creationId xmlns:a16="http://schemas.microsoft.com/office/drawing/2014/main" id="{50EE30C0-3980-4562-8B95-0AF2C3F974E5}"/>
               </a:ext>
             </a:extLst>
           </p:cNvPr>
@@ -4393,7 +4393,7 @@
           <p:cNvPr id="15" name="">
             <a:extLst xmlns:a="http://schemas.openxmlformats.org/drawingml/2006/main">
               <a:ext uri="{FF2B5EF4-FFF2-40B4-BE49-F238E27FC236}">
-                <a16:creationId xmlns:a16="http://schemas.microsoft.com/office/drawing/2014/main" id="{16B8A292-DD3C-4057-BF33-2D24661B7C21}"/>
+                <a16:creationId xmlns:a16="http://schemas.microsoft.com/office/drawing/2014/main" id="{37763FDA-09D3-4509-8D0C-6D7A0B2E508D}"/>
               </a:ext>
             </a:extLst>
           </p:cNvPr>
@@ -4460,7 +4460,7 @@
           <p:cNvPr id="16" name="">
             <a:extLst xmlns:a="http://schemas.openxmlformats.org/drawingml/2006/main">
               <a:ext uri="{FF2B5EF4-FFF2-40B4-BE49-F238E27FC236}">
-                <a16:creationId xmlns:a16="http://schemas.microsoft.com/office/drawing/2014/main" id="{6073E72B-7D41-4214-8552-3BCE3327D6AE}"/>
+                <a16:creationId xmlns:a16="http://schemas.microsoft.com/office/drawing/2014/main" id="{AE1717D3-A0F4-4F87-891A-7A24706EDF1D}"/>
               </a:ext>
             </a:extLst>
           </p:cNvPr>
@@ -4491,7 +4491,7 @@
           <p:cNvPr id="17" name="">
             <a:extLst xmlns:a="http://schemas.openxmlformats.org/drawingml/2006/main">
               <a:ext uri="{FF2B5EF4-FFF2-40B4-BE49-F238E27FC236}">
-                <a16:creationId xmlns:a16="http://schemas.microsoft.com/office/drawing/2014/main" id="{B566B793-0A61-4006-A976-DA00D649B47B}"/>
+                <a16:creationId xmlns:a16="http://schemas.microsoft.com/office/drawing/2014/main" id="{EF12AC95-0764-4DAB-8F44-CD86C64E1D7D}"/>
               </a:ext>
             </a:extLst>
           </p:cNvPr>
@@ -4558,7 +4558,7 @@
           <p:cNvPr id="18" name="">
             <a:extLst xmlns:a="http://schemas.openxmlformats.org/drawingml/2006/main">
               <a:ext uri="{FF2B5EF4-FFF2-40B4-BE49-F238E27FC236}">
-                <a16:creationId xmlns:a16="http://schemas.microsoft.com/office/drawing/2014/main" id="{3D1D2A07-6F6F-44D0-9248-10E5CF5AAB49}"/>
+                <a16:creationId xmlns:a16="http://schemas.microsoft.com/office/drawing/2014/main" id="{9FC6F627-C286-40BA-A78D-DF017A96652A}"/>
               </a:ext>
             </a:extLst>
           </p:cNvPr>
@@ -4625,7 +4625,7 @@
           <p:cNvPr id="19" name="">
             <a:extLst xmlns:a="http://schemas.openxmlformats.org/drawingml/2006/main">
               <a:ext uri="{FF2B5EF4-FFF2-40B4-BE49-F238E27FC236}">
-                <a16:creationId xmlns:a16="http://schemas.microsoft.com/office/drawing/2014/main" id="{F567F08C-23C6-4F2B-A647-CEF2C1EF2498}"/>
+                <a16:creationId xmlns:a16="http://schemas.microsoft.com/office/drawing/2014/main" id="{7DDBA21C-9BB2-4FDB-9256-3B9260B9BAF1}"/>
               </a:ext>
             </a:extLst>
           </p:cNvPr>
@@ -4656,7 +4656,7 @@
           <p:cNvPr id="20" name="">
             <a:extLst xmlns:a="http://schemas.openxmlformats.org/drawingml/2006/main">
               <a:ext uri="{FF2B5EF4-FFF2-40B4-BE49-F238E27FC236}">
-                <a16:creationId xmlns:a16="http://schemas.microsoft.com/office/drawing/2014/main" id="{322566D4-8DEA-441A-A207-4A9F763BF56F}"/>
+                <a16:creationId xmlns:a16="http://schemas.microsoft.com/office/drawing/2014/main" id="{9F871F38-0F2B-460A-8422-525F234D188B}"/>
               </a:ext>
             </a:extLst>
           </p:cNvPr>
@@ -4723,7 +4723,7 @@
           <p:cNvPr id="21" name="">
             <a:extLst xmlns:a="http://schemas.openxmlformats.org/drawingml/2006/main">
               <a:ext uri="{FF2B5EF4-FFF2-40B4-BE49-F238E27FC236}">
-                <a16:creationId xmlns:a16="http://schemas.microsoft.com/office/drawing/2014/main" id="{43DEB5E3-E770-4E03-9D5C-6C59293B1FC8}"/>
+                <a16:creationId xmlns:a16="http://schemas.microsoft.com/office/drawing/2014/main" id="{91D71FBE-1F7A-4B52-AF6E-600044822F33}"/>
               </a:ext>
             </a:extLst>
           </p:cNvPr>
@@ -4790,7 +4790,7 @@
           <p:cNvPr id="22" name="">
             <a:extLst xmlns:a="http://schemas.openxmlformats.org/drawingml/2006/main">
               <a:ext uri="{FF2B5EF4-FFF2-40B4-BE49-F238E27FC236}">
-                <a16:creationId xmlns:a16="http://schemas.microsoft.com/office/drawing/2014/main" id="{C8BC6AAC-2FCB-4DCA-AD75-A3108B40D833}"/>
+                <a16:creationId xmlns:a16="http://schemas.microsoft.com/office/drawing/2014/main" id="{2E0FC933-8E88-4EEC-BE9A-2A767484B229}"/>
               </a:ext>
             </a:extLst>
           </p:cNvPr>
@@ -4821,7 +4821,7 @@
           <p:cNvPr id="23" name="">
             <a:extLst xmlns:a="http://schemas.openxmlformats.org/drawingml/2006/main">
               <a:ext uri="{FF2B5EF4-FFF2-40B4-BE49-F238E27FC236}">
-                <a16:creationId xmlns:a16="http://schemas.microsoft.com/office/drawing/2014/main" id="{6C2E4D3A-8FFF-4903-B9A4-8013C043909A}"/>
+                <a16:creationId xmlns:a16="http://schemas.microsoft.com/office/drawing/2014/main" id="{31C933C4-434F-4851-BD6A-3F3EE89D8DDB}"/>
               </a:ext>
             </a:extLst>
           </p:cNvPr>
@@ -4888,7 +4888,7 @@
           <p:cNvPr id="24" name="">
             <a:extLst xmlns:a="http://schemas.openxmlformats.org/drawingml/2006/main">
               <a:ext uri="{FF2B5EF4-FFF2-40B4-BE49-F238E27FC236}">
-                <a16:creationId xmlns:a16="http://schemas.microsoft.com/office/drawing/2014/main" id="{BE6EDFDF-9CEE-459B-AD3E-4545673B62BE}"/>
+                <a16:creationId xmlns:a16="http://schemas.microsoft.com/office/drawing/2014/main" id="{C1DF1C9F-191C-4482-991D-EB32D9CF96BC}"/>
               </a:ext>
             </a:extLst>
           </p:cNvPr>
@@ -4955,7 +4955,7 @@
           <p:cNvPr id="25" name="">
             <a:extLst xmlns:a="http://schemas.openxmlformats.org/drawingml/2006/main">
               <a:ext uri="{FF2B5EF4-FFF2-40B4-BE49-F238E27FC236}">
-                <a16:creationId xmlns:a16="http://schemas.microsoft.com/office/drawing/2014/main" id="{F2C8CF04-C073-4EFB-A546-AF16E260EAFA}"/>
+                <a16:creationId xmlns:a16="http://schemas.microsoft.com/office/drawing/2014/main" id="{242972AC-CD25-4AB1-8B6F-B03F9DDCE1B9}"/>
               </a:ext>
             </a:extLst>
           </p:cNvPr>
@@ -5020,7 +5020,7 @@
     </p:spTree>
     <p:extLst>
       <p:ext uri="{BB962C8B-B14F-4D97-AF65-F5344CB8AC3E}">
-        <p14:creationId xmlns:p14="http://schemas.microsoft.com/office/powerpoint/2010/main" val="1214180311"/>
+        <p14:creationId xmlns:p14="http://schemas.microsoft.com/office/powerpoint/2010/main" val="1491753588"/>
       </p:ext>
     </p:extLst>
   </p:cSld>
@@ -5051,7 +5051,7 @@
           <p:cNvPr id="24" name="">
             <a:extLst xmlns:a="http://schemas.openxmlformats.org/drawingml/2006/main">
               <a:ext uri="{FF2B5EF4-FFF2-40B4-BE49-F238E27FC236}">
-                <a16:creationId xmlns:a16="http://schemas.microsoft.com/office/drawing/2014/main" id="{A0ECFBE3-5371-41C0-A738-DE48BBCAA3A3}"/>
+                <a16:creationId xmlns:a16="http://schemas.microsoft.com/office/drawing/2014/main" id="{C5CD7F82-FC91-4BC7-8739-19BF0267FCC1}"/>
               </a:ext>
             </a:extLst>
           </p:cNvPr>
@@ -5082,7 +5082,7 @@
           <p:cNvPr id="2" name="">
             <a:extLst xmlns:a="http://schemas.openxmlformats.org/drawingml/2006/main">
               <a:ext uri="{FF2B5EF4-FFF2-40B4-BE49-F238E27FC236}">
-                <a16:creationId xmlns:a16="http://schemas.microsoft.com/office/drawing/2014/main" id="{89126A2B-9B38-4858-BC83-8E7560EEC9BC}"/>
+                <a16:creationId xmlns:a16="http://schemas.microsoft.com/office/drawing/2014/main" id="{3DA4611B-D3B6-4371-83FF-811A08184F3F}"/>
               </a:ext>
             </a:extLst>
           </p:cNvPr>
@@ -5149,7 +5149,7 @@
           <p:cNvPr id="3" name="">
             <a:extLst xmlns:a="http://schemas.openxmlformats.org/drawingml/2006/main">
               <a:ext uri="{FF2B5EF4-FFF2-40B4-BE49-F238E27FC236}">
-                <a16:creationId xmlns:a16="http://schemas.microsoft.com/office/drawing/2014/main" id="{8239E5F9-8920-49B7-9338-13B5DE472FB4}"/>
+                <a16:creationId xmlns:a16="http://schemas.microsoft.com/office/drawing/2014/main" id="{3113D153-9EB9-453F-9D54-6D73761AF86A}"/>
               </a:ext>
             </a:extLst>
           </p:cNvPr>
@@ -5216,7 +5216,7 @@
           <p:cNvPr id="4" name="">
             <a:extLst xmlns:a="http://schemas.openxmlformats.org/drawingml/2006/main">
               <a:ext uri="{FF2B5EF4-FFF2-40B4-BE49-F238E27FC236}">
-                <a16:creationId xmlns:a16="http://schemas.microsoft.com/office/drawing/2014/main" id="{BADFB3A8-E34E-42D1-85E6-361F62BDDD35}"/>
+                <a16:creationId xmlns:a16="http://schemas.microsoft.com/office/drawing/2014/main" id="{287E2796-145B-4A70-AB02-0DFF032B25A3}"/>
               </a:ext>
             </a:extLst>
           </p:cNvPr>
@@ -5247,7 +5247,7 @@
           <p:cNvPr id="5" name="">
             <a:extLst xmlns:a="http://schemas.openxmlformats.org/drawingml/2006/main">
               <a:ext uri="{FF2B5EF4-FFF2-40B4-BE49-F238E27FC236}">
-                <a16:creationId xmlns:a16="http://schemas.microsoft.com/office/drawing/2014/main" id="{58C5BA64-AC90-4C25-85EE-92968EAD2930}"/>
+                <a16:creationId xmlns:a16="http://schemas.microsoft.com/office/drawing/2014/main" id="{DA359C19-3287-40BE-B8C3-F4780CF6E416}"/>
               </a:ext>
             </a:extLst>
           </p:cNvPr>
@@ -5314,7 +5314,7 @@
           <p:cNvPr id="6" name="">
             <a:extLst xmlns:a="http://schemas.openxmlformats.org/drawingml/2006/main">
               <a:ext uri="{FF2B5EF4-FFF2-40B4-BE49-F238E27FC236}">
-                <a16:creationId xmlns:a16="http://schemas.microsoft.com/office/drawing/2014/main" id="{99D7A4CD-3D13-459B-9500-F992C8D7CEB0}"/>
+                <a16:creationId xmlns:a16="http://schemas.microsoft.com/office/drawing/2014/main" id="{051627AE-12A6-43B8-B5CA-1DA3C7230CB5}"/>
               </a:ext>
             </a:extLst>
           </p:cNvPr>
@@ -5381,7 +5381,7 @@
           <p:cNvPr id="7" name="">
             <a:extLst xmlns:a="http://schemas.openxmlformats.org/drawingml/2006/main">
               <a:ext uri="{FF2B5EF4-FFF2-40B4-BE49-F238E27FC236}">
-                <a16:creationId xmlns:a16="http://schemas.microsoft.com/office/drawing/2014/main" id="{F07EF3B3-3497-4EF4-B175-D890E24D3F0E}"/>
+                <a16:creationId xmlns:a16="http://schemas.microsoft.com/office/drawing/2014/main" id="{67FD7537-4EAA-498C-AA4B-290200CEBE91}"/>
               </a:ext>
             </a:extLst>
           </p:cNvPr>
@@ -5416,7 +5416,7 @@
           <p:cNvPr id="8" name="">
             <a:extLst xmlns:a="http://schemas.openxmlformats.org/drawingml/2006/main">
               <a:ext uri="{FF2B5EF4-FFF2-40B4-BE49-F238E27FC236}">
-                <a16:creationId xmlns:a16="http://schemas.microsoft.com/office/drawing/2014/main" id="{C2BD2686-F02D-45C4-8637-6BE93844D418}"/>
+                <a16:creationId xmlns:a16="http://schemas.microsoft.com/office/drawing/2014/main" id="{F5F9CC66-8C63-4552-9B91-9AFD1494F252}"/>
               </a:ext>
             </a:extLst>
           </p:cNvPr>
@@ -5447,7 +5447,7 @@
           <p:cNvPr id="9" name="">
             <a:extLst xmlns:a="http://schemas.openxmlformats.org/drawingml/2006/main">
               <a:ext uri="{FF2B5EF4-FFF2-40B4-BE49-F238E27FC236}">
-                <a16:creationId xmlns:a16="http://schemas.microsoft.com/office/drawing/2014/main" id="{D34630F0-E189-4EC3-850A-FCE4C1794C46}"/>
+                <a16:creationId xmlns:a16="http://schemas.microsoft.com/office/drawing/2014/main" id="{473C9546-F340-48F9-9409-8FB04EDF260E}"/>
               </a:ext>
             </a:extLst>
           </p:cNvPr>
@@ -5514,7 +5514,7 @@
           <p:cNvPr id="10" name="">
             <a:extLst xmlns:a="http://schemas.openxmlformats.org/drawingml/2006/main">
               <a:ext uri="{FF2B5EF4-FFF2-40B4-BE49-F238E27FC236}">
-                <a16:creationId xmlns:a16="http://schemas.microsoft.com/office/drawing/2014/main" id="{477E7D5E-B125-41E1-96FF-060AFDE8F2FA}"/>
+                <a16:creationId xmlns:a16="http://schemas.microsoft.com/office/drawing/2014/main" id="{39E43EF5-CD43-4908-9821-FE0744997F5F}"/>
               </a:ext>
             </a:extLst>
           </p:cNvPr>
@@ -5640,6 +5640,29 @@
                 <a:ea typeface="Aptos"/>
                 <a:cs typeface="Aptos"/>
               </a:rPr>
+              <a:t>genre</a:t>
+            </a:r>
+          </a:p>
+          <a:p xmlns:a="http://schemas.openxmlformats.org/drawingml/2006/main">
+            <a:pPr algn="l">
+              <a:defRPr sz="1500" b="0">
+                <a:solidFill>
+                  <a:srgbClr val="182A3A"/>
+                </a:solidFill>
+                <a:latin typeface="Aptos"/>
+                <a:ea typeface="Aptos"/>
+                <a:cs typeface="Aptos"/>
+              </a:defRPr>
+            </a:pPr>
+            <a:r>
+              <a:rPr sz="1500" b="0">
+                <a:solidFill>
+                  <a:srgbClr val="182A3A"/>
+                </a:solidFill>
+                <a:latin typeface="Aptos"/>
+                <a:ea typeface="Aptos"/>
+                <a:cs typeface="Aptos"/>
+              </a:rPr>
               <a:t>available</a:t>
             </a:r>
           </a:p>
@@ -5650,7 +5673,7 @@
           <p:cNvPr id="11" name="">
             <a:extLst xmlns:a="http://schemas.openxmlformats.org/drawingml/2006/main">
               <a:ext uri="{FF2B5EF4-FFF2-40B4-BE49-F238E27FC236}">
-                <a16:creationId xmlns:a16="http://schemas.microsoft.com/office/drawing/2014/main" id="{CF443787-6D5F-4BC7-8A80-8ACAAED67D2C}"/>
+                <a16:creationId xmlns:a16="http://schemas.microsoft.com/office/drawing/2014/main" id="{8E97CF80-81C1-4C0A-826E-1EC3901224E8}"/>
               </a:ext>
             </a:extLst>
           </p:cNvPr>
@@ -5685,7 +5708,7 @@
           <p:cNvPr id="12" name="">
             <a:extLst xmlns:a="http://schemas.openxmlformats.org/drawingml/2006/main">
               <a:ext uri="{FF2B5EF4-FFF2-40B4-BE49-F238E27FC236}">
-                <a16:creationId xmlns:a16="http://schemas.microsoft.com/office/drawing/2014/main" id="{1DD25BF6-4F00-4030-85BE-011115A8B27E}"/>
+                <a16:creationId xmlns:a16="http://schemas.microsoft.com/office/drawing/2014/main" id="{7E136A7C-30A6-4883-B464-94C845E85862}"/>
               </a:ext>
             </a:extLst>
           </p:cNvPr>
@@ -5716,7 +5739,7 @@
           <p:cNvPr id="13" name="">
             <a:extLst xmlns:a="http://schemas.openxmlformats.org/drawingml/2006/main">
               <a:ext uri="{FF2B5EF4-FFF2-40B4-BE49-F238E27FC236}">
-                <a16:creationId xmlns:a16="http://schemas.microsoft.com/office/drawing/2014/main" id="{1FDD1DF7-AED7-4125-B38D-15C9BA2A4261}"/>
+                <a16:creationId xmlns:a16="http://schemas.microsoft.com/office/drawing/2014/main" id="{4E94CD8C-9D3A-470B-9BA2-298ADD948FFA}"/>
               </a:ext>
             </a:extLst>
           </p:cNvPr>
@@ -5783,7 +5806,7 @@
           <p:cNvPr id="14" name="">
             <a:extLst xmlns:a="http://schemas.openxmlformats.org/drawingml/2006/main">
               <a:ext uri="{FF2B5EF4-FFF2-40B4-BE49-F238E27FC236}">
-                <a16:creationId xmlns:a16="http://schemas.microsoft.com/office/drawing/2014/main" id="{2E5B8A6E-AB58-4625-95C9-E67CD65BA10D}"/>
+                <a16:creationId xmlns:a16="http://schemas.microsoft.com/office/drawing/2014/main" id="{23FCA6C5-8993-48F8-BA9F-82569EA229EE}"/>
               </a:ext>
             </a:extLst>
           </p:cNvPr>
@@ -5909,7 +5932,7 @@
                 <a:ea typeface="Aptos"/>
                 <a:cs typeface="Aptos"/>
               </a:rPr>
-              <a:t>returned</a:t>
+              <a:t>borrowed / due / returned</a:t>
             </a:r>
           </a:p>
         </p:txBody>
@@ -5919,7 +5942,7 @@
           <p:cNvPr id="15" name="">
             <a:extLst xmlns:a="http://schemas.openxmlformats.org/drawingml/2006/main">
               <a:ext uri="{FF2B5EF4-FFF2-40B4-BE49-F238E27FC236}">
-                <a16:creationId xmlns:a16="http://schemas.microsoft.com/office/drawing/2014/main" id="{9CD94C8B-626A-4939-A89B-37C2AB0289B3}"/>
+                <a16:creationId xmlns:a16="http://schemas.microsoft.com/office/drawing/2014/main" id="{7411652B-5F64-44CA-A4E8-61EBEC91FE44}"/>
               </a:ext>
             </a:extLst>
           </p:cNvPr>
@@ -5954,7 +5977,7 @@
           <p:cNvPr id="16" name="">
             <a:extLst xmlns:a="http://schemas.openxmlformats.org/drawingml/2006/main">
               <a:ext uri="{FF2B5EF4-FFF2-40B4-BE49-F238E27FC236}">
-                <a16:creationId xmlns:a16="http://schemas.microsoft.com/office/drawing/2014/main" id="{2B47ADC3-CCC8-4037-A7F8-5C940956E8E3}"/>
+                <a16:creationId xmlns:a16="http://schemas.microsoft.com/office/drawing/2014/main" id="{C76B12DE-60EA-49F6-9478-5481CF84A9CB}"/>
               </a:ext>
             </a:extLst>
           </p:cNvPr>
@@ -5985,7 +6008,7 @@
           <p:cNvPr id="17" name="">
             <a:extLst xmlns:a="http://schemas.openxmlformats.org/drawingml/2006/main">
               <a:ext uri="{FF2B5EF4-FFF2-40B4-BE49-F238E27FC236}">
-                <a16:creationId xmlns:a16="http://schemas.microsoft.com/office/drawing/2014/main" id="{EEAA91E2-9B4A-46FA-8104-A935B134A68F}"/>
+                <a16:creationId xmlns:a16="http://schemas.microsoft.com/office/drawing/2014/main" id="{9D018282-072B-4C95-9FFF-A3418AD28191}"/>
               </a:ext>
             </a:extLst>
           </p:cNvPr>
@@ -6052,7 +6075,7 @@
           <p:cNvPr id="18" name="">
             <a:extLst xmlns:a="http://schemas.openxmlformats.org/drawingml/2006/main">
               <a:ext uri="{FF2B5EF4-FFF2-40B4-BE49-F238E27FC236}">
-                <a16:creationId xmlns:a16="http://schemas.microsoft.com/office/drawing/2014/main" id="{908D03DC-DC6B-46F5-A916-3B97D84FD5CD}"/>
+                <a16:creationId xmlns:a16="http://schemas.microsoft.com/office/drawing/2014/main" id="{01632383-67B2-4987-B913-4539851F50B3}"/>
               </a:ext>
             </a:extLst>
           </p:cNvPr>
@@ -6158,6 +6181,29 @@
               <a:t>email</a:t>
             </a:r>
           </a:p>
+          <a:p xmlns:a="http://schemas.openxmlformats.org/drawingml/2006/main">
+            <a:pPr algn="l">
+              <a:defRPr sz="1500" b="0">
+                <a:solidFill>
+                  <a:srgbClr val="182A3A"/>
+                </a:solidFill>
+                <a:latin typeface="Aptos"/>
+                <a:ea typeface="Aptos"/>
+                <a:cs typeface="Aptos"/>
+              </a:defRPr>
+            </a:pPr>
+            <a:r>
+              <a:rPr sz="1500" b="0">
+                <a:solidFill>
+                  <a:srgbClr val="182A3A"/>
+                </a:solidFill>
+                <a:latin typeface="Aptos"/>
+                <a:ea typeface="Aptos"/>
+                <a:cs typeface="Aptos"/>
+              </a:rPr>
+              <a:t>study program</a:t>
+            </a:r>
+          </a:p>
         </p:txBody>
       </p:sp>
       <p:sp>
@@ -6165,7 +6211,7 @@
           <p:cNvPr id="19" name="">
             <a:extLst xmlns:a="http://schemas.openxmlformats.org/drawingml/2006/main">
               <a:ext uri="{FF2B5EF4-FFF2-40B4-BE49-F238E27FC236}">
-                <a16:creationId xmlns:a16="http://schemas.microsoft.com/office/drawing/2014/main" id="{4B069EEA-8A1D-496B-B397-2220825CB2EA}"/>
+                <a16:creationId xmlns:a16="http://schemas.microsoft.com/office/drawing/2014/main" id="{6CB4C851-EA5F-4043-B658-BB8ADE6A3A48}"/>
               </a:ext>
             </a:extLst>
           </p:cNvPr>
@@ -6196,7 +6242,7 @@
           <p:cNvPr id="20" name="">
             <a:extLst xmlns:a="http://schemas.openxmlformats.org/drawingml/2006/main">
               <a:ext uri="{FF2B5EF4-FFF2-40B4-BE49-F238E27FC236}">
-                <a16:creationId xmlns:a16="http://schemas.microsoft.com/office/drawing/2014/main" id="{8B80FBDF-4B55-4F3C-9378-3AD3E8A547DF}"/>
+                <a16:creationId xmlns:a16="http://schemas.microsoft.com/office/drawing/2014/main" id="{DD89543D-D47C-47AE-8F7F-19754BBA9850}"/>
               </a:ext>
             </a:extLst>
           </p:cNvPr>
@@ -6263,7 +6309,7 @@
           <p:cNvPr id="21" name="">
             <a:extLst xmlns:a="http://schemas.openxmlformats.org/drawingml/2006/main">
               <a:ext uri="{FF2B5EF4-FFF2-40B4-BE49-F238E27FC236}">
-                <a16:creationId xmlns:a16="http://schemas.microsoft.com/office/drawing/2014/main" id="{33B1F933-CE36-44D2-B184-89BD81EE9523}"/>
+                <a16:creationId xmlns:a16="http://schemas.microsoft.com/office/drawing/2014/main" id="{69C08AB5-FD86-4C1C-8610-53AFD9083165}"/>
               </a:ext>
             </a:extLst>
           </p:cNvPr>
@@ -6294,7 +6340,7 @@
           <p:cNvPr id="22" name="">
             <a:extLst xmlns:a="http://schemas.openxmlformats.org/drawingml/2006/main">
               <a:ext uri="{FF2B5EF4-FFF2-40B4-BE49-F238E27FC236}">
-                <a16:creationId xmlns:a16="http://schemas.microsoft.com/office/drawing/2014/main" id="{9E8E3788-817D-44A1-9047-37B9046F2B10}"/>
+                <a16:creationId xmlns:a16="http://schemas.microsoft.com/office/drawing/2014/main" id="{D084EF41-BD90-461B-9749-CDFF047BB868}"/>
               </a:ext>
             </a:extLst>
           </p:cNvPr>
@@ -6361,7 +6407,7 @@
           <p:cNvPr id="23" name="">
             <a:extLst xmlns:a="http://schemas.openxmlformats.org/drawingml/2006/main">
               <a:ext uri="{FF2B5EF4-FFF2-40B4-BE49-F238E27FC236}">
-                <a16:creationId xmlns:a16="http://schemas.microsoft.com/office/drawing/2014/main" id="{1080BC8E-6E72-4E97-AB79-BC28889CFB0B}"/>
+                <a16:creationId xmlns:a16="http://schemas.microsoft.com/office/drawing/2014/main" id="{6440499A-8F24-499B-8C25-40D758FB49BE}"/>
               </a:ext>
             </a:extLst>
           </p:cNvPr>
@@ -6426,7 +6472,7 @@
     </p:spTree>
     <p:extLst>
       <p:ext uri="{BB962C8B-B14F-4D97-AF65-F5344CB8AC3E}">
-        <p14:creationId xmlns:p14="http://schemas.microsoft.com/office/powerpoint/2010/main" val="1542975085"/>
+        <p14:creationId xmlns:p14="http://schemas.microsoft.com/office/powerpoint/2010/main" val="980392784"/>
       </p:ext>
     </p:extLst>
   </p:cSld>
@@ -6457,7 +6503,7 @@
           <p:cNvPr id="25" name="">
             <a:extLst xmlns:a="http://schemas.openxmlformats.org/drawingml/2006/main">
               <a:ext uri="{FF2B5EF4-FFF2-40B4-BE49-F238E27FC236}">
-                <a16:creationId xmlns:a16="http://schemas.microsoft.com/office/drawing/2014/main" id="{38AD9CC7-A5D7-4C91-8702-F074B11DDA0A}"/>
+                <a16:creationId xmlns:a16="http://schemas.microsoft.com/office/drawing/2014/main" id="{90690C28-C5AE-4707-B2A6-F7D148350E7B}"/>
               </a:ext>
             </a:extLst>
           </p:cNvPr>
@@ -6488,7 +6534,7 @@
           <p:cNvPr id="2" name="">
             <a:extLst xmlns:a="http://schemas.openxmlformats.org/drawingml/2006/main">
               <a:ext uri="{FF2B5EF4-FFF2-40B4-BE49-F238E27FC236}">
-                <a16:creationId xmlns:a16="http://schemas.microsoft.com/office/drawing/2014/main" id="{44CE0F49-C91E-4BD5-B573-CCC24A3ED261}"/>
+                <a16:creationId xmlns:a16="http://schemas.microsoft.com/office/drawing/2014/main" id="{0415BB04-64FE-49FD-82E3-36C988899CF6}"/>
               </a:ext>
             </a:extLst>
           </p:cNvPr>
@@ -6555,7 +6601,7 @@
           <p:cNvPr id="3" name="">
             <a:extLst xmlns:a="http://schemas.openxmlformats.org/drawingml/2006/main">
               <a:ext uri="{FF2B5EF4-FFF2-40B4-BE49-F238E27FC236}">
-                <a16:creationId xmlns:a16="http://schemas.microsoft.com/office/drawing/2014/main" id="{92A98EAA-FA4E-4CF9-8F94-F4C3F057999E}"/>
+                <a16:creationId xmlns:a16="http://schemas.microsoft.com/office/drawing/2014/main" id="{B904FE3A-CD52-4E07-B01D-0B9293E8A7FF}"/>
               </a:ext>
             </a:extLst>
           </p:cNvPr>
@@ -6622,7 +6668,7 @@
           <p:cNvPr id="4" name="">
             <a:extLst xmlns:a="http://schemas.openxmlformats.org/drawingml/2006/main">
               <a:ext uri="{FF2B5EF4-FFF2-40B4-BE49-F238E27FC236}">
-                <a16:creationId xmlns:a16="http://schemas.microsoft.com/office/drawing/2014/main" id="{F4D4305E-9D5F-4E32-B975-8A7F2411AACB}"/>
+                <a16:creationId xmlns:a16="http://schemas.microsoft.com/office/drawing/2014/main" id="{306A4602-9C9A-4364-B957-252B60DF6684}"/>
               </a:ext>
             </a:extLst>
           </p:cNvPr>
@@ -6653,7 +6699,7 @@
           <p:cNvPr id="5" name="">
             <a:extLst xmlns:a="http://schemas.openxmlformats.org/drawingml/2006/main">
               <a:ext uri="{FF2B5EF4-FFF2-40B4-BE49-F238E27FC236}">
-                <a16:creationId xmlns:a16="http://schemas.microsoft.com/office/drawing/2014/main" id="{3EF06873-7490-4BED-8CFE-4347BE129617}"/>
+                <a16:creationId xmlns:a16="http://schemas.microsoft.com/office/drawing/2014/main" id="{34714F69-FB77-40C3-8844-EC56027F24F7}"/>
               </a:ext>
             </a:extLst>
           </p:cNvPr>
@@ -6720,7 +6766,7 @@
           <p:cNvPr id="6" name="">
             <a:extLst xmlns:a="http://schemas.openxmlformats.org/drawingml/2006/main">
               <a:ext uri="{FF2B5EF4-FFF2-40B4-BE49-F238E27FC236}">
-                <a16:creationId xmlns:a16="http://schemas.microsoft.com/office/drawing/2014/main" id="{F85A0A6B-60F0-4C7A-A496-7DDE6AD7838D}"/>
+                <a16:creationId xmlns:a16="http://schemas.microsoft.com/office/drawing/2014/main" id="{CAB654E6-FAC4-4271-9665-60718944B848}"/>
               </a:ext>
             </a:extLst>
           </p:cNvPr>
@@ -6787,7 +6833,7 @@
           <p:cNvPr id="7" name="">
             <a:extLst xmlns:a="http://schemas.openxmlformats.org/drawingml/2006/main">
               <a:ext uri="{FF2B5EF4-FFF2-40B4-BE49-F238E27FC236}">
-                <a16:creationId xmlns:a16="http://schemas.microsoft.com/office/drawing/2014/main" id="{AEA40BF3-73D0-4CC7-9FD9-0A23C165894C}"/>
+                <a16:creationId xmlns:a16="http://schemas.microsoft.com/office/drawing/2014/main" id="{60F73D08-62A7-4E0C-8B83-DEADE0EDED4E}"/>
               </a:ext>
             </a:extLst>
           </p:cNvPr>
@@ -6822,7 +6868,7 @@
           <p:cNvPr id="8" name="">
             <a:extLst xmlns:a="http://schemas.openxmlformats.org/drawingml/2006/main">
               <a:ext uri="{FF2B5EF4-FFF2-40B4-BE49-F238E27FC236}">
-                <a16:creationId xmlns:a16="http://schemas.microsoft.com/office/drawing/2014/main" id="{F79A5623-C437-43D9-8DAE-7D8A7AF94C8A}"/>
+                <a16:creationId xmlns:a16="http://schemas.microsoft.com/office/drawing/2014/main" id="{920E0CEB-07BA-422B-8B7D-F88DE4C003BD}"/>
               </a:ext>
             </a:extLst>
           </p:cNvPr>
@@ -6889,7 +6935,7 @@
           <p:cNvPr id="9" name="">
             <a:extLst xmlns:a="http://schemas.openxmlformats.org/drawingml/2006/main">
               <a:ext uri="{FF2B5EF4-FFF2-40B4-BE49-F238E27FC236}">
-                <a16:creationId xmlns:a16="http://schemas.microsoft.com/office/drawing/2014/main" id="{C0603297-B752-485F-90CB-BB88AC112611}"/>
+                <a16:creationId xmlns:a16="http://schemas.microsoft.com/office/drawing/2014/main" id="{01E02A8E-492A-4BCE-BA17-542988BCD3DB}"/>
               </a:ext>
             </a:extLst>
           </p:cNvPr>
@@ -6956,7 +7002,7 @@
           <p:cNvPr id="10" name="">
             <a:extLst xmlns:a="http://schemas.openxmlformats.org/drawingml/2006/main">
               <a:ext uri="{FF2B5EF4-FFF2-40B4-BE49-F238E27FC236}">
-                <a16:creationId xmlns:a16="http://schemas.microsoft.com/office/drawing/2014/main" id="{DA063C64-75ED-408F-9AFB-6EBC2BEC1F16}"/>
+                <a16:creationId xmlns:a16="http://schemas.microsoft.com/office/drawing/2014/main" id="{5CA00588-2402-4947-8055-704D0323E7F8}"/>
               </a:ext>
             </a:extLst>
           </p:cNvPr>
@@ -6991,7 +7037,7 @@
           <p:cNvPr id="11" name="">
             <a:extLst xmlns:a="http://schemas.openxmlformats.org/drawingml/2006/main">
               <a:ext uri="{FF2B5EF4-FFF2-40B4-BE49-F238E27FC236}">
-                <a16:creationId xmlns:a16="http://schemas.microsoft.com/office/drawing/2014/main" id="{9C0F3AE0-7A00-4069-A3BE-172B5D9C6F4E}"/>
+                <a16:creationId xmlns:a16="http://schemas.microsoft.com/office/drawing/2014/main" id="{84E317DF-D60F-41FE-BF58-C9C4D31609BF}"/>
               </a:ext>
             </a:extLst>
           </p:cNvPr>
@@ -7058,7 +7104,7 @@
           <p:cNvPr id="12" name="">
             <a:extLst xmlns:a="http://schemas.openxmlformats.org/drawingml/2006/main">
               <a:ext uri="{FF2B5EF4-FFF2-40B4-BE49-F238E27FC236}">
-                <a16:creationId xmlns:a16="http://schemas.microsoft.com/office/drawing/2014/main" id="{71A2F74A-2D27-435B-8297-223C47D35E39}"/>
+                <a16:creationId xmlns:a16="http://schemas.microsoft.com/office/drawing/2014/main" id="{FEF22933-43F6-49B1-B321-7874398086D8}"/>
               </a:ext>
             </a:extLst>
           </p:cNvPr>
@@ -7125,7 +7171,7 @@
           <p:cNvPr id="13" name="">
             <a:extLst xmlns:a="http://schemas.openxmlformats.org/drawingml/2006/main">
               <a:ext uri="{FF2B5EF4-FFF2-40B4-BE49-F238E27FC236}">
-                <a16:creationId xmlns:a16="http://schemas.microsoft.com/office/drawing/2014/main" id="{572653D3-B743-44FF-A0BD-B43DE6F9AEFB}"/>
+                <a16:creationId xmlns:a16="http://schemas.microsoft.com/office/drawing/2014/main" id="{D73B2AE0-4DC8-4AD0-B281-917415B17632}"/>
               </a:ext>
             </a:extLst>
           </p:cNvPr>
@@ -7160,7 +7206,7 @@
           <p:cNvPr id="14" name="">
             <a:extLst xmlns:a="http://schemas.openxmlformats.org/drawingml/2006/main">
               <a:ext uri="{FF2B5EF4-FFF2-40B4-BE49-F238E27FC236}">
-                <a16:creationId xmlns:a16="http://schemas.microsoft.com/office/drawing/2014/main" id="{9363F326-998C-44E8-B0A7-A79E2E74E997}"/>
+                <a16:creationId xmlns:a16="http://schemas.microsoft.com/office/drawing/2014/main" id="{0E11E542-38B2-4A9F-AEEB-9745596AB09D}"/>
               </a:ext>
             </a:extLst>
           </p:cNvPr>
@@ -7227,7 +7273,7 @@
           <p:cNvPr id="15" name="">
             <a:extLst xmlns:a="http://schemas.openxmlformats.org/drawingml/2006/main">
               <a:ext uri="{FF2B5EF4-FFF2-40B4-BE49-F238E27FC236}">
-                <a16:creationId xmlns:a16="http://schemas.microsoft.com/office/drawing/2014/main" id="{61104B42-1B1A-4C14-9160-BA138E973F51}"/>
+                <a16:creationId xmlns:a16="http://schemas.microsoft.com/office/drawing/2014/main" id="{08333AD0-92AF-4636-9041-FAB7DED5EB4B}"/>
               </a:ext>
             </a:extLst>
           </p:cNvPr>
@@ -7294,7 +7340,7 @@
           <p:cNvPr id="16" name="">
             <a:extLst xmlns:a="http://schemas.openxmlformats.org/drawingml/2006/main">
               <a:ext uri="{FF2B5EF4-FFF2-40B4-BE49-F238E27FC236}">
-                <a16:creationId xmlns:a16="http://schemas.microsoft.com/office/drawing/2014/main" id="{6B991919-8717-424F-BBDF-71BDEEED5E42}"/>
+                <a16:creationId xmlns:a16="http://schemas.microsoft.com/office/drawing/2014/main" id="{8BCF565D-2DEB-4CC9-BFE9-0FD18B17FB5B}"/>
               </a:ext>
             </a:extLst>
           </p:cNvPr>
@@ -7329,7 +7375,7 @@
           <p:cNvPr id="17" name="">
             <a:extLst xmlns:a="http://schemas.openxmlformats.org/drawingml/2006/main">
               <a:ext uri="{FF2B5EF4-FFF2-40B4-BE49-F238E27FC236}">
-                <a16:creationId xmlns:a16="http://schemas.microsoft.com/office/drawing/2014/main" id="{B28D288B-3EA6-461E-8E87-B9C9BA07EC7F}"/>
+                <a16:creationId xmlns:a16="http://schemas.microsoft.com/office/drawing/2014/main" id="{CBBDAD4F-D860-4201-AE7F-6DF719CA6D22}"/>
               </a:ext>
             </a:extLst>
           </p:cNvPr>
@@ -7396,7 +7442,7 @@
           <p:cNvPr id="18" name="">
             <a:extLst xmlns:a="http://schemas.openxmlformats.org/drawingml/2006/main">
               <a:ext uri="{FF2B5EF4-FFF2-40B4-BE49-F238E27FC236}">
-                <a16:creationId xmlns:a16="http://schemas.microsoft.com/office/drawing/2014/main" id="{1A5893E9-89A2-4733-8850-E88BAFA63F1E}"/>
+                <a16:creationId xmlns:a16="http://schemas.microsoft.com/office/drawing/2014/main" id="{3FFDAB10-E5B4-4345-B951-86D8D1E215CC}"/>
               </a:ext>
             </a:extLst>
           </p:cNvPr>
@@ -7463,7 +7509,7 @@
           <p:cNvPr id="19" name="">
             <a:extLst xmlns:a="http://schemas.openxmlformats.org/drawingml/2006/main">
               <a:ext uri="{FF2B5EF4-FFF2-40B4-BE49-F238E27FC236}">
-                <a16:creationId xmlns:a16="http://schemas.microsoft.com/office/drawing/2014/main" id="{F838BEF1-A53F-4B5A-99AE-03AD2F6505DE}"/>
+                <a16:creationId xmlns:a16="http://schemas.microsoft.com/office/drawing/2014/main" id="{C2C8716D-8506-4A3F-962F-446B889CD1F1}"/>
               </a:ext>
             </a:extLst>
           </p:cNvPr>
@@ -7498,7 +7544,7 @@
           <p:cNvPr id="20" name="">
             <a:extLst xmlns:a="http://schemas.openxmlformats.org/drawingml/2006/main">
               <a:ext uri="{FF2B5EF4-FFF2-40B4-BE49-F238E27FC236}">
-                <a16:creationId xmlns:a16="http://schemas.microsoft.com/office/drawing/2014/main" id="{9107252D-E741-4DA1-87EE-3F0CAEE9E902}"/>
+                <a16:creationId xmlns:a16="http://schemas.microsoft.com/office/drawing/2014/main" id="{B7BD98E0-D516-4EC9-8FC5-66436298FD30}"/>
               </a:ext>
             </a:extLst>
           </p:cNvPr>
@@ -7565,7 +7611,7 @@
           <p:cNvPr id="21" name="">
             <a:extLst xmlns:a="http://schemas.openxmlformats.org/drawingml/2006/main">
               <a:ext uri="{FF2B5EF4-FFF2-40B4-BE49-F238E27FC236}">
-                <a16:creationId xmlns:a16="http://schemas.microsoft.com/office/drawing/2014/main" id="{4B2EC63A-053B-42C1-BED2-028349A3B77A}"/>
+                <a16:creationId xmlns:a16="http://schemas.microsoft.com/office/drawing/2014/main" id="{4D9AFF85-92FF-4A81-A606-055607476E78}"/>
               </a:ext>
             </a:extLst>
           </p:cNvPr>
@@ -7632,7 +7678,7 @@
           <p:cNvPr id="22" name="">
             <a:extLst xmlns:a="http://schemas.openxmlformats.org/drawingml/2006/main">
               <a:ext uri="{FF2B5EF4-FFF2-40B4-BE49-F238E27FC236}">
-                <a16:creationId xmlns:a16="http://schemas.microsoft.com/office/drawing/2014/main" id="{90B4F15D-4D05-47FB-87E8-BCDDF477322E}"/>
+                <a16:creationId xmlns:a16="http://schemas.microsoft.com/office/drawing/2014/main" id="{631F37D9-E106-4BB8-B29A-C11C72E17102}"/>
               </a:ext>
             </a:extLst>
           </p:cNvPr>
@@ -7667,7 +7713,7 @@
           <p:cNvPr id="23" name="">
             <a:extLst xmlns:a="http://schemas.openxmlformats.org/drawingml/2006/main">
               <a:ext uri="{FF2B5EF4-FFF2-40B4-BE49-F238E27FC236}">
-                <a16:creationId xmlns:a16="http://schemas.microsoft.com/office/drawing/2014/main" id="{6E7DC104-476F-44E9-BE2E-A8860452B915}"/>
+                <a16:creationId xmlns:a16="http://schemas.microsoft.com/office/drawing/2014/main" id="{3CF80D2D-181D-4A5B-BBDD-059F67D9084E}"/>
               </a:ext>
             </a:extLst>
           </p:cNvPr>
@@ -7734,7 +7780,7 @@
           <p:cNvPr id="24" name="">
             <a:extLst xmlns:a="http://schemas.openxmlformats.org/drawingml/2006/main">
               <a:ext uri="{FF2B5EF4-FFF2-40B4-BE49-F238E27FC236}">
-                <a16:creationId xmlns:a16="http://schemas.microsoft.com/office/drawing/2014/main" id="{837E3CD8-6D83-48DE-A241-5E2837384C78}"/>
+                <a16:creationId xmlns:a16="http://schemas.microsoft.com/office/drawing/2014/main" id="{2E635787-A3BF-465D-B5DC-8585236B5811}"/>
               </a:ext>
             </a:extLst>
           </p:cNvPr>
@@ -7799,7 +7845,7 @@
     </p:spTree>
     <p:extLst>
       <p:ext uri="{BB962C8B-B14F-4D97-AF65-F5344CB8AC3E}">
-        <p14:creationId xmlns:p14="http://schemas.microsoft.com/office/powerpoint/2010/main" val="601660768"/>
+        <p14:creationId xmlns:p14="http://schemas.microsoft.com/office/powerpoint/2010/main" val="190748883"/>
       </p:ext>
     </p:extLst>
   </p:cSld>
@@ -7830,7 +7876,7 @@
           <p:cNvPr id="26" name="">
             <a:extLst xmlns:a="http://schemas.openxmlformats.org/drawingml/2006/main">
               <a:ext uri="{FF2B5EF4-FFF2-40B4-BE49-F238E27FC236}">
-                <a16:creationId xmlns:a16="http://schemas.microsoft.com/office/drawing/2014/main" id="{3D39D049-4EFC-4179-9A90-E3F8A161F46C}"/>
+                <a16:creationId xmlns:a16="http://schemas.microsoft.com/office/drawing/2014/main" id="{0B95BB39-1884-429B-8A31-1CFB9F2AF094}"/>
               </a:ext>
             </a:extLst>
           </p:cNvPr>
@@ -7861,7 +7907,7 @@
           <p:cNvPr id="2" name="">
             <a:extLst xmlns:a="http://schemas.openxmlformats.org/drawingml/2006/main">
               <a:ext uri="{FF2B5EF4-FFF2-40B4-BE49-F238E27FC236}">
-                <a16:creationId xmlns:a16="http://schemas.microsoft.com/office/drawing/2014/main" id="{346C26C5-FAFA-4855-8C03-8D361F20A878}"/>
+                <a16:creationId xmlns:a16="http://schemas.microsoft.com/office/drawing/2014/main" id="{624630E9-648C-4E01-8AC8-FF0E71524F37}"/>
               </a:ext>
             </a:extLst>
           </p:cNvPr>
@@ -7928,7 +7974,7 @@
           <p:cNvPr id="3" name="">
             <a:extLst xmlns:a="http://schemas.openxmlformats.org/drawingml/2006/main">
               <a:ext uri="{FF2B5EF4-FFF2-40B4-BE49-F238E27FC236}">
-                <a16:creationId xmlns:a16="http://schemas.microsoft.com/office/drawing/2014/main" id="{035601E4-D1C5-4EAC-B0A8-56022E7447FE}"/>
+                <a16:creationId xmlns:a16="http://schemas.microsoft.com/office/drawing/2014/main" id="{8D1D6505-D359-4EFE-875C-13B62274CE28}"/>
               </a:ext>
             </a:extLst>
           </p:cNvPr>
@@ -7995,7 +8041,7 @@
           <p:cNvPr id="4" name="">
             <a:extLst xmlns:a="http://schemas.openxmlformats.org/drawingml/2006/main">
               <a:ext uri="{FF2B5EF4-FFF2-40B4-BE49-F238E27FC236}">
-                <a16:creationId xmlns:a16="http://schemas.microsoft.com/office/drawing/2014/main" id="{453F64EA-2B4C-4370-818F-FFF6B674F729}"/>
+                <a16:creationId xmlns:a16="http://schemas.microsoft.com/office/drawing/2014/main" id="{5551F1E9-D769-406B-A567-7B88E6EE7F9C}"/>
               </a:ext>
             </a:extLst>
           </p:cNvPr>
@@ -8026,7 +8072,7 @@
           <p:cNvPr id="5" name="">
             <a:extLst xmlns:a="http://schemas.openxmlformats.org/drawingml/2006/main">
               <a:ext uri="{FF2B5EF4-FFF2-40B4-BE49-F238E27FC236}">
-                <a16:creationId xmlns:a16="http://schemas.microsoft.com/office/drawing/2014/main" id="{6BDF1322-8F30-4FA6-A18B-B5C4A605DDF1}"/>
+                <a16:creationId xmlns:a16="http://schemas.microsoft.com/office/drawing/2014/main" id="{C7C81379-404D-4284-93E8-A7FCC898A55A}"/>
               </a:ext>
             </a:extLst>
           </p:cNvPr>
@@ -8093,7 +8139,7 @@
           <p:cNvPr id="6" name="">
             <a:extLst xmlns:a="http://schemas.openxmlformats.org/drawingml/2006/main">
               <a:ext uri="{FF2B5EF4-FFF2-40B4-BE49-F238E27FC236}">
-                <a16:creationId xmlns:a16="http://schemas.microsoft.com/office/drawing/2014/main" id="{EEF88410-925A-400A-9F1D-ED5F05FD607E}"/>
+                <a16:creationId xmlns:a16="http://schemas.microsoft.com/office/drawing/2014/main" id="{A14102FC-608C-4CBA-968C-D5157FABD1E7}"/>
               </a:ext>
             </a:extLst>
           </p:cNvPr>
@@ -8160,7 +8206,7 @@
           <p:cNvPr id="7" name="">
             <a:extLst xmlns:a="http://schemas.openxmlformats.org/drawingml/2006/main">
               <a:ext uri="{FF2B5EF4-FFF2-40B4-BE49-F238E27FC236}">
-                <a16:creationId xmlns:a16="http://schemas.microsoft.com/office/drawing/2014/main" id="{688BC458-004C-4E1D-AA82-F393EF26072A}"/>
+                <a16:creationId xmlns:a16="http://schemas.microsoft.com/office/drawing/2014/main" id="{D3437BD2-D61A-4B85-9CBD-6A898837D981}"/>
               </a:ext>
             </a:extLst>
           </p:cNvPr>
@@ -8195,7 +8241,7 @@
           <p:cNvPr id="8" name="">
             <a:extLst xmlns:a="http://schemas.openxmlformats.org/drawingml/2006/main">
               <a:ext uri="{FF2B5EF4-FFF2-40B4-BE49-F238E27FC236}">
-                <a16:creationId xmlns:a16="http://schemas.microsoft.com/office/drawing/2014/main" id="{38C4EC90-F385-4973-B4A1-1C74C42109ED}"/>
+                <a16:creationId xmlns:a16="http://schemas.microsoft.com/office/drawing/2014/main" id="{39634186-D4EE-4025-831A-909C1C9A99D6}"/>
               </a:ext>
             </a:extLst>
           </p:cNvPr>
@@ -8262,7 +8308,7 @@
           <p:cNvPr id="9" name="">
             <a:extLst xmlns:a="http://schemas.openxmlformats.org/drawingml/2006/main">
               <a:ext uri="{FF2B5EF4-FFF2-40B4-BE49-F238E27FC236}">
-                <a16:creationId xmlns:a16="http://schemas.microsoft.com/office/drawing/2014/main" id="{461F62BF-9234-4543-A353-EBAADF5C6FAF}"/>
+                <a16:creationId xmlns:a16="http://schemas.microsoft.com/office/drawing/2014/main" id="{18CF5FE0-2FD8-4378-9D30-0D3FC23E5AB9}"/>
               </a:ext>
             </a:extLst>
           </p:cNvPr>
@@ -8329,7 +8375,7 @@
           <p:cNvPr id="10" name="">
             <a:extLst xmlns:a="http://schemas.openxmlformats.org/drawingml/2006/main">
               <a:ext uri="{FF2B5EF4-FFF2-40B4-BE49-F238E27FC236}">
-                <a16:creationId xmlns:a16="http://schemas.microsoft.com/office/drawing/2014/main" id="{C95D9328-9123-4D0C-8532-4EDF6ECB35E4}"/>
+                <a16:creationId xmlns:a16="http://schemas.microsoft.com/office/drawing/2014/main" id="{8033F6F6-DAB1-4A7D-A2B0-A1C83E4E8CE2}"/>
               </a:ext>
             </a:extLst>
           </p:cNvPr>
@@ -8364,7 +8410,7 @@
           <p:cNvPr id="11" name="">
             <a:extLst xmlns:a="http://schemas.openxmlformats.org/drawingml/2006/main">
               <a:ext uri="{FF2B5EF4-FFF2-40B4-BE49-F238E27FC236}">
-                <a16:creationId xmlns:a16="http://schemas.microsoft.com/office/drawing/2014/main" id="{D245866B-B71A-4948-B9C6-DA74E5A4619E}"/>
+                <a16:creationId xmlns:a16="http://schemas.microsoft.com/office/drawing/2014/main" id="{354F0888-E7EB-487B-9418-8AC93C516290}"/>
               </a:ext>
             </a:extLst>
           </p:cNvPr>
@@ -8421,7 +8467,7 @@
                 <a:ea typeface="Aptos"/>
                 <a:cs typeface="Aptos"/>
               </a:rPr>
-              <a:t>30</a:t>
+              <a:t>60</a:t>
             </a:r>
           </a:p>
         </p:txBody>
@@ -8431,7 +8477,7 @@
           <p:cNvPr id="12" name="">
             <a:extLst xmlns:a="http://schemas.openxmlformats.org/drawingml/2006/main">
               <a:ext uri="{FF2B5EF4-FFF2-40B4-BE49-F238E27FC236}">
-                <a16:creationId xmlns:a16="http://schemas.microsoft.com/office/drawing/2014/main" id="{0A67D208-1342-41FD-A1D7-367A58162BF7}"/>
+                <a16:creationId xmlns:a16="http://schemas.microsoft.com/office/drawing/2014/main" id="{D2372BA0-68B8-47B3-944C-754F9AC64BF0}"/>
               </a:ext>
             </a:extLst>
           </p:cNvPr>
@@ -8498,7 +8544,7 @@
           <p:cNvPr id="13" name="">
             <a:extLst xmlns:a="http://schemas.openxmlformats.org/drawingml/2006/main">
               <a:ext uri="{FF2B5EF4-FFF2-40B4-BE49-F238E27FC236}">
-                <a16:creationId xmlns:a16="http://schemas.microsoft.com/office/drawing/2014/main" id="{842EFDAB-4831-411A-BD2E-C5E42E4CC177}"/>
+                <a16:creationId xmlns:a16="http://schemas.microsoft.com/office/drawing/2014/main" id="{C008FFB6-0628-44CE-8FBC-9984A796AD90}"/>
               </a:ext>
             </a:extLst>
           </p:cNvPr>
@@ -8533,7 +8579,7 @@
           <p:cNvPr id="14" name="">
             <a:extLst xmlns:a="http://schemas.openxmlformats.org/drawingml/2006/main">
               <a:ext uri="{FF2B5EF4-FFF2-40B4-BE49-F238E27FC236}">
-                <a16:creationId xmlns:a16="http://schemas.microsoft.com/office/drawing/2014/main" id="{5C68AE0E-F10C-4CCA-B972-4690D90613FE}"/>
+                <a16:creationId xmlns:a16="http://schemas.microsoft.com/office/drawing/2014/main" id="{DC624486-35E2-4FB8-9F57-3AC9F6D87FA7}"/>
               </a:ext>
             </a:extLst>
           </p:cNvPr>
@@ -8590,7 +8636,7 @@
                 <a:ea typeface="Aptos"/>
                 <a:cs typeface="Aptos"/>
               </a:rPr>
-              <a:t>30</a:t>
+              <a:t>100</a:t>
             </a:r>
           </a:p>
         </p:txBody>
@@ -8600,7 +8646,7 @@
           <p:cNvPr id="15" name="">
             <a:extLst xmlns:a="http://schemas.openxmlformats.org/drawingml/2006/main">
               <a:ext uri="{FF2B5EF4-FFF2-40B4-BE49-F238E27FC236}">
-                <a16:creationId xmlns:a16="http://schemas.microsoft.com/office/drawing/2014/main" id="{8CDB9251-73B3-4D53-A56E-8E9E9520EACD}"/>
+                <a16:creationId xmlns:a16="http://schemas.microsoft.com/office/drawing/2014/main" id="{322709C3-5079-4A54-9CA1-FA03F55D353D}"/>
               </a:ext>
             </a:extLst>
           </p:cNvPr>
@@ -8667,7 +8713,7 @@
           <p:cNvPr id="16" name="">
             <a:extLst xmlns:a="http://schemas.openxmlformats.org/drawingml/2006/main">
               <a:ext uri="{FF2B5EF4-FFF2-40B4-BE49-F238E27FC236}">
-                <a16:creationId xmlns:a16="http://schemas.microsoft.com/office/drawing/2014/main" id="{76C86EC0-E097-44CF-806D-B793377567E9}"/>
+                <a16:creationId xmlns:a16="http://schemas.microsoft.com/office/drawing/2014/main" id="{3C3EC312-0557-4FEB-9396-BD3CC80DB243}"/>
               </a:ext>
             </a:extLst>
           </p:cNvPr>
@@ -8702,7 +8748,7 @@
           <p:cNvPr id="17" name="">
             <a:extLst xmlns:a="http://schemas.openxmlformats.org/drawingml/2006/main">
               <a:ext uri="{FF2B5EF4-FFF2-40B4-BE49-F238E27FC236}">
-                <a16:creationId xmlns:a16="http://schemas.microsoft.com/office/drawing/2014/main" id="{C1AAE5AD-2B4B-4B6C-B12C-181360CD1BCA}"/>
+                <a16:creationId xmlns:a16="http://schemas.microsoft.com/office/drawing/2014/main" id="{0A36037C-B20D-4E28-BC78-D788D5B5A8D4}"/>
               </a:ext>
             </a:extLst>
           </p:cNvPr>
@@ -8759,7 +8805,7 @@
                 <a:ea typeface="Aptos"/>
                 <a:cs typeface="Aptos"/>
               </a:rPr>
-              <a:t>20</a:t>
+              <a:t>25</a:t>
             </a:r>
           </a:p>
         </p:txBody>
@@ -8769,7 +8815,7 @@
           <p:cNvPr id="18" name="">
             <a:extLst xmlns:a="http://schemas.openxmlformats.org/drawingml/2006/main">
               <a:ext uri="{FF2B5EF4-FFF2-40B4-BE49-F238E27FC236}">
-                <a16:creationId xmlns:a16="http://schemas.microsoft.com/office/drawing/2014/main" id="{33B4E2C5-6194-4262-B216-880A54663289}"/>
+                <a16:creationId xmlns:a16="http://schemas.microsoft.com/office/drawing/2014/main" id="{83CECBF4-3F27-498E-90F1-DAC7B8219621}"/>
               </a:ext>
             </a:extLst>
           </p:cNvPr>
@@ -8836,7 +8882,7 @@
           <p:cNvPr id="19" name="">
             <a:extLst xmlns:a="http://schemas.openxmlformats.org/drawingml/2006/main">
               <a:ext uri="{FF2B5EF4-FFF2-40B4-BE49-F238E27FC236}">
-                <a16:creationId xmlns:a16="http://schemas.microsoft.com/office/drawing/2014/main" id="{30D5F990-6273-418A-8072-D1291814B047}"/>
+                <a16:creationId xmlns:a16="http://schemas.microsoft.com/office/drawing/2014/main" id="{7DAC4A7D-2382-44BA-8166-FEBCF44445B1}"/>
               </a:ext>
             </a:extLst>
           </p:cNvPr>
@@ -8903,7 +8949,7 @@
           <p:cNvPr id="20" name="">
             <a:extLst xmlns:a="http://schemas.openxmlformats.org/drawingml/2006/main">
               <a:ext uri="{FF2B5EF4-FFF2-40B4-BE49-F238E27FC236}">
-                <a16:creationId xmlns:a16="http://schemas.microsoft.com/office/drawing/2014/main" id="{53092BE5-3CFB-4776-B4A6-24E22756EB38}"/>
+                <a16:creationId xmlns:a16="http://schemas.microsoft.com/office/drawing/2014/main" id="{2283EDB2-4462-45C3-A257-CDA364DE9B84}"/>
               </a:ext>
             </a:extLst>
           </p:cNvPr>
@@ -8960,7 +9006,7 @@
                 <a:ea typeface="Aptos"/>
                 <a:cs typeface="Aptos"/>
               </a:rPr>
-              <a:t>30 borrowing records  •  20 active loans  •  most borrowed book count: 1</a:t>
+              <a:t>100 borrowing records  •  25 active loans  •  Python Crash Course: 14 loans</a:t>
             </a:r>
           </a:p>
         </p:txBody>
@@ -8970,7 +9016,7 @@
           <p:cNvPr id="21" name="">
             <a:extLst xmlns:a="http://schemas.openxmlformats.org/drawingml/2006/main">
               <a:ext uri="{FF2B5EF4-FFF2-40B4-BE49-F238E27FC236}">
-                <a16:creationId xmlns:a16="http://schemas.microsoft.com/office/drawing/2014/main" id="{B79B6474-C48B-4170-9D85-C32374DEB559}"/>
+                <a16:creationId xmlns:a16="http://schemas.microsoft.com/office/drawing/2014/main" id="{6ABD9813-3C93-4348-89BE-9BE7D4C6FF30}"/>
               </a:ext>
             </a:extLst>
           </p:cNvPr>
@@ -9037,7 +9083,7 @@
           <p:cNvPr id="22" name="">
             <a:extLst xmlns:a="http://schemas.openxmlformats.org/drawingml/2006/main">
               <a:ext uri="{FF2B5EF4-FFF2-40B4-BE49-F238E27FC236}">
-                <a16:creationId xmlns:a16="http://schemas.microsoft.com/office/drawing/2014/main" id="{A0B849EA-259F-4C29-8236-42610A321248}"/>
+                <a16:creationId xmlns:a16="http://schemas.microsoft.com/office/drawing/2014/main" id="{E84654EE-8637-4246-879E-61DA8F1B3A22}"/>
               </a:ext>
             </a:extLst>
           </p:cNvPr>
@@ -9104,7 +9150,7 @@
           <p:cNvPr id="23" name="">
             <a:extLst xmlns:a="http://schemas.openxmlformats.org/drawingml/2006/main">
               <a:ext uri="{FF2B5EF4-FFF2-40B4-BE49-F238E27FC236}">
-                <a16:creationId xmlns:a16="http://schemas.microsoft.com/office/drawing/2014/main" id="{383EC7D0-1D71-4D86-BD51-D3529311A420}"/>
+                <a16:creationId xmlns:a16="http://schemas.microsoft.com/office/drawing/2014/main" id="{353B4729-CE73-422E-8047-B41D97A6D462}"/>
               </a:ext>
             </a:extLst>
           </p:cNvPr>
@@ -9171,7 +9217,7 @@
           <p:cNvPr id="24" name="">
             <a:extLst xmlns:a="http://schemas.openxmlformats.org/drawingml/2006/main">
               <a:ext uri="{FF2B5EF4-FFF2-40B4-BE49-F238E27FC236}">
-                <a16:creationId xmlns:a16="http://schemas.microsoft.com/office/drawing/2014/main" id="{16CA556F-91A3-40DF-9C42-E378B6D0A561}"/>
+                <a16:creationId xmlns:a16="http://schemas.microsoft.com/office/drawing/2014/main" id="{4718239F-6EC8-424B-BCD4-3CBF01F49297}"/>
               </a:ext>
             </a:extLst>
           </p:cNvPr>
@@ -9238,7 +9284,7 @@
           <p:cNvPr id="25" name="">
             <a:extLst xmlns:a="http://schemas.openxmlformats.org/drawingml/2006/main">
               <a:ext uri="{FF2B5EF4-FFF2-40B4-BE49-F238E27FC236}">
-                <a16:creationId xmlns:a16="http://schemas.microsoft.com/office/drawing/2014/main" id="{0AA9F0FC-2359-424A-BE0F-FF948B67F67F}"/>
+                <a16:creationId xmlns:a16="http://schemas.microsoft.com/office/drawing/2014/main" id="{6CA7CE5D-1ECE-425B-BF90-C6A48F7C6BE1}"/>
               </a:ext>
             </a:extLst>
           </p:cNvPr>
@@ -9303,7 +9349,7 @@
     </p:spTree>
     <p:extLst>
       <p:ext uri="{BB962C8B-B14F-4D97-AF65-F5344CB8AC3E}">
-        <p14:creationId xmlns:p14="http://schemas.microsoft.com/office/powerpoint/2010/main" val="391687902"/>
+        <p14:creationId xmlns:p14="http://schemas.microsoft.com/office/powerpoint/2010/main" val="234711161"/>
       </p:ext>
     </p:extLst>
   </p:cSld>

</xml_diff>

<commit_message>
Simplify library app to lecture topics
</commit_message>
<xml_diff>
--- a/ProjectPresentation.pptx
+++ b/ProjectPresentation.pptx
@@ -2,17 +2,17 @@
 <file path=ppt/presentation.xml><?xml version="1.0" encoding="utf-8"?>
 <p:presentation xmlns:p="http://schemas.openxmlformats.org/presentationml/2006/main">
   <p:sldMasterIdLst>
-    <p:sldMasterId xmlns:r="http://schemas.openxmlformats.org/officeDocument/2006/relationships" id="2147483648" r:id="Rce279dc9bbb74fca"/>
+    <p:sldMasterId xmlns:r="http://schemas.openxmlformats.org/officeDocument/2006/relationships" id="2147483648" r:id="Rec50b91c985b44b1"/>
   </p:sldMasterIdLst>
   <p:notesMasterIdLst>
-    <p:notesMasterId xmlns:r="http://schemas.openxmlformats.org/officeDocument/2006/relationships" r:id="R5174cae511184519"/>
+    <p:notesMasterId xmlns:r="http://schemas.openxmlformats.org/officeDocument/2006/relationships" r:id="R2928b74f5dfe44a8"/>
   </p:notesMasterIdLst>
   <p:sldIdLst>
-    <p:sldId xmlns:r="http://schemas.openxmlformats.org/officeDocument/2006/relationships" id="256" r:id="R30a17699a4bf4e2c"/>
-    <p:sldId xmlns:r="http://schemas.openxmlformats.org/officeDocument/2006/relationships" id="257" r:id="R457d6575bfa649df"/>
-    <p:sldId xmlns:r="http://schemas.openxmlformats.org/officeDocument/2006/relationships" id="258" r:id="R230d3472cae74759"/>
-    <p:sldId xmlns:r="http://schemas.openxmlformats.org/officeDocument/2006/relationships" id="259" r:id="R369b96a6899d4877"/>
-    <p:sldId xmlns:r="http://schemas.openxmlformats.org/officeDocument/2006/relationships" id="260" r:id="Rd74d799672694d4c"/>
+    <p:sldId xmlns:r="http://schemas.openxmlformats.org/officeDocument/2006/relationships" id="256" r:id="Rd9f3850555a240d6"/>
+    <p:sldId xmlns:r="http://schemas.openxmlformats.org/officeDocument/2006/relationships" id="257" r:id="Re21e4060bd9c4d6b"/>
+    <p:sldId xmlns:r="http://schemas.openxmlformats.org/officeDocument/2006/relationships" id="258" r:id="Raf0e610d2c094e82"/>
+    <p:sldId xmlns:r="http://schemas.openxmlformats.org/officeDocument/2006/relationships" id="259" r:id="Rab44a220c1d0415f"/>
+    <p:sldId xmlns:r="http://schemas.openxmlformats.org/officeDocument/2006/relationships" id="260" r:id="Rc7f86803b70546d1"/>
   </p:sldIdLst>
   <p:sldSz cx="12192000" cy="6858000"/>
   <p:notesSz cx="6858000" cy="9144000"/>
@@ -753,7 +753,7 @@
           <p:cNvPr id="3" name="Title">
             <a:extLst xmlns:a="http://schemas.openxmlformats.org/drawingml/2006/main">
               <a:ext uri="{FF2B5EF4-FFF2-40B4-BE49-F238E27FC236}">
-                <a16:creationId xmlns:a16="http://schemas.microsoft.com/office/drawing/2014/main" id="{A58F1E79-5EE8-45F7-B6DC-BAE875180D50}"/>
+                <a16:creationId xmlns:a16="http://schemas.microsoft.com/office/drawing/2014/main" id="{93B8D12C-04CC-443C-991E-6A5FE3EE8672}"/>
               </a:ext>
             </a:extLst>
           </p:cNvPr>
@@ -910,7 +910,7 @@
           <p:cNvPr id="2" name="Subtitle">
             <a:extLst xmlns:a="http://schemas.openxmlformats.org/drawingml/2006/main">
               <a:ext uri="{FF2B5EF4-FFF2-40B4-BE49-F238E27FC236}">
-                <a16:creationId xmlns:a16="http://schemas.microsoft.com/office/drawing/2014/main" id="{ACBC1AAF-BADE-48AA-A994-2980EAE8B2F7}"/>
+                <a16:creationId xmlns:a16="http://schemas.microsoft.com/office/drawing/2014/main" id="{232DB7AD-3160-41FC-BDBC-981B009B8C4D}"/>
               </a:ext>
             </a:extLst>
           </p:cNvPr>
@@ -1084,7 +1084,7 @@
           <p:cNvPr id="2" name="Section title">
             <a:extLst xmlns:a="http://schemas.openxmlformats.org/drawingml/2006/main">
               <a:ext uri="{FF2B5EF4-FFF2-40B4-BE49-F238E27FC236}">
-                <a16:creationId xmlns:a16="http://schemas.microsoft.com/office/drawing/2014/main" id="{5F1B5027-64F4-46A0-8124-F45EC485EBCF}"/>
+                <a16:creationId xmlns:a16="http://schemas.microsoft.com/office/drawing/2014/main" id="{F6BA8921-33EC-4D14-82EF-8B90ADD67B6B}"/>
               </a:ext>
             </a:extLst>
           </p:cNvPr>
@@ -1258,7 +1258,7 @@
           <p:cNvPr id="3" name="Title">
             <a:extLst xmlns:a="http://schemas.openxmlformats.org/drawingml/2006/main">
               <a:ext uri="{FF2B5EF4-FFF2-40B4-BE49-F238E27FC236}">
-                <a16:creationId xmlns:a16="http://schemas.microsoft.com/office/drawing/2014/main" id="{64AD4A9B-6538-40A4-B8D2-4A56F675DB4F}"/>
+                <a16:creationId xmlns:a16="http://schemas.microsoft.com/office/drawing/2014/main" id="{45556E14-4680-47D3-8E66-F55C00DFCD05}"/>
               </a:ext>
             </a:extLst>
           </p:cNvPr>
@@ -1415,7 +1415,7 @@
           <p:cNvPr id="2" name="Body">
             <a:extLst xmlns:a="http://schemas.openxmlformats.org/drawingml/2006/main">
               <a:ext uri="{FF2B5EF4-FFF2-40B4-BE49-F238E27FC236}">
-                <a16:creationId xmlns:a16="http://schemas.microsoft.com/office/drawing/2014/main" id="{1A94D85A-7899-47A6-9200-D36DE7539F85}"/>
+                <a16:creationId xmlns:a16="http://schemas.microsoft.com/office/drawing/2014/main" id="{F0941556-1477-4D93-A62E-6A872608674E}"/>
               </a:ext>
             </a:extLst>
           </p:cNvPr>
@@ -1589,7 +1589,7 @@
           <p:cNvPr id="4" name="Title">
             <a:extLst xmlns:a="http://schemas.openxmlformats.org/drawingml/2006/main">
               <a:ext uri="{FF2B5EF4-FFF2-40B4-BE49-F238E27FC236}">
-                <a16:creationId xmlns:a16="http://schemas.microsoft.com/office/drawing/2014/main" id="{83760F92-8774-421A-B838-C5A6D3A1E0B9}"/>
+                <a16:creationId xmlns:a16="http://schemas.microsoft.com/office/drawing/2014/main" id="{0F2896AC-52FC-426A-8B32-CD05EE156BD6}"/>
               </a:ext>
             </a:extLst>
           </p:cNvPr>
@@ -1746,7 +1746,7 @@
           <p:cNvPr id="2" name="Left column">
             <a:extLst xmlns:a="http://schemas.openxmlformats.org/drawingml/2006/main">
               <a:ext uri="{FF2B5EF4-FFF2-40B4-BE49-F238E27FC236}">
-                <a16:creationId xmlns:a16="http://schemas.microsoft.com/office/drawing/2014/main" id="{B91C1759-E783-4F38-8A09-5658DD52D049}"/>
+                <a16:creationId xmlns:a16="http://schemas.microsoft.com/office/drawing/2014/main" id="{48C5A5B5-8C67-453B-8AF2-5C5A14FF646E}"/>
               </a:ext>
             </a:extLst>
           </p:cNvPr>
@@ -1903,7 +1903,7 @@
           <p:cNvPr id="3" name="Right column">
             <a:extLst xmlns:a="http://schemas.openxmlformats.org/drawingml/2006/main">
               <a:ext uri="{FF2B5EF4-FFF2-40B4-BE49-F238E27FC236}">
-                <a16:creationId xmlns:a16="http://schemas.microsoft.com/office/drawing/2014/main" id="{22DA3DDF-29B2-4E04-9A85-88A02628DAF6}"/>
+                <a16:creationId xmlns:a16="http://schemas.microsoft.com/office/drawing/2014/main" id="{A1F4D010-BFC9-4005-84E0-9E781EC943F4}"/>
               </a:ext>
             </a:extLst>
           </p:cNvPr>
@@ -2077,7 +2077,7 @@
           <p:cNvPr id="3" name="Title">
             <a:extLst xmlns:a="http://schemas.openxmlformats.org/drawingml/2006/main">
               <a:ext uri="{FF2B5EF4-FFF2-40B4-BE49-F238E27FC236}">
-                <a16:creationId xmlns:a16="http://schemas.microsoft.com/office/drawing/2014/main" id="{9107D1B1-E57D-439B-80E5-E373BABCD365}"/>
+                <a16:creationId xmlns:a16="http://schemas.microsoft.com/office/drawing/2014/main" id="{21D9482C-EEDB-478D-A3C6-484EE304B84E}"/>
               </a:ext>
             </a:extLst>
           </p:cNvPr>
@@ -2234,7 +2234,7 @@
           <p:cNvPr id="2" name="Left column">
             <a:extLst xmlns:a="http://schemas.openxmlformats.org/drawingml/2006/main">
               <a:ext uri="{FF2B5EF4-FFF2-40B4-BE49-F238E27FC236}">
-                <a16:creationId xmlns:a16="http://schemas.microsoft.com/office/drawing/2014/main" id="{38BA69B6-209B-4153-8A85-1E14E0E23AF3}"/>
+                <a16:creationId xmlns:a16="http://schemas.microsoft.com/office/drawing/2014/main" id="{136CA029-2E24-4AAC-8A66-3DFDB930D040}"/>
               </a:ext>
             </a:extLst>
           </p:cNvPr>
@@ -2429,12 +2429,12 @@
   </p:cSld>
   <p:clrMap bg1="lt1" tx1="dk1" bg2="lt2" tx2="dk2" accent1="accent1" accent2="accent2" accent3="accent3" accent4="accent4" accent5="accent5" accent6="accent6" hlink="hlink" folHlink="folHlink"/>
   <p:sldLayoutIdLst>
-    <p:sldLayoutId xmlns:r="http://schemas.openxmlformats.org/officeDocument/2006/relationships" id="2147483649" r:id="R5d9394d5c7f74b2a"/>
-    <p:sldLayoutId xmlns:r="http://schemas.openxmlformats.org/officeDocument/2006/relationships" id="2147483650" r:id="Redfc73be6e7b4fbd"/>
-    <p:sldLayoutId xmlns:r="http://schemas.openxmlformats.org/officeDocument/2006/relationships" id="2147483651" r:id="R7e7cd8d3aa41403c"/>
-    <p:sldLayoutId xmlns:r="http://schemas.openxmlformats.org/officeDocument/2006/relationships" id="2147483652" r:id="R27b15fac099d4d26"/>
-    <p:sldLayoutId xmlns:r="http://schemas.openxmlformats.org/officeDocument/2006/relationships" id="2147483653" r:id="R72ecdc7863654695"/>
-    <p:sldLayoutId xmlns:r="http://schemas.openxmlformats.org/officeDocument/2006/relationships" id="2147483654" r:id="R43a940e47cde450e"/>
+    <p:sldLayoutId xmlns:r="http://schemas.openxmlformats.org/officeDocument/2006/relationships" id="2147483649" r:id="R33b40489e2df4d4e"/>
+    <p:sldLayoutId xmlns:r="http://schemas.openxmlformats.org/officeDocument/2006/relationships" id="2147483650" r:id="Rbb4df6d1ebf74fc1"/>
+    <p:sldLayoutId xmlns:r="http://schemas.openxmlformats.org/officeDocument/2006/relationships" id="2147483651" r:id="Ref893fe98ab943a5"/>
+    <p:sldLayoutId xmlns:r="http://schemas.openxmlformats.org/officeDocument/2006/relationships" id="2147483652" r:id="R8a220cf54e814189"/>
+    <p:sldLayoutId xmlns:r="http://schemas.openxmlformats.org/officeDocument/2006/relationships" id="2147483653" r:id="Rcfd098ea06254919"/>
+    <p:sldLayoutId xmlns:r="http://schemas.openxmlformats.org/officeDocument/2006/relationships" id="2147483654" r:id="Rb2efee4047fb410e"/>
   </p:sldLayoutIdLst>
   <p:txStyles>
     <p:titleStyle>
@@ -2985,7 +2985,7 @@
           <p:cNvPr id="13" name="">
             <a:extLst xmlns:a="http://schemas.openxmlformats.org/drawingml/2006/main">
               <a:ext uri="{FF2B5EF4-FFF2-40B4-BE49-F238E27FC236}">
-                <a16:creationId xmlns:a16="http://schemas.microsoft.com/office/drawing/2014/main" id="{2D3F0C3D-1B93-4630-91DC-72C3F92ACB22}"/>
+                <a16:creationId xmlns:a16="http://schemas.microsoft.com/office/drawing/2014/main" id="{10B5998A-BEC7-4F91-9F1C-F78BF8D614EE}"/>
               </a:ext>
             </a:extLst>
           </p:cNvPr>
@@ -3016,7 +3016,7 @@
           <p:cNvPr id="2" name="">
             <a:extLst xmlns:a="http://schemas.openxmlformats.org/drawingml/2006/main">
               <a:ext uri="{FF2B5EF4-FFF2-40B4-BE49-F238E27FC236}">
-                <a16:creationId xmlns:a16="http://schemas.microsoft.com/office/drawing/2014/main" id="{7CB85F0F-A835-4F90-960B-3A7C69F4C6C8}"/>
+                <a16:creationId xmlns:a16="http://schemas.microsoft.com/office/drawing/2014/main" id="{D5BAC2DE-C1AC-4CC9-AE0D-1F88D1A9CBDF}"/>
               </a:ext>
             </a:extLst>
           </p:cNvPr>
@@ -3083,7 +3083,7 @@
           <p:cNvPr id="3" name="">
             <a:extLst xmlns:a="http://schemas.openxmlformats.org/drawingml/2006/main">
               <a:ext uri="{FF2B5EF4-FFF2-40B4-BE49-F238E27FC236}">
-                <a16:creationId xmlns:a16="http://schemas.microsoft.com/office/drawing/2014/main" id="{160C33C0-E712-49ED-B916-89F2531199AC}"/>
+                <a16:creationId xmlns:a16="http://schemas.microsoft.com/office/drawing/2014/main" id="{BB712283-B78C-43EC-BB39-7BC00BAD9C69}"/>
               </a:ext>
             </a:extLst>
           </p:cNvPr>
@@ -3173,7 +3173,7 @@
           <p:cNvPr id="4" name="">
             <a:extLst xmlns:a="http://schemas.openxmlformats.org/drawingml/2006/main">
               <a:ext uri="{FF2B5EF4-FFF2-40B4-BE49-F238E27FC236}">
-                <a16:creationId xmlns:a16="http://schemas.microsoft.com/office/drawing/2014/main" id="{B6608F1D-1261-4ACC-AF07-F7586D91539A}"/>
+                <a16:creationId xmlns:a16="http://schemas.microsoft.com/office/drawing/2014/main" id="{78753BDB-059B-4079-BB3D-337787C3CED3}"/>
               </a:ext>
             </a:extLst>
           </p:cNvPr>
@@ -3240,7 +3240,7 @@
           <p:cNvPr id="5" name="">
             <a:extLst xmlns:a="http://schemas.openxmlformats.org/drawingml/2006/main">
               <a:ext uri="{FF2B5EF4-FFF2-40B4-BE49-F238E27FC236}">
-                <a16:creationId xmlns:a16="http://schemas.microsoft.com/office/drawing/2014/main" id="{A1D578A9-F387-4EBA-87D7-8016ABFD9F7B}"/>
+                <a16:creationId xmlns:a16="http://schemas.microsoft.com/office/drawing/2014/main" id="{8A974150-6C72-4463-99E4-C3586AF6BBEF}"/>
               </a:ext>
             </a:extLst>
           </p:cNvPr>
@@ -3307,7 +3307,7 @@
           <p:cNvPr id="6" name="">
             <a:extLst xmlns:a="http://schemas.openxmlformats.org/drawingml/2006/main">
               <a:ext uri="{FF2B5EF4-FFF2-40B4-BE49-F238E27FC236}">
-                <a16:creationId xmlns:a16="http://schemas.microsoft.com/office/drawing/2014/main" id="{759B4F5E-81F0-4FBF-8A66-3B42993A4D94}"/>
+                <a16:creationId xmlns:a16="http://schemas.microsoft.com/office/drawing/2014/main" id="{7FC6CA81-229F-4793-B53C-454D134FB7BB}"/>
               </a:ext>
             </a:extLst>
           </p:cNvPr>
@@ -3374,7 +3374,7 @@
           <p:cNvPr id="7" name="">
             <a:extLst xmlns:a="http://schemas.openxmlformats.org/drawingml/2006/main">
               <a:ext uri="{FF2B5EF4-FFF2-40B4-BE49-F238E27FC236}">
-                <a16:creationId xmlns:a16="http://schemas.microsoft.com/office/drawing/2014/main" id="{55EED3DF-7EB8-4ABA-AC93-F46E311D4003}"/>
+                <a16:creationId xmlns:a16="http://schemas.microsoft.com/office/drawing/2014/main" id="{30870861-EE1F-47B6-B2BB-83D4228A23D3}"/>
               </a:ext>
             </a:extLst>
           </p:cNvPr>
@@ -3407,7 +3407,7 @@
           <p:cNvPr id="8" name="">
             <a:extLst xmlns:a="http://schemas.openxmlformats.org/drawingml/2006/main">
               <a:ext uri="{FF2B5EF4-FFF2-40B4-BE49-F238E27FC236}">
-                <a16:creationId xmlns:a16="http://schemas.microsoft.com/office/drawing/2014/main" id="{2BD3CAFA-CB1B-470B-8969-0E4FF9186399}"/>
+                <a16:creationId xmlns:a16="http://schemas.microsoft.com/office/drawing/2014/main" id="{F8910D0E-B67B-4B8C-A57E-5937AA767D80}"/>
               </a:ext>
             </a:extLst>
           </p:cNvPr>
@@ -3440,7 +3440,7 @@
           <p:cNvPr id="9" name="">
             <a:extLst xmlns:a="http://schemas.openxmlformats.org/drawingml/2006/main">
               <a:ext uri="{FF2B5EF4-FFF2-40B4-BE49-F238E27FC236}">
-                <a16:creationId xmlns:a16="http://schemas.microsoft.com/office/drawing/2014/main" id="{930781DD-D85F-420E-9427-8873BC66B027}"/>
+                <a16:creationId xmlns:a16="http://schemas.microsoft.com/office/drawing/2014/main" id="{73FB4BDF-87C2-4A41-BB09-B968ED4BCB6F}"/>
               </a:ext>
             </a:extLst>
           </p:cNvPr>
@@ -3473,7 +3473,7 @@
           <p:cNvPr id="10" name="">
             <a:extLst xmlns:a="http://schemas.openxmlformats.org/drawingml/2006/main">
               <a:ext uri="{FF2B5EF4-FFF2-40B4-BE49-F238E27FC236}">
-                <a16:creationId xmlns:a16="http://schemas.microsoft.com/office/drawing/2014/main" id="{92258C36-1E83-46B5-983A-C5592EBC1232}"/>
+                <a16:creationId xmlns:a16="http://schemas.microsoft.com/office/drawing/2014/main" id="{4008E3CD-A7A4-4333-BA9F-C7E1B078D3B5}"/>
               </a:ext>
             </a:extLst>
           </p:cNvPr>
@@ -3506,7 +3506,7 @@
           <p:cNvPr id="11" name="">
             <a:extLst xmlns:a="http://schemas.openxmlformats.org/drawingml/2006/main">
               <a:ext uri="{FF2B5EF4-FFF2-40B4-BE49-F238E27FC236}">
-                <a16:creationId xmlns:a16="http://schemas.microsoft.com/office/drawing/2014/main" id="{739B970B-E305-4681-9312-F42129772D3B}"/>
+                <a16:creationId xmlns:a16="http://schemas.microsoft.com/office/drawing/2014/main" id="{F5A8E9F1-5A18-4B3A-B58A-05923A137EAE}"/>
               </a:ext>
             </a:extLst>
           </p:cNvPr>
@@ -3539,7 +3539,7 @@
           <p:cNvPr id="12" name="">
             <a:extLst xmlns:a="http://schemas.openxmlformats.org/drawingml/2006/main">
               <a:ext uri="{FF2B5EF4-FFF2-40B4-BE49-F238E27FC236}">
-                <a16:creationId xmlns:a16="http://schemas.microsoft.com/office/drawing/2014/main" id="{A432168E-8913-422E-9342-6DDACA09FAAD}"/>
+                <a16:creationId xmlns:a16="http://schemas.microsoft.com/office/drawing/2014/main" id="{EE1EFF01-6CA5-4392-99BE-04D6EF3CB94A}"/>
               </a:ext>
             </a:extLst>
           </p:cNvPr>
@@ -3604,7 +3604,7 @@
     </p:spTree>
     <p:extLst>
       <p:ext uri="{BB962C8B-B14F-4D97-AF65-F5344CB8AC3E}">
-        <p14:creationId xmlns:p14="http://schemas.microsoft.com/office/powerpoint/2010/main" val="1257023167"/>
+        <p14:creationId xmlns:p14="http://schemas.microsoft.com/office/powerpoint/2010/main" val="1660376168"/>
       </p:ext>
     </p:extLst>
   </p:cSld>
@@ -3635,7 +3635,7 @@
           <p:cNvPr id="26" name="">
             <a:extLst xmlns:a="http://schemas.openxmlformats.org/drawingml/2006/main">
               <a:ext uri="{FF2B5EF4-FFF2-40B4-BE49-F238E27FC236}">
-                <a16:creationId xmlns:a16="http://schemas.microsoft.com/office/drawing/2014/main" id="{DD0E54E7-3806-4DD0-8F8A-4509CA79CE64}"/>
+                <a16:creationId xmlns:a16="http://schemas.microsoft.com/office/drawing/2014/main" id="{6DF3EDD5-2755-4719-BC4F-0052357B7D1A}"/>
               </a:ext>
             </a:extLst>
           </p:cNvPr>
@@ -3666,7 +3666,7 @@
           <p:cNvPr id="2" name="">
             <a:extLst xmlns:a="http://schemas.openxmlformats.org/drawingml/2006/main">
               <a:ext uri="{FF2B5EF4-FFF2-40B4-BE49-F238E27FC236}">
-                <a16:creationId xmlns:a16="http://schemas.microsoft.com/office/drawing/2014/main" id="{2E1BD498-81B8-4B73-8812-6783145F15F1}"/>
+                <a16:creationId xmlns:a16="http://schemas.microsoft.com/office/drawing/2014/main" id="{7A2113B1-FD5D-41BB-B40B-099725292A83}"/>
               </a:ext>
             </a:extLst>
           </p:cNvPr>
@@ -3733,7 +3733,7 @@
           <p:cNvPr id="3" name="">
             <a:extLst xmlns:a="http://schemas.openxmlformats.org/drawingml/2006/main">
               <a:ext uri="{FF2B5EF4-FFF2-40B4-BE49-F238E27FC236}">
-                <a16:creationId xmlns:a16="http://schemas.microsoft.com/office/drawing/2014/main" id="{CEB9B8D3-287E-46A4-8C9C-53DB9C4D9B7C}"/>
+                <a16:creationId xmlns:a16="http://schemas.microsoft.com/office/drawing/2014/main" id="{2D9235FF-9C28-4739-AC5D-D9EFB5D5B5A8}"/>
               </a:ext>
             </a:extLst>
           </p:cNvPr>
@@ -3800,7 +3800,7 @@
           <p:cNvPr id="4" name="">
             <a:extLst xmlns:a="http://schemas.openxmlformats.org/drawingml/2006/main">
               <a:ext uri="{FF2B5EF4-FFF2-40B4-BE49-F238E27FC236}">
-                <a16:creationId xmlns:a16="http://schemas.microsoft.com/office/drawing/2014/main" id="{8E6D0EAF-E723-44F6-B6AA-EBA677BD168C}"/>
+                <a16:creationId xmlns:a16="http://schemas.microsoft.com/office/drawing/2014/main" id="{9336FE93-E967-4CA1-95DB-D86F8DC57814}"/>
               </a:ext>
             </a:extLst>
           </p:cNvPr>
@@ -3831,7 +3831,7 @@
           <p:cNvPr id="5" name="">
             <a:extLst xmlns:a="http://schemas.openxmlformats.org/drawingml/2006/main">
               <a:ext uri="{FF2B5EF4-FFF2-40B4-BE49-F238E27FC236}">
-                <a16:creationId xmlns:a16="http://schemas.microsoft.com/office/drawing/2014/main" id="{CF4B98C4-044E-476E-A438-BEC56ED569C8}"/>
+                <a16:creationId xmlns:a16="http://schemas.microsoft.com/office/drawing/2014/main" id="{6FE51DA6-EE05-4A98-B9C6-68B606E0E922}"/>
               </a:ext>
             </a:extLst>
           </p:cNvPr>
@@ -3898,7 +3898,7 @@
           <p:cNvPr id="6" name="">
             <a:extLst xmlns:a="http://schemas.openxmlformats.org/drawingml/2006/main">
               <a:ext uri="{FF2B5EF4-FFF2-40B4-BE49-F238E27FC236}">
-                <a16:creationId xmlns:a16="http://schemas.microsoft.com/office/drawing/2014/main" id="{F3CF8C72-7A1A-488E-9440-A1BE83BF4FA0}"/>
+                <a16:creationId xmlns:a16="http://schemas.microsoft.com/office/drawing/2014/main" id="{CF42DABA-6CB9-48FE-8322-248775EC36C6}"/>
               </a:ext>
             </a:extLst>
           </p:cNvPr>
@@ -3965,7 +3965,7 @@
           <p:cNvPr id="7" name="">
             <a:extLst xmlns:a="http://schemas.openxmlformats.org/drawingml/2006/main">
               <a:ext uri="{FF2B5EF4-FFF2-40B4-BE49-F238E27FC236}">
-                <a16:creationId xmlns:a16="http://schemas.microsoft.com/office/drawing/2014/main" id="{59CB6E8E-6369-46E3-A1D1-12E26C8E26BC}"/>
+                <a16:creationId xmlns:a16="http://schemas.microsoft.com/office/drawing/2014/main" id="{E43FD322-2A2A-48A9-9FC3-058791481FF1}"/>
               </a:ext>
             </a:extLst>
           </p:cNvPr>
@@ -3996,7 +3996,7 @@
           <p:cNvPr id="8" name="">
             <a:extLst xmlns:a="http://schemas.openxmlformats.org/drawingml/2006/main">
               <a:ext uri="{FF2B5EF4-FFF2-40B4-BE49-F238E27FC236}">
-                <a16:creationId xmlns:a16="http://schemas.microsoft.com/office/drawing/2014/main" id="{964A13C3-1E9F-49A5-AA9C-4074D69822E5}"/>
+                <a16:creationId xmlns:a16="http://schemas.microsoft.com/office/drawing/2014/main" id="{06E7F97D-582E-49C2-B0F1-5C6D31D6C36B}"/>
               </a:ext>
             </a:extLst>
           </p:cNvPr>
@@ -4063,7 +4063,7 @@
           <p:cNvPr id="9" name="">
             <a:extLst xmlns:a="http://schemas.openxmlformats.org/drawingml/2006/main">
               <a:ext uri="{FF2B5EF4-FFF2-40B4-BE49-F238E27FC236}">
-                <a16:creationId xmlns:a16="http://schemas.microsoft.com/office/drawing/2014/main" id="{350D5DC1-E28B-4615-B69D-36A8FDCA46A2}"/>
+                <a16:creationId xmlns:a16="http://schemas.microsoft.com/office/drawing/2014/main" id="{5052F459-864C-4235-B094-086230604E18}"/>
               </a:ext>
             </a:extLst>
           </p:cNvPr>
@@ -4130,7 +4130,7 @@
           <p:cNvPr id="10" name="">
             <a:extLst xmlns:a="http://schemas.openxmlformats.org/drawingml/2006/main">
               <a:ext uri="{FF2B5EF4-FFF2-40B4-BE49-F238E27FC236}">
-                <a16:creationId xmlns:a16="http://schemas.microsoft.com/office/drawing/2014/main" id="{C2C17B66-8246-401B-BAE6-4E24369FFDF1}"/>
+                <a16:creationId xmlns:a16="http://schemas.microsoft.com/office/drawing/2014/main" id="{99BF1247-909A-477A-AB0F-35EE57BC1FD1}"/>
               </a:ext>
             </a:extLst>
           </p:cNvPr>
@@ -4161,7 +4161,7 @@
           <p:cNvPr id="11" name="">
             <a:extLst xmlns:a="http://schemas.openxmlformats.org/drawingml/2006/main">
               <a:ext uri="{FF2B5EF4-FFF2-40B4-BE49-F238E27FC236}">
-                <a16:creationId xmlns:a16="http://schemas.microsoft.com/office/drawing/2014/main" id="{6E08885D-C6B7-4725-843C-5A652746F838}"/>
+                <a16:creationId xmlns:a16="http://schemas.microsoft.com/office/drawing/2014/main" id="{BB055C54-7751-4ABE-97B2-C35F9B5EA687}"/>
               </a:ext>
             </a:extLst>
           </p:cNvPr>
@@ -4228,7 +4228,7 @@
           <p:cNvPr id="12" name="">
             <a:extLst xmlns:a="http://schemas.openxmlformats.org/drawingml/2006/main">
               <a:ext uri="{FF2B5EF4-FFF2-40B4-BE49-F238E27FC236}">
-                <a16:creationId xmlns:a16="http://schemas.microsoft.com/office/drawing/2014/main" id="{BBAB91D2-C64F-40B7-897B-7646423DD913}"/>
+                <a16:creationId xmlns:a16="http://schemas.microsoft.com/office/drawing/2014/main" id="{26C10B4B-13F2-48C9-B3C7-C40B58D1FB19}"/>
               </a:ext>
             </a:extLst>
           </p:cNvPr>
@@ -4295,7 +4295,7 @@
           <p:cNvPr id="13" name="">
             <a:extLst xmlns:a="http://schemas.openxmlformats.org/drawingml/2006/main">
               <a:ext uri="{FF2B5EF4-FFF2-40B4-BE49-F238E27FC236}">
-                <a16:creationId xmlns:a16="http://schemas.microsoft.com/office/drawing/2014/main" id="{9C3922EB-0EDF-41F3-B8F7-4D3FCC9109B1}"/>
+                <a16:creationId xmlns:a16="http://schemas.microsoft.com/office/drawing/2014/main" id="{DD839B5E-7492-42A4-AC9C-8127B61A53F7}"/>
               </a:ext>
             </a:extLst>
           </p:cNvPr>
@@ -4326,7 +4326,7 @@
           <p:cNvPr id="14" name="">
             <a:extLst xmlns:a="http://schemas.openxmlformats.org/drawingml/2006/main">
               <a:ext uri="{FF2B5EF4-FFF2-40B4-BE49-F238E27FC236}">
-                <a16:creationId xmlns:a16="http://schemas.microsoft.com/office/drawing/2014/main" id="{50EE30C0-3980-4562-8B95-0AF2C3F974E5}"/>
+                <a16:creationId xmlns:a16="http://schemas.microsoft.com/office/drawing/2014/main" id="{FB646D2F-0C8C-4692-92CA-271AEF195157}"/>
               </a:ext>
             </a:extLst>
           </p:cNvPr>
@@ -4393,7 +4393,7 @@
           <p:cNvPr id="15" name="">
             <a:extLst xmlns:a="http://schemas.openxmlformats.org/drawingml/2006/main">
               <a:ext uri="{FF2B5EF4-FFF2-40B4-BE49-F238E27FC236}">
-                <a16:creationId xmlns:a16="http://schemas.microsoft.com/office/drawing/2014/main" id="{37763FDA-09D3-4509-8D0C-6D7A0B2E508D}"/>
+                <a16:creationId xmlns:a16="http://schemas.microsoft.com/office/drawing/2014/main" id="{6579F82B-CBB0-4E03-9345-34F71E6BDDEB}"/>
               </a:ext>
             </a:extLst>
           </p:cNvPr>
@@ -4460,7 +4460,7 @@
           <p:cNvPr id="16" name="">
             <a:extLst xmlns:a="http://schemas.openxmlformats.org/drawingml/2006/main">
               <a:ext uri="{FF2B5EF4-FFF2-40B4-BE49-F238E27FC236}">
-                <a16:creationId xmlns:a16="http://schemas.microsoft.com/office/drawing/2014/main" id="{AE1717D3-A0F4-4F87-891A-7A24706EDF1D}"/>
+                <a16:creationId xmlns:a16="http://schemas.microsoft.com/office/drawing/2014/main" id="{49FB360A-B172-4201-BDE0-5DD223F0208D}"/>
               </a:ext>
             </a:extLst>
           </p:cNvPr>
@@ -4491,7 +4491,7 @@
           <p:cNvPr id="17" name="">
             <a:extLst xmlns:a="http://schemas.openxmlformats.org/drawingml/2006/main">
               <a:ext uri="{FF2B5EF4-FFF2-40B4-BE49-F238E27FC236}">
-                <a16:creationId xmlns:a16="http://schemas.microsoft.com/office/drawing/2014/main" id="{EF12AC95-0764-4DAB-8F44-CD86C64E1D7D}"/>
+                <a16:creationId xmlns:a16="http://schemas.microsoft.com/office/drawing/2014/main" id="{BD2E9F22-4A79-4DE7-8448-8E8610DEB7F6}"/>
               </a:ext>
             </a:extLst>
           </p:cNvPr>
@@ -4558,7 +4558,7 @@
           <p:cNvPr id="18" name="">
             <a:extLst xmlns:a="http://schemas.openxmlformats.org/drawingml/2006/main">
               <a:ext uri="{FF2B5EF4-FFF2-40B4-BE49-F238E27FC236}">
-                <a16:creationId xmlns:a16="http://schemas.microsoft.com/office/drawing/2014/main" id="{9FC6F627-C286-40BA-A78D-DF017A96652A}"/>
+                <a16:creationId xmlns:a16="http://schemas.microsoft.com/office/drawing/2014/main" id="{EE9C5AA1-6A8C-4D80-8CC0-AED9E7A52C94}"/>
               </a:ext>
             </a:extLst>
           </p:cNvPr>
@@ -4625,7 +4625,7 @@
           <p:cNvPr id="19" name="">
             <a:extLst xmlns:a="http://schemas.openxmlformats.org/drawingml/2006/main">
               <a:ext uri="{FF2B5EF4-FFF2-40B4-BE49-F238E27FC236}">
-                <a16:creationId xmlns:a16="http://schemas.microsoft.com/office/drawing/2014/main" id="{7DDBA21C-9BB2-4FDB-9256-3B9260B9BAF1}"/>
+                <a16:creationId xmlns:a16="http://schemas.microsoft.com/office/drawing/2014/main" id="{0B0717E6-C6AC-4882-83B9-9123D651E24C}"/>
               </a:ext>
             </a:extLst>
           </p:cNvPr>
@@ -4656,7 +4656,7 @@
           <p:cNvPr id="20" name="">
             <a:extLst xmlns:a="http://schemas.openxmlformats.org/drawingml/2006/main">
               <a:ext uri="{FF2B5EF4-FFF2-40B4-BE49-F238E27FC236}">
-                <a16:creationId xmlns:a16="http://schemas.microsoft.com/office/drawing/2014/main" id="{9F871F38-0F2B-460A-8422-525F234D188B}"/>
+                <a16:creationId xmlns:a16="http://schemas.microsoft.com/office/drawing/2014/main" id="{93A957FC-E8AB-494A-BE60-71E269ADB1A0}"/>
               </a:ext>
             </a:extLst>
           </p:cNvPr>
@@ -4723,7 +4723,7 @@
           <p:cNvPr id="21" name="">
             <a:extLst xmlns:a="http://schemas.openxmlformats.org/drawingml/2006/main">
               <a:ext uri="{FF2B5EF4-FFF2-40B4-BE49-F238E27FC236}">
-                <a16:creationId xmlns:a16="http://schemas.microsoft.com/office/drawing/2014/main" id="{91D71FBE-1F7A-4B52-AF6E-600044822F33}"/>
+                <a16:creationId xmlns:a16="http://schemas.microsoft.com/office/drawing/2014/main" id="{D7BD0591-DBCA-4A50-AF87-D03BC2DF07D2}"/>
               </a:ext>
             </a:extLst>
           </p:cNvPr>
@@ -4790,7 +4790,7 @@
           <p:cNvPr id="22" name="">
             <a:extLst xmlns:a="http://schemas.openxmlformats.org/drawingml/2006/main">
               <a:ext uri="{FF2B5EF4-FFF2-40B4-BE49-F238E27FC236}">
-                <a16:creationId xmlns:a16="http://schemas.microsoft.com/office/drawing/2014/main" id="{2E0FC933-8E88-4EEC-BE9A-2A767484B229}"/>
+                <a16:creationId xmlns:a16="http://schemas.microsoft.com/office/drawing/2014/main" id="{89460F59-8E23-469A-984A-D53FDBFC2410}"/>
               </a:ext>
             </a:extLst>
           </p:cNvPr>
@@ -4821,7 +4821,7 @@
           <p:cNvPr id="23" name="">
             <a:extLst xmlns:a="http://schemas.openxmlformats.org/drawingml/2006/main">
               <a:ext uri="{FF2B5EF4-FFF2-40B4-BE49-F238E27FC236}">
-                <a16:creationId xmlns:a16="http://schemas.microsoft.com/office/drawing/2014/main" id="{31C933C4-434F-4851-BD6A-3F3EE89D8DDB}"/>
+                <a16:creationId xmlns:a16="http://schemas.microsoft.com/office/drawing/2014/main" id="{55E5747D-9BE8-461E-A48C-29953153C7BD}"/>
               </a:ext>
             </a:extLst>
           </p:cNvPr>
@@ -4888,7 +4888,7 @@
           <p:cNvPr id="24" name="">
             <a:extLst xmlns:a="http://schemas.openxmlformats.org/drawingml/2006/main">
               <a:ext uri="{FF2B5EF4-FFF2-40B4-BE49-F238E27FC236}">
-                <a16:creationId xmlns:a16="http://schemas.microsoft.com/office/drawing/2014/main" id="{C1DF1C9F-191C-4482-991D-EB32D9CF96BC}"/>
+                <a16:creationId xmlns:a16="http://schemas.microsoft.com/office/drawing/2014/main" id="{138FE6F5-2918-4A46-AF8D-B9A4BB50466C}"/>
               </a:ext>
             </a:extLst>
           </p:cNvPr>
@@ -4955,7 +4955,7 @@
           <p:cNvPr id="25" name="">
             <a:extLst xmlns:a="http://schemas.openxmlformats.org/drawingml/2006/main">
               <a:ext uri="{FF2B5EF4-FFF2-40B4-BE49-F238E27FC236}">
-                <a16:creationId xmlns:a16="http://schemas.microsoft.com/office/drawing/2014/main" id="{242972AC-CD25-4AB1-8B6F-B03F9DDCE1B9}"/>
+                <a16:creationId xmlns:a16="http://schemas.microsoft.com/office/drawing/2014/main" id="{0E2CF02F-F346-4BF6-A7AB-C9C6C21A8352}"/>
               </a:ext>
             </a:extLst>
           </p:cNvPr>
@@ -5020,7 +5020,7 @@
     </p:spTree>
     <p:extLst>
       <p:ext uri="{BB962C8B-B14F-4D97-AF65-F5344CB8AC3E}">
-        <p14:creationId xmlns:p14="http://schemas.microsoft.com/office/powerpoint/2010/main" val="1491753588"/>
+        <p14:creationId xmlns:p14="http://schemas.microsoft.com/office/powerpoint/2010/main" val="1614612483"/>
       </p:ext>
     </p:extLst>
   </p:cSld>
@@ -5051,7 +5051,7 @@
           <p:cNvPr id="24" name="">
             <a:extLst xmlns:a="http://schemas.openxmlformats.org/drawingml/2006/main">
               <a:ext uri="{FF2B5EF4-FFF2-40B4-BE49-F238E27FC236}">
-                <a16:creationId xmlns:a16="http://schemas.microsoft.com/office/drawing/2014/main" id="{C5CD7F82-FC91-4BC7-8739-19BF0267FCC1}"/>
+                <a16:creationId xmlns:a16="http://schemas.microsoft.com/office/drawing/2014/main" id="{CD656B1E-9B2D-4AD5-A6DD-A781FDE4A578}"/>
               </a:ext>
             </a:extLst>
           </p:cNvPr>
@@ -5082,7 +5082,7 @@
           <p:cNvPr id="2" name="">
             <a:extLst xmlns:a="http://schemas.openxmlformats.org/drawingml/2006/main">
               <a:ext uri="{FF2B5EF4-FFF2-40B4-BE49-F238E27FC236}">
-                <a16:creationId xmlns:a16="http://schemas.microsoft.com/office/drawing/2014/main" id="{3DA4611B-D3B6-4371-83FF-811A08184F3F}"/>
+                <a16:creationId xmlns:a16="http://schemas.microsoft.com/office/drawing/2014/main" id="{A5C6DE3C-4AA7-4A6E-AE95-8CC5F2C1405F}"/>
               </a:ext>
             </a:extLst>
           </p:cNvPr>
@@ -5149,7 +5149,7 @@
           <p:cNvPr id="3" name="">
             <a:extLst xmlns:a="http://schemas.openxmlformats.org/drawingml/2006/main">
               <a:ext uri="{FF2B5EF4-FFF2-40B4-BE49-F238E27FC236}">
-                <a16:creationId xmlns:a16="http://schemas.microsoft.com/office/drawing/2014/main" id="{3113D153-9EB9-453F-9D54-6D73761AF86A}"/>
+                <a16:creationId xmlns:a16="http://schemas.microsoft.com/office/drawing/2014/main" id="{61C263EC-35C2-4BB7-947D-702B23E3EC0D}"/>
               </a:ext>
             </a:extLst>
           </p:cNvPr>
@@ -5216,7 +5216,7 @@
           <p:cNvPr id="4" name="">
             <a:extLst xmlns:a="http://schemas.openxmlformats.org/drawingml/2006/main">
               <a:ext uri="{FF2B5EF4-FFF2-40B4-BE49-F238E27FC236}">
-                <a16:creationId xmlns:a16="http://schemas.microsoft.com/office/drawing/2014/main" id="{287E2796-145B-4A70-AB02-0DFF032B25A3}"/>
+                <a16:creationId xmlns:a16="http://schemas.microsoft.com/office/drawing/2014/main" id="{5FC631F9-9DB5-418E-9E1E-288F2CB96B92}"/>
               </a:ext>
             </a:extLst>
           </p:cNvPr>
@@ -5247,7 +5247,7 @@
           <p:cNvPr id="5" name="">
             <a:extLst xmlns:a="http://schemas.openxmlformats.org/drawingml/2006/main">
               <a:ext uri="{FF2B5EF4-FFF2-40B4-BE49-F238E27FC236}">
-                <a16:creationId xmlns:a16="http://schemas.microsoft.com/office/drawing/2014/main" id="{DA359C19-3287-40BE-B8C3-F4780CF6E416}"/>
+                <a16:creationId xmlns:a16="http://schemas.microsoft.com/office/drawing/2014/main" id="{44650A4E-B058-4D5F-A816-ED810B8F8223}"/>
               </a:ext>
             </a:extLst>
           </p:cNvPr>
@@ -5314,7 +5314,7 @@
           <p:cNvPr id="6" name="">
             <a:extLst xmlns:a="http://schemas.openxmlformats.org/drawingml/2006/main">
               <a:ext uri="{FF2B5EF4-FFF2-40B4-BE49-F238E27FC236}">
-                <a16:creationId xmlns:a16="http://schemas.microsoft.com/office/drawing/2014/main" id="{051627AE-12A6-43B8-B5CA-1DA3C7230CB5}"/>
+                <a16:creationId xmlns:a16="http://schemas.microsoft.com/office/drawing/2014/main" id="{C9A4D3DE-5B6D-4E36-BBCD-B114E71E3E81}"/>
               </a:ext>
             </a:extLst>
           </p:cNvPr>
@@ -5381,7 +5381,7 @@
           <p:cNvPr id="7" name="">
             <a:extLst xmlns:a="http://schemas.openxmlformats.org/drawingml/2006/main">
               <a:ext uri="{FF2B5EF4-FFF2-40B4-BE49-F238E27FC236}">
-                <a16:creationId xmlns:a16="http://schemas.microsoft.com/office/drawing/2014/main" id="{67FD7537-4EAA-498C-AA4B-290200CEBE91}"/>
+                <a16:creationId xmlns:a16="http://schemas.microsoft.com/office/drawing/2014/main" id="{91FDF3D5-DB85-4572-B8DC-2812FFFEAA29}"/>
               </a:ext>
             </a:extLst>
           </p:cNvPr>
@@ -5416,7 +5416,7 @@
           <p:cNvPr id="8" name="">
             <a:extLst xmlns:a="http://schemas.openxmlformats.org/drawingml/2006/main">
               <a:ext uri="{FF2B5EF4-FFF2-40B4-BE49-F238E27FC236}">
-                <a16:creationId xmlns:a16="http://schemas.microsoft.com/office/drawing/2014/main" id="{F5F9CC66-8C63-4552-9B91-9AFD1494F252}"/>
+                <a16:creationId xmlns:a16="http://schemas.microsoft.com/office/drawing/2014/main" id="{F828C130-CB83-4141-8DD7-43FD23109B10}"/>
               </a:ext>
             </a:extLst>
           </p:cNvPr>
@@ -5447,7 +5447,7 @@
           <p:cNvPr id="9" name="">
             <a:extLst xmlns:a="http://schemas.openxmlformats.org/drawingml/2006/main">
               <a:ext uri="{FF2B5EF4-FFF2-40B4-BE49-F238E27FC236}">
-                <a16:creationId xmlns:a16="http://schemas.microsoft.com/office/drawing/2014/main" id="{473C9546-F340-48F9-9409-8FB04EDF260E}"/>
+                <a16:creationId xmlns:a16="http://schemas.microsoft.com/office/drawing/2014/main" id="{1D3509AE-0944-4BE2-B51A-B083908C1F67}"/>
               </a:ext>
             </a:extLst>
           </p:cNvPr>
@@ -5514,7 +5514,7 @@
           <p:cNvPr id="10" name="">
             <a:extLst xmlns:a="http://schemas.openxmlformats.org/drawingml/2006/main">
               <a:ext uri="{FF2B5EF4-FFF2-40B4-BE49-F238E27FC236}">
-                <a16:creationId xmlns:a16="http://schemas.microsoft.com/office/drawing/2014/main" id="{39E43EF5-CD43-4908-9821-FE0744997F5F}"/>
+                <a16:creationId xmlns:a16="http://schemas.microsoft.com/office/drawing/2014/main" id="{61C6A76E-F05C-4788-995F-377F29D90DC5}"/>
               </a:ext>
             </a:extLst>
           </p:cNvPr>
@@ -5673,7 +5673,7 @@
           <p:cNvPr id="11" name="">
             <a:extLst xmlns:a="http://schemas.openxmlformats.org/drawingml/2006/main">
               <a:ext uri="{FF2B5EF4-FFF2-40B4-BE49-F238E27FC236}">
-                <a16:creationId xmlns:a16="http://schemas.microsoft.com/office/drawing/2014/main" id="{8E97CF80-81C1-4C0A-826E-1EC3901224E8}"/>
+                <a16:creationId xmlns:a16="http://schemas.microsoft.com/office/drawing/2014/main" id="{C9E7DA55-A16D-4437-9579-4CB2813C6151}"/>
               </a:ext>
             </a:extLst>
           </p:cNvPr>
@@ -5708,7 +5708,7 @@
           <p:cNvPr id="12" name="">
             <a:extLst xmlns:a="http://schemas.openxmlformats.org/drawingml/2006/main">
               <a:ext uri="{FF2B5EF4-FFF2-40B4-BE49-F238E27FC236}">
-                <a16:creationId xmlns:a16="http://schemas.microsoft.com/office/drawing/2014/main" id="{7E136A7C-30A6-4883-B464-94C845E85862}"/>
+                <a16:creationId xmlns:a16="http://schemas.microsoft.com/office/drawing/2014/main" id="{AC0E88CF-A3B9-4722-83E2-7C370387BADE}"/>
               </a:ext>
             </a:extLst>
           </p:cNvPr>
@@ -5739,7 +5739,7 @@
           <p:cNvPr id="13" name="">
             <a:extLst xmlns:a="http://schemas.openxmlformats.org/drawingml/2006/main">
               <a:ext uri="{FF2B5EF4-FFF2-40B4-BE49-F238E27FC236}">
-                <a16:creationId xmlns:a16="http://schemas.microsoft.com/office/drawing/2014/main" id="{4E94CD8C-9D3A-470B-9BA2-298ADD948FFA}"/>
+                <a16:creationId xmlns:a16="http://schemas.microsoft.com/office/drawing/2014/main" id="{C66668C0-7A56-45CE-96EE-11AE82FF7047}"/>
               </a:ext>
             </a:extLst>
           </p:cNvPr>
@@ -5806,7 +5806,7 @@
           <p:cNvPr id="14" name="">
             <a:extLst xmlns:a="http://schemas.openxmlformats.org/drawingml/2006/main">
               <a:ext uri="{FF2B5EF4-FFF2-40B4-BE49-F238E27FC236}">
-                <a16:creationId xmlns:a16="http://schemas.microsoft.com/office/drawing/2014/main" id="{23FCA6C5-8993-48F8-BA9F-82569EA229EE}"/>
+                <a16:creationId xmlns:a16="http://schemas.microsoft.com/office/drawing/2014/main" id="{C0AC3B8A-1F90-4DBC-AE72-16A7AAA78DD6}"/>
               </a:ext>
             </a:extLst>
           </p:cNvPr>
@@ -5932,7 +5932,7 @@
                 <a:ea typeface="Aptos"/>
                 <a:cs typeface="Aptos"/>
               </a:rPr>
-              <a:t>borrowed / due / returned</a:t>
+              <a:t>returned</a:t>
             </a:r>
           </a:p>
         </p:txBody>
@@ -5942,7 +5942,7 @@
           <p:cNvPr id="15" name="">
             <a:extLst xmlns:a="http://schemas.openxmlformats.org/drawingml/2006/main">
               <a:ext uri="{FF2B5EF4-FFF2-40B4-BE49-F238E27FC236}">
-                <a16:creationId xmlns:a16="http://schemas.microsoft.com/office/drawing/2014/main" id="{7411652B-5F64-44CA-A4E8-61EBEC91FE44}"/>
+                <a16:creationId xmlns:a16="http://schemas.microsoft.com/office/drawing/2014/main" id="{E0741056-F16C-44F1-8882-0365E0EBAC18}"/>
               </a:ext>
             </a:extLst>
           </p:cNvPr>
@@ -5977,7 +5977,7 @@
           <p:cNvPr id="16" name="">
             <a:extLst xmlns:a="http://schemas.openxmlformats.org/drawingml/2006/main">
               <a:ext uri="{FF2B5EF4-FFF2-40B4-BE49-F238E27FC236}">
-                <a16:creationId xmlns:a16="http://schemas.microsoft.com/office/drawing/2014/main" id="{C76B12DE-60EA-49F6-9478-5481CF84A9CB}"/>
+                <a16:creationId xmlns:a16="http://schemas.microsoft.com/office/drawing/2014/main" id="{B6D75CC5-BD48-4522-83F1-4D5CB390B148}"/>
               </a:ext>
             </a:extLst>
           </p:cNvPr>
@@ -6008,7 +6008,7 @@
           <p:cNvPr id="17" name="">
             <a:extLst xmlns:a="http://schemas.openxmlformats.org/drawingml/2006/main">
               <a:ext uri="{FF2B5EF4-FFF2-40B4-BE49-F238E27FC236}">
-                <a16:creationId xmlns:a16="http://schemas.microsoft.com/office/drawing/2014/main" id="{9D018282-072B-4C95-9FFF-A3418AD28191}"/>
+                <a16:creationId xmlns:a16="http://schemas.microsoft.com/office/drawing/2014/main" id="{EAC0D982-8673-4D4F-990D-2644739085A7}"/>
               </a:ext>
             </a:extLst>
           </p:cNvPr>
@@ -6075,7 +6075,7 @@
           <p:cNvPr id="18" name="">
             <a:extLst xmlns:a="http://schemas.openxmlformats.org/drawingml/2006/main">
               <a:ext uri="{FF2B5EF4-FFF2-40B4-BE49-F238E27FC236}">
-                <a16:creationId xmlns:a16="http://schemas.microsoft.com/office/drawing/2014/main" id="{01632383-67B2-4987-B913-4539851F50B3}"/>
+                <a16:creationId xmlns:a16="http://schemas.microsoft.com/office/drawing/2014/main" id="{6BA2A1D5-68D7-4DEA-8522-78350025957C}"/>
               </a:ext>
             </a:extLst>
           </p:cNvPr>
@@ -6211,7 +6211,7 @@
           <p:cNvPr id="19" name="">
             <a:extLst xmlns:a="http://schemas.openxmlformats.org/drawingml/2006/main">
               <a:ext uri="{FF2B5EF4-FFF2-40B4-BE49-F238E27FC236}">
-                <a16:creationId xmlns:a16="http://schemas.microsoft.com/office/drawing/2014/main" id="{6CB4C851-EA5F-4043-B658-BB8ADE6A3A48}"/>
+                <a16:creationId xmlns:a16="http://schemas.microsoft.com/office/drawing/2014/main" id="{0664548B-9AA5-427C-A8EA-24ADAB9919FD}"/>
               </a:ext>
             </a:extLst>
           </p:cNvPr>
@@ -6242,7 +6242,7 @@
           <p:cNvPr id="20" name="">
             <a:extLst xmlns:a="http://schemas.openxmlformats.org/drawingml/2006/main">
               <a:ext uri="{FF2B5EF4-FFF2-40B4-BE49-F238E27FC236}">
-                <a16:creationId xmlns:a16="http://schemas.microsoft.com/office/drawing/2014/main" id="{DD89543D-D47C-47AE-8F7F-19754BBA9850}"/>
+                <a16:creationId xmlns:a16="http://schemas.microsoft.com/office/drawing/2014/main" id="{7260B922-4551-46E8-9564-C6656EEB266D}"/>
               </a:ext>
             </a:extLst>
           </p:cNvPr>
@@ -6309,7 +6309,7 @@
           <p:cNvPr id="21" name="">
             <a:extLst xmlns:a="http://schemas.openxmlformats.org/drawingml/2006/main">
               <a:ext uri="{FF2B5EF4-FFF2-40B4-BE49-F238E27FC236}">
-                <a16:creationId xmlns:a16="http://schemas.microsoft.com/office/drawing/2014/main" id="{69C08AB5-FD86-4C1C-8610-53AFD9083165}"/>
+                <a16:creationId xmlns:a16="http://schemas.microsoft.com/office/drawing/2014/main" id="{8C8B0A7C-7CB0-4CA6-AF3F-2714380C6030}"/>
               </a:ext>
             </a:extLst>
           </p:cNvPr>
@@ -6340,7 +6340,7 @@
           <p:cNvPr id="22" name="">
             <a:extLst xmlns:a="http://schemas.openxmlformats.org/drawingml/2006/main">
               <a:ext uri="{FF2B5EF4-FFF2-40B4-BE49-F238E27FC236}">
-                <a16:creationId xmlns:a16="http://schemas.microsoft.com/office/drawing/2014/main" id="{D084EF41-BD90-461B-9749-CDFF047BB868}"/>
+                <a16:creationId xmlns:a16="http://schemas.microsoft.com/office/drawing/2014/main" id="{EB9DF38B-69A9-49EF-B0DF-2B74A053F58A}"/>
               </a:ext>
             </a:extLst>
           </p:cNvPr>
@@ -6407,7 +6407,7 @@
           <p:cNvPr id="23" name="">
             <a:extLst xmlns:a="http://schemas.openxmlformats.org/drawingml/2006/main">
               <a:ext uri="{FF2B5EF4-FFF2-40B4-BE49-F238E27FC236}">
-                <a16:creationId xmlns:a16="http://schemas.microsoft.com/office/drawing/2014/main" id="{6440499A-8F24-499B-8C25-40D758FB49BE}"/>
+                <a16:creationId xmlns:a16="http://schemas.microsoft.com/office/drawing/2014/main" id="{5B612F1C-DB0B-48BF-A6ED-A6A2D703DCFE}"/>
               </a:ext>
             </a:extLst>
           </p:cNvPr>
@@ -6472,7 +6472,7 @@
     </p:spTree>
     <p:extLst>
       <p:ext uri="{BB962C8B-B14F-4D97-AF65-F5344CB8AC3E}">
-        <p14:creationId xmlns:p14="http://schemas.microsoft.com/office/powerpoint/2010/main" val="980392784"/>
+        <p14:creationId xmlns:p14="http://schemas.microsoft.com/office/powerpoint/2010/main" val="2031282422"/>
       </p:ext>
     </p:extLst>
   </p:cSld>
@@ -6503,7 +6503,7 @@
           <p:cNvPr id="25" name="">
             <a:extLst xmlns:a="http://schemas.openxmlformats.org/drawingml/2006/main">
               <a:ext uri="{FF2B5EF4-FFF2-40B4-BE49-F238E27FC236}">
-                <a16:creationId xmlns:a16="http://schemas.microsoft.com/office/drawing/2014/main" id="{90690C28-C5AE-4707-B2A6-F7D148350E7B}"/>
+                <a16:creationId xmlns:a16="http://schemas.microsoft.com/office/drawing/2014/main" id="{A3A8C240-0330-494D-ACFD-23866B5DCD49}"/>
               </a:ext>
             </a:extLst>
           </p:cNvPr>
@@ -6534,7 +6534,7 @@
           <p:cNvPr id="2" name="">
             <a:extLst xmlns:a="http://schemas.openxmlformats.org/drawingml/2006/main">
               <a:ext uri="{FF2B5EF4-FFF2-40B4-BE49-F238E27FC236}">
-                <a16:creationId xmlns:a16="http://schemas.microsoft.com/office/drawing/2014/main" id="{0415BB04-64FE-49FD-82E3-36C988899CF6}"/>
+                <a16:creationId xmlns:a16="http://schemas.microsoft.com/office/drawing/2014/main" id="{D1DABDB5-086B-4D4D-BE56-C2B7405D2A12}"/>
               </a:ext>
             </a:extLst>
           </p:cNvPr>
@@ -6601,7 +6601,7 @@
           <p:cNvPr id="3" name="">
             <a:extLst xmlns:a="http://schemas.openxmlformats.org/drawingml/2006/main">
               <a:ext uri="{FF2B5EF4-FFF2-40B4-BE49-F238E27FC236}">
-                <a16:creationId xmlns:a16="http://schemas.microsoft.com/office/drawing/2014/main" id="{B904FE3A-CD52-4E07-B01D-0B9293E8A7FF}"/>
+                <a16:creationId xmlns:a16="http://schemas.microsoft.com/office/drawing/2014/main" id="{C4D0A268-FCCE-4D68-8179-EE5F5E21CABB}"/>
               </a:ext>
             </a:extLst>
           </p:cNvPr>
@@ -6668,7 +6668,7 @@
           <p:cNvPr id="4" name="">
             <a:extLst xmlns:a="http://schemas.openxmlformats.org/drawingml/2006/main">
               <a:ext uri="{FF2B5EF4-FFF2-40B4-BE49-F238E27FC236}">
-                <a16:creationId xmlns:a16="http://schemas.microsoft.com/office/drawing/2014/main" id="{306A4602-9C9A-4364-B957-252B60DF6684}"/>
+                <a16:creationId xmlns:a16="http://schemas.microsoft.com/office/drawing/2014/main" id="{03ECD29D-CB21-4CBE-829E-1A2AB516045C}"/>
               </a:ext>
             </a:extLst>
           </p:cNvPr>
@@ -6699,7 +6699,7 @@
           <p:cNvPr id="5" name="">
             <a:extLst xmlns:a="http://schemas.openxmlformats.org/drawingml/2006/main">
               <a:ext uri="{FF2B5EF4-FFF2-40B4-BE49-F238E27FC236}">
-                <a16:creationId xmlns:a16="http://schemas.microsoft.com/office/drawing/2014/main" id="{34714F69-FB77-40C3-8844-EC56027F24F7}"/>
+                <a16:creationId xmlns:a16="http://schemas.microsoft.com/office/drawing/2014/main" id="{FDB54C74-2D1B-4384-B3DD-22DCBAF14F2C}"/>
               </a:ext>
             </a:extLst>
           </p:cNvPr>
@@ -6766,7 +6766,7 @@
           <p:cNvPr id="6" name="">
             <a:extLst xmlns:a="http://schemas.openxmlformats.org/drawingml/2006/main">
               <a:ext uri="{FF2B5EF4-FFF2-40B4-BE49-F238E27FC236}">
-                <a16:creationId xmlns:a16="http://schemas.microsoft.com/office/drawing/2014/main" id="{CAB654E6-FAC4-4271-9665-60718944B848}"/>
+                <a16:creationId xmlns:a16="http://schemas.microsoft.com/office/drawing/2014/main" id="{1847A624-FB16-4813-A570-3A3E243F1A3B}"/>
               </a:ext>
             </a:extLst>
           </p:cNvPr>
@@ -6833,7 +6833,7 @@
           <p:cNvPr id="7" name="">
             <a:extLst xmlns:a="http://schemas.openxmlformats.org/drawingml/2006/main">
               <a:ext uri="{FF2B5EF4-FFF2-40B4-BE49-F238E27FC236}">
-                <a16:creationId xmlns:a16="http://schemas.microsoft.com/office/drawing/2014/main" id="{60F73D08-62A7-4E0C-8B83-DEADE0EDED4E}"/>
+                <a16:creationId xmlns:a16="http://schemas.microsoft.com/office/drawing/2014/main" id="{0A3202E0-FCAC-4F70-B8AD-A7618AE83547}"/>
               </a:ext>
             </a:extLst>
           </p:cNvPr>
@@ -6868,7 +6868,7 @@
           <p:cNvPr id="8" name="">
             <a:extLst xmlns:a="http://schemas.openxmlformats.org/drawingml/2006/main">
               <a:ext uri="{FF2B5EF4-FFF2-40B4-BE49-F238E27FC236}">
-                <a16:creationId xmlns:a16="http://schemas.microsoft.com/office/drawing/2014/main" id="{920E0CEB-07BA-422B-8B7D-F88DE4C003BD}"/>
+                <a16:creationId xmlns:a16="http://schemas.microsoft.com/office/drawing/2014/main" id="{6970F8A6-9444-45A2-A879-665B940385B8}"/>
               </a:ext>
             </a:extLst>
           </p:cNvPr>
@@ -6935,7 +6935,7 @@
           <p:cNvPr id="9" name="">
             <a:extLst xmlns:a="http://schemas.openxmlformats.org/drawingml/2006/main">
               <a:ext uri="{FF2B5EF4-FFF2-40B4-BE49-F238E27FC236}">
-                <a16:creationId xmlns:a16="http://schemas.microsoft.com/office/drawing/2014/main" id="{01E02A8E-492A-4BCE-BA17-542988BCD3DB}"/>
+                <a16:creationId xmlns:a16="http://schemas.microsoft.com/office/drawing/2014/main" id="{5302F281-4CDE-4169-BE3D-CC275F0D7E5B}"/>
               </a:ext>
             </a:extLst>
           </p:cNvPr>
@@ -7002,7 +7002,7 @@
           <p:cNvPr id="10" name="">
             <a:extLst xmlns:a="http://schemas.openxmlformats.org/drawingml/2006/main">
               <a:ext uri="{FF2B5EF4-FFF2-40B4-BE49-F238E27FC236}">
-                <a16:creationId xmlns:a16="http://schemas.microsoft.com/office/drawing/2014/main" id="{5CA00588-2402-4947-8055-704D0323E7F8}"/>
+                <a16:creationId xmlns:a16="http://schemas.microsoft.com/office/drawing/2014/main" id="{1660FAC1-7BE5-4DAA-80CE-851362C36038}"/>
               </a:ext>
             </a:extLst>
           </p:cNvPr>
@@ -7037,7 +7037,7 @@
           <p:cNvPr id="11" name="">
             <a:extLst xmlns:a="http://schemas.openxmlformats.org/drawingml/2006/main">
               <a:ext uri="{FF2B5EF4-FFF2-40B4-BE49-F238E27FC236}">
-                <a16:creationId xmlns:a16="http://schemas.microsoft.com/office/drawing/2014/main" id="{84E317DF-D60F-41FE-BF58-C9C4D31609BF}"/>
+                <a16:creationId xmlns:a16="http://schemas.microsoft.com/office/drawing/2014/main" id="{67C56E0A-AA58-4136-8781-89A4485255BB}"/>
               </a:ext>
             </a:extLst>
           </p:cNvPr>
@@ -7104,7 +7104,7 @@
           <p:cNvPr id="12" name="">
             <a:extLst xmlns:a="http://schemas.openxmlformats.org/drawingml/2006/main">
               <a:ext uri="{FF2B5EF4-FFF2-40B4-BE49-F238E27FC236}">
-                <a16:creationId xmlns:a16="http://schemas.microsoft.com/office/drawing/2014/main" id="{FEF22933-43F6-49B1-B321-7874398086D8}"/>
+                <a16:creationId xmlns:a16="http://schemas.microsoft.com/office/drawing/2014/main" id="{001210C9-D883-4229-8457-F7352B95800C}"/>
               </a:ext>
             </a:extLst>
           </p:cNvPr>
@@ -7171,7 +7171,7 @@
           <p:cNvPr id="13" name="">
             <a:extLst xmlns:a="http://schemas.openxmlformats.org/drawingml/2006/main">
               <a:ext uri="{FF2B5EF4-FFF2-40B4-BE49-F238E27FC236}">
-                <a16:creationId xmlns:a16="http://schemas.microsoft.com/office/drawing/2014/main" id="{D73B2AE0-4DC8-4AD0-B281-917415B17632}"/>
+                <a16:creationId xmlns:a16="http://schemas.microsoft.com/office/drawing/2014/main" id="{D89E831D-349A-4959-9D11-1B1EED356BA8}"/>
               </a:ext>
             </a:extLst>
           </p:cNvPr>
@@ -7206,7 +7206,7 @@
           <p:cNvPr id="14" name="">
             <a:extLst xmlns:a="http://schemas.openxmlformats.org/drawingml/2006/main">
               <a:ext uri="{FF2B5EF4-FFF2-40B4-BE49-F238E27FC236}">
-                <a16:creationId xmlns:a16="http://schemas.microsoft.com/office/drawing/2014/main" id="{0E11E542-38B2-4A9F-AEEB-9745596AB09D}"/>
+                <a16:creationId xmlns:a16="http://schemas.microsoft.com/office/drawing/2014/main" id="{D8B7A06C-038A-4569-AC34-87CBB7210B94}"/>
               </a:ext>
             </a:extLst>
           </p:cNvPr>
@@ -7273,7 +7273,7 @@
           <p:cNvPr id="15" name="">
             <a:extLst xmlns:a="http://schemas.openxmlformats.org/drawingml/2006/main">
               <a:ext uri="{FF2B5EF4-FFF2-40B4-BE49-F238E27FC236}">
-                <a16:creationId xmlns:a16="http://schemas.microsoft.com/office/drawing/2014/main" id="{08333AD0-92AF-4636-9041-FAB7DED5EB4B}"/>
+                <a16:creationId xmlns:a16="http://schemas.microsoft.com/office/drawing/2014/main" id="{C7AB585E-CAFE-4C74-A2ED-6B5DEF26666D}"/>
               </a:ext>
             </a:extLst>
           </p:cNvPr>
@@ -7340,7 +7340,7 @@
           <p:cNvPr id="16" name="">
             <a:extLst xmlns:a="http://schemas.openxmlformats.org/drawingml/2006/main">
               <a:ext uri="{FF2B5EF4-FFF2-40B4-BE49-F238E27FC236}">
-                <a16:creationId xmlns:a16="http://schemas.microsoft.com/office/drawing/2014/main" id="{8BCF565D-2DEB-4CC9-BFE9-0FD18B17FB5B}"/>
+                <a16:creationId xmlns:a16="http://schemas.microsoft.com/office/drawing/2014/main" id="{AC4012EF-7978-406F-9520-3FF54064F722}"/>
               </a:ext>
             </a:extLst>
           </p:cNvPr>
@@ -7375,7 +7375,7 @@
           <p:cNvPr id="17" name="">
             <a:extLst xmlns:a="http://schemas.openxmlformats.org/drawingml/2006/main">
               <a:ext uri="{FF2B5EF4-FFF2-40B4-BE49-F238E27FC236}">
-                <a16:creationId xmlns:a16="http://schemas.microsoft.com/office/drawing/2014/main" id="{CBBDAD4F-D860-4201-AE7F-6DF719CA6D22}"/>
+                <a16:creationId xmlns:a16="http://schemas.microsoft.com/office/drawing/2014/main" id="{1A42EB00-C72C-4BAC-9D0C-ED40D5257BBA}"/>
               </a:ext>
             </a:extLst>
           </p:cNvPr>
@@ -7442,7 +7442,7 @@
           <p:cNvPr id="18" name="">
             <a:extLst xmlns:a="http://schemas.openxmlformats.org/drawingml/2006/main">
               <a:ext uri="{FF2B5EF4-FFF2-40B4-BE49-F238E27FC236}">
-                <a16:creationId xmlns:a16="http://schemas.microsoft.com/office/drawing/2014/main" id="{3FFDAB10-E5B4-4345-B951-86D8D1E215CC}"/>
+                <a16:creationId xmlns:a16="http://schemas.microsoft.com/office/drawing/2014/main" id="{C70383B6-7C1F-4FE3-A5A6-2FCB5FFE65C6}"/>
               </a:ext>
             </a:extLst>
           </p:cNvPr>
@@ -7509,7 +7509,7 @@
           <p:cNvPr id="19" name="">
             <a:extLst xmlns:a="http://schemas.openxmlformats.org/drawingml/2006/main">
               <a:ext uri="{FF2B5EF4-FFF2-40B4-BE49-F238E27FC236}">
-                <a16:creationId xmlns:a16="http://schemas.microsoft.com/office/drawing/2014/main" id="{C2C8716D-8506-4A3F-962F-446B889CD1F1}"/>
+                <a16:creationId xmlns:a16="http://schemas.microsoft.com/office/drawing/2014/main" id="{CA427B07-D9B3-430F-B0AF-6E8F0B166657}"/>
               </a:ext>
             </a:extLst>
           </p:cNvPr>
@@ -7544,7 +7544,7 @@
           <p:cNvPr id="20" name="">
             <a:extLst xmlns:a="http://schemas.openxmlformats.org/drawingml/2006/main">
               <a:ext uri="{FF2B5EF4-FFF2-40B4-BE49-F238E27FC236}">
-                <a16:creationId xmlns:a16="http://schemas.microsoft.com/office/drawing/2014/main" id="{B7BD98E0-D516-4EC9-8FC5-66436298FD30}"/>
+                <a16:creationId xmlns:a16="http://schemas.microsoft.com/office/drawing/2014/main" id="{CF4BF062-FA2C-4E4F-A053-E5FD183E121D}"/>
               </a:ext>
             </a:extLst>
           </p:cNvPr>
@@ -7611,7 +7611,7 @@
           <p:cNvPr id="21" name="">
             <a:extLst xmlns:a="http://schemas.openxmlformats.org/drawingml/2006/main">
               <a:ext uri="{FF2B5EF4-FFF2-40B4-BE49-F238E27FC236}">
-                <a16:creationId xmlns:a16="http://schemas.microsoft.com/office/drawing/2014/main" id="{4D9AFF85-92FF-4A81-A606-055607476E78}"/>
+                <a16:creationId xmlns:a16="http://schemas.microsoft.com/office/drawing/2014/main" id="{80D5E5EE-8DC1-4EB1-8C2A-17228BE51E2B}"/>
               </a:ext>
             </a:extLst>
           </p:cNvPr>
@@ -7678,7 +7678,7 @@
           <p:cNvPr id="22" name="">
             <a:extLst xmlns:a="http://schemas.openxmlformats.org/drawingml/2006/main">
               <a:ext uri="{FF2B5EF4-FFF2-40B4-BE49-F238E27FC236}">
-                <a16:creationId xmlns:a16="http://schemas.microsoft.com/office/drawing/2014/main" id="{631F37D9-E106-4BB8-B29A-C11C72E17102}"/>
+                <a16:creationId xmlns:a16="http://schemas.microsoft.com/office/drawing/2014/main" id="{D9C23C42-BBF7-45FC-8957-4DA954B9ABAA}"/>
               </a:ext>
             </a:extLst>
           </p:cNvPr>
@@ -7713,7 +7713,7 @@
           <p:cNvPr id="23" name="">
             <a:extLst xmlns:a="http://schemas.openxmlformats.org/drawingml/2006/main">
               <a:ext uri="{FF2B5EF4-FFF2-40B4-BE49-F238E27FC236}">
-                <a16:creationId xmlns:a16="http://schemas.microsoft.com/office/drawing/2014/main" id="{3CF80D2D-181D-4A5B-BBDD-059F67D9084E}"/>
+                <a16:creationId xmlns:a16="http://schemas.microsoft.com/office/drawing/2014/main" id="{C55719A0-693E-4056-B745-517A7852CEA1}"/>
               </a:ext>
             </a:extLst>
           </p:cNvPr>
@@ -7780,7 +7780,7 @@
           <p:cNvPr id="24" name="">
             <a:extLst xmlns:a="http://schemas.openxmlformats.org/drawingml/2006/main">
               <a:ext uri="{FF2B5EF4-FFF2-40B4-BE49-F238E27FC236}">
-                <a16:creationId xmlns:a16="http://schemas.microsoft.com/office/drawing/2014/main" id="{2E635787-A3BF-465D-B5DC-8585236B5811}"/>
+                <a16:creationId xmlns:a16="http://schemas.microsoft.com/office/drawing/2014/main" id="{AC975909-67B6-4FDA-B60F-3CDCB50A52C0}"/>
               </a:ext>
             </a:extLst>
           </p:cNvPr>
@@ -7845,7 +7845,7 @@
     </p:spTree>
     <p:extLst>
       <p:ext uri="{BB962C8B-B14F-4D97-AF65-F5344CB8AC3E}">
-        <p14:creationId xmlns:p14="http://schemas.microsoft.com/office/powerpoint/2010/main" val="190748883"/>
+        <p14:creationId xmlns:p14="http://schemas.microsoft.com/office/powerpoint/2010/main" val="1123404727"/>
       </p:ext>
     </p:extLst>
   </p:cSld>
@@ -7876,7 +7876,7 @@
           <p:cNvPr id="26" name="">
             <a:extLst xmlns:a="http://schemas.openxmlformats.org/drawingml/2006/main">
               <a:ext uri="{FF2B5EF4-FFF2-40B4-BE49-F238E27FC236}">
-                <a16:creationId xmlns:a16="http://schemas.microsoft.com/office/drawing/2014/main" id="{0B95BB39-1884-429B-8A31-1CFB9F2AF094}"/>
+                <a16:creationId xmlns:a16="http://schemas.microsoft.com/office/drawing/2014/main" id="{4D167219-E2A3-423A-B52E-85BCECDBB808}"/>
               </a:ext>
             </a:extLst>
           </p:cNvPr>
@@ -7907,7 +7907,7 @@
           <p:cNvPr id="2" name="">
             <a:extLst xmlns:a="http://schemas.openxmlformats.org/drawingml/2006/main">
               <a:ext uri="{FF2B5EF4-FFF2-40B4-BE49-F238E27FC236}">
-                <a16:creationId xmlns:a16="http://schemas.microsoft.com/office/drawing/2014/main" id="{624630E9-648C-4E01-8AC8-FF0E71524F37}"/>
+                <a16:creationId xmlns:a16="http://schemas.microsoft.com/office/drawing/2014/main" id="{D7692155-54F9-4D66-A4A3-A3FCB5FDB4C6}"/>
               </a:ext>
             </a:extLst>
           </p:cNvPr>
@@ -7974,7 +7974,7 @@
           <p:cNvPr id="3" name="">
             <a:extLst xmlns:a="http://schemas.openxmlformats.org/drawingml/2006/main">
               <a:ext uri="{FF2B5EF4-FFF2-40B4-BE49-F238E27FC236}">
-                <a16:creationId xmlns:a16="http://schemas.microsoft.com/office/drawing/2014/main" id="{8D1D6505-D359-4EFE-875C-13B62274CE28}"/>
+                <a16:creationId xmlns:a16="http://schemas.microsoft.com/office/drawing/2014/main" id="{D1247EFE-5152-4BCC-A122-FDA4A5883B1F}"/>
               </a:ext>
             </a:extLst>
           </p:cNvPr>
@@ -8041,7 +8041,7 @@
           <p:cNvPr id="4" name="">
             <a:extLst xmlns:a="http://schemas.openxmlformats.org/drawingml/2006/main">
               <a:ext uri="{FF2B5EF4-FFF2-40B4-BE49-F238E27FC236}">
-                <a16:creationId xmlns:a16="http://schemas.microsoft.com/office/drawing/2014/main" id="{5551F1E9-D769-406B-A567-7B88E6EE7F9C}"/>
+                <a16:creationId xmlns:a16="http://schemas.microsoft.com/office/drawing/2014/main" id="{DC4D1D75-8F78-43B1-962D-AC4D6256BC4C}"/>
               </a:ext>
             </a:extLst>
           </p:cNvPr>
@@ -8072,7 +8072,7 @@
           <p:cNvPr id="5" name="">
             <a:extLst xmlns:a="http://schemas.openxmlformats.org/drawingml/2006/main">
               <a:ext uri="{FF2B5EF4-FFF2-40B4-BE49-F238E27FC236}">
-                <a16:creationId xmlns:a16="http://schemas.microsoft.com/office/drawing/2014/main" id="{C7C81379-404D-4284-93E8-A7FCC898A55A}"/>
+                <a16:creationId xmlns:a16="http://schemas.microsoft.com/office/drawing/2014/main" id="{0705FA3E-B4B4-45F2-AD95-169356F64853}"/>
               </a:ext>
             </a:extLst>
           </p:cNvPr>
@@ -8139,7 +8139,7 @@
           <p:cNvPr id="6" name="">
             <a:extLst xmlns:a="http://schemas.openxmlformats.org/drawingml/2006/main">
               <a:ext uri="{FF2B5EF4-FFF2-40B4-BE49-F238E27FC236}">
-                <a16:creationId xmlns:a16="http://schemas.microsoft.com/office/drawing/2014/main" id="{A14102FC-608C-4CBA-968C-D5157FABD1E7}"/>
+                <a16:creationId xmlns:a16="http://schemas.microsoft.com/office/drawing/2014/main" id="{8B92EE95-AF5C-41A5-840E-0932701F326D}"/>
               </a:ext>
             </a:extLst>
           </p:cNvPr>
@@ -8206,7 +8206,7 @@
           <p:cNvPr id="7" name="">
             <a:extLst xmlns:a="http://schemas.openxmlformats.org/drawingml/2006/main">
               <a:ext uri="{FF2B5EF4-FFF2-40B4-BE49-F238E27FC236}">
-                <a16:creationId xmlns:a16="http://schemas.microsoft.com/office/drawing/2014/main" id="{D3437BD2-D61A-4B85-9CBD-6A898837D981}"/>
+                <a16:creationId xmlns:a16="http://schemas.microsoft.com/office/drawing/2014/main" id="{4B79A809-C4AA-4E6B-92C0-F10607D7E9BE}"/>
               </a:ext>
             </a:extLst>
           </p:cNvPr>
@@ -8241,7 +8241,7 @@
           <p:cNvPr id="8" name="">
             <a:extLst xmlns:a="http://schemas.openxmlformats.org/drawingml/2006/main">
               <a:ext uri="{FF2B5EF4-FFF2-40B4-BE49-F238E27FC236}">
-                <a16:creationId xmlns:a16="http://schemas.microsoft.com/office/drawing/2014/main" id="{39634186-D4EE-4025-831A-909C1C9A99D6}"/>
+                <a16:creationId xmlns:a16="http://schemas.microsoft.com/office/drawing/2014/main" id="{247D5A23-AAF5-4F88-AEF2-02C0D27A6B7F}"/>
               </a:ext>
             </a:extLst>
           </p:cNvPr>
@@ -8308,7 +8308,7 @@
           <p:cNvPr id="9" name="">
             <a:extLst xmlns:a="http://schemas.openxmlformats.org/drawingml/2006/main">
               <a:ext uri="{FF2B5EF4-FFF2-40B4-BE49-F238E27FC236}">
-                <a16:creationId xmlns:a16="http://schemas.microsoft.com/office/drawing/2014/main" id="{18CF5FE0-2FD8-4378-9D30-0D3FC23E5AB9}"/>
+                <a16:creationId xmlns:a16="http://schemas.microsoft.com/office/drawing/2014/main" id="{15DD57F1-CCB4-4519-9ADF-F7813970634B}"/>
               </a:ext>
             </a:extLst>
           </p:cNvPr>
@@ -8375,7 +8375,7 @@
           <p:cNvPr id="10" name="">
             <a:extLst xmlns:a="http://schemas.openxmlformats.org/drawingml/2006/main">
               <a:ext uri="{FF2B5EF4-FFF2-40B4-BE49-F238E27FC236}">
-                <a16:creationId xmlns:a16="http://schemas.microsoft.com/office/drawing/2014/main" id="{8033F6F6-DAB1-4A7D-A2B0-A1C83E4E8CE2}"/>
+                <a16:creationId xmlns:a16="http://schemas.microsoft.com/office/drawing/2014/main" id="{CE012C4B-6064-4D42-A127-5F893365E993}"/>
               </a:ext>
             </a:extLst>
           </p:cNvPr>
@@ -8410,7 +8410,7 @@
           <p:cNvPr id="11" name="">
             <a:extLst xmlns:a="http://schemas.openxmlformats.org/drawingml/2006/main">
               <a:ext uri="{FF2B5EF4-FFF2-40B4-BE49-F238E27FC236}">
-                <a16:creationId xmlns:a16="http://schemas.microsoft.com/office/drawing/2014/main" id="{354F0888-E7EB-487B-9418-8AC93C516290}"/>
+                <a16:creationId xmlns:a16="http://schemas.microsoft.com/office/drawing/2014/main" id="{87510984-A797-4E7D-8E77-CEF1C2B8A4E0}"/>
               </a:ext>
             </a:extLst>
           </p:cNvPr>
@@ -8477,7 +8477,7 @@
           <p:cNvPr id="12" name="">
             <a:extLst xmlns:a="http://schemas.openxmlformats.org/drawingml/2006/main">
               <a:ext uri="{FF2B5EF4-FFF2-40B4-BE49-F238E27FC236}">
-                <a16:creationId xmlns:a16="http://schemas.microsoft.com/office/drawing/2014/main" id="{D2372BA0-68B8-47B3-944C-754F9AC64BF0}"/>
+                <a16:creationId xmlns:a16="http://schemas.microsoft.com/office/drawing/2014/main" id="{82F83F84-1C1A-4FBB-BC66-0882F11C05FF}"/>
               </a:ext>
             </a:extLst>
           </p:cNvPr>
@@ -8544,7 +8544,7 @@
           <p:cNvPr id="13" name="">
             <a:extLst xmlns:a="http://schemas.openxmlformats.org/drawingml/2006/main">
               <a:ext uri="{FF2B5EF4-FFF2-40B4-BE49-F238E27FC236}">
-                <a16:creationId xmlns:a16="http://schemas.microsoft.com/office/drawing/2014/main" id="{C008FFB6-0628-44CE-8FBC-9984A796AD90}"/>
+                <a16:creationId xmlns:a16="http://schemas.microsoft.com/office/drawing/2014/main" id="{9B38754D-021F-4B04-8A20-EAD2BAF116F9}"/>
               </a:ext>
             </a:extLst>
           </p:cNvPr>
@@ -8579,7 +8579,7 @@
           <p:cNvPr id="14" name="">
             <a:extLst xmlns:a="http://schemas.openxmlformats.org/drawingml/2006/main">
               <a:ext uri="{FF2B5EF4-FFF2-40B4-BE49-F238E27FC236}">
-                <a16:creationId xmlns:a16="http://schemas.microsoft.com/office/drawing/2014/main" id="{DC624486-35E2-4FB8-9F57-3AC9F6D87FA7}"/>
+                <a16:creationId xmlns:a16="http://schemas.microsoft.com/office/drawing/2014/main" id="{BC9C39C4-D6FA-4A65-9625-EADFE013666B}"/>
               </a:ext>
             </a:extLst>
           </p:cNvPr>
@@ -8646,7 +8646,7 @@
           <p:cNvPr id="15" name="">
             <a:extLst xmlns:a="http://schemas.openxmlformats.org/drawingml/2006/main">
               <a:ext uri="{FF2B5EF4-FFF2-40B4-BE49-F238E27FC236}">
-                <a16:creationId xmlns:a16="http://schemas.microsoft.com/office/drawing/2014/main" id="{322709C3-5079-4A54-9CA1-FA03F55D353D}"/>
+                <a16:creationId xmlns:a16="http://schemas.microsoft.com/office/drawing/2014/main" id="{DDA9E4FB-94A0-4913-B88C-1045DCE9A118}"/>
               </a:ext>
             </a:extLst>
           </p:cNvPr>
@@ -8713,7 +8713,7 @@
           <p:cNvPr id="16" name="">
             <a:extLst xmlns:a="http://schemas.openxmlformats.org/drawingml/2006/main">
               <a:ext uri="{FF2B5EF4-FFF2-40B4-BE49-F238E27FC236}">
-                <a16:creationId xmlns:a16="http://schemas.microsoft.com/office/drawing/2014/main" id="{3C3EC312-0557-4FEB-9396-BD3CC80DB243}"/>
+                <a16:creationId xmlns:a16="http://schemas.microsoft.com/office/drawing/2014/main" id="{8BDE5AEA-7D84-4A38-8E25-0DD903CD2BC4}"/>
               </a:ext>
             </a:extLst>
           </p:cNvPr>
@@ -8748,7 +8748,7 @@
           <p:cNvPr id="17" name="">
             <a:extLst xmlns:a="http://schemas.openxmlformats.org/drawingml/2006/main">
               <a:ext uri="{FF2B5EF4-FFF2-40B4-BE49-F238E27FC236}">
-                <a16:creationId xmlns:a16="http://schemas.microsoft.com/office/drawing/2014/main" id="{0A36037C-B20D-4E28-BC78-D788D5B5A8D4}"/>
+                <a16:creationId xmlns:a16="http://schemas.microsoft.com/office/drawing/2014/main" id="{2B401377-4551-4A9C-9F7D-DBD4835CF522}"/>
               </a:ext>
             </a:extLst>
           </p:cNvPr>
@@ -8815,7 +8815,7 @@
           <p:cNvPr id="18" name="">
             <a:extLst xmlns:a="http://schemas.openxmlformats.org/drawingml/2006/main">
               <a:ext uri="{FF2B5EF4-FFF2-40B4-BE49-F238E27FC236}">
-                <a16:creationId xmlns:a16="http://schemas.microsoft.com/office/drawing/2014/main" id="{83CECBF4-3F27-498E-90F1-DAC7B8219621}"/>
+                <a16:creationId xmlns:a16="http://schemas.microsoft.com/office/drawing/2014/main" id="{FDAFFC83-52C4-481A-94E7-8AA9AD3E7EAA}"/>
               </a:ext>
             </a:extLst>
           </p:cNvPr>
@@ -8882,7 +8882,7 @@
           <p:cNvPr id="19" name="">
             <a:extLst xmlns:a="http://schemas.openxmlformats.org/drawingml/2006/main">
               <a:ext uri="{FF2B5EF4-FFF2-40B4-BE49-F238E27FC236}">
-                <a16:creationId xmlns:a16="http://schemas.microsoft.com/office/drawing/2014/main" id="{7DAC4A7D-2382-44BA-8166-FEBCF44445B1}"/>
+                <a16:creationId xmlns:a16="http://schemas.microsoft.com/office/drawing/2014/main" id="{5D17F02B-EBD0-4E1E-9577-6622BF6419B3}"/>
               </a:ext>
             </a:extLst>
           </p:cNvPr>
@@ -8949,7 +8949,7 @@
           <p:cNvPr id="20" name="">
             <a:extLst xmlns:a="http://schemas.openxmlformats.org/drawingml/2006/main">
               <a:ext uri="{FF2B5EF4-FFF2-40B4-BE49-F238E27FC236}">
-                <a16:creationId xmlns:a16="http://schemas.microsoft.com/office/drawing/2014/main" id="{2283EDB2-4462-45C3-A257-CDA364DE9B84}"/>
+                <a16:creationId xmlns:a16="http://schemas.microsoft.com/office/drawing/2014/main" id="{EDD05AEB-5314-4B9E-AE4B-434A9E55FE84}"/>
               </a:ext>
             </a:extLst>
           </p:cNvPr>
@@ -9016,7 +9016,7 @@
           <p:cNvPr id="21" name="">
             <a:extLst xmlns:a="http://schemas.openxmlformats.org/drawingml/2006/main">
               <a:ext uri="{FF2B5EF4-FFF2-40B4-BE49-F238E27FC236}">
-                <a16:creationId xmlns:a16="http://schemas.microsoft.com/office/drawing/2014/main" id="{6ABD9813-3C93-4348-89BE-9BE7D4C6FF30}"/>
+                <a16:creationId xmlns:a16="http://schemas.microsoft.com/office/drawing/2014/main" id="{88BECB2F-D9CC-4806-9919-3E0D1054BF10}"/>
               </a:ext>
             </a:extLst>
           </p:cNvPr>
@@ -9083,7 +9083,7 @@
           <p:cNvPr id="22" name="">
             <a:extLst xmlns:a="http://schemas.openxmlformats.org/drawingml/2006/main">
               <a:ext uri="{FF2B5EF4-FFF2-40B4-BE49-F238E27FC236}">
-                <a16:creationId xmlns:a16="http://schemas.microsoft.com/office/drawing/2014/main" id="{E84654EE-8637-4246-879E-61DA8F1B3A22}"/>
+                <a16:creationId xmlns:a16="http://schemas.microsoft.com/office/drawing/2014/main" id="{823B8007-2741-4A75-A4E3-49680FA8DA75}"/>
               </a:ext>
             </a:extLst>
           </p:cNvPr>
@@ -9150,7 +9150,7 @@
           <p:cNvPr id="23" name="">
             <a:extLst xmlns:a="http://schemas.openxmlformats.org/drawingml/2006/main">
               <a:ext uri="{FF2B5EF4-FFF2-40B4-BE49-F238E27FC236}">
-                <a16:creationId xmlns:a16="http://schemas.microsoft.com/office/drawing/2014/main" id="{353B4729-CE73-422E-8047-B41D97A6D462}"/>
+                <a16:creationId xmlns:a16="http://schemas.microsoft.com/office/drawing/2014/main" id="{B9128FAB-B323-4265-8E69-0603C75F55B2}"/>
               </a:ext>
             </a:extLst>
           </p:cNvPr>
@@ -9217,7 +9217,7 @@
           <p:cNvPr id="24" name="">
             <a:extLst xmlns:a="http://schemas.openxmlformats.org/drawingml/2006/main">
               <a:ext uri="{FF2B5EF4-FFF2-40B4-BE49-F238E27FC236}">
-                <a16:creationId xmlns:a16="http://schemas.microsoft.com/office/drawing/2014/main" id="{4718239F-6EC8-424B-BCD4-3CBF01F49297}"/>
+                <a16:creationId xmlns:a16="http://schemas.microsoft.com/office/drawing/2014/main" id="{43CA93C2-92FE-4FCF-9BEF-38C5AF8C7C89}"/>
               </a:ext>
             </a:extLst>
           </p:cNvPr>
@@ -9284,7 +9284,7 @@
           <p:cNvPr id="25" name="">
             <a:extLst xmlns:a="http://schemas.openxmlformats.org/drawingml/2006/main">
               <a:ext uri="{FF2B5EF4-FFF2-40B4-BE49-F238E27FC236}">
-                <a16:creationId xmlns:a16="http://schemas.microsoft.com/office/drawing/2014/main" id="{6CA7CE5D-1ECE-425B-BF90-C6A48F7C6BE1}"/>
+                <a16:creationId xmlns:a16="http://schemas.microsoft.com/office/drawing/2014/main" id="{3CF1188C-C7B1-4E83-8FCF-29D19E60D316}"/>
               </a:ext>
             </a:extLst>
           </p:cNvPr>
@@ -9349,7 +9349,7 @@
     </p:spTree>
     <p:extLst>
       <p:ext uri="{BB962C8B-B14F-4D97-AF65-F5344CB8AC3E}">
-        <p14:creationId xmlns:p14="http://schemas.microsoft.com/office/powerpoint/2010/main" val="234711161"/>
+        <p14:creationId xmlns:p14="http://schemas.microsoft.com/office/powerpoint/2010/main" val="547405110"/>
       </p:ext>
     </p:extLst>
   </p:cSld>

</xml_diff>

<commit_message>
Reduce library demo dataset to course minimums
</commit_message>
<xml_diff>
--- a/ProjectPresentation.pptx
+++ b/ProjectPresentation.pptx
@@ -2,17 +2,17 @@
 <file path=ppt/presentation.xml><?xml version="1.0" encoding="utf-8"?>
 <p:presentation xmlns:p="http://schemas.openxmlformats.org/presentationml/2006/main">
   <p:sldMasterIdLst>
-    <p:sldMasterId xmlns:r="http://schemas.openxmlformats.org/officeDocument/2006/relationships" id="2147483648" r:id="Rec50b91c985b44b1"/>
+    <p:sldMasterId xmlns:r="http://schemas.openxmlformats.org/officeDocument/2006/relationships" id="2147483648" r:id="Re9e77775d7b947ab"/>
   </p:sldMasterIdLst>
   <p:notesMasterIdLst>
-    <p:notesMasterId xmlns:r="http://schemas.openxmlformats.org/officeDocument/2006/relationships" r:id="R2928b74f5dfe44a8"/>
+    <p:notesMasterId xmlns:r="http://schemas.openxmlformats.org/officeDocument/2006/relationships" r:id="Rfebf202fde194b20"/>
   </p:notesMasterIdLst>
   <p:sldIdLst>
-    <p:sldId xmlns:r="http://schemas.openxmlformats.org/officeDocument/2006/relationships" id="256" r:id="Rd9f3850555a240d6"/>
-    <p:sldId xmlns:r="http://schemas.openxmlformats.org/officeDocument/2006/relationships" id="257" r:id="Re21e4060bd9c4d6b"/>
-    <p:sldId xmlns:r="http://schemas.openxmlformats.org/officeDocument/2006/relationships" id="258" r:id="Raf0e610d2c094e82"/>
-    <p:sldId xmlns:r="http://schemas.openxmlformats.org/officeDocument/2006/relationships" id="259" r:id="Rab44a220c1d0415f"/>
-    <p:sldId xmlns:r="http://schemas.openxmlformats.org/officeDocument/2006/relationships" id="260" r:id="Rc7f86803b70546d1"/>
+    <p:sldId xmlns:r="http://schemas.openxmlformats.org/officeDocument/2006/relationships" id="256" r:id="Rd4f7766ff90541a9"/>
+    <p:sldId xmlns:r="http://schemas.openxmlformats.org/officeDocument/2006/relationships" id="257" r:id="R442957c3381a4d28"/>
+    <p:sldId xmlns:r="http://schemas.openxmlformats.org/officeDocument/2006/relationships" id="258" r:id="R2f089c6d599b4e6d"/>
+    <p:sldId xmlns:r="http://schemas.openxmlformats.org/officeDocument/2006/relationships" id="259" r:id="R5cb8973b92844331"/>
+    <p:sldId xmlns:r="http://schemas.openxmlformats.org/officeDocument/2006/relationships" id="260" r:id="Rd17742356c39446a"/>
   </p:sldIdLst>
   <p:sldSz cx="12192000" cy="6858000"/>
   <p:notesSz cx="6858000" cy="9144000"/>
@@ -753,7 +753,7 @@
           <p:cNvPr id="3" name="Title">
             <a:extLst xmlns:a="http://schemas.openxmlformats.org/drawingml/2006/main">
               <a:ext uri="{FF2B5EF4-FFF2-40B4-BE49-F238E27FC236}">
-                <a16:creationId xmlns:a16="http://schemas.microsoft.com/office/drawing/2014/main" id="{93B8D12C-04CC-443C-991E-6A5FE3EE8672}"/>
+                <a16:creationId xmlns:a16="http://schemas.microsoft.com/office/drawing/2014/main" id="{EDB41274-CA9F-4428-8794-0BEB47B3F5F1}"/>
               </a:ext>
             </a:extLst>
           </p:cNvPr>
@@ -910,7 +910,7 @@
           <p:cNvPr id="2" name="Subtitle">
             <a:extLst xmlns:a="http://schemas.openxmlformats.org/drawingml/2006/main">
               <a:ext uri="{FF2B5EF4-FFF2-40B4-BE49-F238E27FC236}">
-                <a16:creationId xmlns:a16="http://schemas.microsoft.com/office/drawing/2014/main" id="{232DB7AD-3160-41FC-BDBC-981B009B8C4D}"/>
+                <a16:creationId xmlns:a16="http://schemas.microsoft.com/office/drawing/2014/main" id="{79F65E7F-E669-4EF8-989E-4AF1DE8823F4}"/>
               </a:ext>
             </a:extLst>
           </p:cNvPr>
@@ -1084,7 +1084,7 @@
           <p:cNvPr id="2" name="Section title">
             <a:extLst xmlns:a="http://schemas.openxmlformats.org/drawingml/2006/main">
               <a:ext uri="{FF2B5EF4-FFF2-40B4-BE49-F238E27FC236}">
-                <a16:creationId xmlns:a16="http://schemas.microsoft.com/office/drawing/2014/main" id="{F6BA8921-33EC-4D14-82EF-8B90ADD67B6B}"/>
+                <a16:creationId xmlns:a16="http://schemas.microsoft.com/office/drawing/2014/main" id="{ABFFEAE4-8857-4010-A9A9-D43A475FEF2B}"/>
               </a:ext>
             </a:extLst>
           </p:cNvPr>
@@ -1258,7 +1258,7 @@
           <p:cNvPr id="3" name="Title">
             <a:extLst xmlns:a="http://schemas.openxmlformats.org/drawingml/2006/main">
               <a:ext uri="{FF2B5EF4-FFF2-40B4-BE49-F238E27FC236}">
-                <a16:creationId xmlns:a16="http://schemas.microsoft.com/office/drawing/2014/main" id="{45556E14-4680-47D3-8E66-F55C00DFCD05}"/>
+                <a16:creationId xmlns:a16="http://schemas.microsoft.com/office/drawing/2014/main" id="{888D38F6-5536-4781-AA9B-851EF6C60711}"/>
               </a:ext>
             </a:extLst>
           </p:cNvPr>
@@ -1415,7 +1415,7 @@
           <p:cNvPr id="2" name="Body">
             <a:extLst xmlns:a="http://schemas.openxmlformats.org/drawingml/2006/main">
               <a:ext uri="{FF2B5EF4-FFF2-40B4-BE49-F238E27FC236}">
-                <a16:creationId xmlns:a16="http://schemas.microsoft.com/office/drawing/2014/main" id="{F0941556-1477-4D93-A62E-6A872608674E}"/>
+                <a16:creationId xmlns:a16="http://schemas.microsoft.com/office/drawing/2014/main" id="{A7EEA21A-4DB7-46A1-A553-2D281AA549B2}"/>
               </a:ext>
             </a:extLst>
           </p:cNvPr>
@@ -1589,7 +1589,7 @@
           <p:cNvPr id="4" name="Title">
             <a:extLst xmlns:a="http://schemas.openxmlformats.org/drawingml/2006/main">
               <a:ext uri="{FF2B5EF4-FFF2-40B4-BE49-F238E27FC236}">
-                <a16:creationId xmlns:a16="http://schemas.microsoft.com/office/drawing/2014/main" id="{0F2896AC-52FC-426A-8B32-CD05EE156BD6}"/>
+                <a16:creationId xmlns:a16="http://schemas.microsoft.com/office/drawing/2014/main" id="{5BD9229B-8D8C-4ED5-8D79-EDA0B5A95EBB}"/>
               </a:ext>
             </a:extLst>
           </p:cNvPr>
@@ -1746,7 +1746,7 @@
           <p:cNvPr id="2" name="Left column">
             <a:extLst xmlns:a="http://schemas.openxmlformats.org/drawingml/2006/main">
               <a:ext uri="{FF2B5EF4-FFF2-40B4-BE49-F238E27FC236}">
-                <a16:creationId xmlns:a16="http://schemas.microsoft.com/office/drawing/2014/main" id="{48C5A5B5-8C67-453B-8AF2-5C5A14FF646E}"/>
+                <a16:creationId xmlns:a16="http://schemas.microsoft.com/office/drawing/2014/main" id="{1D6ACF74-4B37-42FE-B662-302CE51E8F1E}"/>
               </a:ext>
             </a:extLst>
           </p:cNvPr>
@@ -1903,7 +1903,7 @@
           <p:cNvPr id="3" name="Right column">
             <a:extLst xmlns:a="http://schemas.openxmlformats.org/drawingml/2006/main">
               <a:ext uri="{FF2B5EF4-FFF2-40B4-BE49-F238E27FC236}">
-                <a16:creationId xmlns:a16="http://schemas.microsoft.com/office/drawing/2014/main" id="{A1F4D010-BFC9-4005-84E0-9E781EC943F4}"/>
+                <a16:creationId xmlns:a16="http://schemas.microsoft.com/office/drawing/2014/main" id="{7B7DF57D-25AB-4D04-A7C9-D1152B829CB8}"/>
               </a:ext>
             </a:extLst>
           </p:cNvPr>
@@ -2077,7 +2077,7 @@
           <p:cNvPr id="3" name="Title">
             <a:extLst xmlns:a="http://schemas.openxmlformats.org/drawingml/2006/main">
               <a:ext uri="{FF2B5EF4-FFF2-40B4-BE49-F238E27FC236}">
-                <a16:creationId xmlns:a16="http://schemas.microsoft.com/office/drawing/2014/main" id="{21D9482C-EEDB-478D-A3C6-484EE304B84E}"/>
+                <a16:creationId xmlns:a16="http://schemas.microsoft.com/office/drawing/2014/main" id="{416FBBC0-FD59-4E3D-99AD-071A05AC0B70}"/>
               </a:ext>
             </a:extLst>
           </p:cNvPr>
@@ -2234,7 +2234,7 @@
           <p:cNvPr id="2" name="Left column">
             <a:extLst xmlns:a="http://schemas.openxmlformats.org/drawingml/2006/main">
               <a:ext uri="{FF2B5EF4-FFF2-40B4-BE49-F238E27FC236}">
-                <a16:creationId xmlns:a16="http://schemas.microsoft.com/office/drawing/2014/main" id="{136CA029-2E24-4AAC-8A66-3DFDB930D040}"/>
+                <a16:creationId xmlns:a16="http://schemas.microsoft.com/office/drawing/2014/main" id="{8AC14F1F-6D3A-4564-B1A9-0BD81C786CDC}"/>
               </a:ext>
             </a:extLst>
           </p:cNvPr>
@@ -2429,12 +2429,12 @@
   </p:cSld>
   <p:clrMap bg1="lt1" tx1="dk1" bg2="lt2" tx2="dk2" accent1="accent1" accent2="accent2" accent3="accent3" accent4="accent4" accent5="accent5" accent6="accent6" hlink="hlink" folHlink="folHlink"/>
   <p:sldLayoutIdLst>
-    <p:sldLayoutId xmlns:r="http://schemas.openxmlformats.org/officeDocument/2006/relationships" id="2147483649" r:id="R33b40489e2df4d4e"/>
-    <p:sldLayoutId xmlns:r="http://schemas.openxmlformats.org/officeDocument/2006/relationships" id="2147483650" r:id="Rbb4df6d1ebf74fc1"/>
-    <p:sldLayoutId xmlns:r="http://schemas.openxmlformats.org/officeDocument/2006/relationships" id="2147483651" r:id="Ref893fe98ab943a5"/>
-    <p:sldLayoutId xmlns:r="http://schemas.openxmlformats.org/officeDocument/2006/relationships" id="2147483652" r:id="R8a220cf54e814189"/>
-    <p:sldLayoutId xmlns:r="http://schemas.openxmlformats.org/officeDocument/2006/relationships" id="2147483653" r:id="Rcfd098ea06254919"/>
-    <p:sldLayoutId xmlns:r="http://schemas.openxmlformats.org/officeDocument/2006/relationships" id="2147483654" r:id="Rb2efee4047fb410e"/>
+    <p:sldLayoutId xmlns:r="http://schemas.openxmlformats.org/officeDocument/2006/relationships" id="2147483649" r:id="Rfd95621726e74bc9"/>
+    <p:sldLayoutId xmlns:r="http://schemas.openxmlformats.org/officeDocument/2006/relationships" id="2147483650" r:id="Rc3d80859b601433e"/>
+    <p:sldLayoutId xmlns:r="http://schemas.openxmlformats.org/officeDocument/2006/relationships" id="2147483651" r:id="Rd7778a64fde14f7b"/>
+    <p:sldLayoutId xmlns:r="http://schemas.openxmlformats.org/officeDocument/2006/relationships" id="2147483652" r:id="R0a2d1bb1a1f74d00"/>
+    <p:sldLayoutId xmlns:r="http://schemas.openxmlformats.org/officeDocument/2006/relationships" id="2147483653" r:id="Ra108662cd648499a"/>
+    <p:sldLayoutId xmlns:r="http://schemas.openxmlformats.org/officeDocument/2006/relationships" id="2147483654" r:id="R1a9cf30190024562"/>
   </p:sldLayoutIdLst>
   <p:txStyles>
     <p:titleStyle>
@@ -2985,7 +2985,7 @@
           <p:cNvPr id="13" name="">
             <a:extLst xmlns:a="http://schemas.openxmlformats.org/drawingml/2006/main">
               <a:ext uri="{FF2B5EF4-FFF2-40B4-BE49-F238E27FC236}">
-                <a16:creationId xmlns:a16="http://schemas.microsoft.com/office/drawing/2014/main" id="{10B5998A-BEC7-4F91-9F1C-F78BF8D614EE}"/>
+                <a16:creationId xmlns:a16="http://schemas.microsoft.com/office/drawing/2014/main" id="{4D94868F-9C8C-42F3-A203-DABA0144303D}"/>
               </a:ext>
             </a:extLst>
           </p:cNvPr>
@@ -3016,7 +3016,7 @@
           <p:cNvPr id="2" name="">
             <a:extLst xmlns:a="http://schemas.openxmlformats.org/drawingml/2006/main">
               <a:ext uri="{FF2B5EF4-FFF2-40B4-BE49-F238E27FC236}">
-                <a16:creationId xmlns:a16="http://schemas.microsoft.com/office/drawing/2014/main" id="{D5BAC2DE-C1AC-4CC9-AE0D-1F88D1A9CBDF}"/>
+                <a16:creationId xmlns:a16="http://schemas.microsoft.com/office/drawing/2014/main" id="{25A24CEA-331D-40F9-BDA2-11CA7F110C9E}"/>
               </a:ext>
             </a:extLst>
           </p:cNvPr>
@@ -3083,7 +3083,7 @@
           <p:cNvPr id="3" name="">
             <a:extLst xmlns:a="http://schemas.openxmlformats.org/drawingml/2006/main">
               <a:ext uri="{FF2B5EF4-FFF2-40B4-BE49-F238E27FC236}">
-                <a16:creationId xmlns:a16="http://schemas.microsoft.com/office/drawing/2014/main" id="{BB712283-B78C-43EC-BB39-7BC00BAD9C69}"/>
+                <a16:creationId xmlns:a16="http://schemas.microsoft.com/office/drawing/2014/main" id="{A08AB7DD-41A0-4AE9-BA00-E98A95AFF602}"/>
               </a:ext>
             </a:extLst>
           </p:cNvPr>
@@ -3173,7 +3173,7 @@
           <p:cNvPr id="4" name="">
             <a:extLst xmlns:a="http://schemas.openxmlformats.org/drawingml/2006/main">
               <a:ext uri="{FF2B5EF4-FFF2-40B4-BE49-F238E27FC236}">
-                <a16:creationId xmlns:a16="http://schemas.microsoft.com/office/drawing/2014/main" id="{78753BDB-059B-4079-BB3D-337787C3CED3}"/>
+                <a16:creationId xmlns:a16="http://schemas.microsoft.com/office/drawing/2014/main" id="{8F733DED-D797-4917-A36C-58A9E77D1751}"/>
               </a:ext>
             </a:extLst>
           </p:cNvPr>
@@ -3240,7 +3240,7 @@
           <p:cNvPr id="5" name="">
             <a:extLst xmlns:a="http://schemas.openxmlformats.org/drawingml/2006/main">
               <a:ext uri="{FF2B5EF4-FFF2-40B4-BE49-F238E27FC236}">
-                <a16:creationId xmlns:a16="http://schemas.microsoft.com/office/drawing/2014/main" id="{8A974150-6C72-4463-99E4-C3586AF6BBEF}"/>
+                <a16:creationId xmlns:a16="http://schemas.microsoft.com/office/drawing/2014/main" id="{ECB4D2F4-21F6-4A7F-BE08-FA4CB512B9B8}"/>
               </a:ext>
             </a:extLst>
           </p:cNvPr>
@@ -3307,7 +3307,7 @@
           <p:cNvPr id="6" name="">
             <a:extLst xmlns:a="http://schemas.openxmlformats.org/drawingml/2006/main">
               <a:ext uri="{FF2B5EF4-FFF2-40B4-BE49-F238E27FC236}">
-                <a16:creationId xmlns:a16="http://schemas.microsoft.com/office/drawing/2014/main" id="{7FC6CA81-229F-4793-B53C-454D134FB7BB}"/>
+                <a16:creationId xmlns:a16="http://schemas.microsoft.com/office/drawing/2014/main" id="{C0B7D777-DA62-4E4C-BAF6-B048B755CAC1}"/>
               </a:ext>
             </a:extLst>
           </p:cNvPr>
@@ -3374,7 +3374,7 @@
           <p:cNvPr id="7" name="">
             <a:extLst xmlns:a="http://schemas.openxmlformats.org/drawingml/2006/main">
               <a:ext uri="{FF2B5EF4-FFF2-40B4-BE49-F238E27FC236}">
-                <a16:creationId xmlns:a16="http://schemas.microsoft.com/office/drawing/2014/main" id="{30870861-EE1F-47B6-B2BB-83D4228A23D3}"/>
+                <a16:creationId xmlns:a16="http://schemas.microsoft.com/office/drawing/2014/main" id="{C3A6224F-5A68-455E-AF5A-68606F8F437B}"/>
               </a:ext>
             </a:extLst>
           </p:cNvPr>
@@ -3407,7 +3407,7 @@
           <p:cNvPr id="8" name="">
             <a:extLst xmlns:a="http://schemas.openxmlformats.org/drawingml/2006/main">
               <a:ext uri="{FF2B5EF4-FFF2-40B4-BE49-F238E27FC236}">
-                <a16:creationId xmlns:a16="http://schemas.microsoft.com/office/drawing/2014/main" id="{F8910D0E-B67B-4B8C-A57E-5937AA767D80}"/>
+                <a16:creationId xmlns:a16="http://schemas.microsoft.com/office/drawing/2014/main" id="{1ED3E419-06E9-4C72-9DBE-85A4064D7470}"/>
               </a:ext>
             </a:extLst>
           </p:cNvPr>
@@ -3440,7 +3440,7 @@
           <p:cNvPr id="9" name="">
             <a:extLst xmlns:a="http://schemas.openxmlformats.org/drawingml/2006/main">
               <a:ext uri="{FF2B5EF4-FFF2-40B4-BE49-F238E27FC236}">
-                <a16:creationId xmlns:a16="http://schemas.microsoft.com/office/drawing/2014/main" id="{73FB4BDF-87C2-4A41-BB09-B968ED4BCB6F}"/>
+                <a16:creationId xmlns:a16="http://schemas.microsoft.com/office/drawing/2014/main" id="{8A6DC2CD-6AB1-4BC1-AC60-3884A84C2D5A}"/>
               </a:ext>
             </a:extLst>
           </p:cNvPr>
@@ -3473,7 +3473,7 @@
           <p:cNvPr id="10" name="">
             <a:extLst xmlns:a="http://schemas.openxmlformats.org/drawingml/2006/main">
               <a:ext uri="{FF2B5EF4-FFF2-40B4-BE49-F238E27FC236}">
-                <a16:creationId xmlns:a16="http://schemas.microsoft.com/office/drawing/2014/main" id="{4008E3CD-A7A4-4333-BA9F-C7E1B078D3B5}"/>
+                <a16:creationId xmlns:a16="http://schemas.microsoft.com/office/drawing/2014/main" id="{455B82A0-5345-4F49-875A-C2E4C6EB2467}"/>
               </a:ext>
             </a:extLst>
           </p:cNvPr>
@@ -3506,7 +3506,7 @@
           <p:cNvPr id="11" name="">
             <a:extLst xmlns:a="http://schemas.openxmlformats.org/drawingml/2006/main">
               <a:ext uri="{FF2B5EF4-FFF2-40B4-BE49-F238E27FC236}">
-                <a16:creationId xmlns:a16="http://schemas.microsoft.com/office/drawing/2014/main" id="{F5A8E9F1-5A18-4B3A-B58A-05923A137EAE}"/>
+                <a16:creationId xmlns:a16="http://schemas.microsoft.com/office/drawing/2014/main" id="{07BCE342-BB1D-49C0-B5DA-878FF53C352D}"/>
               </a:ext>
             </a:extLst>
           </p:cNvPr>
@@ -3539,7 +3539,7 @@
           <p:cNvPr id="12" name="">
             <a:extLst xmlns:a="http://schemas.openxmlformats.org/drawingml/2006/main">
               <a:ext uri="{FF2B5EF4-FFF2-40B4-BE49-F238E27FC236}">
-                <a16:creationId xmlns:a16="http://schemas.microsoft.com/office/drawing/2014/main" id="{EE1EFF01-6CA5-4392-99BE-04D6EF3CB94A}"/>
+                <a16:creationId xmlns:a16="http://schemas.microsoft.com/office/drawing/2014/main" id="{93A13BDE-C5DA-41A4-9E24-997F30EB5AD0}"/>
               </a:ext>
             </a:extLst>
           </p:cNvPr>
@@ -3604,7 +3604,7 @@
     </p:spTree>
     <p:extLst>
       <p:ext uri="{BB962C8B-B14F-4D97-AF65-F5344CB8AC3E}">
-        <p14:creationId xmlns:p14="http://schemas.microsoft.com/office/powerpoint/2010/main" val="1660376168"/>
+        <p14:creationId xmlns:p14="http://schemas.microsoft.com/office/powerpoint/2010/main" val="507102478"/>
       </p:ext>
     </p:extLst>
   </p:cSld>
@@ -3635,7 +3635,7 @@
           <p:cNvPr id="26" name="">
             <a:extLst xmlns:a="http://schemas.openxmlformats.org/drawingml/2006/main">
               <a:ext uri="{FF2B5EF4-FFF2-40B4-BE49-F238E27FC236}">
-                <a16:creationId xmlns:a16="http://schemas.microsoft.com/office/drawing/2014/main" id="{6DF3EDD5-2755-4719-BC4F-0052357B7D1A}"/>
+                <a16:creationId xmlns:a16="http://schemas.microsoft.com/office/drawing/2014/main" id="{A8465022-E4DF-46EF-A2E4-508F97D47B7F}"/>
               </a:ext>
             </a:extLst>
           </p:cNvPr>
@@ -3666,7 +3666,7 @@
           <p:cNvPr id="2" name="">
             <a:extLst xmlns:a="http://schemas.openxmlformats.org/drawingml/2006/main">
               <a:ext uri="{FF2B5EF4-FFF2-40B4-BE49-F238E27FC236}">
-                <a16:creationId xmlns:a16="http://schemas.microsoft.com/office/drawing/2014/main" id="{7A2113B1-FD5D-41BB-B40B-099725292A83}"/>
+                <a16:creationId xmlns:a16="http://schemas.microsoft.com/office/drawing/2014/main" id="{CD584D34-D015-42BD-9FAB-012E7F3D4F0A}"/>
               </a:ext>
             </a:extLst>
           </p:cNvPr>
@@ -3733,7 +3733,7 @@
           <p:cNvPr id="3" name="">
             <a:extLst xmlns:a="http://schemas.openxmlformats.org/drawingml/2006/main">
               <a:ext uri="{FF2B5EF4-FFF2-40B4-BE49-F238E27FC236}">
-                <a16:creationId xmlns:a16="http://schemas.microsoft.com/office/drawing/2014/main" id="{2D9235FF-9C28-4739-AC5D-D9EFB5D5B5A8}"/>
+                <a16:creationId xmlns:a16="http://schemas.microsoft.com/office/drawing/2014/main" id="{8FF3BDB7-B014-40AC-8C07-0E7CC021719C}"/>
               </a:ext>
             </a:extLst>
           </p:cNvPr>
@@ -3800,7 +3800,7 @@
           <p:cNvPr id="4" name="">
             <a:extLst xmlns:a="http://schemas.openxmlformats.org/drawingml/2006/main">
               <a:ext uri="{FF2B5EF4-FFF2-40B4-BE49-F238E27FC236}">
-                <a16:creationId xmlns:a16="http://schemas.microsoft.com/office/drawing/2014/main" id="{9336FE93-E967-4CA1-95DB-D86F8DC57814}"/>
+                <a16:creationId xmlns:a16="http://schemas.microsoft.com/office/drawing/2014/main" id="{0BD070EA-C929-4598-9042-868B0F76A9F9}"/>
               </a:ext>
             </a:extLst>
           </p:cNvPr>
@@ -3831,7 +3831,7 @@
           <p:cNvPr id="5" name="">
             <a:extLst xmlns:a="http://schemas.openxmlformats.org/drawingml/2006/main">
               <a:ext uri="{FF2B5EF4-FFF2-40B4-BE49-F238E27FC236}">
-                <a16:creationId xmlns:a16="http://schemas.microsoft.com/office/drawing/2014/main" id="{6FE51DA6-EE05-4A98-B9C6-68B606E0E922}"/>
+                <a16:creationId xmlns:a16="http://schemas.microsoft.com/office/drawing/2014/main" id="{4929C8BF-035F-4544-91C4-00B921047562}"/>
               </a:ext>
             </a:extLst>
           </p:cNvPr>
@@ -3898,7 +3898,7 @@
           <p:cNvPr id="6" name="">
             <a:extLst xmlns:a="http://schemas.openxmlformats.org/drawingml/2006/main">
               <a:ext uri="{FF2B5EF4-FFF2-40B4-BE49-F238E27FC236}">
-                <a16:creationId xmlns:a16="http://schemas.microsoft.com/office/drawing/2014/main" id="{CF42DABA-6CB9-48FE-8322-248775EC36C6}"/>
+                <a16:creationId xmlns:a16="http://schemas.microsoft.com/office/drawing/2014/main" id="{0DD48633-5B8E-4FCC-8E97-3AFD4C75E5B1}"/>
               </a:ext>
             </a:extLst>
           </p:cNvPr>
@@ -3965,7 +3965,7 @@
           <p:cNvPr id="7" name="">
             <a:extLst xmlns:a="http://schemas.openxmlformats.org/drawingml/2006/main">
               <a:ext uri="{FF2B5EF4-FFF2-40B4-BE49-F238E27FC236}">
-                <a16:creationId xmlns:a16="http://schemas.microsoft.com/office/drawing/2014/main" id="{E43FD322-2A2A-48A9-9FC3-058791481FF1}"/>
+                <a16:creationId xmlns:a16="http://schemas.microsoft.com/office/drawing/2014/main" id="{1E8076D1-A22A-4A43-9B17-DA8534C0C6B7}"/>
               </a:ext>
             </a:extLst>
           </p:cNvPr>
@@ -3996,7 +3996,7 @@
           <p:cNvPr id="8" name="">
             <a:extLst xmlns:a="http://schemas.openxmlformats.org/drawingml/2006/main">
               <a:ext uri="{FF2B5EF4-FFF2-40B4-BE49-F238E27FC236}">
-                <a16:creationId xmlns:a16="http://schemas.microsoft.com/office/drawing/2014/main" id="{06E7F97D-582E-49C2-B0F1-5C6D31D6C36B}"/>
+                <a16:creationId xmlns:a16="http://schemas.microsoft.com/office/drawing/2014/main" id="{FDB87ABC-749A-4F75-A7D2-62B49510D188}"/>
               </a:ext>
             </a:extLst>
           </p:cNvPr>
@@ -4063,7 +4063,7 @@
           <p:cNvPr id="9" name="">
             <a:extLst xmlns:a="http://schemas.openxmlformats.org/drawingml/2006/main">
               <a:ext uri="{FF2B5EF4-FFF2-40B4-BE49-F238E27FC236}">
-                <a16:creationId xmlns:a16="http://schemas.microsoft.com/office/drawing/2014/main" id="{5052F459-864C-4235-B094-086230604E18}"/>
+                <a16:creationId xmlns:a16="http://schemas.microsoft.com/office/drawing/2014/main" id="{A101D1C6-3AA6-4E39-AD73-F5C8FABE68FB}"/>
               </a:ext>
             </a:extLst>
           </p:cNvPr>
@@ -4130,7 +4130,7 @@
           <p:cNvPr id="10" name="">
             <a:extLst xmlns:a="http://schemas.openxmlformats.org/drawingml/2006/main">
               <a:ext uri="{FF2B5EF4-FFF2-40B4-BE49-F238E27FC236}">
-                <a16:creationId xmlns:a16="http://schemas.microsoft.com/office/drawing/2014/main" id="{99BF1247-909A-477A-AB0F-35EE57BC1FD1}"/>
+                <a16:creationId xmlns:a16="http://schemas.microsoft.com/office/drawing/2014/main" id="{6A6767CB-24BE-4693-8813-F8FA294C5D77}"/>
               </a:ext>
             </a:extLst>
           </p:cNvPr>
@@ -4161,7 +4161,7 @@
           <p:cNvPr id="11" name="">
             <a:extLst xmlns:a="http://schemas.openxmlformats.org/drawingml/2006/main">
               <a:ext uri="{FF2B5EF4-FFF2-40B4-BE49-F238E27FC236}">
-                <a16:creationId xmlns:a16="http://schemas.microsoft.com/office/drawing/2014/main" id="{BB055C54-7751-4ABE-97B2-C35F9B5EA687}"/>
+                <a16:creationId xmlns:a16="http://schemas.microsoft.com/office/drawing/2014/main" id="{405A31B1-1FBD-40AA-9413-2B1C6EA49134}"/>
               </a:ext>
             </a:extLst>
           </p:cNvPr>
@@ -4228,7 +4228,7 @@
           <p:cNvPr id="12" name="">
             <a:extLst xmlns:a="http://schemas.openxmlformats.org/drawingml/2006/main">
               <a:ext uri="{FF2B5EF4-FFF2-40B4-BE49-F238E27FC236}">
-                <a16:creationId xmlns:a16="http://schemas.microsoft.com/office/drawing/2014/main" id="{26C10B4B-13F2-48C9-B3C7-C40B58D1FB19}"/>
+                <a16:creationId xmlns:a16="http://schemas.microsoft.com/office/drawing/2014/main" id="{58A823E0-6A04-4683-9320-550DA959E8D3}"/>
               </a:ext>
             </a:extLst>
           </p:cNvPr>
@@ -4295,7 +4295,7 @@
           <p:cNvPr id="13" name="">
             <a:extLst xmlns:a="http://schemas.openxmlformats.org/drawingml/2006/main">
               <a:ext uri="{FF2B5EF4-FFF2-40B4-BE49-F238E27FC236}">
-                <a16:creationId xmlns:a16="http://schemas.microsoft.com/office/drawing/2014/main" id="{DD839B5E-7492-42A4-AC9C-8127B61A53F7}"/>
+                <a16:creationId xmlns:a16="http://schemas.microsoft.com/office/drawing/2014/main" id="{B3E5DAC1-9D8F-4160-A456-CF5C50E518E6}"/>
               </a:ext>
             </a:extLst>
           </p:cNvPr>
@@ -4326,7 +4326,7 @@
           <p:cNvPr id="14" name="">
             <a:extLst xmlns:a="http://schemas.openxmlformats.org/drawingml/2006/main">
               <a:ext uri="{FF2B5EF4-FFF2-40B4-BE49-F238E27FC236}">
-                <a16:creationId xmlns:a16="http://schemas.microsoft.com/office/drawing/2014/main" id="{FB646D2F-0C8C-4692-92CA-271AEF195157}"/>
+                <a16:creationId xmlns:a16="http://schemas.microsoft.com/office/drawing/2014/main" id="{4717ED7D-E212-4CF1-8F1A-E518727B5C12}"/>
               </a:ext>
             </a:extLst>
           </p:cNvPr>
@@ -4393,7 +4393,7 @@
           <p:cNvPr id="15" name="">
             <a:extLst xmlns:a="http://schemas.openxmlformats.org/drawingml/2006/main">
               <a:ext uri="{FF2B5EF4-FFF2-40B4-BE49-F238E27FC236}">
-                <a16:creationId xmlns:a16="http://schemas.microsoft.com/office/drawing/2014/main" id="{6579F82B-CBB0-4E03-9345-34F71E6BDDEB}"/>
+                <a16:creationId xmlns:a16="http://schemas.microsoft.com/office/drawing/2014/main" id="{6D6B7647-BF2F-498C-9EAF-E7E5318C1E92}"/>
               </a:ext>
             </a:extLst>
           </p:cNvPr>
@@ -4460,7 +4460,7 @@
           <p:cNvPr id="16" name="">
             <a:extLst xmlns:a="http://schemas.openxmlformats.org/drawingml/2006/main">
               <a:ext uri="{FF2B5EF4-FFF2-40B4-BE49-F238E27FC236}">
-                <a16:creationId xmlns:a16="http://schemas.microsoft.com/office/drawing/2014/main" id="{49FB360A-B172-4201-BDE0-5DD223F0208D}"/>
+                <a16:creationId xmlns:a16="http://schemas.microsoft.com/office/drawing/2014/main" id="{52C251B0-1CE6-454D-A551-B0DE89AA28A1}"/>
               </a:ext>
             </a:extLst>
           </p:cNvPr>
@@ -4491,7 +4491,7 @@
           <p:cNvPr id="17" name="">
             <a:extLst xmlns:a="http://schemas.openxmlformats.org/drawingml/2006/main">
               <a:ext uri="{FF2B5EF4-FFF2-40B4-BE49-F238E27FC236}">
-                <a16:creationId xmlns:a16="http://schemas.microsoft.com/office/drawing/2014/main" id="{BD2E9F22-4A79-4DE7-8448-8E8610DEB7F6}"/>
+                <a16:creationId xmlns:a16="http://schemas.microsoft.com/office/drawing/2014/main" id="{22386D44-001A-4333-982A-BB2423D8291A}"/>
               </a:ext>
             </a:extLst>
           </p:cNvPr>
@@ -4558,7 +4558,7 @@
           <p:cNvPr id="18" name="">
             <a:extLst xmlns:a="http://schemas.openxmlformats.org/drawingml/2006/main">
               <a:ext uri="{FF2B5EF4-FFF2-40B4-BE49-F238E27FC236}">
-                <a16:creationId xmlns:a16="http://schemas.microsoft.com/office/drawing/2014/main" id="{EE9C5AA1-6A8C-4D80-8CC0-AED9E7A52C94}"/>
+                <a16:creationId xmlns:a16="http://schemas.microsoft.com/office/drawing/2014/main" id="{F5550535-E4DE-41D0-9426-12DDA5DD391C}"/>
               </a:ext>
             </a:extLst>
           </p:cNvPr>
@@ -4625,7 +4625,7 @@
           <p:cNvPr id="19" name="">
             <a:extLst xmlns:a="http://schemas.openxmlformats.org/drawingml/2006/main">
               <a:ext uri="{FF2B5EF4-FFF2-40B4-BE49-F238E27FC236}">
-                <a16:creationId xmlns:a16="http://schemas.microsoft.com/office/drawing/2014/main" id="{0B0717E6-C6AC-4882-83B9-9123D651E24C}"/>
+                <a16:creationId xmlns:a16="http://schemas.microsoft.com/office/drawing/2014/main" id="{4C5326F7-C3EB-4927-9CA2-2783803E7DB6}"/>
               </a:ext>
             </a:extLst>
           </p:cNvPr>
@@ -4656,7 +4656,7 @@
           <p:cNvPr id="20" name="">
             <a:extLst xmlns:a="http://schemas.openxmlformats.org/drawingml/2006/main">
               <a:ext uri="{FF2B5EF4-FFF2-40B4-BE49-F238E27FC236}">
-                <a16:creationId xmlns:a16="http://schemas.microsoft.com/office/drawing/2014/main" id="{93A957FC-E8AB-494A-BE60-71E269ADB1A0}"/>
+                <a16:creationId xmlns:a16="http://schemas.microsoft.com/office/drawing/2014/main" id="{8D0E6DBC-D43E-4FF0-A500-A3B1EEE78740}"/>
               </a:ext>
             </a:extLst>
           </p:cNvPr>
@@ -4723,7 +4723,7 @@
           <p:cNvPr id="21" name="">
             <a:extLst xmlns:a="http://schemas.openxmlformats.org/drawingml/2006/main">
               <a:ext uri="{FF2B5EF4-FFF2-40B4-BE49-F238E27FC236}">
-                <a16:creationId xmlns:a16="http://schemas.microsoft.com/office/drawing/2014/main" id="{D7BD0591-DBCA-4A50-AF87-D03BC2DF07D2}"/>
+                <a16:creationId xmlns:a16="http://schemas.microsoft.com/office/drawing/2014/main" id="{EED356E0-4837-450A-BDFF-292951A9C65D}"/>
               </a:ext>
             </a:extLst>
           </p:cNvPr>
@@ -4790,7 +4790,7 @@
           <p:cNvPr id="22" name="">
             <a:extLst xmlns:a="http://schemas.openxmlformats.org/drawingml/2006/main">
               <a:ext uri="{FF2B5EF4-FFF2-40B4-BE49-F238E27FC236}">
-                <a16:creationId xmlns:a16="http://schemas.microsoft.com/office/drawing/2014/main" id="{89460F59-8E23-469A-984A-D53FDBFC2410}"/>
+                <a16:creationId xmlns:a16="http://schemas.microsoft.com/office/drawing/2014/main" id="{F9BDCA4D-F3D6-430E-9346-B7B72AEEC8A9}"/>
               </a:ext>
             </a:extLst>
           </p:cNvPr>
@@ -4821,7 +4821,7 @@
           <p:cNvPr id="23" name="">
             <a:extLst xmlns:a="http://schemas.openxmlformats.org/drawingml/2006/main">
               <a:ext uri="{FF2B5EF4-FFF2-40B4-BE49-F238E27FC236}">
-                <a16:creationId xmlns:a16="http://schemas.microsoft.com/office/drawing/2014/main" id="{55E5747D-9BE8-461E-A48C-29953153C7BD}"/>
+                <a16:creationId xmlns:a16="http://schemas.microsoft.com/office/drawing/2014/main" id="{21925C52-FFBD-41B6-BBBF-1C78A256D0FB}"/>
               </a:ext>
             </a:extLst>
           </p:cNvPr>
@@ -4888,7 +4888,7 @@
           <p:cNvPr id="24" name="">
             <a:extLst xmlns:a="http://schemas.openxmlformats.org/drawingml/2006/main">
               <a:ext uri="{FF2B5EF4-FFF2-40B4-BE49-F238E27FC236}">
-                <a16:creationId xmlns:a16="http://schemas.microsoft.com/office/drawing/2014/main" id="{138FE6F5-2918-4A46-AF8D-B9A4BB50466C}"/>
+                <a16:creationId xmlns:a16="http://schemas.microsoft.com/office/drawing/2014/main" id="{E8022213-6420-4AA2-BD46-D68ED518191F}"/>
               </a:ext>
             </a:extLst>
           </p:cNvPr>
@@ -4955,7 +4955,7 @@
           <p:cNvPr id="25" name="">
             <a:extLst xmlns:a="http://schemas.openxmlformats.org/drawingml/2006/main">
               <a:ext uri="{FF2B5EF4-FFF2-40B4-BE49-F238E27FC236}">
-                <a16:creationId xmlns:a16="http://schemas.microsoft.com/office/drawing/2014/main" id="{0E2CF02F-F346-4BF6-A7AB-C9C6C21A8352}"/>
+                <a16:creationId xmlns:a16="http://schemas.microsoft.com/office/drawing/2014/main" id="{1D47EA55-9634-4751-A005-B4E2107C3C66}"/>
               </a:ext>
             </a:extLst>
           </p:cNvPr>
@@ -5020,7 +5020,7 @@
     </p:spTree>
     <p:extLst>
       <p:ext uri="{BB962C8B-B14F-4D97-AF65-F5344CB8AC3E}">
-        <p14:creationId xmlns:p14="http://schemas.microsoft.com/office/powerpoint/2010/main" val="1614612483"/>
+        <p14:creationId xmlns:p14="http://schemas.microsoft.com/office/powerpoint/2010/main" val="1765869490"/>
       </p:ext>
     </p:extLst>
   </p:cSld>
@@ -5051,7 +5051,7 @@
           <p:cNvPr id="24" name="">
             <a:extLst xmlns:a="http://schemas.openxmlformats.org/drawingml/2006/main">
               <a:ext uri="{FF2B5EF4-FFF2-40B4-BE49-F238E27FC236}">
-                <a16:creationId xmlns:a16="http://schemas.microsoft.com/office/drawing/2014/main" id="{CD656B1E-9B2D-4AD5-A6DD-A781FDE4A578}"/>
+                <a16:creationId xmlns:a16="http://schemas.microsoft.com/office/drawing/2014/main" id="{3564ADE0-BEF0-4110-95DE-3A32D90E7A48}"/>
               </a:ext>
             </a:extLst>
           </p:cNvPr>
@@ -5082,7 +5082,7 @@
           <p:cNvPr id="2" name="">
             <a:extLst xmlns:a="http://schemas.openxmlformats.org/drawingml/2006/main">
               <a:ext uri="{FF2B5EF4-FFF2-40B4-BE49-F238E27FC236}">
-                <a16:creationId xmlns:a16="http://schemas.microsoft.com/office/drawing/2014/main" id="{A5C6DE3C-4AA7-4A6E-AE95-8CC5F2C1405F}"/>
+                <a16:creationId xmlns:a16="http://schemas.microsoft.com/office/drawing/2014/main" id="{D3303042-EE59-4DF3-A504-8B4953BDB9F7}"/>
               </a:ext>
             </a:extLst>
           </p:cNvPr>
@@ -5149,7 +5149,7 @@
           <p:cNvPr id="3" name="">
             <a:extLst xmlns:a="http://schemas.openxmlformats.org/drawingml/2006/main">
               <a:ext uri="{FF2B5EF4-FFF2-40B4-BE49-F238E27FC236}">
-                <a16:creationId xmlns:a16="http://schemas.microsoft.com/office/drawing/2014/main" id="{61C263EC-35C2-4BB7-947D-702B23E3EC0D}"/>
+                <a16:creationId xmlns:a16="http://schemas.microsoft.com/office/drawing/2014/main" id="{95B9912E-E278-489C-AA2E-A259BBF6FF34}"/>
               </a:ext>
             </a:extLst>
           </p:cNvPr>
@@ -5216,7 +5216,7 @@
           <p:cNvPr id="4" name="">
             <a:extLst xmlns:a="http://schemas.openxmlformats.org/drawingml/2006/main">
               <a:ext uri="{FF2B5EF4-FFF2-40B4-BE49-F238E27FC236}">
-                <a16:creationId xmlns:a16="http://schemas.microsoft.com/office/drawing/2014/main" id="{5FC631F9-9DB5-418E-9E1E-288F2CB96B92}"/>
+                <a16:creationId xmlns:a16="http://schemas.microsoft.com/office/drawing/2014/main" id="{0770F711-AE62-499E-BC6F-D6ACBC7D422E}"/>
               </a:ext>
             </a:extLst>
           </p:cNvPr>
@@ -5247,7 +5247,7 @@
           <p:cNvPr id="5" name="">
             <a:extLst xmlns:a="http://schemas.openxmlformats.org/drawingml/2006/main">
               <a:ext uri="{FF2B5EF4-FFF2-40B4-BE49-F238E27FC236}">
-                <a16:creationId xmlns:a16="http://schemas.microsoft.com/office/drawing/2014/main" id="{44650A4E-B058-4D5F-A816-ED810B8F8223}"/>
+                <a16:creationId xmlns:a16="http://schemas.microsoft.com/office/drawing/2014/main" id="{7A9ADEFD-B5F9-4BAF-A714-EFE3BF786652}"/>
               </a:ext>
             </a:extLst>
           </p:cNvPr>
@@ -5314,7 +5314,7 @@
           <p:cNvPr id="6" name="">
             <a:extLst xmlns:a="http://schemas.openxmlformats.org/drawingml/2006/main">
               <a:ext uri="{FF2B5EF4-FFF2-40B4-BE49-F238E27FC236}">
-                <a16:creationId xmlns:a16="http://schemas.microsoft.com/office/drawing/2014/main" id="{C9A4D3DE-5B6D-4E36-BBCD-B114E71E3E81}"/>
+                <a16:creationId xmlns:a16="http://schemas.microsoft.com/office/drawing/2014/main" id="{865C1D46-42CC-48FC-B540-2222F0BC2915}"/>
               </a:ext>
             </a:extLst>
           </p:cNvPr>
@@ -5381,7 +5381,7 @@
           <p:cNvPr id="7" name="">
             <a:extLst xmlns:a="http://schemas.openxmlformats.org/drawingml/2006/main">
               <a:ext uri="{FF2B5EF4-FFF2-40B4-BE49-F238E27FC236}">
-                <a16:creationId xmlns:a16="http://schemas.microsoft.com/office/drawing/2014/main" id="{91FDF3D5-DB85-4572-B8DC-2812FFFEAA29}"/>
+                <a16:creationId xmlns:a16="http://schemas.microsoft.com/office/drawing/2014/main" id="{C47886F4-24A7-4D3F-8535-DEE39A02B4BC}"/>
               </a:ext>
             </a:extLst>
           </p:cNvPr>
@@ -5416,7 +5416,7 @@
           <p:cNvPr id="8" name="">
             <a:extLst xmlns:a="http://schemas.openxmlformats.org/drawingml/2006/main">
               <a:ext uri="{FF2B5EF4-FFF2-40B4-BE49-F238E27FC236}">
-                <a16:creationId xmlns:a16="http://schemas.microsoft.com/office/drawing/2014/main" id="{F828C130-CB83-4141-8DD7-43FD23109B10}"/>
+                <a16:creationId xmlns:a16="http://schemas.microsoft.com/office/drawing/2014/main" id="{3E18BBA5-E18C-4371-B8D0-778D05410E28}"/>
               </a:ext>
             </a:extLst>
           </p:cNvPr>
@@ -5447,7 +5447,7 @@
           <p:cNvPr id="9" name="">
             <a:extLst xmlns:a="http://schemas.openxmlformats.org/drawingml/2006/main">
               <a:ext uri="{FF2B5EF4-FFF2-40B4-BE49-F238E27FC236}">
-                <a16:creationId xmlns:a16="http://schemas.microsoft.com/office/drawing/2014/main" id="{1D3509AE-0944-4BE2-B51A-B083908C1F67}"/>
+                <a16:creationId xmlns:a16="http://schemas.microsoft.com/office/drawing/2014/main" id="{B6AD4E50-1841-40F3-96F8-9FF9FCDA5562}"/>
               </a:ext>
             </a:extLst>
           </p:cNvPr>
@@ -5514,7 +5514,7 @@
           <p:cNvPr id="10" name="">
             <a:extLst xmlns:a="http://schemas.openxmlformats.org/drawingml/2006/main">
               <a:ext uri="{FF2B5EF4-FFF2-40B4-BE49-F238E27FC236}">
-                <a16:creationId xmlns:a16="http://schemas.microsoft.com/office/drawing/2014/main" id="{61C6A76E-F05C-4788-995F-377F29D90DC5}"/>
+                <a16:creationId xmlns:a16="http://schemas.microsoft.com/office/drawing/2014/main" id="{ED37D3CD-C0C5-4DF7-BAD5-BE9C4C44821E}"/>
               </a:ext>
             </a:extLst>
           </p:cNvPr>
@@ -5673,7 +5673,7 @@
           <p:cNvPr id="11" name="">
             <a:extLst xmlns:a="http://schemas.openxmlformats.org/drawingml/2006/main">
               <a:ext uri="{FF2B5EF4-FFF2-40B4-BE49-F238E27FC236}">
-                <a16:creationId xmlns:a16="http://schemas.microsoft.com/office/drawing/2014/main" id="{C9E7DA55-A16D-4437-9579-4CB2813C6151}"/>
+                <a16:creationId xmlns:a16="http://schemas.microsoft.com/office/drawing/2014/main" id="{F3AC97FA-1EEC-4602-8C43-8458C12A5F92}"/>
               </a:ext>
             </a:extLst>
           </p:cNvPr>
@@ -5708,7 +5708,7 @@
           <p:cNvPr id="12" name="">
             <a:extLst xmlns:a="http://schemas.openxmlformats.org/drawingml/2006/main">
               <a:ext uri="{FF2B5EF4-FFF2-40B4-BE49-F238E27FC236}">
-                <a16:creationId xmlns:a16="http://schemas.microsoft.com/office/drawing/2014/main" id="{AC0E88CF-A3B9-4722-83E2-7C370387BADE}"/>
+                <a16:creationId xmlns:a16="http://schemas.microsoft.com/office/drawing/2014/main" id="{FF0852C5-F2E5-4CD6-8600-090CF16DA456}"/>
               </a:ext>
             </a:extLst>
           </p:cNvPr>
@@ -5739,7 +5739,7 @@
           <p:cNvPr id="13" name="">
             <a:extLst xmlns:a="http://schemas.openxmlformats.org/drawingml/2006/main">
               <a:ext uri="{FF2B5EF4-FFF2-40B4-BE49-F238E27FC236}">
-                <a16:creationId xmlns:a16="http://schemas.microsoft.com/office/drawing/2014/main" id="{C66668C0-7A56-45CE-96EE-11AE82FF7047}"/>
+                <a16:creationId xmlns:a16="http://schemas.microsoft.com/office/drawing/2014/main" id="{1191FEC4-E1E5-438F-9152-0ED9F4DC0690}"/>
               </a:ext>
             </a:extLst>
           </p:cNvPr>
@@ -5806,7 +5806,7 @@
           <p:cNvPr id="14" name="">
             <a:extLst xmlns:a="http://schemas.openxmlformats.org/drawingml/2006/main">
               <a:ext uri="{FF2B5EF4-FFF2-40B4-BE49-F238E27FC236}">
-                <a16:creationId xmlns:a16="http://schemas.microsoft.com/office/drawing/2014/main" id="{C0AC3B8A-1F90-4DBC-AE72-16A7AAA78DD6}"/>
+                <a16:creationId xmlns:a16="http://schemas.microsoft.com/office/drawing/2014/main" id="{78D74AB4-8CDD-44BD-87FA-DC949781B33A}"/>
               </a:ext>
             </a:extLst>
           </p:cNvPr>
@@ -5942,7 +5942,7 @@
           <p:cNvPr id="15" name="">
             <a:extLst xmlns:a="http://schemas.openxmlformats.org/drawingml/2006/main">
               <a:ext uri="{FF2B5EF4-FFF2-40B4-BE49-F238E27FC236}">
-                <a16:creationId xmlns:a16="http://schemas.microsoft.com/office/drawing/2014/main" id="{E0741056-F16C-44F1-8882-0365E0EBAC18}"/>
+                <a16:creationId xmlns:a16="http://schemas.microsoft.com/office/drawing/2014/main" id="{D763430B-BB0C-4D97-B57B-30EBB78478C1}"/>
               </a:ext>
             </a:extLst>
           </p:cNvPr>
@@ -5977,7 +5977,7 @@
           <p:cNvPr id="16" name="">
             <a:extLst xmlns:a="http://schemas.openxmlformats.org/drawingml/2006/main">
               <a:ext uri="{FF2B5EF4-FFF2-40B4-BE49-F238E27FC236}">
-                <a16:creationId xmlns:a16="http://schemas.microsoft.com/office/drawing/2014/main" id="{B6D75CC5-BD48-4522-83F1-4D5CB390B148}"/>
+                <a16:creationId xmlns:a16="http://schemas.microsoft.com/office/drawing/2014/main" id="{2238D3CE-A3BE-42CF-A7BE-3371D73812E3}"/>
               </a:ext>
             </a:extLst>
           </p:cNvPr>
@@ -6008,7 +6008,7 @@
           <p:cNvPr id="17" name="">
             <a:extLst xmlns:a="http://schemas.openxmlformats.org/drawingml/2006/main">
               <a:ext uri="{FF2B5EF4-FFF2-40B4-BE49-F238E27FC236}">
-                <a16:creationId xmlns:a16="http://schemas.microsoft.com/office/drawing/2014/main" id="{EAC0D982-8673-4D4F-990D-2644739085A7}"/>
+                <a16:creationId xmlns:a16="http://schemas.microsoft.com/office/drawing/2014/main" id="{E2B579C4-F808-47C9-8A52-90E16C4923CC}"/>
               </a:ext>
             </a:extLst>
           </p:cNvPr>
@@ -6075,7 +6075,7 @@
           <p:cNvPr id="18" name="">
             <a:extLst xmlns:a="http://schemas.openxmlformats.org/drawingml/2006/main">
               <a:ext uri="{FF2B5EF4-FFF2-40B4-BE49-F238E27FC236}">
-                <a16:creationId xmlns:a16="http://schemas.microsoft.com/office/drawing/2014/main" id="{6BA2A1D5-68D7-4DEA-8522-78350025957C}"/>
+                <a16:creationId xmlns:a16="http://schemas.microsoft.com/office/drawing/2014/main" id="{0C0BDC5A-9D0F-41AF-A2D1-3019752C41B2}"/>
               </a:ext>
             </a:extLst>
           </p:cNvPr>
@@ -6211,7 +6211,7 @@
           <p:cNvPr id="19" name="">
             <a:extLst xmlns:a="http://schemas.openxmlformats.org/drawingml/2006/main">
               <a:ext uri="{FF2B5EF4-FFF2-40B4-BE49-F238E27FC236}">
-                <a16:creationId xmlns:a16="http://schemas.microsoft.com/office/drawing/2014/main" id="{0664548B-9AA5-427C-A8EA-24ADAB9919FD}"/>
+                <a16:creationId xmlns:a16="http://schemas.microsoft.com/office/drawing/2014/main" id="{2E66644A-6560-4B75-98E1-761C0A60670A}"/>
               </a:ext>
             </a:extLst>
           </p:cNvPr>
@@ -6242,7 +6242,7 @@
           <p:cNvPr id="20" name="">
             <a:extLst xmlns:a="http://schemas.openxmlformats.org/drawingml/2006/main">
               <a:ext uri="{FF2B5EF4-FFF2-40B4-BE49-F238E27FC236}">
-                <a16:creationId xmlns:a16="http://schemas.microsoft.com/office/drawing/2014/main" id="{7260B922-4551-46E8-9564-C6656EEB266D}"/>
+                <a16:creationId xmlns:a16="http://schemas.microsoft.com/office/drawing/2014/main" id="{2A6B78F6-DA86-4914-8A83-23525F31BF22}"/>
               </a:ext>
             </a:extLst>
           </p:cNvPr>
@@ -6309,7 +6309,7 @@
           <p:cNvPr id="21" name="">
             <a:extLst xmlns:a="http://schemas.openxmlformats.org/drawingml/2006/main">
               <a:ext uri="{FF2B5EF4-FFF2-40B4-BE49-F238E27FC236}">
-                <a16:creationId xmlns:a16="http://schemas.microsoft.com/office/drawing/2014/main" id="{8C8B0A7C-7CB0-4CA6-AF3F-2714380C6030}"/>
+                <a16:creationId xmlns:a16="http://schemas.microsoft.com/office/drawing/2014/main" id="{FE5975BD-D770-46A2-9BCF-B9C328AE4E9C}"/>
               </a:ext>
             </a:extLst>
           </p:cNvPr>
@@ -6340,7 +6340,7 @@
           <p:cNvPr id="22" name="">
             <a:extLst xmlns:a="http://schemas.openxmlformats.org/drawingml/2006/main">
               <a:ext uri="{FF2B5EF4-FFF2-40B4-BE49-F238E27FC236}">
-                <a16:creationId xmlns:a16="http://schemas.microsoft.com/office/drawing/2014/main" id="{EB9DF38B-69A9-49EF-B0DF-2B74A053F58A}"/>
+                <a16:creationId xmlns:a16="http://schemas.microsoft.com/office/drawing/2014/main" id="{2487F032-02B2-4274-8C03-9B4DE28E4877}"/>
               </a:ext>
             </a:extLst>
           </p:cNvPr>
@@ -6407,7 +6407,7 @@
           <p:cNvPr id="23" name="">
             <a:extLst xmlns:a="http://schemas.openxmlformats.org/drawingml/2006/main">
               <a:ext uri="{FF2B5EF4-FFF2-40B4-BE49-F238E27FC236}">
-                <a16:creationId xmlns:a16="http://schemas.microsoft.com/office/drawing/2014/main" id="{5B612F1C-DB0B-48BF-A6ED-A6A2D703DCFE}"/>
+                <a16:creationId xmlns:a16="http://schemas.microsoft.com/office/drawing/2014/main" id="{FE055CED-FC74-41B9-ACA2-F98CD5BC322B}"/>
               </a:ext>
             </a:extLst>
           </p:cNvPr>
@@ -6472,7 +6472,7 @@
     </p:spTree>
     <p:extLst>
       <p:ext uri="{BB962C8B-B14F-4D97-AF65-F5344CB8AC3E}">
-        <p14:creationId xmlns:p14="http://schemas.microsoft.com/office/powerpoint/2010/main" val="2031282422"/>
+        <p14:creationId xmlns:p14="http://schemas.microsoft.com/office/powerpoint/2010/main" val="1523702618"/>
       </p:ext>
     </p:extLst>
   </p:cSld>
@@ -6503,7 +6503,7 @@
           <p:cNvPr id="25" name="">
             <a:extLst xmlns:a="http://schemas.openxmlformats.org/drawingml/2006/main">
               <a:ext uri="{FF2B5EF4-FFF2-40B4-BE49-F238E27FC236}">
-                <a16:creationId xmlns:a16="http://schemas.microsoft.com/office/drawing/2014/main" id="{A3A8C240-0330-494D-ACFD-23866B5DCD49}"/>
+                <a16:creationId xmlns:a16="http://schemas.microsoft.com/office/drawing/2014/main" id="{E0250192-3EF2-494B-AAD2-9F1B321EF642}"/>
               </a:ext>
             </a:extLst>
           </p:cNvPr>
@@ -6534,7 +6534,7 @@
           <p:cNvPr id="2" name="">
             <a:extLst xmlns:a="http://schemas.openxmlformats.org/drawingml/2006/main">
               <a:ext uri="{FF2B5EF4-FFF2-40B4-BE49-F238E27FC236}">
-                <a16:creationId xmlns:a16="http://schemas.microsoft.com/office/drawing/2014/main" id="{D1DABDB5-086B-4D4D-BE56-C2B7405D2A12}"/>
+                <a16:creationId xmlns:a16="http://schemas.microsoft.com/office/drawing/2014/main" id="{42E12E8C-FF42-4B2B-8821-56D570D02A87}"/>
               </a:ext>
             </a:extLst>
           </p:cNvPr>
@@ -6601,7 +6601,7 @@
           <p:cNvPr id="3" name="">
             <a:extLst xmlns:a="http://schemas.openxmlformats.org/drawingml/2006/main">
               <a:ext uri="{FF2B5EF4-FFF2-40B4-BE49-F238E27FC236}">
-                <a16:creationId xmlns:a16="http://schemas.microsoft.com/office/drawing/2014/main" id="{C4D0A268-FCCE-4D68-8179-EE5F5E21CABB}"/>
+                <a16:creationId xmlns:a16="http://schemas.microsoft.com/office/drawing/2014/main" id="{C108086D-0D59-4E0E-8C0A-ABF7F609F63A}"/>
               </a:ext>
             </a:extLst>
           </p:cNvPr>
@@ -6668,7 +6668,7 @@
           <p:cNvPr id="4" name="">
             <a:extLst xmlns:a="http://schemas.openxmlformats.org/drawingml/2006/main">
               <a:ext uri="{FF2B5EF4-FFF2-40B4-BE49-F238E27FC236}">
-                <a16:creationId xmlns:a16="http://schemas.microsoft.com/office/drawing/2014/main" id="{03ECD29D-CB21-4CBE-829E-1A2AB516045C}"/>
+                <a16:creationId xmlns:a16="http://schemas.microsoft.com/office/drawing/2014/main" id="{EAB19438-4B96-4FCB-BEB6-9DBC5657EA78}"/>
               </a:ext>
             </a:extLst>
           </p:cNvPr>
@@ -6699,7 +6699,7 @@
           <p:cNvPr id="5" name="">
             <a:extLst xmlns:a="http://schemas.openxmlformats.org/drawingml/2006/main">
               <a:ext uri="{FF2B5EF4-FFF2-40B4-BE49-F238E27FC236}">
-                <a16:creationId xmlns:a16="http://schemas.microsoft.com/office/drawing/2014/main" id="{FDB54C74-2D1B-4384-B3DD-22DCBAF14F2C}"/>
+                <a16:creationId xmlns:a16="http://schemas.microsoft.com/office/drawing/2014/main" id="{B2C8257A-2886-48CA-B90E-32804B236554}"/>
               </a:ext>
             </a:extLst>
           </p:cNvPr>
@@ -6766,7 +6766,7 @@
           <p:cNvPr id="6" name="">
             <a:extLst xmlns:a="http://schemas.openxmlformats.org/drawingml/2006/main">
               <a:ext uri="{FF2B5EF4-FFF2-40B4-BE49-F238E27FC236}">
-                <a16:creationId xmlns:a16="http://schemas.microsoft.com/office/drawing/2014/main" id="{1847A624-FB16-4813-A570-3A3E243F1A3B}"/>
+                <a16:creationId xmlns:a16="http://schemas.microsoft.com/office/drawing/2014/main" id="{3DCFCEAC-9AD5-403F-9739-D1D82BCC64AC}"/>
               </a:ext>
             </a:extLst>
           </p:cNvPr>
@@ -6833,7 +6833,7 @@
           <p:cNvPr id="7" name="">
             <a:extLst xmlns:a="http://schemas.openxmlformats.org/drawingml/2006/main">
               <a:ext uri="{FF2B5EF4-FFF2-40B4-BE49-F238E27FC236}">
-                <a16:creationId xmlns:a16="http://schemas.microsoft.com/office/drawing/2014/main" id="{0A3202E0-FCAC-4F70-B8AD-A7618AE83547}"/>
+                <a16:creationId xmlns:a16="http://schemas.microsoft.com/office/drawing/2014/main" id="{4727403D-E297-4A3D-A763-B815CAFA04F8}"/>
               </a:ext>
             </a:extLst>
           </p:cNvPr>
@@ -6868,7 +6868,7 @@
           <p:cNvPr id="8" name="">
             <a:extLst xmlns:a="http://schemas.openxmlformats.org/drawingml/2006/main">
               <a:ext uri="{FF2B5EF4-FFF2-40B4-BE49-F238E27FC236}">
-                <a16:creationId xmlns:a16="http://schemas.microsoft.com/office/drawing/2014/main" id="{6970F8A6-9444-45A2-A879-665B940385B8}"/>
+                <a16:creationId xmlns:a16="http://schemas.microsoft.com/office/drawing/2014/main" id="{FCC1F900-45C5-406A-8741-718E9B6E3ED8}"/>
               </a:ext>
             </a:extLst>
           </p:cNvPr>
@@ -6935,7 +6935,7 @@
           <p:cNvPr id="9" name="">
             <a:extLst xmlns:a="http://schemas.openxmlformats.org/drawingml/2006/main">
               <a:ext uri="{FF2B5EF4-FFF2-40B4-BE49-F238E27FC236}">
-                <a16:creationId xmlns:a16="http://schemas.microsoft.com/office/drawing/2014/main" id="{5302F281-4CDE-4169-BE3D-CC275F0D7E5B}"/>
+                <a16:creationId xmlns:a16="http://schemas.microsoft.com/office/drawing/2014/main" id="{EFF37E95-5C7B-43C3-8D20-787FB5CE1FB3}"/>
               </a:ext>
             </a:extLst>
           </p:cNvPr>
@@ -7002,7 +7002,7 @@
           <p:cNvPr id="10" name="">
             <a:extLst xmlns:a="http://schemas.openxmlformats.org/drawingml/2006/main">
               <a:ext uri="{FF2B5EF4-FFF2-40B4-BE49-F238E27FC236}">
-                <a16:creationId xmlns:a16="http://schemas.microsoft.com/office/drawing/2014/main" id="{1660FAC1-7BE5-4DAA-80CE-851362C36038}"/>
+                <a16:creationId xmlns:a16="http://schemas.microsoft.com/office/drawing/2014/main" id="{3739409A-CCC7-40F9-B9EF-198D32DC4EBD}"/>
               </a:ext>
             </a:extLst>
           </p:cNvPr>
@@ -7037,7 +7037,7 @@
           <p:cNvPr id="11" name="">
             <a:extLst xmlns:a="http://schemas.openxmlformats.org/drawingml/2006/main">
               <a:ext uri="{FF2B5EF4-FFF2-40B4-BE49-F238E27FC236}">
-                <a16:creationId xmlns:a16="http://schemas.microsoft.com/office/drawing/2014/main" id="{67C56E0A-AA58-4136-8781-89A4485255BB}"/>
+                <a16:creationId xmlns:a16="http://schemas.microsoft.com/office/drawing/2014/main" id="{24C08662-D170-4378-B1B4-04FCA12991C2}"/>
               </a:ext>
             </a:extLst>
           </p:cNvPr>
@@ -7104,7 +7104,7 @@
           <p:cNvPr id="12" name="">
             <a:extLst xmlns:a="http://schemas.openxmlformats.org/drawingml/2006/main">
               <a:ext uri="{FF2B5EF4-FFF2-40B4-BE49-F238E27FC236}">
-                <a16:creationId xmlns:a16="http://schemas.microsoft.com/office/drawing/2014/main" id="{001210C9-D883-4229-8457-F7352B95800C}"/>
+                <a16:creationId xmlns:a16="http://schemas.microsoft.com/office/drawing/2014/main" id="{06D5813F-FD53-448D-812B-975B0B8E7436}"/>
               </a:ext>
             </a:extLst>
           </p:cNvPr>
@@ -7171,7 +7171,7 @@
           <p:cNvPr id="13" name="">
             <a:extLst xmlns:a="http://schemas.openxmlformats.org/drawingml/2006/main">
               <a:ext uri="{FF2B5EF4-FFF2-40B4-BE49-F238E27FC236}">
-                <a16:creationId xmlns:a16="http://schemas.microsoft.com/office/drawing/2014/main" id="{D89E831D-349A-4959-9D11-1B1EED356BA8}"/>
+                <a16:creationId xmlns:a16="http://schemas.microsoft.com/office/drawing/2014/main" id="{66EE90D5-AF1B-47AA-B6B7-7D6599F2C6A4}"/>
               </a:ext>
             </a:extLst>
           </p:cNvPr>
@@ -7206,7 +7206,7 @@
           <p:cNvPr id="14" name="">
             <a:extLst xmlns:a="http://schemas.openxmlformats.org/drawingml/2006/main">
               <a:ext uri="{FF2B5EF4-FFF2-40B4-BE49-F238E27FC236}">
-                <a16:creationId xmlns:a16="http://schemas.microsoft.com/office/drawing/2014/main" id="{D8B7A06C-038A-4569-AC34-87CBB7210B94}"/>
+                <a16:creationId xmlns:a16="http://schemas.microsoft.com/office/drawing/2014/main" id="{6FFD0DB5-B580-46DD-8B63-00950B17179A}"/>
               </a:ext>
             </a:extLst>
           </p:cNvPr>
@@ -7273,7 +7273,7 @@
           <p:cNvPr id="15" name="">
             <a:extLst xmlns:a="http://schemas.openxmlformats.org/drawingml/2006/main">
               <a:ext uri="{FF2B5EF4-FFF2-40B4-BE49-F238E27FC236}">
-                <a16:creationId xmlns:a16="http://schemas.microsoft.com/office/drawing/2014/main" id="{C7AB585E-CAFE-4C74-A2ED-6B5DEF26666D}"/>
+                <a16:creationId xmlns:a16="http://schemas.microsoft.com/office/drawing/2014/main" id="{FCB5A541-7709-4185-B82D-5D08407CFFC0}"/>
               </a:ext>
             </a:extLst>
           </p:cNvPr>
@@ -7340,7 +7340,7 @@
           <p:cNvPr id="16" name="">
             <a:extLst xmlns:a="http://schemas.openxmlformats.org/drawingml/2006/main">
               <a:ext uri="{FF2B5EF4-FFF2-40B4-BE49-F238E27FC236}">
-                <a16:creationId xmlns:a16="http://schemas.microsoft.com/office/drawing/2014/main" id="{AC4012EF-7978-406F-9520-3FF54064F722}"/>
+                <a16:creationId xmlns:a16="http://schemas.microsoft.com/office/drawing/2014/main" id="{35E8EB5E-2EEB-4D76-A9BA-41F718B2C78D}"/>
               </a:ext>
             </a:extLst>
           </p:cNvPr>
@@ -7375,7 +7375,7 @@
           <p:cNvPr id="17" name="">
             <a:extLst xmlns:a="http://schemas.openxmlformats.org/drawingml/2006/main">
               <a:ext uri="{FF2B5EF4-FFF2-40B4-BE49-F238E27FC236}">
-                <a16:creationId xmlns:a16="http://schemas.microsoft.com/office/drawing/2014/main" id="{1A42EB00-C72C-4BAC-9D0C-ED40D5257BBA}"/>
+                <a16:creationId xmlns:a16="http://schemas.microsoft.com/office/drawing/2014/main" id="{E85B4D17-69CF-44C6-A08A-BC88147998EE}"/>
               </a:ext>
             </a:extLst>
           </p:cNvPr>
@@ -7442,7 +7442,7 @@
           <p:cNvPr id="18" name="">
             <a:extLst xmlns:a="http://schemas.openxmlformats.org/drawingml/2006/main">
               <a:ext uri="{FF2B5EF4-FFF2-40B4-BE49-F238E27FC236}">
-                <a16:creationId xmlns:a16="http://schemas.microsoft.com/office/drawing/2014/main" id="{C70383B6-7C1F-4FE3-A5A6-2FCB5FFE65C6}"/>
+                <a16:creationId xmlns:a16="http://schemas.microsoft.com/office/drawing/2014/main" id="{68F102B5-DC54-427E-8090-D738AA97A791}"/>
               </a:ext>
             </a:extLst>
           </p:cNvPr>
@@ -7509,7 +7509,7 @@
           <p:cNvPr id="19" name="">
             <a:extLst xmlns:a="http://schemas.openxmlformats.org/drawingml/2006/main">
               <a:ext uri="{FF2B5EF4-FFF2-40B4-BE49-F238E27FC236}">
-                <a16:creationId xmlns:a16="http://schemas.microsoft.com/office/drawing/2014/main" id="{CA427B07-D9B3-430F-B0AF-6E8F0B166657}"/>
+                <a16:creationId xmlns:a16="http://schemas.microsoft.com/office/drawing/2014/main" id="{0DCE51C0-A782-4530-A86A-E26950A3F4A4}"/>
               </a:ext>
             </a:extLst>
           </p:cNvPr>
@@ -7544,7 +7544,7 @@
           <p:cNvPr id="20" name="">
             <a:extLst xmlns:a="http://schemas.openxmlformats.org/drawingml/2006/main">
               <a:ext uri="{FF2B5EF4-FFF2-40B4-BE49-F238E27FC236}">
-                <a16:creationId xmlns:a16="http://schemas.microsoft.com/office/drawing/2014/main" id="{CF4BF062-FA2C-4E4F-A053-E5FD183E121D}"/>
+                <a16:creationId xmlns:a16="http://schemas.microsoft.com/office/drawing/2014/main" id="{00557802-A4EC-4432-AC8E-5CC7382EB544}"/>
               </a:ext>
             </a:extLst>
           </p:cNvPr>
@@ -7611,7 +7611,7 @@
           <p:cNvPr id="21" name="">
             <a:extLst xmlns:a="http://schemas.openxmlformats.org/drawingml/2006/main">
               <a:ext uri="{FF2B5EF4-FFF2-40B4-BE49-F238E27FC236}">
-                <a16:creationId xmlns:a16="http://schemas.microsoft.com/office/drawing/2014/main" id="{80D5E5EE-8DC1-4EB1-8C2A-17228BE51E2B}"/>
+                <a16:creationId xmlns:a16="http://schemas.microsoft.com/office/drawing/2014/main" id="{703203C9-72A1-47AE-81EC-72204DA7676E}"/>
               </a:ext>
             </a:extLst>
           </p:cNvPr>
@@ -7678,7 +7678,7 @@
           <p:cNvPr id="22" name="">
             <a:extLst xmlns:a="http://schemas.openxmlformats.org/drawingml/2006/main">
               <a:ext uri="{FF2B5EF4-FFF2-40B4-BE49-F238E27FC236}">
-                <a16:creationId xmlns:a16="http://schemas.microsoft.com/office/drawing/2014/main" id="{D9C23C42-BBF7-45FC-8957-4DA954B9ABAA}"/>
+                <a16:creationId xmlns:a16="http://schemas.microsoft.com/office/drawing/2014/main" id="{3A97508C-9709-42BC-BDD1-414B6FB1576C}"/>
               </a:ext>
             </a:extLst>
           </p:cNvPr>
@@ -7713,7 +7713,7 @@
           <p:cNvPr id="23" name="">
             <a:extLst xmlns:a="http://schemas.openxmlformats.org/drawingml/2006/main">
               <a:ext uri="{FF2B5EF4-FFF2-40B4-BE49-F238E27FC236}">
-                <a16:creationId xmlns:a16="http://schemas.microsoft.com/office/drawing/2014/main" id="{C55719A0-693E-4056-B745-517A7852CEA1}"/>
+                <a16:creationId xmlns:a16="http://schemas.microsoft.com/office/drawing/2014/main" id="{9B437FBE-B558-41A0-8185-32D85A76068E}"/>
               </a:ext>
             </a:extLst>
           </p:cNvPr>
@@ -7780,7 +7780,7 @@
           <p:cNvPr id="24" name="">
             <a:extLst xmlns:a="http://schemas.openxmlformats.org/drawingml/2006/main">
               <a:ext uri="{FF2B5EF4-FFF2-40B4-BE49-F238E27FC236}">
-                <a16:creationId xmlns:a16="http://schemas.microsoft.com/office/drawing/2014/main" id="{AC975909-67B6-4FDA-B60F-3CDCB50A52C0}"/>
+                <a16:creationId xmlns:a16="http://schemas.microsoft.com/office/drawing/2014/main" id="{0C67847E-6EA1-4682-9EE7-B79FD256F916}"/>
               </a:ext>
             </a:extLst>
           </p:cNvPr>
@@ -7845,7 +7845,7 @@
     </p:spTree>
     <p:extLst>
       <p:ext uri="{BB962C8B-B14F-4D97-AF65-F5344CB8AC3E}">
-        <p14:creationId xmlns:p14="http://schemas.microsoft.com/office/powerpoint/2010/main" val="1123404727"/>
+        <p14:creationId xmlns:p14="http://schemas.microsoft.com/office/powerpoint/2010/main" val="791972664"/>
       </p:ext>
     </p:extLst>
   </p:cSld>
@@ -7876,7 +7876,7 @@
           <p:cNvPr id="26" name="">
             <a:extLst xmlns:a="http://schemas.openxmlformats.org/drawingml/2006/main">
               <a:ext uri="{FF2B5EF4-FFF2-40B4-BE49-F238E27FC236}">
-                <a16:creationId xmlns:a16="http://schemas.microsoft.com/office/drawing/2014/main" id="{4D167219-E2A3-423A-B52E-85BCECDBB808}"/>
+                <a16:creationId xmlns:a16="http://schemas.microsoft.com/office/drawing/2014/main" id="{15628BC1-98F1-4475-9BA7-B51BB0613FF8}"/>
               </a:ext>
             </a:extLst>
           </p:cNvPr>
@@ -7907,7 +7907,7 @@
           <p:cNvPr id="2" name="">
             <a:extLst xmlns:a="http://schemas.openxmlformats.org/drawingml/2006/main">
               <a:ext uri="{FF2B5EF4-FFF2-40B4-BE49-F238E27FC236}">
-                <a16:creationId xmlns:a16="http://schemas.microsoft.com/office/drawing/2014/main" id="{D7692155-54F9-4D66-A4A3-A3FCB5FDB4C6}"/>
+                <a16:creationId xmlns:a16="http://schemas.microsoft.com/office/drawing/2014/main" id="{0171C980-D096-4F58-AAE2-7D79502371BF}"/>
               </a:ext>
             </a:extLst>
           </p:cNvPr>
@@ -7974,7 +7974,7 @@
           <p:cNvPr id="3" name="">
             <a:extLst xmlns:a="http://schemas.openxmlformats.org/drawingml/2006/main">
               <a:ext uri="{FF2B5EF4-FFF2-40B4-BE49-F238E27FC236}">
-                <a16:creationId xmlns:a16="http://schemas.microsoft.com/office/drawing/2014/main" id="{D1247EFE-5152-4BCC-A122-FDA4A5883B1F}"/>
+                <a16:creationId xmlns:a16="http://schemas.microsoft.com/office/drawing/2014/main" id="{6923E007-53F1-49ED-9DF2-0E15C3D87107}"/>
               </a:ext>
             </a:extLst>
           </p:cNvPr>
@@ -8041,7 +8041,7 @@
           <p:cNvPr id="4" name="">
             <a:extLst xmlns:a="http://schemas.openxmlformats.org/drawingml/2006/main">
               <a:ext uri="{FF2B5EF4-FFF2-40B4-BE49-F238E27FC236}">
-                <a16:creationId xmlns:a16="http://schemas.microsoft.com/office/drawing/2014/main" id="{DC4D1D75-8F78-43B1-962D-AC4D6256BC4C}"/>
+                <a16:creationId xmlns:a16="http://schemas.microsoft.com/office/drawing/2014/main" id="{1E3839F5-AF85-4937-AC48-83B839DCF48E}"/>
               </a:ext>
             </a:extLst>
           </p:cNvPr>
@@ -8072,7 +8072,7 @@
           <p:cNvPr id="5" name="">
             <a:extLst xmlns:a="http://schemas.openxmlformats.org/drawingml/2006/main">
               <a:ext uri="{FF2B5EF4-FFF2-40B4-BE49-F238E27FC236}">
-                <a16:creationId xmlns:a16="http://schemas.microsoft.com/office/drawing/2014/main" id="{0705FA3E-B4B4-45F2-AD95-169356F64853}"/>
+                <a16:creationId xmlns:a16="http://schemas.microsoft.com/office/drawing/2014/main" id="{BEF10219-2B14-48B3-B6EE-AB797362928D}"/>
               </a:ext>
             </a:extLst>
           </p:cNvPr>
@@ -8139,7 +8139,7 @@
           <p:cNvPr id="6" name="">
             <a:extLst xmlns:a="http://schemas.openxmlformats.org/drawingml/2006/main">
               <a:ext uri="{FF2B5EF4-FFF2-40B4-BE49-F238E27FC236}">
-                <a16:creationId xmlns:a16="http://schemas.microsoft.com/office/drawing/2014/main" id="{8B92EE95-AF5C-41A5-840E-0932701F326D}"/>
+                <a16:creationId xmlns:a16="http://schemas.microsoft.com/office/drawing/2014/main" id="{E1C7C739-D0EA-401F-8873-3CF2B06FF6FB}"/>
               </a:ext>
             </a:extLst>
           </p:cNvPr>
@@ -8206,7 +8206,7 @@
           <p:cNvPr id="7" name="">
             <a:extLst xmlns:a="http://schemas.openxmlformats.org/drawingml/2006/main">
               <a:ext uri="{FF2B5EF4-FFF2-40B4-BE49-F238E27FC236}">
-                <a16:creationId xmlns:a16="http://schemas.microsoft.com/office/drawing/2014/main" id="{4B79A809-C4AA-4E6B-92C0-F10607D7E9BE}"/>
+                <a16:creationId xmlns:a16="http://schemas.microsoft.com/office/drawing/2014/main" id="{C2C6FC15-8447-48D7-A240-BC1B5BDEE996}"/>
               </a:ext>
             </a:extLst>
           </p:cNvPr>
@@ -8241,7 +8241,7 @@
           <p:cNvPr id="8" name="">
             <a:extLst xmlns:a="http://schemas.openxmlformats.org/drawingml/2006/main">
               <a:ext uri="{FF2B5EF4-FFF2-40B4-BE49-F238E27FC236}">
-                <a16:creationId xmlns:a16="http://schemas.microsoft.com/office/drawing/2014/main" id="{247D5A23-AAF5-4F88-AEF2-02C0D27A6B7F}"/>
+                <a16:creationId xmlns:a16="http://schemas.microsoft.com/office/drawing/2014/main" id="{636484DF-81FD-4FF7-BE40-BDA971BCF78E}"/>
               </a:ext>
             </a:extLst>
           </p:cNvPr>
@@ -8308,7 +8308,7 @@
           <p:cNvPr id="9" name="">
             <a:extLst xmlns:a="http://schemas.openxmlformats.org/drawingml/2006/main">
               <a:ext uri="{FF2B5EF4-FFF2-40B4-BE49-F238E27FC236}">
-                <a16:creationId xmlns:a16="http://schemas.microsoft.com/office/drawing/2014/main" id="{15DD57F1-CCB4-4519-9ADF-F7813970634B}"/>
+                <a16:creationId xmlns:a16="http://schemas.microsoft.com/office/drawing/2014/main" id="{CF910BAC-A167-49ED-9F1C-CFC7C9479A48}"/>
               </a:ext>
             </a:extLst>
           </p:cNvPr>
@@ -8375,7 +8375,7 @@
           <p:cNvPr id="10" name="">
             <a:extLst xmlns:a="http://schemas.openxmlformats.org/drawingml/2006/main">
               <a:ext uri="{FF2B5EF4-FFF2-40B4-BE49-F238E27FC236}">
-                <a16:creationId xmlns:a16="http://schemas.microsoft.com/office/drawing/2014/main" id="{CE012C4B-6064-4D42-A127-5F893365E993}"/>
+                <a16:creationId xmlns:a16="http://schemas.microsoft.com/office/drawing/2014/main" id="{ECFA25F6-D36C-4192-BCDF-4F8486ED80AF}"/>
               </a:ext>
             </a:extLst>
           </p:cNvPr>
@@ -8410,7 +8410,7 @@
           <p:cNvPr id="11" name="">
             <a:extLst xmlns:a="http://schemas.openxmlformats.org/drawingml/2006/main">
               <a:ext uri="{FF2B5EF4-FFF2-40B4-BE49-F238E27FC236}">
-                <a16:creationId xmlns:a16="http://schemas.microsoft.com/office/drawing/2014/main" id="{87510984-A797-4E7D-8E77-CEF1C2B8A4E0}"/>
+                <a16:creationId xmlns:a16="http://schemas.microsoft.com/office/drawing/2014/main" id="{3274A887-C434-4B97-B42D-A66ADDC6C29C}"/>
               </a:ext>
             </a:extLst>
           </p:cNvPr>
@@ -8467,7 +8467,7 @@
                 <a:ea typeface="Aptos"/>
                 <a:cs typeface="Aptos"/>
               </a:rPr>
-              <a:t>60</a:t>
+              <a:t>40</a:t>
             </a:r>
           </a:p>
         </p:txBody>
@@ -8477,7 +8477,7 @@
           <p:cNvPr id="12" name="">
             <a:extLst xmlns:a="http://schemas.openxmlformats.org/drawingml/2006/main">
               <a:ext uri="{FF2B5EF4-FFF2-40B4-BE49-F238E27FC236}">
-                <a16:creationId xmlns:a16="http://schemas.microsoft.com/office/drawing/2014/main" id="{82F83F84-1C1A-4FBB-BC66-0882F11C05FF}"/>
+                <a16:creationId xmlns:a16="http://schemas.microsoft.com/office/drawing/2014/main" id="{45A09245-43F7-403B-A355-242F6E7F944C}"/>
               </a:ext>
             </a:extLst>
           </p:cNvPr>
@@ -8544,7 +8544,7 @@
           <p:cNvPr id="13" name="">
             <a:extLst xmlns:a="http://schemas.openxmlformats.org/drawingml/2006/main">
               <a:ext uri="{FF2B5EF4-FFF2-40B4-BE49-F238E27FC236}">
-                <a16:creationId xmlns:a16="http://schemas.microsoft.com/office/drawing/2014/main" id="{9B38754D-021F-4B04-8A20-EAD2BAF116F9}"/>
+                <a16:creationId xmlns:a16="http://schemas.microsoft.com/office/drawing/2014/main" id="{5A97344C-AAEA-4081-BA26-D0E8FCB46CAD}"/>
               </a:ext>
             </a:extLst>
           </p:cNvPr>
@@ -8579,7 +8579,7 @@
           <p:cNvPr id="14" name="">
             <a:extLst xmlns:a="http://schemas.openxmlformats.org/drawingml/2006/main">
               <a:ext uri="{FF2B5EF4-FFF2-40B4-BE49-F238E27FC236}">
-                <a16:creationId xmlns:a16="http://schemas.microsoft.com/office/drawing/2014/main" id="{BC9C39C4-D6FA-4A65-9625-EADFE013666B}"/>
+                <a16:creationId xmlns:a16="http://schemas.microsoft.com/office/drawing/2014/main" id="{5E0AE39D-C92D-4E13-803F-B4248B122465}"/>
               </a:ext>
             </a:extLst>
           </p:cNvPr>
@@ -8636,7 +8636,7 @@
                 <a:ea typeface="Aptos"/>
                 <a:cs typeface="Aptos"/>
               </a:rPr>
-              <a:t>100</a:t>
+              <a:t>30</a:t>
             </a:r>
           </a:p>
         </p:txBody>
@@ -8646,7 +8646,7 @@
           <p:cNvPr id="15" name="">
             <a:extLst xmlns:a="http://schemas.openxmlformats.org/drawingml/2006/main">
               <a:ext uri="{FF2B5EF4-FFF2-40B4-BE49-F238E27FC236}">
-                <a16:creationId xmlns:a16="http://schemas.microsoft.com/office/drawing/2014/main" id="{DDA9E4FB-94A0-4913-B88C-1045DCE9A118}"/>
+                <a16:creationId xmlns:a16="http://schemas.microsoft.com/office/drawing/2014/main" id="{F5B600F0-593D-4838-9CA7-95EC351E46E2}"/>
               </a:ext>
             </a:extLst>
           </p:cNvPr>
@@ -8713,7 +8713,7 @@
           <p:cNvPr id="16" name="">
             <a:extLst xmlns:a="http://schemas.openxmlformats.org/drawingml/2006/main">
               <a:ext uri="{FF2B5EF4-FFF2-40B4-BE49-F238E27FC236}">
-                <a16:creationId xmlns:a16="http://schemas.microsoft.com/office/drawing/2014/main" id="{8BDE5AEA-7D84-4A38-8E25-0DD903CD2BC4}"/>
+                <a16:creationId xmlns:a16="http://schemas.microsoft.com/office/drawing/2014/main" id="{8189CD5C-089B-4629-878B-812CD9EA7DFC}"/>
               </a:ext>
             </a:extLst>
           </p:cNvPr>
@@ -8748,7 +8748,7 @@
           <p:cNvPr id="17" name="">
             <a:extLst xmlns:a="http://schemas.openxmlformats.org/drawingml/2006/main">
               <a:ext uri="{FF2B5EF4-FFF2-40B4-BE49-F238E27FC236}">
-                <a16:creationId xmlns:a16="http://schemas.microsoft.com/office/drawing/2014/main" id="{2B401377-4551-4A9C-9F7D-DBD4835CF522}"/>
+                <a16:creationId xmlns:a16="http://schemas.microsoft.com/office/drawing/2014/main" id="{5A1C7744-4D8D-4FB1-896E-FFE6CA0EBCE5}"/>
               </a:ext>
             </a:extLst>
           </p:cNvPr>
@@ -8805,7 +8805,7 @@
                 <a:ea typeface="Aptos"/>
                 <a:cs typeface="Aptos"/>
               </a:rPr>
-              <a:t>25</a:t>
+              <a:t>12</a:t>
             </a:r>
           </a:p>
         </p:txBody>
@@ -8815,7 +8815,7 @@
           <p:cNvPr id="18" name="">
             <a:extLst xmlns:a="http://schemas.openxmlformats.org/drawingml/2006/main">
               <a:ext uri="{FF2B5EF4-FFF2-40B4-BE49-F238E27FC236}">
-                <a16:creationId xmlns:a16="http://schemas.microsoft.com/office/drawing/2014/main" id="{FDAFFC83-52C4-481A-94E7-8AA9AD3E7EAA}"/>
+                <a16:creationId xmlns:a16="http://schemas.microsoft.com/office/drawing/2014/main" id="{7E18CB6C-75B4-4296-889F-A4CA18F282A7}"/>
               </a:ext>
             </a:extLst>
           </p:cNvPr>
@@ -8882,7 +8882,7 @@
           <p:cNvPr id="19" name="">
             <a:extLst xmlns:a="http://schemas.openxmlformats.org/drawingml/2006/main">
               <a:ext uri="{FF2B5EF4-FFF2-40B4-BE49-F238E27FC236}">
-                <a16:creationId xmlns:a16="http://schemas.microsoft.com/office/drawing/2014/main" id="{5D17F02B-EBD0-4E1E-9577-6622BF6419B3}"/>
+                <a16:creationId xmlns:a16="http://schemas.microsoft.com/office/drawing/2014/main" id="{08ACF07D-C1DE-4AAA-BA1C-642F42272D47}"/>
               </a:ext>
             </a:extLst>
           </p:cNvPr>
@@ -8949,7 +8949,7 @@
           <p:cNvPr id="20" name="">
             <a:extLst xmlns:a="http://schemas.openxmlformats.org/drawingml/2006/main">
               <a:ext uri="{FF2B5EF4-FFF2-40B4-BE49-F238E27FC236}">
-                <a16:creationId xmlns:a16="http://schemas.microsoft.com/office/drawing/2014/main" id="{EDD05AEB-5314-4B9E-AE4B-434A9E55FE84}"/>
+                <a16:creationId xmlns:a16="http://schemas.microsoft.com/office/drawing/2014/main" id="{D26BA378-9F76-4798-91BF-48EAA82F3B9A}"/>
               </a:ext>
             </a:extLst>
           </p:cNvPr>
@@ -9006,7 +9006,7 @@
                 <a:ea typeface="Aptos"/>
                 <a:cs typeface="Aptos"/>
               </a:rPr>
-              <a:t>100 borrowing records  •  25 active loans  •  Python Crash Course: 14 loans</a:t>
+              <a:t>30 borrowing records  •  12 active loans  •  Python Crash Course: 8 loans</a:t>
             </a:r>
           </a:p>
         </p:txBody>
@@ -9016,7 +9016,7 @@
           <p:cNvPr id="21" name="">
             <a:extLst xmlns:a="http://schemas.openxmlformats.org/drawingml/2006/main">
               <a:ext uri="{FF2B5EF4-FFF2-40B4-BE49-F238E27FC236}">
-                <a16:creationId xmlns:a16="http://schemas.microsoft.com/office/drawing/2014/main" id="{88BECB2F-D9CC-4806-9919-3E0D1054BF10}"/>
+                <a16:creationId xmlns:a16="http://schemas.microsoft.com/office/drawing/2014/main" id="{C5983A2B-7F00-42E6-AB4D-0363C5D26EC7}"/>
               </a:ext>
             </a:extLst>
           </p:cNvPr>
@@ -9083,7 +9083,7 @@
           <p:cNvPr id="22" name="">
             <a:extLst xmlns:a="http://schemas.openxmlformats.org/drawingml/2006/main">
               <a:ext uri="{FF2B5EF4-FFF2-40B4-BE49-F238E27FC236}">
-                <a16:creationId xmlns:a16="http://schemas.microsoft.com/office/drawing/2014/main" id="{823B8007-2741-4A75-A4E3-49680FA8DA75}"/>
+                <a16:creationId xmlns:a16="http://schemas.microsoft.com/office/drawing/2014/main" id="{0AC0771B-0B4F-4FBA-BDA5-0CE00286C644}"/>
               </a:ext>
             </a:extLst>
           </p:cNvPr>
@@ -9150,7 +9150,7 @@
           <p:cNvPr id="23" name="">
             <a:extLst xmlns:a="http://schemas.openxmlformats.org/drawingml/2006/main">
               <a:ext uri="{FF2B5EF4-FFF2-40B4-BE49-F238E27FC236}">
-                <a16:creationId xmlns:a16="http://schemas.microsoft.com/office/drawing/2014/main" id="{B9128FAB-B323-4265-8E69-0603C75F55B2}"/>
+                <a16:creationId xmlns:a16="http://schemas.microsoft.com/office/drawing/2014/main" id="{0190E2EC-47CF-4795-BE8D-E260B8FA0079}"/>
               </a:ext>
             </a:extLst>
           </p:cNvPr>
@@ -9217,7 +9217,7 @@
           <p:cNvPr id="24" name="">
             <a:extLst xmlns:a="http://schemas.openxmlformats.org/drawingml/2006/main">
               <a:ext uri="{FF2B5EF4-FFF2-40B4-BE49-F238E27FC236}">
-                <a16:creationId xmlns:a16="http://schemas.microsoft.com/office/drawing/2014/main" id="{43CA93C2-92FE-4FCF-9BEF-38C5AF8C7C89}"/>
+                <a16:creationId xmlns:a16="http://schemas.microsoft.com/office/drawing/2014/main" id="{30EEEDBF-B683-49B1-A796-E5A1BF91CF4D}"/>
               </a:ext>
             </a:extLst>
           </p:cNvPr>
@@ -9284,7 +9284,7 @@
           <p:cNvPr id="25" name="">
             <a:extLst xmlns:a="http://schemas.openxmlformats.org/drawingml/2006/main">
               <a:ext uri="{FF2B5EF4-FFF2-40B4-BE49-F238E27FC236}">
-                <a16:creationId xmlns:a16="http://schemas.microsoft.com/office/drawing/2014/main" id="{3CF1188C-C7B1-4E83-8FCF-29D19E60D316}"/>
+                <a16:creationId xmlns:a16="http://schemas.microsoft.com/office/drawing/2014/main" id="{73C115A2-AA24-45EB-8031-E43A871833CF}"/>
               </a:ext>
             </a:extLst>
           </p:cNvPr>
@@ -9349,7 +9349,7 @@
     </p:spTree>
     <p:extLst>
       <p:ext uri="{BB962C8B-B14F-4D97-AF65-F5344CB8AC3E}">
-        <p14:creationId xmlns:p14="http://schemas.microsoft.com/office/powerpoint/2010/main" val="547405110"/>
+        <p14:creationId xmlns:p14="http://schemas.microsoft.com/office/powerpoint/2010/main" val="1080766826"/>
       </p:ext>
     </p:extLst>
   </p:cSld>

</xml_diff>

<commit_message>
Use pandas for console record tables
</commit_message>
<xml_diff>
--- a/ProjectPresentation.pptx
+++ b/ProjectPresentation.pptx
@@ -2,17 +2,17 @@
 <file path=ppt/presentation.xml><?xml version="1.0" encoding="utf-8"?>
 <p:presentation xmlns:p="http://schemas.openxmlformats.org/presentationml/2006/main">
   <p:sldMasterIdLst>
-    <p:sldMasterId xmlns:r="http://schemas.openxmlformats.org/officeDocument/2006/relationships" id="2147483648" r:id="Re9e77775d7b947ab"/>
+    <p:sldMasterId xmlns:r="http://schemas.openxmlformats.org/officeDocument/2006/relationships" id="2147483648" r:id="R2eb3618976814edf"/>
   </p:sldMasterIdLst>
   <p:notesMasterIdLst>
-    <p:notesMasterId xmlns:r="http://schemas.openxmlformats.org/officeDocument/2006/relationships" r:id="Rfebf202fde194b20"/>
+    <p:notesMasterId xmlns:r="http://schemas.openxmlformats.org/officeDocument/2006/relationships" r:id="Rb68f5392a5cf488f"/>
   </p:notesMasterIdLst>
   <p:sldIdLst>
-    <p:sldId xmlns:r="http://schemas.openxmlformats.org/officeDocument/2006/relationships" id="256" r:id="Rd4f7766ff90541a9"/>
-    <p:sldId xmlns:r="http://schemas.openxmlformats.org/officeDocument/2006/relationships" id="257" r:id="R442957c3381a4d28"/>
-    <p:sldId xmlns:r="http://schemas.openxmlformats.org/officeDocument/2006/relationships" id="258" r:id="R2f089c6d599b4e6d"/>
-    <p:sldId xmlns:r="http://schemas.openxmlformats.org/officeDocument/2006/relationships" id="259" r:id="R5cb8973b92844331"/>
-    <p:sldId xmlns:r="http://schemas.openxmlformats.org/officeDocument/2006/relationships" id="260" r:id="Rd17742356c39446a"/>
+    <p:sldId xmlns:r="http://schemas.openxmlformats.org/officeDocument/2006/relationships" id="256" r:id="R662a0f6e7723452c"/>
+    <p:sldId xmlns:r="http://schemas.openxmlformats.org/officeDocument/2006/relationships" id="257" r:id="R8bbdcac216d04e98"/>
+    <p:sldId xmlns:r="http://schemas.openxmlformats.org/officeDocument/2006/relationships" id="258" r:id="R0a3bc0af1fcb4dc5"/>
+    <p:sldId xmlns:r="http://schemas.openxmlformats.org/officeDocument/2006/relationships" id="259" r:id="R91c27dcdad124a4a"/>
+    <p:sldId xmlns:r="http://schemas.openxmlformats.org/officeDocument/2006/relationships" id="260" r:id="R2f5da8f7bc0c432c"/>
   </p:sldIdLst>
   <p:sldSz cx="12192000" cy="6858000"/>
   <p:notesSz cx="6858000" cy="9144000"/>
@@ -753,7 +753,7 @@
           <p:cNvPr id="3" name="Title">
             <a:extLst xmlns:a="http://schemas.openxmlformats.org/drawingml/2006/main">
               <a:ext uri="{FF2B5EF4-FFF2-40B4-BE49-F238E27FC236}">
-                <a16:creationId xmlns:a16="http://schemas.microsoft.com/office/drawing/2014/main" id="{EDB41274-CA9F-4428-8794-0BEB47B3F5F1}"/>
+                <a16:creationId xmlns:a16="http://schemas.microsoft.com/office/drawing/2014/main" id="{4AB47F8D-65E7-4468-9F70-D613BFFE3EC6}"/>
               </a:ext>
             </a:extLst>
           </p:cNvPr>
@@ -910,7 +910,7 @@
           <p:cNvPr id="2" name="Subtitle">
             <a:extLst xmlns:a="http://schemas.openxmlformats.org/drawingml/2006/main">
               <a:ext uri="{FF2B5EF4-FFF2-40B4-BE49-F238E27FC236}">
-                <a16:creationId xmlns:a16="http://schemas.microsoft.com/office/drawing/2014/main" id="{79F65E7F-E669-4EF8-989E-4AF1DE8823F4}"/>
+                <a16:creationId xmlns:a16="http://schemas.microsoft.com/office/drawing/2014/main" id="{D2670647-1666-4B1E-A531-BB6BAC377878}"/>
               </a:ext>
             </a:extLst>
           </p:cNvPr>
@@ -1084,7 +1084,7 @@
           <p:cNvPr id="2" name="Section title">
             <a:extLst xmlns:a="http://schemas.openxmlformats.org/drawingml/2006/main">
               <a:ext uri="{FF2B5EF4-FFF2-40B4-BE49-F238E27FC236}">
-                <a16:creationId xmlns:a16="http://schemas.microsoft.com/office/drawing/2014/main" id="{ABFFEAE4-8857-4010-A9A9-D43A475FEF2B}"/>
+                <a16:creationId xmlns:a16="http://schemas.microsoft.com/office/drawing/2014/main" id="{99FBE351-1D19-4D72-9E3F-FB1B9EA5486B}"/>
               </a:ext>
             </a:extLst>
           </p:cNvPr>
@@ -1258,7 +1258,7 @@
           <p:cNvPr id="3" name="Title">
             <a:extLst xmlns:a="http://schemas.openxmlformats.org/drawingml/2006/main">
               <a:ext uri="{FF2B5EF4-FFF2-40B4-BE49-F238E27FC236}">
-                <a16:creationId xmlns:a16="http://schemas.microsoft.com/office/drawing/2014/main" id="{888D38F6-5536-4781-AA9B-851EF6C60711}"/>
+                <a16:creationId xmlns:a16="http://schemas.microsoft.com/office/drawing/2014/main" id="{D920387A-6518-4436-A14E-9D42B06098DF}"/>
               </a:ext>
             </a:extLst>
           </p:cNvPr>
@@ -1415,7 +1415,7 @@
           <p:cNvPr id="2" name="Body">
             <a:extLst xmlns:a="http://schemas.openxmlformats.org/drawingml/2006/main">
               <a:ext uri="{FF2B5EF4-FFF2-40B4-BE49-F238E27FC236}">
-                <a16:creationId xmlns:a16="http://schemas.microsoft.com/office/drawing/2014/main" id="{A7EEA21A-4DB7-46A1-A553-2D281AA549B2}"/>
+                <a16:creationId xmlns:a16="http://schemas.microsoft.com/office/drawing/2014/main" id="{8E811F3B-AA06-4E7F-9836-7450776A3D3D}"/>
               </a:ext>
             </a:extLst>
           </p:cNvPr>
@@ -1589,7 +1589,7 @@
           <p:cNvPr id="4" name="Title">
             <a:extLst xmlns:a="http://schemas.openxmlformats.org/drawingml/2006/main">
               <a:ext uri="{FF2B5EF4-FFF2-40B4-BE49-F238E27FC236}">
-                <a16:creationId xmlns:a16="http://schemas.microsoft.com/office/drawing/2014/main" id="{5BD9229B-8D8C-4ED5-8D79-EDA0B5A95EBB}"/>
+                <a16:creationId xmlns:a16="http://schemas.microsoft.com/office/drawing/2014/main" id="{1BF54F59-BBD5-48F5-B159-AB3F66E29871}"/>
               </a:ext>
             </a:extLst>
           </p:cNvPr>
@@ -1746,7 +1746,7 @@
           <p:cNvPr id="2" name="Left column">
             <a:extLst xmlns:a="http://schemas.openxmlformats.org/drawingml/2006/main">
               <a:ext uri="{FF2B5EF4-FFF2-40B4-BE49-F238E27FC236}">
-                <a16:creationId xmlns:a16="http://schemas.microsoft.com/office/drawing/2014/main" id="{1D6ACF74-4B37-42FE-B662-302CE51E8F1E}"/>
+                <a16:creationId xmlns:a16="http://schemas.microsoft.com/office/drawing/2014/main" id="{E02DCFEF-0DB8-46E6-AB6B-68AE2DFE5DA6}"/>
               </a:ext>
             </a:extLst>
           </p:cNvPr>
@@ -1903,7 +1903,7 @@
           <p:cNvPr id="3" name="Right column">
             <a:extLst xmlns:a="http://schemas.openxmlformats.org/drawingml/2006/main">
               <a:ext uri="{FF2B5EF4-FFF2-40B4-BE49-F238E27FC236}">
-                <a16:creationId xmlns:a16="http://schemas.microsoft.com/office/drawing/2014/main" id="{7B7DF57D-25AB-4D04-A7C9-D1152B829CB8}"/>
+                <a16:creationId xmlns:a16="http://schemas.microsoft.com/office/drawing/2014/main" id="{F386FC68-5F79-42C1-8042-60F7C0BFD5B7}"/>
               </a:ext>
             </a:extLst>
           </p:cNvPr>
@@ -2077,7 +2077,7 @@
           <p:cNvPr id="3" name="Title">
             <a:extLst xmlns:a="http://schemas.openxmlformats.org/drawingml/2006/main">
               <a:ext uri="{FF2B5EF4-FFF2-40B4-BE49-F238E27FC236}">
-                <a16:creationId xmlns:a16="http://schemas.microsoft.com/office/drawing/2014/main" id="{416FBBC0-FD59-4E3D-99AD-071A05AC0B70}"/>
+                <a16:creationId xmlns:a16="http://schemas.microsoft.com/office/drawing/2014/main" id="{C5D7629A-262D-4EB2-A19D-6A536323F59F}"/>
               </a:ext>
             </a:extLst>
           </p:cNvPr>
@@ -2234,7 +2234,7 @@
           <p:cNvPr id="2" name="Left column">
             <a:extLst xmlns:a="http://schemas.openxmlformats.org/drawingml/2006/main">
               <a:ext uri="{FF2B5EF4-FFF2-40B4-BE49-F238E27FC236}">
-                <a16:creationId xmlns:a16="http://schemas.microsoft.com/office/drawing/2014/main" id="{8AC14F1F-6D3A-4564-B1A9-0BD81C786CDC}"/>
+                <a16:creationId xmlns:a16="http://schemas.microsoft.com/office/drawing/2014/main" id="{5DA22F45-F10B-47B5-8176-1E5FE213931B}"/>
               </a:ext>
             </a:extLst>
           </p:cNvPr>
@@ -2429,12 +2429,12 @@
   </p:cSld>
   <p:clrMap bg1="lt1" tx1="dk1" bg2="lt2" tx2="dk2" accent1="accent1" accent2="accent2" accent3="accent3" accent4="accent4" accent5="accent5" accent6="accent6" hlink="hlink" folHlink="folHlink"/>
   <p:sldLayoutIdLst>
-    <p:sldLayoutId xmlns:r="http://schemas.openxmlformats.org/officeDocument/2006/relationships" id="2147483649" r:id="Rfd95621726e74bc9"/>
-    <p:sldLayoutId xmlns:r="http://schemas.openxmlformats.org/officeDocument/2006/relationships" id="2147483650" r:id="Rc3d80859b601433e"/>
-    <p:sldLayoutId xmlns:r="http://schemas.openxmlformats.org/officeDocument/2006/relationships" id="2147483651" r:id="Rd7778a64fde14f7b"/>
-    <p:sldLayoutId xmlns:r="http://schemas.openxmlformats.org/officeDocument/2006/relationships" id="2147483652" r:id="R0a2d1bb1a1f74d00"/>
-    <p:sldLayoutId xmlns:r="http://schemas.openxmlformats.org/officeDocument/2006/relationships" id="2147483653" r:id="Ra108662cd648499a"/>
-    <p:sldLayoutId xmlns:r="http://schemas.openxmlformats.org/officeDocument/2006/relationships" id="2147483654" r:id="R1a9cf30190024562"/>
+    <p:sldLayoutId xmlns:r="http://schemas.openxmlformats.org/officeDocument/2006/relationships" id="2147483649" r:id="Rffe0489583bd4e13"/>
+    <p:sldLayoutId xmlns:r="http://schemas.openxmlformats.org/officeDocument/2006/relationships" id="2147483650" r:id="R8f41c5d04307450c"/>
+    <p:sldLayoutId xmlns:r="http://schemas.openxmlformats.org/officeDocument/2006/relationships" id="2147483651" r:id="R0eadcf845de149be"/>
+    <p:sldLayoutId xmlns:r="http://schemas.openxmlformats.org/officeDocument/2006/relationships" id="2147483652" r:id="R13a68d86622240f7"/>
+    <p:sldLayoutId xmlns:r="http://schemas.openxmlformats.org/officeDocument/2006/relationships" id="2147483653" r:id="Ra883af74d14741f9"/>
+    <p:sldLayoutId xmlns:r="http://schemas.openxmlformats.org/officeDocument/2006/relationships" id="2147483654" r:id="R379594b6980547e0"/>
   </p:sldLayoutIdLst>
   <p:txStyles>
     <p:titleStyle>
@@ -2985,7 +2985,7 @@
           <p:cNvPr id="13" name="">
             <a:extLst xmlns:a="http://schemas.openxmlformats.org/drawingml/2006/main">
               <a:ext uri="{FF2B5EF4-FFF2-40B4-BE49-F238E27FC236}">
-                <a16:creationId xmlns:a16="http://schemas.microsoft.com/office/drawing/2014/main" id="{4D94868F-9C8C-42F3-A203-DABA0144303D}"/>
+                <a16:creationId xmlns:a16="http://schemas.microsoft.com/office/drawing/2014/main" id="{694AE15C-DF91-417F-938C-F99266F79B00}"/>
               </a:ext>
             </a:extLst>
           </p:cNvPr>
@@ -3016,7 +3016,7 @@
           <p:cNvPr id="2" name="">
             <a:extLst xmlns:a="http://schemas.openxmlformats.org/drawingml/2006/main">
               <a:ext uri="{FF2B5EF4-FFF2-40B4-BE49-F238E27FC236}">
-                <a16:creationId xmlns:a16="http://schemas.microsoft.com/office/drawing/2014/main" id="{25A24CEA-331D-40F9-BDA2-11CA7F110C9E}"/>
+                <a16:creationId xmlns:a16="http://schemas.microsoft.com/office/drawing/2014/main" id="{5CF0FE77-BBF6-4612-A76D-970F05DB7FDD}"/>
               </a:ext>
             </a:extLst>
           </p:cNvPr>
@@ -3083,7 +3083,7 @@
           <p:cNvPr id="3" name="">
             <a:extLst xmlns:a="http://schemas.openxmlformats.org/drawingml/2006/main">
               <a:ext uri="{FF2B5EF4-FFF2-40B4-BE49-F238E27FC236}">
-                <a16:creationId xmlns:a16="http://schemas.microsoft.com/office/drawing/2014/main" id="{A08AB7DD-41A0-4AE9-BA00-E98A95AFF602}"/>
+                <a16:creationId xmlns:a16="http://schemas.microsoft.com/office/drawing/2014/main" id="{2A695090-9CF1-4B9D-8830-598D38DAC49C}"/>
               </a:ext>
             </a:extLst>
           </p:cNvPr>
@@ -3173,7 +3173,7 @@
           <p:cNvPr id="4" name="">
             <a:extLst xmlns:a="http://schemas.openxmlformats.org/drawingml/2006/main">
               <a:ext uri="{FF2B5EF4-FFF2-40B4-BE49-F238E27FC236}">
-                <a16:creationId xmlns:a16="http://schemas.microsoft.com/office/drawing/2014/main" id="{8F733DED-D797-4917-A36C-58A9E77D1751}"/>
+                <a16:creationId xmlns:a16="http://schemas.microsoft.com/office/drawing/2014/main" id="{C6BA805F-2BDA-4ACF-90A1-DB111F50C0AF}"/>
               </a:ext>
             </a:extLst>
           </p:cNvPr>
@@ -3240,7 +3240,7 @@
           <p:cNvPr id="5" name="">
             <a:extLst xmlns:a="http://schemas.openxmlformats.org/drawingml/2006/main">
               <a:ext uri="{FF2B5EF4-FFF2-40B4-BE49-F238E27FC236}">
-                <a16:creationId xmlns:a16="http://schemas.microsoft.com/office/drawing/2014/main" id="{ECB4D2F4-21F6-4A7F-BE08-FA4CB512B9B8}"/>
+                <a16:creationId xmlns:a16="http://schemas.microsoft.com/office/drawing/2014/main" id="{43C7A595-81CD-4E41-AFAA-00E35071B61E}"/>
               </a:ext>
             </a:extLst>
           </p:cNvPr>
@@ -3307,7 +3307,7 @@
           <p:cNvPr id="6" name="">
             <a:extLst xmlns:a="http://schemas.openxmlformats.org/drawingml/2006/main">
               <a:ext uri="{FF2B5EF4-FFF2-40B4-BE49-F238E27FC236}">
-                <a16:creationId xmlns:a16="http://schemas.microsoft.com/office/drawing/2014/main" id="{C0B7D777-DA62-4E4C-BAF6-B048B755CAC1}"/>
+                <a16:creationId xmlns:a16="http://schemas.microsoft.com/office/drawing/2014/main" id="{7BBCAB61-67D0-4506-88AC-45B6029EA9E8}"/>
               </a:ext>
             </a:extLst>
           </p:cNvPr>
@@ -3374,7 +3374,7 @@
           <p:cNvPr id="7" name="">
             <a:extLst xmlns:a="http://schemas.openxmlformats.org/drawingml/2006/main">
               <a:ext uri="{FF2B5EF4-FFF2-40B4-BE49-F238E27FC236}">
-                <a16:creationId xmlns:a16="http://schemas.microsoft.com/office/drawing/2014/main" id="{C3A6224F-5A68-455E-AF5A-68606F8F437B}"/>
+                <a16:creationId xmlns:a16="http://schemas.microsoft.com/office/drawing/2014/main" id="{DCA19BB1-73E1-4B6F-8C17-A6BC8277DC8C}"/>
               </a:ext>
             </a:extLst>
           </p:cNvPr>
@@ -3407,7 +3407,7 @@
           <p:cNvPr id="8" name="">
             <a:extLst xmlns:a="http://schemas.openxmlformats.org/drawingml/2006/main">
               <a:ext uri="{FF2B5EF4-FFF2-40B4-BE49-F238E27FC236}">
-                <a16:creationId xmlns:a16="http://schemas.microsoft.com/office/drawing/2014/main" id="{1ED3E419-06E9-4C72-9DBE-85A4064D7470}"/>
+                <a16:creationId xmlns:a16="http://schemas.microsoft.com/office/drawing/2014/main" id="{9C7A798B-D29A-4782-B717-703F3A0F6C69}"/>
               </a:ext>
             </a:extLst>
           </p:cNvPr>
@@ -3440,7 +3440,7 @@
           <p:cNvPr id="9" name="">
             <a:extLst xmlns:a="http://schemas.openxmlformats.org/drawingml/2006/main">
               <a:ext uri="{FF2B5EF4-FFF2-40B4-BE49-F238E27FC236}">
-                <a16:creationId xmlns:a16="http://schemas.microsoft.com/office/drawing/2014/main" id="{8A6DC2CD-6AB1-4BC1-AC60-3884A84C2D5A}"/>
+                <a16:creationId xmlns:a16="http://schemas.microsoft.com/office/drawing/2014/main" id="{2C161F0A-C95A-4C6A-9BAE-6D2B25A9CBDF}"/>
               </a:ext>
             </a:extLst>
           </p:cNvPr>
@@ -3473,7 +3473,7 @@
           <p:cNvPr id="10" name="">
             <a:extLst xmlns:a="http://schemas.openxmlformats.org/drawingml/2006/main">
               <a:ext uri="{FF2B5EF4-FFF2-40B4-BE49-F238E27FC236}">
-                <a16:creationId xmlns:a16="http://schemas.microsoft.com/office/drawing/2014/main" id="{455B82A0-5345-4F49-875A-C2E4C6EB2467}"/>
+                <a16:creationId xmlns:a16="http://schemas.microsoft.com/office/drawing/2014/main" id="{38E8CFE9-E743-42F1-A45A-6638175ABE0B}"/>
               </a:ext>
             </a:extLst>
           </p:cNvPr>
@@ -3506,7 +3506,7 @@
           <p:cNvPr id="11" name="">
             <a:extLst xmlns:a="http://schemas.openxmlformats.org/drawingml/2006/main">
               <a:ext uri="{FF2B5EF4-FFF2-40B4-BE49-F238E27FC236}">
-                <a16:creationId xmlns:a16="http://schemas.microsoft.com/office/drawing/2014/main" id="{07BCE342-BB1D-49C0-B5DA-878FF53C352D}"/>
+                <a16:creationId xmlns:a16="http://schemas.microsoft.com/office/drawing/2014/main" id="{553941B0-C79B-452A-9A8A-D672A641DBE3}"/>
               </a:ext>
             </a:extLst>
           </p:cNvPr>
@@ -3539,7 +3539,7 @@
           <p:cNvPr id="12" name="">
             <a:extLst xmlns:a="http://schemas.openxmlformats.org/drawingml/2006/main">
               <a:ext uri="{FF2B5EF4-FFF2-40B4-BE49-F238E27FC236}">
-                <a16:creationId xmlns:a16="http://schemas.microsoft.com/office/drawing/2014/main" id="{93A13BDE-C5DA-41A4-9E24-997F30EB5AD0}"/>
+                <a16:creationId xmlns:a16="http://schemas.microsoft.com/office/drawing/2014/main" id="{7AC0E61B-6E8E-4D3D-802B-D6E1B0554051}"/>
               </a:ext>
             </a:extLst>
           </p:cNvPr>
@@ -3604,7 +3604,7 @@
     </p:spTree>
     <p:extLst>
       <p:ext uri="{BB962C8B-B14F-4D97-AF65-F5344CB8AC3E}">
-        <p14:creationId xmlns:p14="http://schemas.microsoft.com/office/powerpoint/2010/main" val="507102478"/>
+        <p14:creationId xmlns:p14="http://schemas.microsoft.com/office/powerpoint/2010/main" val="248151252"/>
       </p:ext>
     </p:extLst>
   </p:cSld>
@@ -3635,7 +3635,7 @@
           <p:cNvPr id="26" name="">
             <a:extLst xmlns:a="http://schemas.openxmlformats.org/drawingml/2006/main">
               <a:ext uri="{FF2B5EF4-FFF2-40B4-BE49-F238E27FC236}">
-                <a16:creationId xmlns:a16="http://schemas.microsoft.com/office/drawing/2014/main" id="{A8465022-E4DF-46EF-A2E4-508F97D47B7F}"/>
+                <a16:creationId xmlns:a16="http://schemas.microsoft.com/office/drawing/2014/main" id="{02E72837-7896-4CC1-90A6-9B3B25C70BBF}"/>
               </a:ext>
             </a:extLst>
           </p:cNvPr>
@@ -3666,7 +3666,7 @@
           <p:cNvPr id="2" name="">
             <a:extLst xmlns:a="http://schemas.openxmlformats.org/drawingml/2006/main">
               <a:ext uri="{FF2B5EF4-FFF2-40B4-BE49-F238E27FC236}">
-                <a16:creationId xmlns:a16="http://schemas.microsoft.com/office/drawing/2014/main" id="{CD584D34-D015-42BD-9FAB-012E7F3D4F0A}"/>
+                <a16:creationId xmlns:a16="http://schemas.microsoft.com/office/drawing/2014/main" id="{BBD2ACEA-64F0-4875-8F85-67A04BBE71E4}"/>
               </a:ext>
             </a:extLst>
           </p:cNvPr>
@@ -3733,7 +3733,7 @@
           <p:cNvPr id="3" name="">
             <a:extLst xmlns:a="http://schemas.openxmlformats.org/drawingml/2006/main">
               <a:ext uri="{FF2B5EF4-FFF2-40B4-BE49-F238E27FC236}">
-                <a16:creationId xmlns:a16="http://schemas.microsoft.com/office/drawing/2014/main" id="{8FF3BDB7-B014-40AC-8C07-0E7CC021719C}"/>
+                <a16:creationId xmlns:a16="http://schemas.microsoft.com/office/drawing/2014/main" id="{F3FA2C36-8E91-4782-8243-09E5159848EF}"/>
               </a:ext>
             </a:extLst>
           </p:cNvPr>
@@ -3800,7 +3800,7 @@
           <p:cNvPr id="4" name="">
             <a:extLst xmlns:a="http://schemas.openxmlformats.org/drawingml/2006/main">
               <a:ext uri="{FF2B5EF4-FFF2-40B4-BE49-F238E27FC236}">
-                <a16:creationId xmlns:a16="http://schemas.microsoft.com/office/drawing/2014/main" id="{0BD070EA-C929-4598-9042-868B0F76A9F9}"/>
+                <a16:creationId xmlns:a16="http://schemas.microsoft.com/office/drawing/2014/main" id="{F423346E-30AE-47D1-A220-84423C18EE89}"/>
               </a:ext>
             </a:extLst>
           </p:cNvPr>
@@ -3831,7 +3831,7 @@
           <p:cNvPr id="5" name="">
             <a:extLst xmlns:a="http://schemas.openxmlformats.org/drawingml/2006/main">
               <a:ext uri="{FF2B5EF4-FFF2-40B4-BE49-F238E27FC236}">
-                <a16:creationId xmlns:a16="http://schemas.microsoft.com/office/drawing/2014/main" id="{4929C8BF-035F-4544-91C4-00B921047562}"/>
+                <a16:creationId xmlns:a16="http://schemas.microsoft.com/office/drawing/2014/main" id="{63F4C655-2385-41A5-A451-8B362185EC4A}"/>
               </a:ext>
             </a:extLst>
           </p:cNvPr>
@@ -3898,7 +3898,7 @@
           <p:cNvPr id="6" name="">
             <a:extLst xmlns:a="http://schemas.openxmlformats.org/drawingml/2006/main">
               <a:ext uri="{FF2B5EF4-FFF2-40B4-BE49-F238E27FC236}">
-                <a16:creationId xmlns:a16="http://schemas.microsoft.com/office/drawing/2014/main" id="{0DD48633-5B8E-4FCC-8E97-3AFD4C75E5B1}"/>
+                <a16:creationId xmlns:a16="http://schemas.microsoft.com/office/drawing/2014/main" id="{0ACECA17-2D69-4A7B-96E2-BB6B5940EEA1}"/>
               </a:ext>
             </a:extLst>
           </p:cNvPr>
@@ -3965,7 +3965,7 @@
           <p:cNvPr id="7" name="">
             <a:extLst xmlns:a="http://schemas.openxmlformats.org/drawingml/2006/main">
               <a:ext uri="{FF2B5EF4-FFF2-40B4-BE49-F238E27FC236}">
-                <a16:creationId xmlns:a16="http://schemas.microsoft.com/office/drawing/2014/main" id="{1E8076D1-A22A-4A43-9B17-DA8534C0C6B7}"/>
+                <a16:creationId xmlns:a16="http://schemas.microsoft.com/office/drawing/2014/main" id="{805F4565-701D-47D9-A44C-B21EF98065AB}"/>
               </a:ext>
             </a:extLst>
           </p:cNvPr>
@@ -3996,7 +3996,7 @@
           <p:cNvPr id="8" name="">
             <a:extLst xmlns:a="http://schemas.openxmlformats.org/drawingml/2006/main">
               <a:ext uri="{FF2B5EF4-FFF2-40B4-BE49-F238E27FC236}">
-                <a16:creationId xmlns:a16="http://schemas.microsoft.com/office/drawing/2014/main" id="{FDB87ABC-749A-4F75-A7D2-62B49510D188}"/>
+                <a16:creationId xmlns:a16="http://schemas.microsoft.com/office/drawing/2014/main" id="{F75AF689-26BC-4728-8E4B-41A3C9992EB7}"/>
               </a:ext>
             </a:extLst>
           </p:cNvPr>
@@ -4063,7 +4063,7 @@
           <p:cNvPr id="9" name="">
             <a:extLst xmlns:a="http://schemas.openxmlformats.org/drawingml/2006/main">
               <a:ext uri="{FF2B5EF4-FFF2-40B4-BE49-F238E27FC236}">
-                <a16:creationId xmlns:a16="http://schemas.microsoft.com/office/drawing/2014/main" id="{A101D1C6-3AA6-4E39-AD73-F5C8FABE68FB}"/>
+                <a16:creationId xmlns:a16="http://schemas.microsoft.com/office/drawing/2014/main" id="{4F8AC3FE-DF1A-4449-9BE9-B8116F89B9C0}"/>
               </a:ext>
             </a:extLst>
           </p:cNvPr>
@@ -4130,7 +4130,7 @@
           <p:cNvPr id="10" name="">
             <a:extLst xmlns:a="http://schemas.openxmlformats.org/drawingml/2006/main">
               <a:ext uri="{FF2B5EF4-FFF2-40B4-BE49-F238E27FC236}">
-                <a16:creationId xmlns:a16="http://schemas.microsoft.com/office/drawing/2014/main" id="{6A6767CB-24BE-4693-8813-F8FA294C5D77}"/>
+                <a16:creationId xmlns:a16="http://schemas.microsoft.com/office/drawing/2014/main" id="{04FFF684-7A2E-457C-B3E2-621EDDFF73A1}"/>
               </a:ext>
             </a:extLst>
           </p:cNvPr>
@@ -4161,7 +4161,7 @@
           <p:cNvPr id="11" name="">
             <a:extLst xmlns:a="http://schemas.openxmlformats.org/drawingml/2006/main">
               <a:ext uri="{FF2B5EF4-FFF2-40B4-BE49-F238E27FC236}">
-                <a16:creationId xmlns:a16="http://schemas.microsoft.com/office/drawing/2014/main" id="{405A31B1-1FBD-40AA-9413-2B1C6EA49134}"/>
+                <a16:creationId xmlns:a16="http://schemas.microsoft.com/office/drawing/2014/main" id="{BDD27D00-3419-4556-A918-6C0870FADF4A}"/>
               </a:ext>
             </a:extLst>
           </p:cNvPr>
@@ -4228,7 +4228,7 @@
           <p:cNvPr id="12" name="">
             <a:extLst xmlns:a="http://schemas.openxmlformats.org/drawingml/2006/main">
               <a:ext uri="{FF2B5EF4-FFF2-40B4-BE49-F238E27FC236}">
-                <a16:creationId xmlns:a16="http://schemas.microsoft.com/office/drawing/2014/main" id="{58A823E0-6A04-4683-9320-550DA959E8D3}"/>
+                <a16:creationId xmlns:a16="http://schemas.microsoft.com/office/drawing/2014/main" id="{2E742957-57A2-4B69-A3E6-86172C01E5E4}"/>
               </a:ext>
             </a:extLst>
           </p:cNvPr>
@@ -4295,7 +4295,7 @@
           <p:cNvPr id="13" name="">
             <a:extLst xmlns:a="http://schemas.openxmlformats.org/drawingml/2006/main">
               <a:ext uri="{FF2B5EF4-FFF2-40B4-BE49-F238E27FC236}">
-                <a16:creationId xmlns:a16="http://schemas.microsoft.com/office/drawing/2014/main" id="{B3E5DAC1-9D8F-4160-A456-CF5C50E518E6}"/>
+                <a16:creationId xmlns:a16="http://schemas.microsoft.com/office/drawing/2014/main" id="{1506911E-46FF-4FB8-93FC-2370A47E7159}"/>
               </a:ext>
             </a:extLst>
           </p:cNvPr>
@@ -4326,7 +4326,7 @@
           <p:cNvPr id="14" name="">
             <a:extLst xmlns:a="http://schemas.openxmlformats.org/drawingml/2006/main">
               <a:ext uri="{FF2B5EF4-FFF2-40B4-BE49-F238E27FC236}">
-                <a16:creationId xmlns:a16="http://schemas.microsoft.com/office/drawing/2014/main" id="{4717ED7D-E212-4CF1-8F1A-E518727B5C12}"/>
+                <a16:creationId xmlns:a16="http://schemas.microsoft.com/office/drawing/2014/main" id="{E5C327FC-6D3A-4003-886D-77B03F9B13F8}"/>
               </a:ext>
             </a:extLst>
           </p:cNvPr>
@@ -4393,7 +4393,7 @@
           <p:cNvPr id="15" name="">
             <a:extLst xmlns:a="http://schemas.openxmlformats.org/drawingml/2006/main">
               <a:ext uri="{FF2B5EF4-FFF2-40B4-BE49-F238E27FC236}">
-                <a16:creationId xmlns:a16="http://schemas.microsoft.com/office/drawing/2014/main" id="{6D6B7647-BF2F-498C-9EAF-E7E5318C1E92}"/>
+                <a16:creationId xmlns:a16="http://schemas.microsoft.com/office/drawing/2014/main" id="{6EA38C11-2E27-472D-91AB-96C4F641248B}"/>
               </a:ext>
             </a:extLst>
           </p:cNvPr>
@@ -4460,7 +4460,7 @@
           <p:cNvPr id="16" name="">
             <a:extLst xmlns:a="http://schemas.openxmlformats.org/drawingml/2006/main">
               <a:ext uri="{FF2B5EF4-FFF2-40B4-BE49-F238E27FC236}">
-                <a16:creationId xmlns:a16="http://schemas.microsoft.com/office/drawing/2014/main" id="{52C251B0-1CE6-454D-A551-B0DE89AA28A1}"/>
+                <a16:creationId xmlns:a16="http://schemas.microsoft.com/office/drawing/2014/main" id="{366BA250-8639-4E46-8FDE-9D171E68A95A}"/>
               </a:ext>
             </a:extLst>
           </p:cNvPr>
@@ -4491,7 +4491,7 @@
           <p:cNvPr id="17" name="">
             <a:extLst xmlns:a="http://schemas.openxmlformats.org/drawingml/2006/main">
               <a:ext uri="{FF2B5EF4-FFF2-40B4-BE49-F238E27FC236}">
-                <a16:creationId xmlns:a16="http://schemas.microsoft.com/office/drawing/2014/main" id="{22386D44-001A-4333-982A-BB2423D8291A}"/>
+                <a16:creationId xmlns:a16="http://schemas.microsoft.com/office/drawing/2014/main" id="{C59B0327-B558-49F9-BF15-B0C01480950B}"/>
               </a:ext>
             </a:extLst>
           </p:cNvPr>
@@ -4558,7 +4558,7 @@
           <p:cNvPr id="18" name="">
             <a:extLst xmlns:a="http://schemas.openxmlformats.org/drawingml/2006/main">
               <a:ext uri="{FF2B5EF4-FFF2-40B4-BE49-F238E27FC236}">
-                <a16:creationId xmlns:a16="http://schemas.microsoft.com/office/drawing/2014/main" id="{F5550535-E4DE-41D0-9426-12DDA5DD391C}"/>
+                <a16:creationId xmlns:a16="http://schemas.microsoft.com/office/drawing/2014/main" id="{6E4D18C1-5C9C-4895-9258-4286977F170F}"/>
               </a:ext>
             </a:extLst>
           </p:cNvPr>
@@ -4625,7 +4625,7 @@
           <p:cNvPr id="19" name="">
             <a:extLst xmlns:a="http://schemas.openxmlformats.org/drawingml/2006/main">
               <a:ext uri="{FF2B5EF4-FFF2-40B4-BE49-F238E27FC236}">
-                <a16:creationId xmlns:a16="http://schemas.microsoft.com/office/drawing/2014/main" id="{4C5326F7-C3EB-4927-9CA2-2783803E7DB6}"/>
+                <a16:creationId xmlns:a16="http://schemas.microsoft.com/office/drawing/2014/main" id="{726B642E-C07F-47DC-86EC-61E648550729}"/>
               </a:ext>
             </a:extLst>
           </p:cNvPr>
@@ -4656,7 +4656,7 @@
           <p:cNvPr id="20" name="">
             <a:extLst xmlns:a="http://schemas.openxmlformats.org/drawingml/2006/main">
               <a:ext uri="{FF2B5EF4-FFF2-40B4-BE49-F238E27FC236}">
-                <a16:creationId xmlns:a16="http://schemas.microsoft.com/office/drawing/2014/main" id="{8D0E6DBC-D43E-4FF0-A500-A3B1EEE78740}"/>
+                <a16:creationId xmlns:a16="http://schemas.microsoft.com/office/drawing/2014/main" id="{AC4E4CDB-7A46-4F93-858C-E31067A800D7}"/>
               </a:ext>
             </a:extLst>
           </p:cNvPr>
@@ -4723,7 +4723,7 @@
           <p:cNvPr id="21" name="">
             <a:extLst xmlns:a="http://schemas.openxmlformats.org/drawingml/2006/main">
               <a:ext uri="{FF2B5EF4-FFF2-40B4-BE49-F238E27FC236}">
-                <a16:creationId xmlns:a16="http://schemas.microsoft.com/office/drawing/2014/main" id="{EED356E0-4837-450A-BDFF-292951A9C65D}"/>
+                <a16:creationId xmlns:a16="http://schemas.microsoft.com/office/drawing/2014/main" id="{1FAC3996-C2D5-4671-A8F9-2572218D56E2}"/>
               </a:ext>
             </a:extLst>
           </p:cNvPr>
@@ -4790,7 +4790,7 @@
           <p:cNvPr id="22" name="">
             <a:extLst xmlns:a="http://schemas.openxmlformats.org/drawingml/2006/main">
               <a:ext uri="{FF2B5EF4-FFF2-40B4-BE49-F238E27FC236}">
-                <a16:creationId xmlns:a16="http://schemas.microsoft.com/office/drawing/2014/main" id="{F9BDCA4D-F3D6-430E-9346-B7B72AEEC8A9}"/>
+                <a16:creationId xmlns:a16="http://schemas.microsoft.com/office/drawing/2014/main" id="{6961EA92-9B86-43E3-90A7-DD0BED57650E}"/>
               </a:ext>
             </a:extLst>
           </p:cNvPr>
@@ -4821,7 +4821,7 @@
           <p:cNvPr id="23" name="">
             <a:extLst xmlns:a="http://schemas.openxmlformats.org/drawingml/2006/main">
               <a:ext uri="{FF2B5EF4-FFF2-40B4-BE49-F238E27FC236}">
-                <a16:creationId xmlns:a16="http://schemas.microsoft.com/office/drawing/2014/main" id="{21925C52-FFBD-41B6-BBBF-1C78A256D0FB}"/>
+                <a16:creationId xmlns:a16="http://schemas.microsoft.com/office/drawing/2014/main" id="{51B5C091-2190-41B4-9DB4-ACACF7F7E2F2}"/>
               </a:ext>
             </a:extLst>
           </p:cNvPr>
@@ -4888,7 +4888,7 @@
           <p:cNvPr id="24" name="">
             <a:extLst xmlns:a="http://schemas.openxmlformats.org/drawingml/2006/main">
               <a:ext uri="{FF2B5EF4-FFF2-40B4-BE49-F238E27FC236}">
-                <a16:creationId xmlns:a16="http://schemas.microsoft.com/office/drawing/2014/main" id="{E8022213-6420-4AA2-BD46-D68ED518191F}"/>
+                <a16:creationId xmlns:a16="http://schemas.microsoft.com/office/drawing/2014/main" id="{7C8A2B2D-1C4F-48D4-9DCA-9DCB33502657}"/>
               </a:ext>
             </a:extLst>
           </p:cNvPr>
@@ -4955,7 +4955,7 @@
           <p:cNvPr id="25" name="">
             <a:extLst xmlns:a="http://schemas.openxmlformats.org/drawingml/2006/main">
               <a:ext uri="{FF2B5EF4-FFF2-40B4-BE49-F238E27FC236}">
-                <a16:creationId xmlns:a16="http://schemas.microsoft.com/office/drawing/2014/main" id="{1D47EA55-9634-4751-A005-B4E2107C3C66}"/>
+                <a16:creationId xmlns:a16="http://schemas.microsoft.com/office/drawing/2014/main" id="{7B961950-3AAD-4F23-80F5-2AC9256A00BE}"/>
               </a:ext>
             </a:extLst>
           </p:cNvPr>
@@ -5020,7 +5020,7 @@
     </p:spTree>
     <p:extLst>
       <p:ext uri="{BB962C8B-B14F-4D97-AF65-F5344CB8AC3E}">
-        <p14:creationId xmlns:p14="http://schemas.microsoft.com/office/powerpoint/2010/main" val="1765869490"/>
+        <p14:creationId xmlns:p14="http://schemas.microsoft.com/office/powerpoint/2010/main" val="860842181"/>
       </p:ext>
     </p:extLst>
   </p:cSld>
@@ -5051,7 +5051,7 @@
           <p:cNvPr id="24" name="">
             <a:extLst xmlns:a="http://schemas.openxmlformats.org/drawingml/2006/main">
               <a:ext uri="{FF2B5EF4-FFF2-40B4-BE49-F238E27FC236}">
-                <a16:creationId xmlns:a16="http://schemas.microsoft.com/office/drawing/2014/main" id="{3564ADE0-BEF0-4110-95DE-3A32D90E7A48}"/>
+                <a16:creationId xmlns:a16="http://schemas.microsoft.com/office/drawing/2014/main" id="{F02EFFE8-E701-459D-B524-BD4A9167C7EF}"/>
               </a:ext>
             </a:extLst>
           </p:cNvPr>
@@ -5082,7 +5082,7 @@
           <p:cNvPr id="2" name="">
             <a:extLst xmlns:a="http://schemas.openxmlformats.org/drawingml/2006/main">
               <a:ext uri="{FF2B5EF4-FFF2-40B4-BE49-F238E27FC236}">
-                <a16:creationId xmlns:a16="http://schemas.microsoft.com/office/drawing/2014/main" id="{D3303042-EE59-4DF3-A504-8B4953BDB9F7}"/>
+                <a16:creationId xmlns:a16="http://schemas.microsoft.com/office/drawing/2014/main" id="{92ABCEF1-AECB-4A74-AB1D-150975C6FFB9}"/>
               </a:ext>
             </a:extLst>
           </p:cNvPr>
@@ -5149,7 +5149,7 @@
           <p:cNvPr id="3" name="">
             <a:extLst xmlns:a="http://schemas.openxmlformats.org/drawingml/2006/main">
               <a:ext uri="{FF2B5EF4-FFF2-40B4-BE49-F238E27FC236}">
-                <a16:creationId xmlns:a16="http://schemas.microsoft.com/office/drawing/2014/main" id="{95B9912E-E278-489C-AA2E-A259BBF6FF34}"/>
+                <a16:creationId xmlns:a16="http://schemas.microsoft.com/office/drawing/2014/main" id="{ACFB1E2E-6BD6-48C1-B8E9-FBAB4B3E4F3E}"/>
               </a:ext>
             </a:extLst>
           </p:cNvPr>
@@ -5216,7 +5216,7 @@
           <p:cNvPr id="4" name="">
             <a:extLst xmlns:a="http://schemas.openxmlformats.org/drawingml/2006/main">
               <a:ext uri="{FF2B5EF4-FFF2-40B4-BE49-F238E27FC236}">
-                <a16:creationId xmlns:a16="http://schemas.microsoft.com/office/drawing/2014/main" id="{0770F711-AE62-499E-BC6F-D6ACBC7D422E}"/>
+                <a16:creationId xmlns:a16="http://schemas.microsoft.com/office/drawing/2014/main" id="{2A3F279A-8B42-43F9-8BFB-FF6D751D66C9}"/>
               </a:ext>
             </a:extLst>
           </p:cNvPr>
@@ -5247,7 +5247,7 @@
           <p:cNvPr id="5" name="">
             <a:extLst xmlns:a="http://schemas.openxmlformats.org/drawingml/2006/main">
               <a:ext uri="{FF2B5EF4-FFF2-40B4-BE49-F238E27FC236}">
-                <a16:creationId xmlns:a16="http://schemas.microsoft.com/office/drawing/2014/main" id="{7A9ADEFD-B5F9-4BAF-A714-EFE3BF786652}"/>
+                <a16:creationId xmlns:a16="http://schemas.microsoft.com/office/drawing/2014/main" id="{68097A54-716A-428C-AF1F-71F874E66DF3}"/>
               </a:ext>
             </a:extLst>
           </p:cNvPr>
@@ -5314,7 +5314,7 @@
           <p:cNvPr id="6" name="">
             <a:extLst xmlns:a="http://schemas.openxmlformats.org/drawingml/2006/main">
               <a:ext uri="{FF2B5EF4-FFF2-40B4-BE49-F238E27FC236}">
-                <a16:creationId xmlns:a16="http://schemas.microsoft.com/office/drawing/2014/main" id="{865C1D46-42CC-48FC-B540-2222F0BC2915}"/>
+                <a16:creationId xmlns:a16="http://schemas.microsoft.com/office/drawing/2014/main" id="{818F5600-9726-4042-8E4D-756D04534F90}"/>
               </a:ext>
             </a:extLst>
           </p:cNvPr>
@@ -5381,7 +5381,7 @@
           <p:cNvPr id="7" name="">
             <a:extLst xmlns:a="http://schemas.openxmlformats.org/drawingml/2006/main">
               <a:ext uri="{FF2B5EF4-FFF2-40B4-BE49-F238E27FC236}">
-                <a16:creationId xmlns:a16="http://schemas.microsoft.com/office/drawing/2014/main" id="{C47886F4-24A7-4D3F-8535-DEE39A02B4BC}"/>
+                <a16:creationId xmlns:a16="http://schemas.microsoft.com/office/drawing/2014/main" id="{3AF41601-F196-44DC-9713-ED5751FB72F9}"/>
               </a:ext>
             </a:extLst>
           </p:cNvPr>
@@ -5416,7 +5416,7 @@
           <p:cNvPr id="8" name="">
             <a:extLst xmlns:a="http://schemas.openxmlformats.org/drawingml/2006/main">
               <a:ext uri="{FF2B5EF4-FFF2-40B4-BE49-F238E27FC236}">
-                <a16:creationId xmlns:a16="http://schemas.microsoft.com/office/drawing/2014/main" id="{3E18BBA5-E18C-4371-B8D0-778D05410E28}"/>
+                <a16:creationId xmlns:a16="http://schemas.microsoft.com/office/drawing/2014/main" id="{73007428-8E81-4686-893E-F3D185D6DB74}"/>
               </a:ext>
             </a:extLst>
           </p:cNvPr>
@@ -5447,7 +5447,7 @@
           <p:cNvPr id="9" name="">
             <a:extLst xmlns:a="http://schemas.openxmlformats.org/drawingml/2006/main">
               <a:ext uri="{FF2B5EF4-FFF2-40B4-BE49-F238E27FC236}">
-                <a16:creationId xmlns:a16="http://schemas.microsoft.com/office/drawing/2014/main" id="{B6AD4E50-1841-40F3-96F8-9FF9FCDA5562}"/>
+                <a16:creationId xmlns:a16="http://schemas.microsoft.com/office/drawing/2014/main" id="{79BDDD56-5360-4DAC-806B-B3000F9C0AC9}"/>
               </a:ext>
             </a:extLst>
           </p:cNvPr>
@@ -5514,7 +5514,7 @@
           <p:cNvPr id="10" name="">
             <a:extLst xmlns:a="http://schemas.openxmlformats.org/drawingml/2006/main">
               <a:ext uri="{FF2B5EF4-FFF2-40B4-BE49-F238E27FC236}">
-                <a16:creationId xmlns:a16="http://schemas.microsoft.com/office/drawing/2014/main" id="{ED37D3CD-C0C5-4DF7-BAD5-BE9C4C44821E}"/>
+                <a16:creationId xmlns:a16="http://schemas.microsoft.com/office/drawing/2014/main" id="{06869F50-D8F4-426D-A673-86CD969C0D42}"/>
               </a:ext>
             </a:extLst>
           </p:cNvPr>
@@ -5673,7 +5673,7 @@
           <p:cNvPr id="11" name="">
             <a:extLst xmlns:a="http://schemas.openxmlformats.org/drawingml/2006/main">
               <a:ext uri="{FF2B5EF4-FFF2-40B4-BE49-F238E27FC236}">
-                <a16:creationId xmlns:a16="http://schemas.microsoft.com/office/drawing/2014/main" id="{F3AC97FA-1EEC-4602-8C43-8458C12A5F92}"/>
+                <a16:creationId xmlns:a16="http://schemas.microsoft.com/office/drawing/2014/main" id="{0EBEAB09-F497-46D6-9295-D2C7E74CC6DC}"/>
               </a:ext>
             </a:extLst>
           </p:cNvPr>
@@ -5708,7 +5708,7 @@
           <p:cNvPr id="12" name="">
             <a:extLst xmlns:a="http://schemas.openxmlformats.org/drawingml/2006/main">
               <a:ext uri="{FF2B5EF4-FFF2-40B4-BE49-F238E27FC236}">
-                <a16:creationId xmlns:a16="http://schemas.microsoft.com/office/drawing/2014/main" id="{FF0852C5-F2E5-4CD6-8600-090CF16DA456}"/>
+                <a16:creationId xmlns:a16="http://schemas.microsoft.com/office/drawing/2014/main" id="{01B19AF8-3453-44B6-8EFD-D371312EF07E}"/>
               </a:ext>
             </a:extLst>
           </p:cNvPr>
@@ -5739,7 +5739,7 @@
           <p:cNvPr id="13" name="">
             <a:extLst xmlns:a="http://schemas.openxmlformats.org/drawingml/2006/main">
               <a:ext uri="{FF2B5EF4-FFF2-40B4-BE49-F238E27FC236}">
-                <a16:creationId xmlns:a16="http://schemas.microsoft.com/office/drawing/2014/main" id="{1191FEC4-E1E5-438F-9152-0ED9F4DC0690}"/>
+                <a16:creationId xmlns:a16="http://schemas.microsoft.com/office/drawing/2014/main" id="{E32E7A43-1EBE-4EC3-8CC8-715D0D016491}"/>
               </a:ext>
             </a:extLst>
           </p:cNvPr>
@@ -5806,7 +5806,7 @@
           <p:cNvPr id="14" name="">
             <a:extLst xmlns:a="http://schemas.openxmlformats.org/drawingml/2006/main">
               <a:ext uri="{FF2B5EF4-FFF2-40B4-BE49-F238E27FC236}">
-                <a16:creationId xmlns:a16="http://schemas.microsoft.com/office/drawing/2014/main" id="{78D74AB4-8CDD-44BD-87FA-DC949781B33A}"/>
+                <a16:creationId xmlns:a16="http://schemas.microsoft.com/office/drawing/2014/main" id="{907CFCD4-F472-4576-A02B-2BA0767954A1}"/>
               </a:ext>
             </a:extLst>
           </p:cNvPr>
@@ -5942,7 +5942,7 @@
           <p:cNvPr id="15" name="">
             <a:extLst xmlns:a="http://schemas.openxmlformats.org/drawingml/2006/main">
               <a:ext uri="{FF2B5EF4-FFF2-40B4-BE49-F238E27FC236}">
-                <a16:creationId xmlns:a16="http://schemas.microsoft.com/office/drawing/2014/main" id="{D763430B-BB0C-4D97-B57B-30EBB78478C1}"/>
+                <a16:creationId xmlns:a16="http://schemas.microsoft.com/office/drawing/2014/main" id="{07E74B7C-CE0D-47B8-84DB-BB7B9B743042}"/>
               </a:ext>
             </a:extLst>
           </p:cNvPr>
@@ -5977,7 +5977,7 @@
           <p:cNvPr id="16" name="">
             <a:extLst xmlns:a="http://schemas.openxmlformats.org/drawingml/2006/main">
               <a:ext uri="{FF2B5EF4-FFF2-40B4-BE49-F238E27FC236}">
-                <a16:creationId xmlns:a16="http://schemas.microsoft.com/office/drawing/2014/main" id="{2238D3CE-A3BE-42CF-A7BE-3371D73812E3}"/>
+                <a16:creationId xmlns:a16="http://schemas.microsoft.com/office/drawing/2014/main" id="{F5D307C5-7847-4F27-B84C-51E3E2FA69C2}"/>
               </a:ext>
             </a:extLst>
           </p:cNvPr>
@@ -6008,7 +6008,7 @@
           <p:cNvPr id="17" name="">
             <a:extLst xmlns:a="http://schemas.openxmlformats.org/drawingml/2006/main">
               <a:ext uri="{FF2B5EF4-FFF2-40B4-BE49-F238E27FC236}">
-                <a16:creationId xmlns:a16="http://schemas.microsoft.com/office/drawing/2014/main" id="{E2B579C4-F808-47C9-8A52-90E16C4923CC}"/>
+                <a16:creationId xmlns:a16="http://schemas.microsoft.com/office/drawing/2014/main" id="{A2C5C18C-DF25-4698-A9C2-FD8DA43C03A3}"/>
               </a:ext>
             </a:extLst>
           </p:cNvPr>
@@ -6075,7 +6075,7 @@
           <p:cNvPr id="18" name="">
             <a:extLst xmlns:a="http://schemas.openxmlformats.org/drawingml/2006/main">
               <a:ext uri="{FF2B5EF4-FFF2-40B4-BE49-F238E27FC236}">
-                <a16:creationId xmlns:a16="http://schemas.microsoft.com/office/drawing/2014/main" id="{0C0BDC5A-9D0F-41AF-A2D1-3019752C41B2}"/>
+                <a16:creationId xmlns:a16="http://schemas.microsoft.com/office/drawing/2014/main" id="{652CDD67-77C1-4E1C-AE89-E2064B0CC4A9}"/>
               </a:ext>
             </a:extLst>
           </p:cNvPr>
@@ -6211,7 +6211,7 @@
           <p:cNvPr id="19" name="">
             <a:extLst xmlns:a="http://schemas.openxmlformats.org/drawingml/2006/main">
               <a:ext uri="{FF2B5EF4-FFF2-40B4-BE49-F238E27FC236}">
-                <a16:creationId xmlns:a16="http://schemas.microsoft.com/office/drawing/2014/main" id="{2E66644A-6560-4B75-98E1-761C0A60670A}"/>
+                <a16:creationId xmlns:a16="http://schemas.microsoft.com/office/drawing/2014/main" id="{86F64724-88C9-45BF-90A1-DAA4130A26C9}"/>
               </a:ext>
             </a:extLst>
           </p:cNvPr>
@@ -6242,7 +6242,7 @@
           <p:cNvPr id="20" name="">
             <a:extLst xmlns:a="http://schemas.openxmlformats.org/drawingml/2006/main">
               <a:ext uri="{FF2B5EF4-FFF2-40B4-BE49-F238E27FC236}">
-                <a16:creationId xmlns:a16="http://schemas.microsoft.com/office/drawing/2014/main" id="{2A6B78F6-DA86-4914-8A83-23525F31BF22}"/>
+                <a16:creationId xmlns:a16="http://schemas.microsoft.com/office/drawing/2014/main" id="{E0744F4D-7B9B-4A57-B9FD-E1A74E093739}"/>
               </a:ext>
             </a:extLst>
           </p:cNvPr>
@@ -6309,7 +6309,7 @@
           <p:cNvPr id="21" name="">
             <a:extLst xmlns:a="http://schemas.openxmlformats.org/drawingml/2006/main">
               <a:ext uri="{FF2B5EF4-FFF2-40B4-BE49-F238E27FC236}">
-                <a16:creationId xmlns:a16="http://schemas.microsoft.com/office/drawing/2014/main" id="{FE5975BD-D770-46A2-9BCF-B9C328AE4E9C}"/>
+                <a16:creationId xmlns:a16="http://schemas.microsoft.com/office/drawing/2014/main" id="{EE6791D0-A888-49A7-8331-545D4C15D684}"/>
               </a:ext>
             </a:extLst>
           </p:cNvPr>
@@ -6340,7 +6340,7 @@
           <p:cNvPr id="22" name="">
             <a:extLst xmlns:a="http://schemas.openxmlformats.org/drawingml/2006/main">
               <a:ext uri="{FF2B5EF4-FFF2-40B4-BE49-F238E27FC236}">
-                <a16:creationId xmlns:a16="http://schemas.microsoft.com/office/drawing/2014/main" id="{2487F032-02B2-4274-8C03-9B4DE28E4877}"/>
+                <a16:creationId xmlns:a16="http://schemas.microsoft.com/office/drawing/2014/main" id="{9A06CB68-D10E-4FBB-8A1F-C90142E48C3A}"/>
               </a:ext>
             </a:extLst>
           </p:cNvPr>
@@ -6407,7 +6407,7 @@
           <p:cNvPr id="23" name="">
             <a:extLst xmlns:a="http://schemas.openxmlformats.org/drawingml/2006/main">
               <a:ext uri="{FF2B5EF4-FFF2-40B4-BE49-F238E27FC236}">
-                <a16:creationId xmlns:a16="http://schemas.microsoft.com/office/drawing/2014/main" id="{FE055CED-FC74-41B9-ACA2-F98CD5BC322B}"/>
+                <a16:creationId xmlns:a16="http://schemas.microsoft.com/office/drawing/2014/main" id="{40A56163-56EC-4B8B-9AEB-B8B099D17963}"/>
               </a:ext>
             </a:extLst>
           </p:cNvPr>
@@ -6472,7 +6472,7 @@
     </p:spTree>
     <p:extLst>
       <p:ext uri="{BB962C8B-B14F-4D97-AF65-F5344CB8AC3E}">
-        <p14:creationId xmlns:p14="http://schemas.microsoft.com/office/powerpoint/2010/main" val="1523702618"/>
+        <p14:creationId xmlns:p14="http://schemas.microsoft.com/office/powerpoint/2010/main" val="1754748585"/>
       </p:ext>
     </p:extLst>
   </p:cSld>
@@ -6503,7 +6503,7 @@
           <p:cNvPr id="25" name="">
             <a:extLst xmlns:a="http://schemas.openxmlformats.org/drawingml/2006/main">
               <a:ext uri="{FF2B5EF4-FFF2-40B4-BE49-F238E27FC236}">
-                <a16:creationId xmlns:a16="http://schemas.microsoft.com/office/drawing/2014/main" id="{E0250192-3EF2-494B-AAD2-9F1B321EF642}"/>
+                <a16:creationId xmlns:a16="http://schemas.microsoft.com/office/drawing/2014/main" id="{12A92454-2D6F-47DC-BEEE-BA9DBE5C2817}"/>
               </a:ext>
             </a:extLst>
           </p:cNvPr>
@@ -6534,7 +6534,7 @@
           <p:cNvPr id="2" name="">
             <a:extLst xmlns:a="http://schemas.openxmlformats.org/drawingml/2006/main">
               <a:ext uri="{FF2B5EF4-FFF2-40B4-BE49-F238E27FC236}">
-                <a16:creationId xmlns:a16="http://schemas.microsoft.com/office/drawing/2014/main" id="{42E12E8C-FF42-4B2B-8821-56D570D02A87}"/>
+                <a16:creationId xmlns:a16="http://schemas.microsoft.com/office/drawing/2014/main" id="{FC7C8D6D-A81E-4AB3-A0BD-82E35EE3CA5C}"/>
               </a:ext>
             </a:extLst>
           </p:cNvPr>
@@ -6601,7 +6601,7 @@
           <p:cNvPr id="3" name="">
             <a:extLst xmlns:a="http://schemas.openxmlformats.org/drawingml/2006/main">
               <a:ext uri="{FF2B5EF4-FFF2-40B4-BE49-F238E27FC236}">
-                <a16:creationId xmlns:a16="http://schemas.microsoft.com/office/drawing/2014/main" id="{C108086D-0D59-4E0E-8C0A-ABF7F609F63A}"/>
+                <a16:creationId xmlns:a16="http://schemas.microsoft.com/office/drawing/2014/main" id="{0E1D0A04-017A-4E0D-B599-87990FF2DF9D}"/>
               </a:ext>
             </a:extLst>
           </p:cNvPr>
@@ -6668,7 +6668,7 @@
           <p:cNvPr id="4" name="">
             <a:extLst xmlns:a="http://schemas.openxmlformats.org/drawingml/2006/main">
               <a:ext uri="{FF2B5EF4-FFF2-40B4-BE49-F238E27FC236}">
-                <a16:creationId xmlns:a16="http://schemas.microsoft.com/office/drawing/2014/main" id="{EAB19438-4B96-4FCB-BEB6-9DBC5657EA78}"/>
+                <a16:creationId xmlns:a16="http://schemas.microsoft.com/office/drawing/2014/main" id="{3D342A3D-DF16-4986-9291-FD7BCF293E70}"/>
               </a:ext>
             </a:extLst>
           </p:cNvPr>
@@ -6699,7 +6699,7 @@
           <p:cNvPr id="5" name="">
             <a:extLst xmlns:a="http://schemas.openxmlformats.org/drawingml/2006/main">
               <a:ext uri="{FF2B5EF4-FFF2-40B4-BE49-F238E27FC236}">
-                <a16:creationId xmlns:a16="http://schemas.microsoft.com/office/drawing/2014/main" id="{B2C8257A-2886-48CA-B90E-32804B236554}"/>
+                <a16:creationId xmlns:a16="http://schemas.microsoft.com/office/drawing/2014/main" id="{8E8B2B3F-11C8-428C-B6EC-BFD506087AC0}"/>
               </a:ext>
             </a:extLst>
           </p:cNvPr>
@@ -6766,7 +6766,7 @@
           <p:cNvPr id="6" name="">
             <a:extLst xmlns:a="http://schemas.openxmlformats.org/drawingml/2006/main">
               <a:ext uri="{FF2B5EF4-FFF2-40B4-BE49-F238E27FC236}">
-                <a16:creationId xmlns:a16="http://schemas.microsoft.com/office/drawing/2014/main" id="{3DCFCEAC-9AD5-403F-9739-D1D82BCC64AC}"/>
+                <a16:creationId xmlns:a16="http://schemas.microsoft.com/office/drawing/2014/main" id="{4426CC83-399B-41C6-934A-B5A0304385CD}"/>
               </a:ext>
             </a:extLst>
           </p:cNvPr>
@@ -6833,7 +6833,7 @@
           <p:cNvPr id="7" name="">
             <a:extLst xmlns:a="http://schemas.openxmlformats.org/drawingml/2006/main">
               <a:ext uri="{FF2B5EF4-FFF2-40B4-BE49-F238E27FC236}">
-                <a16:creationId xmlns:a16="http://schemas.microsoft.com/office/drawing/2014/main" id="{4727403D-E297-4A3D-A763-B815CAFA04F8}"/>
+                <a16:creationId xmlns:a16="http://schemas.microsoft.com/office/drawing/2014/main" id="{5FA4D834-713B-4CCF-B255-A3A981E93953}"/>
               </a:ext>
             </a:extLst>
           </p:cNvPr>
@@ -6868,7 +6868,7 @@
           <p:cNvPr id="8" name="">
             <a:extLst xmlns:a="http://schemas.openxmlformats.org/drawingml/2006/main">
               <a:ext uri="{FF2B5EF4-FFF2-40B4-BE49-F238E27FC236}">
-                <a16:creationId xmlns:a16="http://schemas.microsoft.com/office/drawing/2014/main" id="{FCC1F900-45C5-406A-8741-718E9B6E3ED8}"/>
+                <a16:creationId xmlns:a16="http://schemas.microsoft.com/office/drawing/2014/main" id="{4F8125FD-684A-4008-8A44-0B35F03FB49D}"/>
               </a:ext>
             </a:extLst>
           </p:cNvPr>
@@ -6935,7 +6935,7 @@
           <p:cNvPr id="9" name="">
             <a:extLst xmlns:a="http://schemas.openxmlformats.org/drawingml/2006/main">
               <a:ext uri="{FF2B5EF4-FFF2-40B4-BE49-F238E27FC236}">
-                <a16:creationId xmlns:a16="http://schemas.microsoft.com/office/drawing/2014/main" id="{EFF37E95-5C7B-43C3-8D20-787FB5CE1FB3}"/>
+                <a16:creationId xmlns:a16="http://schemas.microsoft.com/office/drawing/2014/main" id="{8D3D8831-33AC-4AD2-96C7-C1784A062428}"/>
               </a:ext>
             </a:extLst>
           </p:cNvPr>
@@ -7002,7 +7002,7 @@
           <p:cNvPr id="10" name="">
             <a:extLst xmlns:a="http://schemas.openxmlformats.org/drawingml/2006/main">
               <a:ext uri="{FF2B5EF4-FFF2-40B4-BE49-F238E27FC236}">
-                <a16:creationId xmlns:a16="http://schemas.microsoft.com/office/drawing/2014/main" id="{3739409A-CCC7-40F9-B9EF-198D32DC4EBD}"/>
+                <a16:creationId xmlns:a16="http://schemas.microsoft.com/office/drawing/2014/main" id="{A0FF734B-1767-4BAC-AAB6-E45E4790E1DC}"/>
               </a:ext>
             </a:extLst>
           </p:cNvPr>
@@ -7037,7 +7037,7 @@
           <p:cNvPr id="11" name="">
             <a:extLst xmlns:a="http://schemas.openxmlformats.org/drawingml/2006/main">
               <a:ext uri="{FF2B5EF4-FFF2-40B4-BE49-F238E27FC236}">
-                <a16:creationId xmlns:a16="http://schemas.microsoft.com/office/drawing/2014/main" id="{24C08662-D170-4378-B1B4-04FCA12991C2}"/>
+                <a16:creationId xmlns:a16="http://schemas.microsoft.com/office/drawing/2014/main" id="{9CD8454C-0588-44C2-877F-75354D573A08}"/>
               </a:ext>
             </a:extLst>
           </p:cNvPr>
@@ -7104,7 +7104,7 @@
           <p:cNvPr id="12" name="">
             <a:extLst xmlns:a="http://schemas.openxmlformats.org/drawingml/2006/main">
               <a:ext uri="{FF2B5EF4-FFF2-40B4-BE49-F238E27FC236}">
-                <a16:creationId xmlns:a16="http://schemas.microsoft.com/office/drawing/2014/main" id="{06D5813F-FD53-448D-812B-975B0B8E7436}"/>
+                <a16:creationId xmlns:a16="http://schemas.microsoft.com/office/drawing/2014/main" id="{7F7C2845-41D2-477A-8648-0E620088D72C}"/>
               </a:ext>
             </a:extLst>
           </p:cNvPr>
@@ -7171,7 +7171,7 @@
           <p:cNvPr id="13" name="">
             <a:extLst xmlns:a="http://schemas.openxmlformats.org/drawingml/2006/main">
               <a:ext uri="{FF2B5EF4-FFF2-40B4-BE49-F238E27FC236}">
-                <a16:creationId xmlns:a16="http://schemas.microsoft.com/office/drawing/2014/main" id="{66EE90D5-AF1B-47AA-B6B7-7D6599F2C6A4}"/>
+                <a16:creationId xmlns:a16="http://schemas.microsoft.com/office/drawing/2014/main" id="{3CBC6F1B-6731-42C4-98C3-46CDDE1B8F74}"/>
               </a:ext>
             </a:extLst>
           </p:cNvPr>
@@ -7206,7 +7206,7 @@
           <p:cNvPr id="14" name="">
             <a:extLst xmlns:a="http://schemas.openxmlformats.org/drawingml/2006/main">
               <a:ext uri="{FF2B5EF4-FFF2-40B4-BE49-F238E27FC236}">
-                <a16:creationId xmlns:a16="http://schemas.microsoft.com/office/drawing/2014/main" id="{6FFD0DB5-B580-46DD-8B63-00950B17179A}"/>
+                <a16:creationId xmlns:a16="http://schemas.microsoft.com/office/drawing/2014/main" id="{C0BB1511-CFFB-4B7A-B2B2-3037E6E28F49}"/>
               </a:ext>
             </a:extLst>
           </p:cNvPr>
@@ -7273,7 +7273,7 @@
           <p:cNvPr id="15" name="">
             <a:extLst xmlns:a="http://schemas.openxmlformats.org/drawingml/2006/main">
               <a:ext uri="{FF2B5EF4-FFF2-40B4-BE49-F238E27FC236}">
-                <a16:creationId xmlns:a16="http://schemas.microsoft.com/office/drawing/2014/main" id="{FCB5A541-7709-4185-B82D-5D08407CFFC0}"/>
+                <a16:creationId xmlns:a16="http://schemas.microsoft.com/office/drawing/2014/main" id="{F7699610-F187-4951-9729-3701783647F3}"/>
               </a:ext>
             </a:extLst>
           </p:cNvPr>
@@ -7340,7 +7340,7 @@
           <p:cNvPr id="16" name="">
             <a:extLst xmlns:a="http://schemas.openxmlformats.org/drawingml/2006/main">
               <a:ext uri="{FF2B5EF4-FFF2-40B4-BE49-F238E27FC236}">
-                <a16:creationId xmlns:a16="http://schemas.microsoft.com/office/drawing/2014/main" id="{35E8EB5E-2EEB-4D76-A9BA-41F718B2C78D}"/>
+                <a16:creationId xmlns:a16="http://schemas.microsoft.com/office/drawing/2014/main" id="{4A795DAE-7136-4F1E-B0E8-6544E1FC1885}"/>
               </a:ext>
             </a:extLst>
           </p:cNvPr>
@@ -7375,7 +7375,7 @@
           <p:cNvPr id="17" name="">
             <a:extLst xmlns:a="http://schemas.openxmlformats.org/drawingml/2006/main">
               <a:ext uri="{FF2B5EF4-FFF2-40B4-BE49-F238E27FC236}">
-                <a16:creationId xmlns:a16="http://schemas.microsoft.com/office/drawing/2014/main" id="{E85B4D17-69CF-44C6-A08A-BC88147998EE}"/>
+                <a16:creationId xmlns:a16="http://schemas.microsoft.com/office/drawing/2014/main" id="{71E96A6C-1D00-4941-97FD-AF825BE553F0}"/>
               </a:ext>
             </a:extLst>
           </p:cNvPr>
@@ -7442,7 +7442,7 @@
           <p:cNvPr id="18" name="">
             <a:extLst xmlns:a="http://schemas.openxmlformats.org/drawingml/2006/main">
               <a:ext uri="{FF2B5EF4-FFF2-40B4-BE49-F238E27FC236}">
-                <a16:creationId xmlns:a16="http://schemas.microsoft.com/office/drawing/2014/main" id="{68F102B5-DC54-427E-8090-D738AA97A791}"/>
+                <a16:creationId xmlns:a16="http://schemas.microsoft.com/office/drawing/2014/main" id="{970C5199-E2D6-45C7-A8F9-261E648BCF08}"/>
               </a:ext>
             </a:extLst>
           </p:cNvPr>
@@ -7509,7 +7509,7 @@
           <p:cNvPr id="19" name="">
             <a:extLst xmlns:a="http://schemas.openxmlformats.org/drawingml/2006/main">
               <a:ext uri="{FF2B5EF4-FFF2-40B4-BE49-F238E27FC236}">
-                <a16:creationId xmlns:a16="http://schemas.microsoft.com/office/drawing/2014/main" id="{0DCE51C0-A782-4530-A86A-E26950A3F4A4}"/>
+                <a16:creationId xmlns:a16="http://schemas.microsoft.com/office/drawing/2014/main" id="{9DFD21B8-04A3-4A05-84EA-9F392D85E227}"/>
               </a:ext>
             </a:extLst>
           </p:cNvPr>
@@ -7544,7 +7544,7 @@
           <p:cNvPr id="20" name="">
             <a:extLst xmlns:a="http://schemas.openxmlformats.org/drawingml/2006/main">
               <a:ext uri="{FF2B5EF4-FFF2-40B4-BE49-F238E27FC236}">
-                <a16:creationId xmlns:a16="http://schemas.microsoft.com/office/drawing/2014/main" id="{00557802-A4EC-4432-AC8E-5CC7382EB544}"/>
+                <a16:creationId xmlns:a16="http://schemas.microsoft.com/office/drawing/2014/main" id="{15194ABE-E1B6-4E71-A049-B0E63F2574CB}"/>
               </a:ext>
             </a:extLst>
           </p:cNvPr>
@@ -7611,7 +7611,7 @@
           <p:cNvPr id="21" name="">
             <a:extLst xmlns:a="http://schemas.openxmlformats.org/drawingml/2006/main">
               <a:ext uri="{FF2B5EF4-FFF2-40B4-BE49-F238E27FC236}">
-                <a16:creationId xmlns:a16="http://schemas.microsoft.com/office/drawing/2014/main" id="{703203C9-72A1-47AE-81EC-72204DA7676E}"/>
+                <a16:creationId xmlns:a16="http://schemas.microsoft.com/office/drawing/2014/main" id="{EB41B74F-3631-4344-A71A-2B90330ACC5D}"/>
               </a:ext>
             </a:extLst>
           </p:cNvPr>
@@ -7678,7 +7678,7 @@
           <p:cNvPr id="22" name="">
             <a:extLst xmlns:a="http://schemas.openxmlformats.org/drawingml/2006/main">
               <a:ext uri="{FF2B5EF4-FFF2-40B4-BE49-F238E27FC236}">
-                <a16:creationId xmlns:a16="http://schemas.microsoft.com/office/drawing/2014/main" id="{3A97508C-9709-42BC-BDD1-414B6FB1576C}"/>
+                <a16:creationId xmlns:a16="http://schemas.microsoft.com/office/drawing/2014/main" id="{EDEA160D-A3B6-4DDB-BB2A-ADF3B2B344F7}"/>
               </a:ext>
             </a:extLst>
           </p:cNvPr>
@@ -7713,7 +7713,7 @@
           <p:cNvPr id="23" name="">
             <a:extLst xmlns:a="http://schemas.openxmlformats.org/drawingml/2006/main">
               <a:ext uri="{FF2B5EF4-FFF2-40B4-BE49-F238E27FC236}">
-                <a16:creationId xmlns:a16="http://schemas.microsoft.com/office/drawing/2014/main" id="{9B437FBE-B558-41A0-8185-32D85A76068E}"/>
+                <a16:creationId xmlns:a16="http://schemas.microsoft.com/office/drawing/2014/main" id="{8F72270D-5488-4D74-B9AE-C8A4F390B3A9}"/>
               </a:ext>
             </a:extLst>
           </p:cNvPr>
@@ -7770,7 +7770,7 @@
                 <a:ea typeface="Aptos"/>
                 <a:cs typeface="Aptos"/>
               </a:rPr>
-              <a:t>SQLite and random</a:t>
+              <a:t>Pandas, SQLite, random</a:t>
             </a:r>
           </a:p>
         </p:txBody>
@@ -7780,7 +7780,7 @@
           <p:cNvPr id="24" name="">
             <a:extLst xmlns:a="http://schemas.openxmlformats.org/drawingml/2006/main">
               <a:ext uri="{FF2B5EF4-FFF2-40B4-BE49-F238E27FC236}">
-                <a16:creationId xmlns:a16="http://schemas.microsoft.com/office/drawing/2014/main" id="{0C67847E-6EA1-4682-9EE7-B79FD256F916}"/>
+                <a16:creationId xmlns:a16="http://schemas.microsoft.com/office/drawing/2014/main" id="{2D238A6D-2040-43AD-ACA3-8BB87E2F7EA1}"/>
               </a:ext>
             </a:extLst>
           </p:cNvPr>
@@ -7837,7 +7837,7 @@
                 <a:ea typeface="Aptos"/>
                 <a:cs typeface="Aptos"/>
               </a:rPr>
-              <a:t>Save records; pick sample books and members</a:t>
+              <a:t>Display tables, save data, select sample members</a:t>
             </a:r>
           </a:p>
         </p:txBody>
@@ -7845,7 +7845,7 @@
     </p:spTree>
     <p:extLst>
       <p:ext uri="{BB962C8B-B14F-4D97-AF65-F5344CB8AC3E}">
-        <p14:creationId xmlns:p14="http://schemas.microsoft.com/office/powerpoint/2010/main" val="791972664"/>
+        <p14:creationId xmlns:p14="http://schemas.microsoft.com/office/powerpoint/2010/main" val="569415412"/>
       </p:ext>
     </p:extLst>
   </p:cSld>
@@ -7876,7 +7876,7 @@
           <p:cNvPr id="26" name="">
             <a:extLst xmlns:a="http://schemas.openxmlformats.org/drawingml/2006/main">
               <a:ext uri="{FF2B5EF4-FFF2-40B4-BE49-F238E27FC236}">
-                <a16:creationId xmlns:a16="http://schemas.microsoft.com/office/drawing/2014/main" id="{15628BC1-98F1-4475-9BA7-B51BB0613FF8}"/>
+                <a16:creationId xmlns:a16="http://schemas.microsoft.com/office/drawing/2014/main" id="{004C2B81-EDF3-4588-9D6A-091534F2939C}"/>
               </a:ext>
             </a:extLst>
           </p:cNvPr>
@@ -7907,7 +7907,7 @@
           <p:cNvPr id="2" name="">
             <a:extLst xmlns:a="http://schemas.openxmlformats.org/drawingml/2006/main">
               <a:ext uri="{FF2B5EF4-FFF2-40B4-BE49-F238E27FC236}">
-                <a16:creationId xmlns:a16="http://schemas.microsoft.com/office/drawing/2014/main" id="{0171C980-D096-4F58-AAE2-7D79502371BF}"/>
+                <a16:creationId xmlns:a16="http://schemas.microsoft.com/office/drawing/2014/main" id="{DAFFC511-7C4D-4037-845A-4EBB0E3C6674}"/>
               </a:ext>
             </a:extLst>
           </p:cNvPr>
@@ -7974,7 +7974,7 @@
           <p:cNvPr id="3" name="">
             <a:extLst xmlns:a="http://schemas.openxmlformats.org/drawingml/2006/main">
               <a:ext uri="{FF2B5EF4-FFF2-40B4-BE49-F238E27FC236}">
-                <a16:creationId xmlns:a16="http://schemas.microsoft.com/office/drawing/2014/main" id="{6923E007-53F1-49ED-9DF2-0E15C3D87107}"/>
+                <a16:creationId xmlns:a16="http://schemas.microsoft.com/office/drawing/2014/main" id="{D52D470C-C900-40A1-BC79-91FC3E9A6D77}"/>
               </a:ext>
             </a:extLst>
           </p:cNvPr>
@@ -8041,7 +8041,7 @@
           <p:cNvPr id="4" name="">
             <a:extLst xmlns:a="http://schemas.openxmlformats.org/drawingml/2006/main">
               <a:ext uri="{FF2B5EF4-FFF2-40B4-BE49-F238E27FC236}">
-                <a16:creationId xmlns:a16="http://schemas.microsoft.com/office/drawing/2014/main" id="{1E3839F5-AF85-4937-AC48-83B839DCF48E}"/>
+                <a16:creationId xmlns:a16="http://schemas.microsoft.com/office/drawing/2014/main" id="{EF4DC3F0-9AC9-450A-9A60-749A2C4496E9}"/>
               </a:ext>
             </a:extLst>
           </p:cNvPr>
@@ -8072,7 +8072,7 @@
           <p:cNvPr id="5" name="">
             <a:extLst xmlns:a="http://schemas.openxmlformats.org/drawingml/2006/main">
               <a:ext uri="{FF2B5EF4-FFF2-40B4-BE49-F238E27FC236}">
-                <a16:creationId xmlns:a16="http://schemas.microsoft.com/office/drawing/2014/main" id="{BEF10219-2B14-48B3-B6EE-AB797362928D}"/>
+                <a16:creationId xmlns:a16="http://schemas.microsoft.com/office/drawing/2014/main" id="{E399DE97-8681-43AC-BE44-8673C10AFD41}"/>
               </a:ext>
             </a:extLst>
           </p:cNvPr>
@@ -8139,7 +8139,7 @@
           <p:cNvPr id="6" name="">
             <a:extLst xmlns:a="http://schemas.openxmlformats.org/drawingml/2006/main">
               <a:ext uri="{FF2B5EF4-FFF2-40B4-BE49-F238E27FC236}">
-                <a16:creationId xmlns:a16="http://schemas.microsoft.com/office/drawing/2014/main" id="{E1C7C739-D0EA-401F-8873-3CF2B06FF6FB}"/>
+                <a16:creationId xmlns:a16="http://schemas.microsoft.com/office/drawing/2014/main" id="{5A249F1D-A902-412A-B6B6-5E173C1D38C0}"/>
               </a:ext>
             </a:extLst>
           </p:cNvPr>
@@ -8206,7 +8206,7 @@
           <p:cNvPr id="7" name="">
             <a:extLst xmlns:a="http://schemas.openxmlformats.org/drawingml/2006/main">
               <a:ext uri="{FF2B5EF4-FFF2-40B4-BE49-F238E27FC236}">
-                <a16:creationId xmlns:a16="http://schemas.microsoft.com/office/drawing/2014/main" id="{C2C6FC15-8447-48D7-A240-BC1B5BDEE996}"/>
+                <a16:creationId xmlns:a16="http://schemas.microsoft.com/office/drawing/2014/main" id="{5CF601F8-29CB-466B-BC74-71A109166782}"/>
               </a:ext>
             </a:extLst>
           </p:cNvPr>
@@ -8241,7 +8241,7 @@
           <p:cNvPr id="8" name="">
             <a:extLst xmlns:a="http://schemas.openxmlformats.org/drawingml/2006/main">
               <a:ext uri="{FF2B5EF4-FFF2-40B4-BE49-F238E27FC236}">
-                <a16:creationId xmlns:a16="http://schemas.microsoft.com/office/drawing/2014/main" id="{636484DF-81FD-4FF7-BE40-BDA971BCF78E}"/>
+                <a16:creationId xmlns:a16="http://schemas.microsoft.com/office/drawing/2014/main" id="{D549ADE7-2E38-4B6A-B943-73A175A32A4C}"/>
               </a:ext>
             </a:extLst>
           </p:cNvPr>
@@ -8308,7 +8308,7 @@
           <p:cNvPr id="9" name="">
             <a:extLst xmlns:a="http://schemas.openxmlformats.org/drawingml/2006/main">
               <a:ext uri="{FF2B5EF4-FFF2-40B4-BE49-F238E27FC236}">
-                <a16:creationId xmlns:a16="http://schemas.microsoft.com/office/drawing/2014/main" id="{CF910BAC-A167-49ED-9F1C-CFC7C9479A48}"/>
+                <a16:creationId xmlns:a16="http://schemas.microsoft.com/office/drawing/2014/main" id="{EA230424-5308-41C6-B294-5EFABDEFD572}"/>
               </a:ext>
             </a:extLst>
           </p:cNvPr>
@@ -8375,7 +8375,7 @@
           <p:cNvPr id="10" name="">
             <a:extLst xmlns:a="http://schemas.openxmlformats.org/drawingml/2006/main">
               <a:ext uri="{FF2B5EF4-FFF2-40B4-BE49-F238E27FC236}">
-                <a16:creationId xmlns:a16="http://schemas.microsoft.com/office/drawing/2014/main" id="{ECFA25F6-D36C-4192-BCDF-4F8486ED80AF}"/>
+                <a16:creationId xmlns:a16="http://schemas.microsoft.com/office/drawing/2014/main" id="{D344E6B8-C3AF-415D-9B9E-567CBC23A6BA}"/>
               </a:ext>
             </a:extLst>
           </p:cNvPr>
@@ -8410,7 +8410,7 @@
           <p:cNvPr id="11" name="">
             <a:extLst xmlns:a="http://schemas.openxmlformats.org/drawingml/2006/main">
               <a:ext uri="{FF2B5EF4-FFF2-40B4-BE49-F238E27FC236}">
-                <a16:creationId xmlns:a16="http://schemas.microsoft.com/office/drawing/2014/main" id="{3274A887-C434-4B97-B42D-A66ADDC6C29C}"/>
+                <a16:creationId xmlns:a16="http://schemas.microsoft.com/office/drawing/2014/main" id="{6876F310-F8C4-4803-95F9-BD135CBD7D84}"/>
               </a:ext>
             </a:extLst>
           </p:cNvPr>
@@ -8477,7 +8477,7 @@
           <p:cNvPr id="12" name="">
             <a:extLst xmlns:a="http://schemas.openxmlformats.org/drawingml/2006/main">
               <a:ext uri="{FF2B5EF4-FFF2-40B4-BE49-F238E27FC236}">
-                <a16:creationId xmlns:a16="http://schemas.microsoft.com/office/drawing/2014/main" id="{45A09245-43F7-403B-A355-242F6E7F944C}"/>
+                <a16:creationId xmlns:a16="http://schemas.microsoft.com/office/drawing/2014/main" id="{E072DDE9-A25E-459B-9D94-9DB4877330D6}"/>
               </a:ext>
             </a:extLst>
           </p:cNvPr>
@@ -8544,7 +8544,7 @@
           <p:cNvPr id="13" name="">
             <a:extLst xmlns:a="http://schemas.openxmlformats.org/drawingml/2006/main">
               <a:ext uri="{FF2B5EF4-FFF2-40B4-BE49-F238E27FC236}">
-                <a16:creationId xmlns:a16="http://schemas.microsoft.com/office/drawing/2014/main" id="{5A97344C-AAEA-4081-BA26-D0E8FCB46CAD}"/>
+                <a16:creationId xmlns:a16="http://schemas.microsoft.com/office/drawing/2014/main" id="{126839F6-EE12-461E-ACEE-3D25E94EDB2F}"/>
               </a:ext>
             </a:extLst>
           </p:cNvPr>
@@ -8579,7 +8579,7 @@
           <p:cNvPr id="14" name="">
             <a:extLst xmlns:a="http://schemas.openxmlformats.org/drawingml/2006/main">
               <a:ext uri="{FF2B5EF4-FFF2-40B4-BE49-F238E27FC236}">
-                <a16:creationId xmlns:a16="http://schemas.microsoft.com/office/drawing/2014/main" id="{5E0AE39D-C92D-4E13-803F-B4248B122465}"/>
+                <a16:creationId xmlns:a16="http://schemas.microsoft.com/office/drawing/2014/main" id="{2CA46755-1A7E-480B-B5D9-AECD28D64399}"/>
               </a:ext>
             </a:extLst>
           </p:cNvPr>
@@ -8646,7 +8646,7 @@
           <p:cNvPr id="15" name="">
             <a:extLst xmlns:a="http://schemas.openxmlformats.org/drawingml/2006/main">
               <a:ext uri="{FF2B5EF4-FFF2-40B4-BE49-F238E27FC236}">
-                <a16:creationId xmlns:a16="http://schemas.microsoft.com/office/drawing/2014/main" id="{F5B600F0-593D-4838-9CA7-95EC351E46E2}"/>
+                <a16:creationId xmlns:a16="http://schemas.microsoft.com/office/drawing/2014/main" id="{1DDE6C87-5B75-4F02-9366-98A3CC636450}"/>
               </a:ext>
             </a:extLst>
           </p:cNvPr>
@@ -8713,7 +8713,7 @@
           <p:cNvPr id="16" name="">
             <a:extLst xmlns:a="http://schemas.openxmlformats.org/drawingml/2006/main">
               <a:ext uri="{FF2B5EF4-FFF2-40B4-BE49-F238E27FC236}">
-                <a16:creationId xmlns:a16="http://schemas.microsoft.com/office/drawing/2014/main" id="{8189CD5C-089B-4629-878B-812CD9EA7DFC}"/>
+                <a16:creationId xmlns:a16="http://schemas.microsoft.com/office/drawing/2014/main" id="{61B5C5BC-2C18-49B6-B4F2-FD3C53C279EF}"/>
               </a:ext>
             </a:extLst>
           </p:cNvPr>
@@ -8748,7 +8748,7 @@
           <p:cNvPr id="17" name="">
             <a:extLst xmlns:a="http://schemas.openxmlformats.org/drawingml/2006/main">
               <a:ext uri="{FF2B5EF4-FFF2-40B4-BE49-F238E27FC236}">
-                <a16:creationId xmlns:a16="http://schemas.microsoft.com/office/drawing/2014/main" id="{5A1C7744-4D8D-4FB1-896E-FFE6CA0EBCE5}"/>
+                <a16:creationId xmlns:a16="http://schemas.microsoft.com/office/drawing/2014/main" id="{B76935F2-EB66-422A-B1DA-16C0CB7F7D49}"/>
               </a:ext>
             </a:extLst>
           </p:cNvPr>
@@ -8815,7 +8815,7 @@
           <p:cNvPr id="18" name="">
             <a:extLst xmlns:a="http://schemas.openxmlformats.org/drawingml/2006/main">
               <a:ext uri="{FF2B5EF4-FFF2-40B4-BE49-F238E27FC236}">
-                <a16:creationId xmlns:a16="http://schemas.microsoft.com/office/drawing/2014/main" id="{7E18CB6C-75B4-4296-889F-A4CA18F282A7}"/>
+                <a16:creationId xmlns:a16="http://schemas.microsoft.com/office/drawing/2014/main" id="{9CD8BAC8-E457-4113-B9DE-572CDA218274}"/>
               </a:ext>
             </a:extLst>
           </p:cNvPr>
@@ -8882,7 +8882,7 @@
           <p:cNvPr id="19" name="">
             <a:extLst xmlns:a="http://schemas.openxmlformats.org/drawingml/2006/main">
               <a:ext uri="{FF2B5EF4-FFF2-40B4-BE49-F238E27FC236}">
-                <a16:creationId xmlns:a16="http://schemas.microsoft.com/office/drawing/2014/main" id="{08ACF07D-C1DE-4AAA-BA1C-642F42272D47}"/>
+                <a16:creationId xmlns:a16="http://schemas.microsoft.com/office/drawing/2014/main" id="{AEB8A50B-EDC0-4C75-A90D-B451D54CB50C}"/>
               </a:ext>
             </a:extLst>
           </p:cNvPr>
@@ -8949,7 +8949,7 @@
           <p:cNvPr id="20" name="">
             <a:extLst xmlns:a="http://schemas.openxmlformats.org/drawingml/2006/main">
               <a:ext uri="{FF2B5EF4-FFF2-40B4-BE49-F238E27FC236}">
-                <a16:creationId xmlns:a16="http://schemas.microsoft.com/office/drawing/2014/main" id="{D26BA378-9F76-4798-91BF-48EAA82F3B9A}"/>
+                <a16:creationId xmlns:a16="http://schemas.microsoft.com/office/drawing/2014/main" id="{D8FA845E-5335-46E5-ADE8-DB435603EBE6}"/>
               </a:ext>
             </a:extLst>
           </p:cNvPr>
@@ -9016,7 +9016,7 @@
           <p:cNvPr id="21" name="">
             <a:extLst xmlns:a="http://schemas.openxmlformats.org/drawingml/2006/main">
               <a:ext uri="{FF2B5EF4-FFF2-40B4-BE49-F238E27FC236}">
-                <a16:creationId xmlns:a16="http://schemas.microsoft.com/office/drawing/2014/main" id="{C5983A2B-7F00-42E6-AB4D-0363C5D26EC7}"/>
+                <a16:creationId xmlns:a16="http://schemas.microsoft.com/office/drawing/2014/main" id="{3C1780F4-57FD-45A1-9939-2B6DC7F938CC}"/>
               </a:ext>
             </a:extLst>
           </p:cNvPr>
@@ -9083,7 +9083,7 @@
           <p:cNvPr id="22" name="">
             <a:extLst xmlns:a="http://schemas.openxmlformats.org/drawingml/2006/main">
               <a:ext uri="{FF2B5EF4-FFF2-40B4-BE49-F238E27FC236}">
-                <a16:creationId xmlns:a16="http://schemas.microsoft.com/office/drawing/2014/main" id="{0AC0771B-0B4F-4FBA-BDA5-0CE00286C644}"/>
+                <a16:creationId xmlns:a16="http://schemas.microsoft.com/office/drawing/2014/main" id="{5DB84AA0-BBF6-4290-816F-CEF0590C134F}"/>
               </a:ext>
             </a:extLst>
           </p:cNvPr>
@@ -9150,7 +9150,7 @@
           <p:cNvPr id="23" name="">
             <a:extLst xmlns:a="http://schemas.openxmlformats.org/drawingml/2006/main">
               <a:ext uri="{FF2B5EF4-FFF2-40B4-BE49-F238E27FC236}">
-                <a16:creationId xmlns:a16="http://schemas.microsoft.com/office/drawing/2014/main" id="{0190E2EC-47CF-4795-BE8D-E260B8FA0079}"/>
+                <a16:creationId xmlns:a16="http://schemas.microsoft.com/office/drawing/2014/main" id="{A55A4C61-71A6-47E3-81C5-37FB1E595582}"/>
               </a:ext>
             </a:extLst>
           </p:cNvPr>
@@ -9217,7 +9217,7 @@
           <p:cNvPr id="24" name="">
             <a:extLst xmlns:a="http://schemas.openxmlformats.org/drawingml/2006/main">
               <a:ext uri="{FF2B5EF4-FFF2-40B4-BE49-F238E27FC236}">
-                <a16:creationId xmlns:a16="http://schemas.microsoft.com/office/drawing/2014/main" id="{30EEEDBF-B683-49B1-A796-E5A1BF91CF4D}"/>
+                <a16:creationId xmlns:a16="http://schemas.microsoft.com/office/drawing/2014/main" id="{9A647239-5DD5-41AC-9688-85C3D88CE0E9}"/>
               </a:ext>
             </a:extLst>
           </p:cNvPr>
@@ -9284,7 +9284,7 @@
           <p:cNvPr id="25" name="">
             <a:extLst xmlns:a="http://schemas.openxmlformats.org/drawingml/2006/main">
               <a:ext uri="{FF2B5EF4-FFF2-40B4-BE49-F238E27FC236}">
-                <a16:creationId xmlns:a16="http://schemas.microsoft.com/office/drawing/2014/main" id="{73C115A2-AA24-45EB-8031-E43A871833CF}"/>
+                <a16:creationId xmlns:a16="http://schemas.microsoft.com/office/drawing/2014/main" id="{BE8889B1-FFE8-44CF-B983-A5B2EDA7972B}"/>
               </a:ext>
             </a:extLst>
           </p:cNvPr>
@@ -9349,7 +9349,7 @@
     </p:spTree>
     <p:extLst>
       <p:ext uri="{BB962C8B-B14F-4D97-AF65-F5344CB8AC3E}">
-        <p14:creationId xmlns:p14="http://schemas.microsoft.com/office/powerpoint/2010/main" val="1080766826"/>
+        <p14:creationId xmlns:p14="http://schemas.microsoft.com/office/powerpoint/2010/main" val="1741813340"/>
       </p:ext>
     </p:extLst>
   </p:cSld>

</xml_diff>

<commit_message>
Remove pandas and restore built-in display tables
</commit_message>
<xml_diff>
--- a/ProjectPresentation.pptx
+++ b/ProjectPresentation.pptx
@@ -2,17 +2,17 @@
 <file path=ppt/presentation.xml><?xml version="1.0" encoding="utf-8"?>
 <p:presentation xmlns:p="http://schemas.openxmlformats.org/presentationml/2006/main">
   <p:sldMasterIdLst>
-    <p:sldMasterId xmlns:r="http://schemas.openxmlformats.org/officeDocument/2006/relationships" id="2147483648" r:id="R2eb3618976814edf"/>
+    <p:sldMasterId xmlns:r="http://schemas.openxmlformats.org/officeDocument/2006/relationships" id="2147483648" r:id="Rfda49fed696b4e8d"/>
   </p:sldMasterIdLst>
   <p:notesMasterIdLst>
-    <p:notesMasterId xmlns:r="http://schemas.openxmlformats.org/officeDocument/2006/relationships" r:id="Rb68f5392a5cf488f"/>
+    <p:notesMasterId xmlns:r="http://schemas.openxmlformats.org/officeDocument/2006/relationships" r:id="Rd174cde55e82445c"/>
   </p:notesMasterIdLst>
   <p:sldIdLst>
-    <p:sldId xmlns:r="http://schemas.openxmlformats.org/officeDocument/2006/relationships" id="256" r:id="R662a0f6e7723452c"/>
-    <p:sldId xmlns:r="http://schemas.openxmlformats.org/officeDocument/2006/relationships" id="257" r:id="R8bbdcac216d04e98"/>
-    <p:sldId xmlns:r="http://schemas.openxmlformats.org/officeDocument/2006/relationships" id="258" r:id="R0a3bc0af1fcb4dc5"/>
-    <p:sldId xmlns:r="http://schemas.openxmlformats.org/officeDocument/2006/relationships" id="259" r:id="R91c27dcdad124a4a"/>
-    <p:sldId xmlns:r="http://schemas.openxmlformats.org/officeDocument/2006/relationships" id="260" r:id="R2f5da8f7bc0c432c"/>
+    <p:sldId xmlns:r="http://schemas.openxmlformats.org/officeDocument/2006/relationships" id="256" r:id="R2972596aecd944d6"/>
+    <p:sldId xmlns:r="http://schemas.openxmlformats.org/officeDocument/2006/relationships" id="257" r:id="R53b5a27886bb466f"/>
+    <p:sldId xmlns:r="http://schemas.openxmlformats.org/officeDocument/2006/relationships" id="258" r:id="R228cbdba59f643b7"/>
+    <p:sldId xmlns:r="http://schemas.openxmlformats.org/officeDocument/2006/relationships" id="259" r:id="R9b84e991110f49ea"/>
+    <p:sldId xmlns:r="http://schemas.openxmlformats.org/officeDocument/2006/relationships" id="260" r:id="R83e7a045920b42ec"/>
   </p:sldIdLst>
   <p:sldSz cx="12192000" cy="6858000"/>
   <p:notesSz cx="6858000" cy="9144000"/>
@@ -753,7 +753,7 @@
           <p:cNvPr id="3" name="Title">
             <a:extLst xmlns:a="http://schemas.openxmlformats.org/drawingml/2006/main">
               <a:ext uri="{FF2B5EF4-FFF2-40B4-BE49-F238E27FC236}">
-                <a16:creationId xmlns:a16="http://schemas.microsoft.com/office/drawing/2014/main" id="{4AB47F8D-65E7-4468-9F70-D613BFFE3EC6}"/>
+                <a16:creationId xmlns:a16="http://schemas.microsoft.com/office/drawing/2014/main" id="{3C0C0D9C-4826-4FC7-B67A-767A58FAA0B4}"/>
               </a:ext>
             </a:extLst>
           </p:cNvPr>
@@ -910,7 +910,7 @@
           <p:cNvPr id="2" name="Subtitle">
             <a:extLst xmlns:a="http://schemas.openxmlformats.org/drawingml/2006/main">
               <a:ext uri="{FF2B5EF4-FFF2-40B4-BE49-F238E27FC236}">
-                <a16:creationId xmlns:a16="http://schemas.microsoft.com/office/drawing/2014/main" id="{D2670647-1666-4B1E-A531-BB6BAC377878}"/>
+                <a16:creationId xmlns:a16="http://schemas.microsoft.com/office/drawing/2014/main" id="{C2862A66-1C4B-45DC-98C1-1538A803AF62}"/>
               </a:ext>
             </a:extLst>
           </p:cNvPr>
@@ -1084,7 +1084,7 @@
           <p:cNvPr id="2" name="Section title">
             <a:extLst xmlns:a="http://schemas.openxmlformats.org/drawingml/2006/main">
               <a:ext uri="{FF2B5EF4-FFF2-40B4-BE49-F238E27FC236}">
-                <a16:creationId xmlns:a16="http://schemas.microsoft.com/office/drawing/2014/main" id="{99FBE351-1D19-4D72-9E3F-FB1B9EA5486B}"/>
+                <a16:creationId xmlns:a16="http://schemas.microsoft.com/office/drawing/2014/main" id="{81D32813-1956-4D41-83B7-5A2779D29FA3}"/>
               </a:ext>
             </a:extLst>
           </p:cNvPr>
@@ -1258,7 +1258,7 @@
           <p:cNvPr id="3" name="Title">
             <a:extLst xmlns:a="http://schemas.openxmlformats.org/drawingml/2006/main">
               <a:ext uri="{FF2B5EF4-FFF2-40B4-BE49-F238E27FC236}">
-                <a16:creationId xmlns:a16="http://schemas.microsoft.com/office/drawing/2014/main" id="{D920387A-6518-4436-A14E-9D42B06098DF}"/>
+                <a16:creationId xmlns:a16="http://schemas.microsoft.com/office/drawing/2014/main" id="{36D294EA-ACE2-4995-A0F4-5072172DD7A9}"/>
               </a:ext>
             </a:extLst>
           </p:cNvPr>
@@ -1415,7 +1415,7 @@
           <p:cNvPr id="2" name="Body">
             <a:extLst xmlns:a="http://schemas.openxmlformats.org/drawingml/2006/main">
               <a:ext uri="{FF2B5EF4-FFF2-40B4-BE49-F238E27FC236}">
-                <a16:creationId xmlns:a16="http://schemas.microsoft.com/office/drawing/2014/main" id="{8E811F3B-AA06-4E7F-9836-7450776A3D3D}"/>
+                <a16:creationId xmlns:a16="http://schemas.microsoft.com/office/drawing/2014/main" id="{3ED09107-B1E6-48AD-B7AD-ABF86CF47DE1}"/>
               </a:ext>
             </a:extLst>
           </p:cNvPr>
@@ -1589,7 +1589,7 @@
           <p:cNvPr id="4" name="Title">
             <a:extLst xmlns:a="http://schemas.openxmlformats.org/drawingml/2006/main">
               <a:ext uri="{FF2B5EF4-FFF2-40B4-BE49-F238E27FC236}">
-                <a16:creationId xmlns:a16="http://schemas.microsoft.com/office/drawing/2014/main" id="{1BF54F59-BBD5-48F5-B159-AB3F66E29871}"/>
+                <a16:creationId xmlns:a16="http://schemas.microsoft.com/office/drawing/2014/main" id="{9744EF8C-BF60-4BAD-AC13-F5522D09A91E}"/>
               </a:ext>
             </a:extLst>
           </p:cNvPr>
@@ -1746,7 +1746,7 @@
           <p:cNvPr id="2" name="Left column">
             <a:extLst xmlns:a="http://schemas.openxmlformats.org/drawingml/2006/main">
               <a:ext uri="{FF2B5EF4-FFF2-40B4-BE49-F238E27FC236}">
-                <a16:creationId xmlns:a16="http://schemas.microsoft.com/office/drawing/2014/main" id="{E02DCFEF-0DB8-46E6-AB6B-68AE2DFE5DA6}"/>
+                <a16:creationId xmlns:a16="http://schemas.microsoft.com/office/drawing/2014/main" id="{4C6CDAA2-3AAF-4E79-ADA2-B0AE97AAA365}"/>
               </a:ext>
             </a:extLst>
           </p:cNvPr>
@@ -1903,7 +1903,7 @@
           <p:cNvPr id="3" name="Right column">
             <a:extLst xmlns:a="http://schemas.openxmlformats.org/drawingml/2006/main">
               <a:ext uri="{FF2B5EF4-FFF2-40B4-BE49-F238E27FC236}">
-                <a16:creationId xmlns:a16="http://schemas.microsoft.com/office/drawing/2014/main" id="{F386FC68-5F79-42C1-8042-60F7C0BFD5B7}"/>
+                <a16:creationId xmlns:a16="http://schemas.microsoft.com/office/drawing/2014/main" id="{1802B4B0-D708-4D0D-8D43-ACBA125080D8}"/>
               </a:ext>
             </a:extLst>
           </p:cNvPr>
@@ -2077,7 +2077,7 @@
           <p:cNvPr id="3" name="Title">
             <a:extLst xmlns:a="http://schemas.openxmlformats.org/drawingml/2006/main">
               <a:ext uri="{FF2B5EF4-FFF2-40B4-BE49-F238E27FC236}">
-                <a16:creationId xmlns:a16="http://schemas.microsoft.com/office/drawing/2014/main" id="{C5D7629A-262D-4EB2-A19D-6A536323F59F}"/>
+                <a16:creationId xmlns:a16="http://schemas.microsoft.com/office/drawing/2014/main" id="{9DDB445C-8699-4CCD-BD6D-12AB142967EF}"/>
               </a:ext>
             </a:extLst>
           </p:cNvPr>
@@ -2234,7 +2234,7 @@
           <p:cNvPr id="2" name="Left column">
             <a:extLst xmlns:a="http://schemas.openxmlformats.org/drawingml/2006/main">
               <a:ext uri="{FF2B5EF4-FFF2-40B4-BE49-F238E27FC236}">
-                <a16:creationId xmlns:a16="http://schemas.microsoft.com/office/drawing/2014/main" id="{5DA22F45-F10B-47B5-8176-1E5FE213931B}"/>
+                <a16:creationId xmlns:a16="http://schemas.microsoft.com/office/drawing/2014/main" id="{1C3A4486-8752-4924-8397-F0184B366288}"/>
               </a:ext>
             </a:extLst>
           </p:cNvPr>
@@ -2429,12 +2429,12 @@
   </p:cSld>
   <p:clrMap bg1="lt1" tx1="dk1" bg2="lt2" tx2="dk2" accent1="accent1" accent2="accent2" accent3="accent3" accent4="accent4" accent5="accent5" accent6="accent6" hlink="hlink" folHlink="folHlink"/>
   <p:sldLayoutIdLst>
-    <p:sldLayoutId xmlns:r="http://schemas.openxmlformats.org/officeDocument/2006/relationships" id="2147483649" r:id="Rffe0489583bd4e13"/>
-    <p:sldLayoutId xmlns:r="http://schemas.openxmlformats.org/officeDocument/2006/relationships" id="2147483650" r:id="R8f41c5d04307450c"/>
-    <p:sldLayoutId xmlns:r="http://schemas.openxmlformats.org/officeDocument/2006/relationships" id="2147483651" r:id="R0eadcf845de149be"/>
-    <p:sldLayoutId xmlns:r="http://schemas.openxmlformats.org/officeDocument/2006/relationships" id="2147483652" r:id="R13a68d86622240f7"/>
-    <p:sldLayoutId xmlns:r="http://schemas.openxmlformats.org/officeDocument/2006/relationships" id="2147483653" r:id="Ra883af74d14741f9"/>
-    <p:sldLayoutId xmlns:r="http://schemas.openxmlformats.org/officeDocument/2006/relationships" id="2147483654" r:id="R379594b6980547e0"/>
+    <p:sldLayoutId xmlns:r="http://schemas.openxmlformats.org/officeDocument/2006/relationships" id="2147483649" r:id="R83d74c923449493e"/>
+    <p:sldLayoutId xmlns:r="http://schemas.openxmlformats.org/officeDocument/2006/relationships" id="2147483650" r:id="R0e0db99fea43488c"/>
+    <p:sldLayoutId xmlns:r="http://schemas.openxmlformats.org/officeDocument/2006/relationships" id="2147483651" r:id="R9808c89a28e34d3c"/>
+    <p:sldLayoutId xmlns:r="http://schemas.openxmlformats.org/officeDocument/2006/relationships" id="2147483652" r:id="Rbbb1e25a502e4c98"/>
+    <p:sldLayoutId xmlns:r="http://schemas.openxmlformats.org/officeDocument/2006/relationships" id="2147483653" r:id="Rd92a6b0623cd41bb"/>
+    <p:sldLayoutId xmlns:r="http://schemas.openxmlformats.org/officeDocument/2006/relationships" id="2147483654" r:id="Rfcfd4809ec324e9b"/>
   </p:sldLayoutIdLst>
   <p:txStyles>
     <p:titleStyle>
@@ -2985,7 +2985,7 @@
           <p:cNvPr id="13" name="">
             <a:extLst xmlns:a="http://schemas.openxmlformats.org/drawingml/2006/main">
               <a:ext uri="{FF2B5EF4-FFF2-40B4-BE49-F238E27FC236}">
-                <a16:creationId xmlns:a16="http://schemas.microsoft.com/office/drawing/2014/main" id="{694AE15C-DF91-417F-938C-F99266F79B00}"/>
+                <a16:creationId xmlns:a16="http://schemas.microsoft.com/office/drawing/2014/main" id="{56A71B2B-2C3C-4DEE-BF21-BF5FB3AFF9AA}"/>
               </a:ext>
             </a:extLst>
           </p:cNvPr>
@@ -3016,7 +3016,7 @@
           <p:cNvPr id="2" name="">
             <a:extLst xmlns:a="http://schemas.openxmlformats.org/drawingml/2006/main">
               <a:ext uri="{FF2B5EF4-FFF2-40B4-BE49-F238E27FC236}">
-                <a16:creationId xmlns:a16="http://schemas.microsoft.com/office/drawing/2014/main" id="{5CF0FE77-BBF6-4612-A76D-970F05DB7FDD}"/>
+                <a16:creationId xmlns:a16="http://schemas.microsoft.com/office/drawing/2014/main" id="{DEDA6782-3520-49C5-ADE4-4C2CE17C5385}"/>
               </a:ext>
             </a:extLst>
           </p:cNvPr>
@@ -3083,7 +3083,7 @@
           <p:cNvPr id="3" name="">
             <a:extLst xmlns:a="http://schemas.openxmlformats.org/drawingml/2006/main">
               <a:ext uri="{FF2B5EF4-FFF2-40B4-BE49-F238E27FC236}">
-                <a16:creationId xmlns:a16="http://schemas.microsoft.com/office/drawing/2014/main" id="{2A695090-9CF1-4B9D-8830-598D38DAC49C}"/>
+                <a16:creationId xmlns:a16="http://schemas.microsoft.com/office/drawing/2014/main" id="{B2BE5C2A-4369-482A-A2D6-09EBC8165D60}"/>
               </a:ext>
             </a:extLst>
           </p:cNvPr>
@@ -3173,7 +3173,7 @@
           <p:cNvPr id="4" name="">
             <a:extLst xmlns:a="http://schemas.openxmlformats.org/drawingml/2006/main">
               <a:ext uri="{FF2B5EF4-FFF2-40B4-BE49-F238E27FC236}">
-                <a16:creationId xmlns:a16="http://schemas.microsoft.com/office/drawing/2014/main" id="{C6BA805F-2BDA-4ACF-90A1-DB111F50C0AF}"/>
+                <a16:creationId xmlns:a16="http://schemas.microsoft.com/office/drawing/2014/main" id="{C172D86F-C1A6-4759-AA88-8C0534A0354F}"/>
               </a:ext>
             </a:extLst>
           </p:cNvPr>
@@ -3240,7 +3240,7 @@
           <p:cNvPr id="5" name="">
             <a:extLst xmlns:a="http://schemas.openxmlformats.org/drawingml/2006/main">
               <a:ext uri="{FF2B5EF4-FFF2-40B4-BE49-F238E27FC236}">
-                <a16:creationId xmlns:a16="http://schemas.microsoft.com/office/drawing/2014/main" id="{43C7A595-81CD-4E41-AFAA-00E35071B61E}"/>
+                <a16:creationId xmlns:a16="http://schemas.microsoft.com/office/drawing/2014/main" id="{6558BEEC-DE90-4059-9A23-2C49FDD7DD1C}"/>
               </a:ext>
             </a:extLst>
           </p:cNvPr>
@@ -3307,7 +3307,7 @@
           <p:cNvPr id="6" name="">
             <a:extLst xmlns:a="http://schemas.openxmlformats.org/drawingml/2006/main">
               <a:ext uri="{FF2B5EF4-FFF2-40B4-BE49-F238E27FC236}">
-                <a16:creationId xmlns:a16="http://schemas.microsoft.com/office/drawing/2014/main" id="{7BBCAB61-67D0-4506-88AC-45B6029EA9E8}"/>
+                <a16:creationId xmlns:a16="http://schemas.microsoft.com/office/drawing/2014/main" id="{39107CFD-5550-4432-B320-89A1082EE88E}"/>
               </a:ext>
             </a:extLst>
           </p:cNvPr>
@@ -3374,7 +3374,7 @@
           <p:cNvPr id="7" name="">
             <a:extLst xmlns:a="http://schemas.openxmlformats.org/drawingml/2006/main">
               <a:ext uri="{FF2B5EF4-FFF2-40B4-BE49-F238E27FC236}">
-                <a16:creationId xmlns:a16="http://schemas.microsoft.com/office/drawing/2014/main" id="{DCA19BB1-73E1-4B6F-8C17-A6BC8277DC8C}"/>
+                <a16:creationId xmlns:a16="http://schemas.microsoft.com/office/drawing/2014/main" id="{6E178085-A6B4-4B84-BA3C-F539EBDA462F}"/>
               </a:ext>
             </a:extLst>
           </p:cNvPr>
@@ -3407,7 +3407,7 @@
           <p:cNvPr id="8" name="">
             <a:extLst xmlns:a="http://schemas.openxmlformats.org/drawingml/2006/main">
               <a:ext uri="{FF2B5EF4-FFF2-40B4-BE49-F238E27FC236}">
-                <a16:creationId xmlns:a16="http://schemas.microsoft.com/office/drawing/2014/main" id="{9C7A798B-D29A-4782-B717-703F3A0F6C69}"/>
+                <a16:creationId xmlns:a16="http://schemas.microsoft.com/office/drawing/2014/main" id="{24229E0D-7EBA-4E7B-A92E-399EC6ED3FA3}"/>
               </a:ext>
             </a:extLst>
           </p:cNvPr>
@@ -3440,7 +3440,7 @@
           <p:cNvPr id="9" name="">
             <a:extLst xmlns:a="http://schemas.openxmlformats.org/drawingml/2006/main">
               <a:ext uri="{FF2B5EF4-FFF2-40B4-BE49-F238E27FC236}">
-                <a16:creationId xmlns:a16="http://schemas.microsoft.com/office/drawing/2014/main" id="{2C161F0A-C95A-4C6A-9BAE-6D2B25A9CBDF}"/>
+                <a16:creationId xmlns:a16="http://schemas.microsoft.com/office/drawing/2014/main" id="{3C4BC699-B7D0-4C63-BC1D-35637CF6A996}"/>
               </a:ext>
             </a:extLst>
           </p:cNvPr>
@@ -3473,7 +3473,7 @@
           <p:cNvPr id="10" name="">
             <a:extLst xmlns:a="http://schemas.openxmlformats.org/drawingml/2006/main">
               <a:ext uri="{FF2B5EF4-FFF2-40B4-BE49-F238E27FC236}">
-                <a16:creationId xmlns:a16="http://schemas.microsoft.com/office/drawing/2014/main" id="{38E8CFE9-E743-42F1-A45A-6638175ABE0B}"/>
+                <a16:creationId xmlns:a16="http://schemas.microsoft.com/office/drawing/2014/main" id="{3F6DF692-218A-40E2-B37B-40E157557A52}"/>
               </a:ext>
             </a:extLst>
           </p:cNvPr>
@@ -3506,7 +3506,7 @@
           <p:cNvPr id="11" name="">
             <a:extLst xmlns:a="http://schemas.openxmlformats.org/drawingml/2006/main">
               <a:ext uri="{FF2B5EF4-FFF2-40B4-BE49-F238E27FC236}">
-                <a16:creationId xmlns:a16="http://schemas.microsoft.com/office/drawing/2014/main" id="{553941B0-C79B-452A-9A8A-D672A641DBE3}"/>
+                <a16:creationId xmlns:a16="http://schemas.microsoft.com/office/drawing/2014/main" id="{FFFE3211-E817-4ABC-B250-083BDC24F0E6}"/>
               </a:ext>
             </a:extLst>
           </p:cNvPr>
@@ -3539,7 +3539,7 @@
           <p:cNvPr id="12" name="">
             <a:extLst xmlns:a="http://schemas.openxmlformats.org/drawingml/2006/main">
               <a:ext uri="{FF2B5EF4-FFF2-40B4-BE49-F238E27FC236}">
-                <a16:creationId xmlns:a16="http://schemas.microsoft.com/office/drawing/2014/main" id="{7AC0E61B-6E8E-4D3D-802B-D6E1B0554051}"/>
+                <a16:creationId xmlns:a16="http://schemas.microsoft.com/office/drawing/2014/main" id="{FC5B6DA3-1FA6-4E0D-8C74-F3268CAD69CB}"/>
               </a:ext>
             </a:extLst>
           </p:cNvPr>
@@ -3604,7 +3604,7 @@
     </p:spTree>
     <p:extLst>
       <p:ext uri="{BB962C8B-B14F-4D97-AF65-F5344CB8AC3E}">
-        <p14:creationId xmlns:p14="http://schemas.microsoft.com/office/powerpoint/2010/main" val="248151252"/>
+        <p14:creationId xmlns:p14="http://schemas.microsoft.com/office/powerpoint/2010/main" val="1123968925"/>
       </p:ext>
     </p:extLst>
   </p:cSld>
@@ -3635,7 +3635,7 @@
           <p:cNvPr id="26" name="">
             <a:extLst xmlns:a="http://schemas.openxmlformats.org/drawingml/2006/main">
               <a:ext uri="{FF2B5EF4-FFF2-40B4-BE49-F238E27FC236}">
-                <a16:creationId xmlns:a16="http://schemas.microsoft.com/office/drawing/2014/main" id="{02E72837-7896-4CC1-90A6-9B3B25C70BBF}"/>
+                <a16:creationId xmlns:a16="http://schemas.microsoft.com/office/drawing/2014/main" id="{D7029D17-60E7-4B08-9B82-3538C32BEBA2}"/>
               </a:ext>
             </a:extLst>
           </p:cNvPr>
@@ -3666,7 +3666,7 @@
           <p:cNvPr id="2" name="">
             <a:extLst xmlns:a="http://schemas.openxmlformats.org/drawingml/2006/main">
               <a:ext uri="{FF2B5EF4-FFF2-40B4-BE49-F238E27FC236}">
-                <a16:creationId xmlns:a16="http://schemas.microsoft.com/office/drawing/2014/main" id="{BBD2ACEA-64F0-4875-8F85-67A04BBE71E4}"/>
+                <a16:creationId xmlns:a16="http://schemas.microsoft.com/office/drawing/2014/main" id="{76FADB6E-03A5-4D61-85D0-F6A18F50405B}"/>
               </a:ext>
             </a:extLst>
           </p:cNvPr>
@@ -3733,7 +3733,7 @@
           <p:cNvPr id="3" name="">
             <a:extLst xmlns:a="http://schemas.openxmlformats.org/drawingml/2006/main">
               <a:ext uri="{FF2B5EF4-FFF2-40B4-BE49-F238E27FC236}">
-                <a16:creationId xmlns:a16="http://schemas.microsoft.com/office/drawing/2014/main" id="{F3FA2C36-8E91-4782-8243-09E5159848EF}"/>
+                <a16:creationId xmlns:a16="http://schemas.microsoft.com/office/drawing/2014/main" id="{CA3DCFBE-73D0-4E73-8539-C246F57387D5}"/>
               </a:ext>
             </a:extLst>
           </p:cNvPr>
@@ -3800,7 +3800,7 @@
           <p:cNvPr id="4" name="">
             <a:extLst xmlns:a="http://schemas.openxmlformats.org/drawingml/2006/main">
               <a:ext uri="{FF2B5EF4-FFF2-40B4-BE49-F238E27FC236}">
-                <a16:creationId xmlns:a16="http://schemas.microsoft.com/office/drawing/2014/main" id="{F423346E-30AE-47D1-A220-84423C18EE89}"/>
+                <a16:creationId xmlns:a16="http://schemas.microsoft.com/office/drawing/2014/main" id="{65C49D59-16DD-4207-98AB-A574B824FECF}"/>
               </a:ext>
             </a:extLst>
           </p:cNvPr>
@@ -3831,7 +3831,7 @@
           <p:cNvPr id="5" name="">
             <a:extLst xmlns:a="http://schemas.openxmlformats.org/drawingml/2006/main">
               <a:ext uri="{FF2B5EF4-FFF2-40B4-BE49-F238E27FC236}">
-                <a16:creationId xmlns:a16="http://schemas.microsoft.com/office/drawing/2014/main" id="{63F4C655-2385-41A5-A451-8B362185EC4A}"/>
+                <a16:creationId xmlns:a16="http://schemas.microsoft.com/office/drawing/2014/main" id="{F45B512E-1018-4052-8D69-BC8CF10A1684}"/>
               </a:ext>
             </a:extLst>
           </p:cNvPr>
@@ -3898,7 +3898,7 @@
           <p:cNvPr id="6" name="">
             <a:extLst xmlns:a="http://schemas.openxmlformats.org/drawingml/2006/main">
               <a:ext uri="{FF2B5EF4-FFF2-40B4-BE49-F238E27FC236}">
-                <a16:creationId xmlns:a16="http://schemas.microsoft.com/office/drawing/2014/main" id="{0ACECA17-2D69-4A7B-96E2-BB6B5940EEA1}"/>
+                <a16:creationId xmlns:a16="http://schemas.microsoft.com/office/drawing/2014/main" id="{AA3C1DBB-2D02-4D3A-B5E7-D12B02F3CB6F}"/>
               </a:ext>
             </a:extLst>
           </p:cNvPr>
@@ -3965,7 +3965,7 @@
           <p:cNvPr id="7" name="">
             <a:extLst xmlns:a="http://schemas.openxmlformats.org/drawingml/2006/main">
               <a:ext uri="{FF2B5EF4-FFF2-40B4-BE49-F238E27FC236}">
-                <a16:creationId xmlns:a16="http://schemas.microsoft.com/office/drawing/2014/main" id="{805F4565-701D-47D9-A44C-B21EF98065AB}"/>
+                <a16:creationId xmlns:a16="http://schemas.microsoft.com/office/drawing/2014/main" id="{BAAB9E5D-999A-4BBD-A6C1-15A319FE7153}"/>
               </a:ext>
             </a:extLst>
           </p:cNvPr>
@@ -3996,7 +3996,7 @@
           <p:cNvPr id="8" name="">
             <a:extLst xmlns:a="http://schemas.openxmlformats.org/drawingml/2006/main">
               <a:ext uri="{FF2B5EF4-FFF2-40B4-BE49-F238E27FC236}">
-                <a16:creationId xmlns:a16="http://schemas.microsoft.com/office/drawing/2014/main" id="{F75AF689-26BC-4728-8E4B-41A3C9992EB7}"/>
+                <a16:creationId xmlns:a16="http://schemas.microsoft.com/office/drawing/2014/main" id="{B7FEBFAB-3BC8-49E4-8C87-C0AA750DF72D}"/>
               </a:ext>
             </a:extLst>
           </p:cNvPr>
@@ -4063,7 +4063,7 @@
           <p:cNvPr id="9" name="">
             <a:extLst xmlns:a="http://schemas.openxmlformats.org/drawingml/2006/main">
               <a:ext uri="{FF2B5EF4-FFF2-40B4-BE49-F238E27FC236}">
-                <a16:creationId xmlns:a16="http://schemas.microsoft.com/office/drawing/2014/main" id="{4F8AC3FE-DF1A-4449-9BE9-B8116F89B9C0}"/>
+                <a16:creationId xmlns:a16="http://schemas.microsoft.com/office/drawing/2014/main" id="{01E1B5C4-B794-414C-ABA4-24CB34D32692}"/>
               </a:ext>
             </a:extLst>
           </p:cNvPr>
@@ -4130,7 +4130,7 @@
           <p:cNvPr id="10" name="">
             <a:extLst xmlns:a="http://schemas.openxmlformats.org/drawingml/2006/main">
               <a:ext uri="{FF2B5EF4-FFF2-40B4-BE49-F238E27FC236}">
-                <a16:creationId xmlns:a16="http://schemas.microsoft.com/office/drawing/2014/main" id="{04FFF684-7A2E-457C-B3E2-621EDDFF73A1}"/>
+                <a16:creationId xmlns:a16="http://schemas.microsoft.com/office/drawing/2014/main" id="{ADA2982D-2634-4EFA-9778-B944F6A2ED52}"/>
               </a:ext>
             </a:extLst>
           </p:cNvPr>
@@ -4161,7 +4161,7 @@
           <p:cNvPr id="11" name="">
             <a:extLst xmlns:a="http://schemas.openxmlformats.org/drawingml/2006/main">
               <a:ext uri="{FF2B5EF4-FFF2-40B4-BE49-F238E27FC236}">
-                <a16:creationId xmlns:a16="http://schemas.microsoft.com/office/drawing/2014/main" id="{BDD27D00-3419-4556-A918-6C0870FADF4A}"/>
+                <a16:creationId xmlns:a16="http://schemas.microsoft.com/office/drawing/2014/main" id="{4E3A264F-7093-4CBB-8209-6E65457B6826}"/>
               </a:ext>
             </a:extLst>
           </p:cNvPr>
@@ -4228,7 +4228,7 @@
           <p:cNvPr id="12" name="">
             <a:extLst xmlns:a="http://schemas.openxmlformats.org/drawingml/2006/main">
               <a:ext uri="{FF2B5EF4-FFF2-40B4-BE49-F238E27FC236}">
-                <a16:creationId xmlns:a16="http://schemas.microsoft.com/office/drawing/2014/main" id="{2E742957-57A2-4B69-A3E6-86172C01E5E4}"/>
+                <a16:creationId xmlns:a16="http://schemas.microsoft.com/office/drawing/2014/main" id="{2348AA7C-E062-45EA-94EF-2FA088BCE41F}"/>
               </a:ext>
             </a:extLst>
           </p:cNvPr>
@@ -4295,7 +4295,7 @@
           <p:cNvPr id="13" name="">
             <a:extLst xmlns:a="http://schemas.openxmlformats.org/drawingml/2006/main">
               <a:ext uri="{FF2B5EF4-FFF2-40B4-BE49-F238E27FC236}">
-                <a16:creationId xmlns:a16="http://schemas.microsoft.com/office/drawing/2014/main" id="{1506911E-46FF-4FB8-93FC-2370A47E7159}"/>
+                <a16:creationId xmlns:a16="http://schemas.microsoft.com/office/drawing/2014/main" id="{859DACB8-2E30-4846-A577-074F2C3CE1D7}"/>
               </a:ext>
             </a:extLst>
           </p:cNvPr>
@@ -4326,7 +4326,7 @@
           <p:cNvPr id="14" name="">
             <a:extLst xmlns:a="http://schemas.openxmlformats.org/drawingml/2006/main">
               <a:ext uri="{FF2B5EF4-FFF2-40B4-BE49-F238E27FC236}">
-                <a16:creationId xmlns:a16="http://schemas.microsoft.com/office/drawing/2014/main" id="{E5C327FC-6D3A-4003-886D-77B03F9B13F8}"/>
+                <a16:creationId xmlns:a16="http://schemas.microsoft.com/office/drawing/2014/main" id="{DFBADE26-D635-45C1-B070-A908110059EA}"/>
               </a:ext>
             </a:extLst>
           </p:cNvPr>
@@ -4393,7 +4393,7 @@
           <p:cNvPr id="15" name="">
             <a:extLst xmlns:a="http://schemas.openxmlformats.org/drawingml/2006/main">
               <a:ext uri="{FF2B5EF4-FFF2-40B4-BE49-F238E27FC236}">
-                <a16:creationId xmlns:a16="http://schemas.microsoft.com/office/drawing/2014/main" id="{6EA38C11-2E27-472D-91AB-96C4F641248B}"/>
+                <a16:creationId xmlns:a16="http://schemas.microsoft.com/office/drawing/2014/main" id="{21100143-AB05-4EBD-AAFD-F30973C50D0B}"/>
               </a:ext>
             </a:extLst>
           </p:cNvPr>
@@ -4460,7 +4460,7 @@
           <p:cNvPr id="16" name="">
             <a:extLst xmlns:a="http://schemas.openxmlformats.org/drawingml/2006/main">
               <a:ext uri="{FF2B5EF4-FFF2-40B4-BE49-F238E27FC236}">
-                <a16:creationId xmlns:a16="http://schemas.microsoft.com/office/drawing/2014/main" id="{366BA250-8639-4E46-8FDE-9D171E68A95A}"/>
+                <a16:creationId xmlns:a16="http://schemas.microsoft.com/office/drawing/2014/main" id="{BC992439-D1BD-471D-A948-0B2FF9C0BDBE}"/>
               </a:ext>
             </a:extLst>
           </p:cNvPr>
@@ -4491,7 +4491,7 @@
           <p:cNvPr id="17" name="">
             <a:extLst xmlns:a="http://schemas.openxmlformats.org/drawingml/2006/main">
               <a:ext uri="{FF2B5EF4-FFF2-40B4-BE49-F238E27FC236}">
-                <a16:creationId xmlns:a16="http://schemas.microsoft.com/office/drawing/2014/main" id="{C59B0327-B558-49F9-BF15-B0C01480950B}"/>
+                <a16:creationId xmlns:a16="http://schemas.microsoft.com/office/drawing/2014/main" id="{33E9904A-6748-47DB-84B1-B2669956AFBA}"/>
               </a:ext>
             </a:extLst>
           </p:cNvPr>
@@ -4558,7 +4558,7 @@
           <p:cNvPr id="18" name="">
             <a:extLst xmlns:a="http://schemas.openxmlformats.org/drawingml/2006/main">
               <a:ext uri="{FF2B5EF4-FFF2-40B4-BE49-F238E27FC236}">
-                <a16:creationId xmlns:a16="http://schemas.microsoft.com/office/drawing/2014/main" id="{6E4D18C1-5C9C-4895-9258-4286977F170F}"/>
+                <a16:creationId xmlns:a16="http://schemas.microsoft.com/office/drawing/2014/main" id="{FE8CE6AE-EB0D-4D0E-896D-47F738450827}"/>
               </a:ext>
             </a:extLst>
           </p:cNvPr>
@@ -4625,7 +4625,7 @@
           <p:cNvPr id="19" name="">
             <a:extLst xmlns:a="http://schemas.openxmlformats.org/drawingml/2006/main">
               <a:ext uri="{FF2B5EF4-FFF2-40B4-BE49-F238E27FC236}">
-                <a16:creationId xmlns:a16="http://schemas.microsoft.com/office/drawing/2014/main" id="{726B642E-C07F-47DC-86EC-61E648550729}"/>
+                <a16:creationId xmlns:a16="http://schemas.microsoft.com/office/drawing/2014/main" id="{FFEF74D2-7441-43D0-B603-E2832FDB61E7}"/>
               </a:ext>
             </a:extLst>
           </p:cNvPr>
@@ -4656,7 +4656,7 @@
           <p:cNvPr id="20" name="">
             <a:extLst xmlns:a="http://schemas.openxmlformats.org/drawingml/2006/main">
               <a:ext uri="{FF2B5EF4-FFF2-40B4-BE49-F238E27FC236}">
-                <a16:creationId xmlns:a16="http://schemas.microsoft.com/office/drawing/2014/main" id="{AC4E4CDB-7A46-4F93-858C-E31067A800D7}"/>
+                <a16:creationId xmlns:a16="http://schemas.microsoft.com/office/drawing/2014/main" id="{D1DCA720-DFB5-4662-B745-6EA804B2B2FC}"/>
               </a:ext>
             </a:extLst>
           </p:cNvPr>
@@ -4723,7 +4723,7 @@
           <p:cNvPr id="21" name="">
             <a:extLst xmlns:a="http://schemas.openxmlformats.org/drawingml/2006/main">
               <a:ext uri="{FF2B5EF4-FFF2-40B4-BE49-F238E27FC236}">
-                <a16:creationId xmlns:a16="http://schemas.microsoft.com/office/drawing/2014/main" id="{1FAC3996-C2D5-4671-A8F9-2572218D56E2}"/>
+                <a16:creationId xmlns:a16="http://schemas.microsoft.com/office/drawing/2014/main" id="{DE473236-E0F6-426B-BE87-C6947C9D9DB0}"/>
               </a:ext>
             </a:extLst>
           </p:cNvPr>
@@ -4790,7 +4790,7 @@
           <p:cNvPr id="22" name="">
             <a:extLst xmlns:a="http://schemas.openxmlformats.org/drawingml/2006/main">
               <a:ext uri="{FF2B5EF4-FFF2-40B4-BE49-F238E27FC236}">
-                <a16:creationId xmlns:a16="http://schemas.microsoft.com/office/drawing/2014/main" id="{6961EA92-9B86-43E3-90A7-DD0BED57650E}"/>
+                <a16:creationId xmlns:a16="http://schemas.microsoft.com/office/drawing/2014/main" id="{BCECDD00-16E2-4A10-AEC1-7BDE2FA30FED}"/>
               </a:ext>
             </a:extLst>
           </p:cNvPr>
@@ -4821,7 +4821,7 @@
           <p:cNvPr id="23" name="">
             <a:extLst xmlns:a="http://schemas.openxmlformats.org/drawingml/2006/main">
               <a:ext uri="{FF2B5EF4-FFF2-40B4-BE49-F238E27FC236}">
-                <a16:creationId xmlns:a16="http://schemas.microsoft.com/office/drawing/2014/main" id="{51B5C091-2190-41B4-9DB4-ACACF7F7E2F2}"/>
+                <a16:creationId xmlns:a16="http://schemas.microsoft.com/office/drawing/2014/main" id="{CB5182AA-AEC1-4E11-9282-C56450A31114}"/>
               </a:ext>
             </a:extLst>
           </p:cNvPr>
@@ -4888,7 +4888,7 @@
           <p:cNvPr id="24" name="">
             <a:extLst xmlns:a="http://schemas.openxmlformats.org/drawingml/2006/main">
               <a:ext uri="{FF2B5EF4-FFF2-40B4-BE49-F238E27FC236}">
-                <a16:creationId xmlns:a16="http://schemas.microsoft.com/office/drawing/2014/main" id="{7C8A2B2D-1C4F-48D4-9DCA-9DCB33502657}"/>
+                <a16:creationId xmlns:a16="http://schemas.microsoft.com/office/drawing/2014/main" id="{474DDB3A-EAA4-4DFC-803D-0889A47E079E}"/>
               </a:ext>
             </a:extLst>
           </p:cNvPr>
@@ -4955,7 +4955,7 @@
           <p:cNvPr id="25" name="">
             <a:extLst xmlns:a="http://schemas.openxmlformats.org/drawingml/2006/main">
               <a:ext uri="{FF2B5EF4-FFF2-40B4-BE49-F238E27FC236}">
-                <a16:creationId xmlns:a16="http://schemas.microsoft.com/office/drawing/2014/main" id="{7B961950-3AAD-4F23-80F5-2AC9256A00BE}"/>
+                <a16:creationId xmlns:a16="http://schemas.microsoft.com/office/drawing/2014/main" id="{A0F0EDDF-92F2-4318-9548-A379B4B16A4A}"/>
               </a:ext>
             </a:extLst>
           </p:cNvPr>
@@ -5020,7 +5020,7 @@
     </p:spTree>
     <p:extLst>
       <p:ext uri="{BB962C8B-B14F-4D97-AF65-F5344CB8AC3E}">
-        <p14:creationId xmlns:p14="http://schemas.microsoft.com/office/powerpoint/2010/main" val="860842181"/>
+        <p14:creationId xmlns:p14="http://schemas.microsoft.com/office/powerpoint/2010/main" val="1186434359"/>
       </p:ext>
     </p:extLst>
   </p:cSld>
@@ -5051,7 +5051,7 @@
           <p:cNvPr id="24" name="">
             <a:extLst xmlns:a="http://schemas.openxmlformats.org/drawingml/2006/main">
               <a:ext uri="{FF2B5EF4-FFF2-40B4-BE49-F238E27FC236}">
-                <a16:creationId xmlns:a16="http://schemas.microsoft.com/office/drawing/2014/main" id="{F02EFFE8-E701-459D-B524-BD4A9167C7EF}"/>
+                <a16:creationId xmlns:a16="http://schemas.microsoft.com/office/drawing/2014/main" id="{0E783890-ACC2-47CA-915C-AA5547521664}"/>
               </a:ext>
             </a:extLst>
           </p:cNvPr>
@@ -5082,7 +5082,7 @@
           <p:cNvPr id="2" name="">
             <a:extLst xmlns:a="http://schemas.openxmlformats.org/drawingml/2006/main">
               <a:ext uri="{FF2B5EF4-FFF2-40B4-BE49-F238E27FC236}">
-                <a16:creationId xmlns:a16="http://schemas.microsoft.com/office/drawing/2014/main" id="{92ABCEF1-AECB-4A74-AB1D-150975C6FFB9}"/>
+                <a16:creationId xmlns:a16="http://schemas.microsoft.com/office/drawing/2014/main" id="{C2D3E747-EE47-4FD0-B21E-E693BF1742F5}"/>
               </a:ext>
             </a:extLst>
           </p:cNvPr>
@@ -5149,7 +5149,7 @@
           <p:cNvPr id="3" name="">
             <a:extLst xmlns:a="http://schemas.openxmlformats.org/drawingml/2006/main">
               <a:ext uri="{FF2B5EF4-FFF2-40B4-BE49-F238E27FC236}">
-                <a16:creationId xmlns:a16="http://schemas.microsoft.com/office/drawing/2014/main" id="{ACFB1E2E-6BD6-48C1-B8E9-FBAB4B3E4F3E}"/>
+                <a16:creationId xmlns:a16="http://schemas.microsoft.com/office/drawing/2014/main" id="{EDD0B57E-567E-46E2-8FE2-6CD6630C7A7A}"/>
               </a:ext>
             </a:extLst>
           </p:cNvPr>
@@ -5216,7 +5216,7 @@
           <p:cNvPr id="4" name="">
             <a:extLst xmlns:a="http://schemas.openxmlformats.org/drawingml/2006/main">
               <a:ext uri="{FF2B5EF4-FFF2-40B4-BE49-F238E27FC236}">
-                <a16:creationId xmlns:a16="http://schemas.microsoft.com/office/drawing/2014/main" id="{2A3F279A-8B42-43F9-8BFB-FF6D751D66C9}"/>
+                <a16:creationId xmlns:a16="http://schemas.microsoft.com/office/drawing/2014/main" id="{6A0C40F5-1F60-4F3D-910F-75DECBEDFB18}"/>
               </a:ext>
             </a:extLst>
           </p:cNvPr>
@@ -5247,7 +5247,7 @@
           <p:cNvPr id="5" name="">
             <a:extLst xmlns:a="http://schemas.openxmlformats.org/drawingml/2006/main">
               <a:ext uri="{FF2B5EF4-FFF2-40B4-BE49-F238E27FC236}">
-                <a16:creationId xmlns:a16="http://schemas.microsoft.com/office/drawing/2014/main" id="{68097A54-716A-428C-AF1F-71F874E66DF3}"/>
+                <a16:creationId xmlns:a16="http://schemas.microsoft.com/office/drawing/2014/main" id="{518743A1-D5B4-4393-BF30-5A8FC5EEF601}"/>
               </a:ext>
             </a:extLst>
           </p:cNvPr>
@@ -5314,7 +5314,7 @@
           <p:cNvPr id="6" name="">
             <a:extLst xmlns:a="http://schemas.openxmlformats.org/drawingml/2006/main">
               <a:ext uri="{FF2B5EF4-FFF2-40B4-BE49-F238E27FC236}">
-                <a16:creationId xmlns:a16="http://schemas.microsoft.com/office/drawing/2014/main" id="{818F5600-9726-4042-8E4D-756D04534F90}"/>
+                <a16:creationId xmlns:a16="http://schemas.microsoft.com/office/drawing/2014/main" id="{E1818AFB-5487-438F-8F39-EAF89C0CFC14}"/>
               </a:ext>
             </a:extLst>
           </p:cNvPr>
@@ -5381,7 +5381,7 @@
           <p:cNvPr id="7" name="">
             <a:extLst xmlns:a="http://schemas.openxmlformats.org/drawingml/2006/main">
               <a:ext uri="{FF2B5EF4-FFF2-40B4-BE49-F238E27FC236}">
-                <a16:creationId xmlns:a16="http://schemas.microsoft.com/office/drawing/2014/main" id="{3AF41601-F196-44DC-9713-ED5751FB72F9}"/>
+                <a16:creationId xmlns:a16="http://schemas.microsoft.com/office/drawing/2014/main" id="{15E4F66D-8A23-468D-87E4-13F5ECAD37E0}"/>
               </a:ext>
             </a:extLst>
           </p:cNvPr>
@@ -5416,7 +5416,7 @@
           <p:cNvPr id="8" name="">
             <a:extLst xmlns:a="http://schemas.openxmlformats.org/drawingml/2006/main">
               <a:ext uri="{FF2B5EF4-FFF2-40B4-BE49-F238E27FC236}">
-                <a16:creationId xmlns:a16="http://schemas.microsoft.com/office/drawing/2014/main" id="{73007428-8E81-4686-893E-F3D185D6DB74}"/>
+                <a16:creationId xmlns:a16="http://schemas.microsoft.com/office/drawing/2014/main" id="{180D8EDA-76EB-4F40-B5D9-1D83DB2D2981}"/>
               </a:ext>
             </a:extLst>
           </p:cNvPr>
@@ -5447,7 +5447,7 @@
           <p:cNvPr id="9" name="">
             <a:extLst xmlns:a="http://schemas.openxmlformats.org/drawingml/2006/main">
               <a:ext uri="{FF2B5EF4-FFF2-40B4-BE49-F238E27FC236}">
-                <a16:creationId xmlns:a16="http://schemas.microsoft.com/office/drawing/2014/main" id="{79BDDD56-5360-4DAC-806B-B3000F9C0AC9}"/>
+                <a16:creationId xmlns:a16="http://schemas.microsoft.com/office/drawing/2014/main" id="{D53B20D2-E08F-4676-B8E4-C4BDA05D940D}"/>
               </a:ext>
             </a:extLst>
           </p:cNvPr>
@@ -5514,7 +5514,7 @@
           <p:cNvPr id="10" name="">
             <a:extLst xmlns:a="http://schemas.openxmlformats.org/drawingml/2006/main">
               <a:ext uri="{FF2B5EF4-FFF2-40B4-BE49-F238E27FC236}">
-                <a16:creationId xmlns:a16="http://schemas.microsoft.com/office/drawing/2014/main" id="{06869F50-D8F4-426D-A673-86CD969C0D42}"/>
+                <a16:creationId xmlns:a16="http://schemas.microsoft.com/office/drawing/2014/main" id="{09F74944-7D12-40A1-9EAE-B05913FB1C3F}"/>
               </a:ext>
             </a:extLst>
           </p:cNvPr>
@@ -5673,7 +5673,7 @@
           <p:cNvPr id="11" name="">
             <a:extLst xmlns:a="http://schemas.openxmlformats.org/drawingml/2006/main">
               <a:ext uri="{FF2B5EF4-FFF2-40B4-BE49-F238E27FC236}">
-                <a16:creationId xmlns:a16="http://schemas.microsoft.com/office/drawing/2014/main" id="{0EBEAB09-F497-46D6-9295-D2C7E74CC6DC}"/>
+                <a16:creationId xmlns:a16="http://schemas.microsoft.com/office/drawing/2014/main" id="{785AFAA3-0D80-4EA6-BED6-093CE6DD21AB}"/>
               </a:ext>
             </a:extLst>
           </p:cNvPr>
@@ -5708,7 +5708,7 @@
           <p:cNvPr id="12" name="">
             <a:extLst xmlns:a="http://schemas.openxmlformats.org/drawingml/2006/main">
               <a:ext uri="{FF2B5EF4-FFF2-40B4-BE49-F238E27FC236}">
-                <a16:creationId xmlns:a16="http://schemas.microsoft.com/office/drawing/2014/main" id="{01B19AF8-3453-44B6-8EFD-D371312EF07E}"/>
+                <a16:creationId xmlns:a16="http://schemas.microsoft.com/office/drawing/2014/main" id="{193BE48B-43C4-42D7-BD10-6F10696033F9}"/>
               </a:ext>
             </a:extLst>
           </p:cNvPr>
@@ -5739,7 +5739,7 @@
           <p:cNvPr id="13" name="">
             <a:extLst xmlns:a="http://schemas.openxmlformats.org/drawingml/2006/main">
               <a:ext uri="{FF2B5EF4-FFF2-40B4-BE49-F238E27FC236}">
-                <a16:creationId xmlns:a16="http://schemas.microsoft.com/office/drawing/2014/main" id="{E32E7A43-1EBE-4EC3-8CC8-715D0D016491}"/>
+                <a16:creationId xmlns:a16="http://schemas.microsoft.com/office/drawing/2014/main" id="{F92BE1DF-34CA-46B4-8DE3-2C3C1EC26E66}"/>
               </a:ext>
             </a:extLst>
           </p:cNvPr>
@@ -5806,7 +5806,7 @@
           <p:cNvPr id="14" name="">
             <a:extLst xmlns:a="http://schemas.openxmlformats.org/drawingml/2006/main">
               <a:ext uri="{FF2B5EF4-FFF2-40B4-BE49-F238E27FC236}">
-                <a16:creationId xmlns:a16="http://schemas.microsoft.com/office/drawing/2014/main" id="{907CFCD4-F472-4576-A02B-2BA0767954A1}"/>
+                <a16:creationId xmlns:a16="http://schemas.microsoft.com/office/drawing/2014/main" id="{302BA99B-5F7E-41BD-B366-D5E4EF16D94F}"/>
               </a:ext>
             </a:extLst>
           </p:cNvPr>
@@ -5942,7 +5942,7 @@
           <p:cNvPr id="15" name="">
             <a:extLst xmlns:a="http://schemas.openxmlformats.org/drawingml/2006/main">
               <a:ext uri="{FF2B5EF4-FFF2-40B4-BE49-F238E27FC236}">
-                <a16:creationId xmlns:a16="http://schemas.microsoft.com/office/drawing/2014/main" id="{07E74B7C-CE0D-47B8-84DB-BB7B9B743042}"/>
+                <a16:creationId xmlns:a16="http://schemas.microsoft.com/office/drawing/2014/main" id="{6475AC7B-914D-428F-92C1-9C98891CBD11}"/>
               </a:ext>
             </a:extLst>
           </p:cNvPr>
@@ -5977,7 +5977,7 @@
           <p:cNvPr id="16" name="">
             <a:extLst xmlns:a="http://schemas.openxmlformats.org/drawingml/2006/main">
               <a:ext uri="{FF2B5EF4-FFF2-40B4-BE49-F238E27FC236}">
-                <a16:creationId xmlns:a16="http://schemas.microsoft.com/office/drawing/2014/main" id="{F5D307C5-7847-4F27-B84C-51E3E2FA69C2}"/>
+                <a16:creationId xmlns:a16="http://schemas.microsoft.com/office/drawing/2014/main" id="{594F229D-8860-49F5-908F-8175CC8ADBAB}"/>
               </a:ext>
             </a:extLst>
           </p:cNvPr>
@@ -6008,7 +6008,7 @@
           <p:cNvPr id="17" name="">
             <a:extLst xmlns:a="http://schemas.openxmlformats.org/drawingml/2006/main">
               <a:ext uri="{FF2B5EF4-FFF2-40B4-BE49-F238E27FC236}">
-                <a16:creationId xmlns:a16="http://schemas.microsoft.com/office/drawing/2014/main" id="{A2C5C18C-DF25-4698-A9C2-FD8DA43C03A3}"/>
+                <a16:creationId xmlns:a16="http://schemas.microsoft.com/office/drawing/2014/main" id="{59F48890-5687-45C9-988D-FABA798BB1FE}"/>
               </a:ext>
             </a:extLst>
           </p:cNvPr>
@@ -6075,7 +6075,7 @@
           <p:cNvPr id="18" name="">
             <a:extLst xmlns:a="http://schemas.openxmlformats.org/drawingml/2006/main">
               <a:ext uri="{FF2B5EF4-FFF2-40B4-BE49-F238E27FC236}">
-                <a16:creationId xmlns:a16="http://schemas.microsoft.com/office/drawing/2014/main" id="{652CDD67-77C1-4E1C-AE89-E2064B0CC4A9}"/>
+                <a16:creationId xmlns:a16="http://schemas.microsoft.com/office/drawing/2014/main" id="{3CEFA1E6-A679-41B2-A226-74025EE34AAF}"/>
               </a:ext>
             </a:extLst>
           </p:cNvPr>
@@ -6211,7 +6211,7 @@
           <p:cNvPr id="19" name="">
             <a:extLst xmlns:a="http://schemas.openxmlformats.org/drawingml/2006/main">
               <a:ext uri="{FF2B5EF4-FFF2-40B4-BE49-F238E27FC236}">
-                <a16:creationId xmlns:a16="http://schemas.microsoft.com/office/drawing/2014/main" id="{86F64724-88C9-45BF-90A1-DAA4130A26C9}"/>
+                <a16:creationId xmlns:a16="http://schemas.microsoft.com/office/drawing/2014/main" id="{E4EC0A5D-F8EC-4A62-B44A-7E9F58B8DD07}"/>
               </a:ext>
             </a:extLst>
           </p:cNvPr>
@@ -6242,7 +6242,7 @@
           <p:cNvPr id="20" name="">
             <a:extLst xmlns:a="http://schemas.openxmlformats.org/drawingml/2006/main">
               <a:ext uri="{FF2B5EF4-FFF2-40B4-BE49-F238E27FC236}">
-                <a16:creationId xmlns:a16="http://schemas.microsoft.com/office/drawing/2014/main" id="{E0744F4D-7B9B-4A57-B9FD-E1A74E093739}"/>
+                <a16:creationId xmlns:a16="http://schemas.microsoft.com/office/drawing/2014/main" id="{32838259-E283-4CF0-A923-3DD55DB04A80}"/>
               </a:ext>
             </a:extLst>
           </p:cNvPr>
@@ -6309,7 +6309,7 @@
           <p:cNvPr id="21" name="">
             <a:extLst xmlns:a="http://schemas.openxmlformats.org/drawingml/2006/main">
               <a:ext uri="{FF2B5EF4-FFF2-40B4-BE49-F238E27FC236}">
-                <a16:creationId xmlns:a16="http://schemas.microsoft.com/office/drawing/2014/main" id="{EE6791D0-A888-49A7-8331-545D4C15D684}"/>
+                <a16:creationId xmlns:a16="http://schemas.microsoft.com/office/drawing/2014/main" id="{88509FCB-7C64-4837-91E8-3292FC660D20}"/>
               </a:ext>
             </a:extLst>
           </p:cNvPr>
@@ -6340,7 +6340,7 @@
           <p:cNvPr id="22" name="">
             <a:extLst xmlns:a="http://schemas.openxmlformats.org/drawingml/2006/main">
               <a:ext uri="{FF2B5EF4-FFF2-40B4-BE49-F238E27FC236}">
-                <a16:creationId xmlns:a16="http://schemas.microsoft.com/office/drawing/2014/main" id="{9A06CB68-D10E-4FBB-8A1F-C90142E48C3A}"/>
+                <a16:creationId xmlns:a16="http://schemas.microsoft.com/office/drawing/2014/main" id="{9DDBBEC3-0A05-43D5-BCC9-214C599BAC52}"/>
               </a:ext>
             </a:extLst>
           </p:cNvPr>
@@ -6407,7 +6407,7 @@
           <p:cNvPr id="23" name="">
             <a:extLst xmlns:a="http://schemas.openxmlformats.org/drawingml/2006/main">
               <a:ext uri="{FF2B5EF4-FFF2-40B4-BE49-F238E27FC236}">
-                <a16:creationId xmlns:a16="http://schemas.microsoft.com/office/drawing/2014/main" id="{40A56163-56EC-4B8B-9AEB-B8B099D17963}"/>
+                <a16:creationId xmlns:a16="http://schemas.microsoft.com/office/drawing/2014/main" id="{30F66781-1E5D-4D62-993B-816E5F789305}"/>
               </a:ext>
             </a:extLst>
           </p:cNvPr>
@@ -6472,7 +6472,7 @@
     </p:spTree>
     <p:extLst>
       <p:ext uri="{BB962C8B-B14F-4D97-AF65-F5344CB8AC3E}">
-        <p14:creationId xmlns:p14="http://schemas.microsoft.com/office/powerpoint/2010/main" val="1754748585"/>
+        <p14:creationId xmlns:p14="http://schemas.microsoft.com/office/powerpoint/2010/main" val="1093981322"/>
       </p:ext>
     </p:extLst>
   </p:cSld>
@@ -6503,7 +6503,7 @@
           <p:cNvPr id="25" name="">
             <a:extLst xmlns:a="http://schemas.openxmlformats.org/drawingml/2006/main">
               <a:ext uri="{FF2B5EF4-FFF2-40B4-BE49-F238E27FC236}">
-                <a16:creationId xmlns:a16="http://schemas.microsoft.com/office/drawing/2014/main" id="{12A92454-2D6F-47DC-BEEE-BA9DBE5C2817}"/>
+                <a16:creationId xmlns:a16="http://schemas.microsoft.com/office/drawing/2014/main" id="{A059E0D4-950C-4B0D-A7D0-DA39C912BAC7}"/>
               </a:ext>
             </a:extLst>
           </p:cNvPr>
@@ -6534,7 +6534,7 @@
           <p:cNvPr id="2" name="">
             <a:extLst xmlns:a="http://schemas.openxmlformats.org/drawingml/2006/main">
               <a:ext uri="{FF2B5EF4-FFF2-40B4-BE49-F238E27FC236}">
-                <a16:creationId xmlns:a16="http://schemas.microsoft.com/office/drawing/2014/main" id="{FC7C8D6D-A81E-4AB3-A0BD-82E35EE3CA5C}"/>
+                <a16:creationId xmlns:a16="http://schemas.microsoft.com/office/drawing/2014/main" id="{B1DC139E-630A-4729-A1FF-7F2782161B97}"/>
               </a:ext>
             </a:extLst>
           </p:cNvPr>
@@ -6601,7 +6601,7 @@
           <p:cNvPr id="3" name="">
             <a:extLst xmlns:a="http://schemas.openxmlformats.org/drawingml/2006/main">
               <a:ext uri="{FF2B5EF4-FFF2-40B4-BE49-F238E27FC236}">
-                <a16:creationId xmlns:a16="http://schemas.microsoft.com/office/drawing/2014/main" id="{0E1D0A04-017A-4E0D-B599-87990FF2DF9D}"/>
+                <a16:creationId xmlns:a16="http://schemas.microsoft.com/office/drawing/2014/main" id="{A9CCC92D-71A0-40FB-825B-1CA26D07A4B8}"/>
               </a:ext>
             </a:extLst>
           </p:cNvPr>
@@ -6668,7 +6668,7 @@
           <p:cNvPr id="4" name="">
             <a:extLst xmlns:a="http://schemas.openxmlformats.org/drawingml/2006/main">
               <a:ext uri="{FF2B5EF4-FFF2-40B4-BE49-F238E27FC236}">
-                <a16:creationId xmlns:a16="http://schemas.microsoft.com/office/drawing/2014/main" id="{3D342A3D-DF16-4986-9291-FD7BCF293E70}"/>
+                <a16:creationId xmlns:a16="http://schemas.microsoft.com/office/drawing/2014/main" id="{9CF759A0-A8EE-404E-9435-925283B93DBC}"/>
               </a:ext>
             </a:extLst>
           </p:cNvPr>
@@ -6699,7 +6699,7 @@
           <p:cNvPr id="5" name="">
             <a:extLst xmlns:a="http://schemas.openxmlformats.org/drawingml/2006/main">
               <a:ext uri="{FF2B5EF4-FFF2-40B4-BE49-F238E27FC236}">
-                <a16:creationId xmlns:a16="http://schemas.microsoft.com/office/drawing/2014/main" id="{8E8B2B3F-11C8-428C-B6EC-BFD506087AC0}"/>
+                <a16:creationId xmlns:a16="http://schemas.microsoft.com/office/drawing/2014/main" id="{D39556E2-A8E5-4176-977A-E5415543FB11}"/>
               </a:ext>
             </a:extLst>
           </p:cNvPr>
@@ -6766,7 +6766,7 @@
           <p:cNvPr id="6" name="">
             <a:extLst xmlns:a="http://schemas.openxmlformats.org/drawingml/2006/main">
               <a:ext uri="{FF2B5EF4-FFF2-40B4-BE49-F238E27FC236}">
-                <a16:creationId xmlns:a16="http://schemas.microsoft.com/office/drawing/2014/main" id="{4426CC83-399B-41C6-934A-B5A0304385CD}"/>
+                <a16:creationId xmlns:a16="http://schemas.microsoft.com/office/drawing/2014/main" id="{C0279158-C765-493F-998C-2A0E582F478A}"/>
               </a:ext>
             </a:extLst>
           </p:cNvPr>
@@ -6833,7 +6833,7 @@
           <p:cNvPr id="7" name="">
             <a:extLst xmlns:a="http://schemas.openxmlformats.org/drawingml/2006/main">
               <a:ext uri="{FF2B5EF4-FFF2-40B4-BE49-F238E27FC236}">
-                <a16:creationId xmlns:a16="http://schemas.microsoft.com/office/drawing/2014/main" id="{5FA4D834-713B-4CCF-B255-A3A981E93953}"/>
+                <a16:creationId xmlns:a16="http://schemas.microsoft.com/office/drawing/2014/main" id="{CF95F0F3-B151-4453-AD0F-AA03BBBB036F}"/>
               </a:ext>
             </a:extLst>
           </p:cNvPr>
@@ -6868,7 +6868,7 @@
           <p:cNvPr id="8" name="">
             <a:extLst xmlns:a="http://schemas.openxmlformats.org/drawingml/2006/main">
               <a:ext uri="{FF2B5EF4-FFF2-40B4-BE49-F238E27FC236}">
-                <a16:creationId xmlns:a16="http://schemas.microsoft.com/office/drawing/2014/main" id="{4F8125FD-684A-4008-8A44-0B35F03FB49D}"/>
+                <a16:creationId xmlns:a16="http://schemas.microsoft.com/office/drawing/2014/main" id="{CE502137-B25D-49A1-9F53-4B1CF443C112}"/>
               </a:ext>
             </a:extLst>
           </p:cNvPr>
@@ -6935,7 +6935,7 @@
           <p:cNvPr id="9" name="">
             <a:extLst xmlns:a="http://schemas.openxmlformats.org/drawingml/2006/main">
               <a:ext uri="{FF2B5EF4-FFF2-40B4-BE49-F238E27FC236}">
-                <a16:creationId xmlns:a16="http://schemas.microsoft.com/office/drawing/2014/main" id="{8D3D8831-33AC-4AD2-96C7-C1784A062428}"/>
+                <a16:creationId xmlns:a16="http://schemas.microsoft.com/office/drawing/2014/main" id="{598E775F-EB3F-4F75-BD0E-E6E933E28BD7}"/>
               </a:ext>
             </a:extLst>
           </p:cNvPr>
@@ -7002,7 +7002,7 @@
           <p:cNvPr id="10" name="">
             <a:extLst xmlns:a="http://schemas.openxmlformats.org/drawingml/2006/main">
               <a:ext uri="{FF2B5EF4-FFF2-40B4-BE49-F238E27FC236}">
-                <a16:creationId xmlns:a16="http://schemas.microsoft.com/office/drawing/2014/main" id="{A0FF734B-1767-4BAC-AAB6-E45E4790E1DC}"/>
+                <a16:creationId xmlns:a16="http://schemas.microsoft.com/office/drawing/2014/main" id="{E6A45CD8-CF20-4B93-B01B-3EBBD6C21BDA}"/>
               </a:ext>
             </a:extLst>
           </p:cNvPr>
@@ -7037,7 +7037,7 @@
           <p:cNvPr id="11" name="">
             <a:extLst xmlns:a="http://schemas.openxmlformats.org/drawingml/2006/main">
               <a:ext uri="{FF2B5EF4-FFF2-40B4-BE49-F238E27FC236}">
-                <a16:creationId xmlns:a16="http://schemas.microsoft.com/office/drawing/2014/main" id="{9CD8454C-0588-44C2-877F-75354D573A08}"/>
+                <a16:creationId xmlns:a16="http://schemas.microsoft.com/office/drawing/2014/main" id="{D1D214F2-61D2-48AA-B890-C08434CB72EC}"/>
               </a:ext>
             </a:extLst>
           </p:cNvPr>
@@ -7104,7 +7104,7 @@
           <p:cNvPr id="12" name="">
             <a:extLst xmlns:a="http://schemas.openxmlformats.org/drawingml/2006/main">
               <a:ext uri="{FF2B5EF4-FFF2-40B4-BE49-F238E27FC236}">
-                <a16:creationId xmlns:a16="http://schemas.microsoft.com/office/drawing/2014/main" id="{7F7C2845-41D2-477A-8648-0E620088D72C}"/>
+                <a16:creationId xmlns:a16="http://schemas.microsoft.com/office/drawing/2014/main" id="{8B8291F8-9C5A-44EC-9C8C-BB35A1030B69}"/>
               </a:ext>
             </a:extLst>
           </p:cNvPr>
@@ -7171,7 +7171,7 @@
           <p:cNvPr id="13" name="">
             <a:extLst xmlns:a="http://schemas.openxmlformats.org/drawingml/2006/main">
               <a:ext uri="{FF2B5EF4-FFF2-40B4-BE49-F238E27FC236}">
-                <a16:creationId xmlns:a16="http://schemas.microsoft.com/office/drawing/2014/main" id="{3CBC6F1B-6731-42C4-98C3-46CDDE1B8F74}"/>
+                <a16:creationId xmlns:a16="http://schemas.microsoft.com/office/drawing/2014/main" id="{1AD6EE98-F090-4208-9F07-25A6D9E09367}"/>
               </a:ext>
             </a:extLst>
           </p:cNvPr>
@@ -7206,7 +7206,7 @@
           <p:cNvPr id="14" name="">
             <a:extLst xmlns:a="http://schemas.openxmlformats.org/drawingml/2006/main">
               <a:ext uri="{FF2B5EF4-FFF2-40B4-BE49-F238E27FC236}">
-                <a16:creationId xmlns:a16="http://schemas.microsoft.com/office/drawing/2014/main" id="{C0BB1511-CFFB-4B7A-B2B2-3037E6E28F49}"/>
+                <a16:creationId xmlns:a16="http://schemas.microsoft.com/office/drawing/2014/main" id="{B4964496-3D29-4C2F-BE1F-D61940A08C00}"/>
               </a:ext>
             </a:extLst>
           </p:cNvPr>
@@ -7273,7 +7273,7 @@
           <p:cNvPr id="15" name="">
             <a:extLst xmlns:a="http://schemas.openxmlformats.org/drawingml/2006/main">
               <a:ext uri="{FF2B5EF4-FFF2-40B4-BE49-F238E27FC236}">
-                <a16:creationId xmlns:a16="http://schemas.microsoft.com/office/drawing/2014/main" id="{F7699610-F187-4951-9729-3701783647F3}"/>
+                <a16:creationId xmlns:a16="http://schemas.microsoft.com/office/drawing/2014/main" id="{A1800509-00FA-4272-B472-FDBC04255DA4}"/>
               </a:ext>
             </a:extLst>
           </p:cNvPr>
@@ -7340,7 +7340,7 @@
           <p:cNvPr id="16" name="">
             <a:extLst xmlns:a="http://schemas.openxmlformats.org/drawingml/2006/main">
               <a:ext uri="{FF2B5EF4-FFF2-40B4-BE49-F238E27FC236}">
-                <a16:creationId xmlns:a16="http://schemas.microsoft.com/office/drawing/2014/main" id="{4A795DAE-7136-4F1E-B0E8-6544E1FC1885}"/>
+                <a16:creationId xmlns:a16="http://schemas.microsoft.com/office/drawing/2014/main" id="{43477FE8-EA0E-4A8A-9F65-0202869617C6}"/>
               </a:ext>
             </a:extLst>
           </p:cNvPr>
@@ -7375,7 +7375,7 @@
           <p:cNvPr id="17" name="">
             <a:extLst xmlns:a="http://schemas.openxmlformats.org/drawingml/2006/main">
               <a:ext uri="{FF2B5EF4-FFF2-40B4-BE49-F238E27FC236}">
-                <a16:creationId xmlns:a16="http://schemas.microsoft.com/office/drawing/2014/main" id="{71E96A6C-1D00-4941-97FD-AF825BE553F0}"/>
+                <a16:creationId xmlns:a16="http://schemas.microsoft.com/office/drawing/2014/main" id="{7355A89B-01FB-4B65-B4C0-4EDD5CE307F4}"/>
               </a:ext>
             </a:extLst>
           </p:cNvPr>
@@ -7442,7 +7442,7 @@
           <p:cNvPr id="18" name="">
             <a:extLst xmlns:a="http://schemas.openxmlformats.org/drawingml/2006/main">
               <a:ext uri="{FF2B5EF4-FFF2-40B4-BE49-F238E27FC236}">
-                <a16:creationId xmlns:a16="http://schemas.microsoft.com/office/drawing/2014/main" id="{970C5199-E2D6-45C7-A8F9-261E648BCF08}"/>
+                <a16:creationId xmlns:a16="http://schemas.microsoft.com/office/drawing/2014/main" id="{5C82CBC7-E463-4837-9882-8C94CAD4B198}"/>
               </a:ext>
             </a:extLst>
           </p:cNvPr>
@@ -7509,7 +7509,7 @@
           <p:cNvPr id="19" name="">
             <a:extLst xmlns:a="http://schemas.openxmlformats.org/drawingml/2006/main">
               <a:ext uri="{FF2B5EF4-FFF2-40B4-BE49-F238E27FC236}">
-                <a16:creationId xmlns:a16="http://schemas.microsoft.com/office/drawing/2014/main" id="{9DFD21B8-04A3-4A05-84EA-9F392D85E227}"/>
+                <a16:creationId xmlns:a16="http://schemas.microsoft.com/office/drawing/2014/main" id="{25EBD88E-F619-458B-8C96-45C00E95165C}"/>
               </a:ext>
             </a:extLst>
           </p:cNvPr>
@@ -7544,7 +7544,7 @@
           <p:cNvPr id="20" name="">
             <a:extLst xmlns:a="http://schemas.openxmlformats.org/drawingml/2006/main">
               <a:ext uri="{FF2B5EF4-FFF2-40B4-BE49-F238E27FC236}">
-                <a16:creationId xmlns:a16="http://schemas.microsoft.com/office/drawing/2014/main" id="{15194ABE-E1B6-4E71-A049-B0E63F2574CB}"/>
+                <a16:creationId xmlns:a16="http://schemas.microsoft.com/office/drawing/2014/main" id="{1B588EFC-0AB6-41B0-ADB4-26CF68F6B9B4}"/>
               </a:ext>
             </a:extLst>
           </p:cNvPr>
@@ -7611,7 +7611,7 @@
           <p:cNvPr id="21" name="">
             <a:extLst xmlns:a="http://schemas.openxmlformats.org/drawingml/2006/main">
               <a:ext uri="{FF2B5EF4-FFF2-40B4-BE49-F238E27FC236}">
-                <a16:creationId xmlns:a16="http://schemas.microsoft.com/office/drawing/2014/main" id="{EB41B74F-3631-4344-A71A-2B90330ACC5D}"/>
+                <a16:creationId xmlns:a16="http://schemas.microsoft.com/office/drawing/2014/main" id="{36B6586A-38BB-48C0-AB3B-EA55C8EA1F12}"/>
               </a:ext>
             </a:extLst>
           </p:cNvPr>
@@ -7678,7 +7678,7 @@
           <p:cNvPr id="22" name="">
             <a:extLst xmlns:a="http://schemas.openxmlformats.org/drawingml/2006/main">
               <a:ext uri="{FF2B5EF4-FFF2-40B4-BE49-F238E27FC236}">
-                <a16:creationId xmlns:a16="http://schemas.microsoft.com/office/drawing/2014/main" id="{EDEA160D-A3B6-4DDB-BB2A-ADF3B2B344F7}"/>
+                <a16:creationId xmlns:a16="http://schemas.microsoft.com/office/drawing/2014/main" id="{1AF9C9DC-C830-4052-A5E1-0D5005D60677}"/>
               </a:ext>
             </a:extLst>
           </p:cNvPr>
@@ -7713,7 +7713,7 @@
           <p:cNvPr id="23" name="">
             <a:extLst xmlns:a="http://schemas.openxmlformats.org/drawingml/2006/main">
               <a:ext uri="{FF2B5EF4-FFF2-40B4-BE49-F238E27FC236}">
-                <a16:creationId xmlns:a16="http://schemas.microsoft.com/office/drawing/2014/main" id="{8F72270D-5488-4D74-B9AE-C8A4F390B3A9}"/>
+                <a16:creationId xmlns:a16="http://schemas.microsoft.com/office/drawing/2014/main" id="{312A78A2-1711-4CBE-B0E0-9555DEB04C48}"/>
               </a:ext>
             </a:extLst>
           </p:cNvPr>
@@ -7770,7 +7770,7 @@
                 <a:ea typeface="Aptos"/>
                 <a:cs typeface="Aptos"/>
               </a:rPr>
-              <a:t>Pandas, SQLite, random</a:t>
+              <a:t>SQLite and random</a:t>
             </a:r>
           </a:p>
         </p:txBody>
@@ -7780,7 +7780,7 @@
           <p:cNvPr id="24" name="">
             <a:extLst xmlns:a="http://schemas.openxmlformats.org/drawingml/2006/main">
               <a:ext uri="{FF2B5EF4-FFF2-40B4-BE49-F238E27FC236}">
-                <a16:creationId xmlns:a16="http://schemas.microsoft.com/office/drawing/2014/main" id="{2D238A6D-2040-43AD-ACA3-8BB87E2F7EA1}"/>
+                <a16:creationId xmlns:a16="http://schemas.microsoft.com/office/drawing/2014/main" id="{5AC4A79C-5FE7-433F-9272-768AF1CB992E}"/>
               </a:ext>
             </a:extLst>
           </p:cNvPr>
@@ -7837,7 +7837,7 @@
                 <a:ea typeface="Aptos"/>
                 <a:cs typeface="Aptos"/>
               </a:rPr>
-              <a:t>Display tables, save data, select sample members</a:t>
+              <a:t>Save records; select sample members</a:t>
             </a:r>
           </a:p>
         </p:txBody>
@@ -7845,7 +7845,7 @@
     </p:spTree>
     <p:extLst>
       <p:ext uri="{BB962C8B-B14F-4D97-AF65-F5344CB8AC3E}">
-        <p14:creationId xmlns:p14="http://schemas.microsoft.com/office/powerpoint/2010/main" val="569415412"/>
+        <p14:creationId xmlns:p14="http://schemas.microsoft.com/office/powerpoint/2010/main" val="1349311407"/>
       </p:ext>
     </p:extLst>
   </p:cSld>
@@ -7876,7 +7876,7 @@
           <p:cNvPr id="26" name="">
             <a:extLst xmlns:a="http://schemas.openxmlformats.org/drawingml/2006/main">
               <a:ext uri="{FF2B5EF4-FFF2-40B4-BE49-F238E27FC236}">
-                <a16:creationId xmlns:a16="http://schemas.microsoft.com/office/drawing/2014/main" id="{004C2B81-EDF3-4588-9D6A-091534F2939C}"/>
+                <a16:creationId xmlns:a16="http://schemas.microsoft.com/office/drawing/2014/main" id="{B4148727-64DA-4B1B-A1B9-A2F58D1ADDA1}"/>
               </a:ext>
             </a:extLst>
           </p:cNvPr>
@@ -7907,7 +7907,7 @@
           <p:cNvPr id="2" name="">
             <a:extLst xmlns:a="http://schemas.openxmlformats.org/drawingml/2006/main">
               <a:ext uri="{FF2B5EF4-FFF2-40B4-BE49-F238E27FC236}">
-                <a16:creationId xmlns:a16="http://schemas.microsoft.com/office/drawing/2014/main" id="{DAFFC511-7C4D-4037-845A-4EBB0E3C6674}"/>
+                <a16:creationId xmlns:a16="http://schemas.microsoft.com/office/drawing/2014/main" id="{E0AFE428-8EA7-4BD5-AE18-0337946A9928}"/>
               </a:ext>
             </a:extLst>
           </p:cNvPr>
@@ -7974,7 +7974,7 @@
           <p:cNvPr id="3" name="">
             <a:extLst xmlns:a="http://schemas.openxmlformats.org/drawingml/2006/main">
               <a:ext uri="{FF2B5EF4-FFF2-40B4-BE49-F238E27FC236}">
-                <a16:creationId xmlns:a16="http://schemas.microsoft.com/office/drawing/2014/main" id="{D52D470C-C900-40A1-BC79-91FC3E9A6D77}"/>
+                <a16:creationId xmlns:a16="http://schemas.microsoft.com/office/drawing/2014/main" id="{6FDA7437-0682-4ADE-81BC-9F949D84C6D6}"/>
               </a:ext>
             </a:extLst>
           </p:cNvPr>
@@ -8041,7 +8041,7 @@
           <p:cNvPr id="4" name="">
             <a:extLst xmlns:a="http://schemas.openxmlformats.org/drawingml/2006/main">
               <a:ext uri="{FF2B5EF4-FFF2-40B4-BE49-F238E27FC236}">
-                <a16:creationId xmlns:a16="http://schemas.microsoft.com/office/drawing/2014/main" id="{EF4DC3F0-9AC9-450A-9A60-749A2C4496E9}"/>
+                <a16:creationId xmlns:a16="http://schemas.microsoft.com/office/drawing/2014/main" id="{B43EECC4-4276-43C4-B768-E24F4A3C5D76}"/>
               </a:ext>
             </a:extLst>
           </p:cNvPr>
@@ -8072,7 +8072,7 @@
           <p:cNvPr id="5" name="">
             <a:extLst xmlns:a="http://schemas.openxmlformats.org/drawingml/2006/main">
               <a:ext uri="{FF2B5EF4-FFF2-40B4-BE49-F238E27FC236}">
-                <a16:creationId xmlns:a16="http://schemas.microsoft.com/office/drawing/2014/main" id="{E399DE97-8681-43AC-BE44-8673C10AFD41}"/>
+                <a16:creationId xmlns:a16="http://schemas.microsoft.com/office/drawing/2014/main" id="{AF69BFB3-EA15-4609-9B5A-470B999F753B}"/>
               </a:ext>
             </a:extLst>
           </p:cNvPr>
@@ -8139,7 +8139,7 @@
           <p:cNvPr id="6" name="">
             <a:extLst xmlns:a="http://schemas.openxmlformats.org/drawingml/2006/main">
               <a:ext uri="{FF2B5EF4-FFF2-40B4-BE49-F238E27FC236}">
-                <a16:creationId xmlns:a16="http://schemas.microsoft.com/office/drawing/2014/main" id="{5A249F1D-A902-412A-B6B6-5E173C1D38C0}"/>
+                <a16:creationId xmlns:a16="http://schemas.microsoft.com/office/drawing/2014/main" id="{A1AC0127-83FA-4811-9BAE-02C7CCD8A2FF}"/>
               </a:ext>
             </a:extLst>
           </p:cNvPr>
@@ -8206,7 +8206,7 @@
           <p:cNvPr id="7" name="">
             <a:extLst xmlns:a="http://schemas.openxmlformats.org/drawingml/2006/main">
               <a:ext uri="{FF2B5EF4-FFF2-40B4-BE49-F238E27FC236}">
-                <a16:creationId xmlns:a16="http://schemas.microsoft.com/office/drawing/2014/main" id="{5CF601F8-29CB-466B-BC74-71A109166782}"/>
+                <a16:creationId xmlns:a16="http://schemas.microsoft.com/office/drawing/2014/main" id="{34153F96-F120-4E65-9709-8610962A501B}"/>
               </a:ext>
             </a:extLst>
           </p:cNvPr>
@@ -8241,7 +8241,7 @@
           <p:cNvPr id="8" name="">
             <a:extLst xmlns:a="http://schemas.openxmlformats.org/drawingml/2006/main">
               <a:ext uri="{FF2B5EF4-FFF2-40B4-BE49-F238E27FC236}">
-                <a16:creationId xmlns:a16="http://schemas.microsoft.com/office/drawing/2014/main" id="{D549ADE7-2E38-4B6A-B943-73A175A32A4C}"/>
+                <a16:creationId xmlns:a16="http://schemas.microsoft.com/office/drawing/2014/main" id="{C5ADB55A-EDE5-4E34-8225-1CB599BAFEE0}"/>
               </a:ext>
             </a:extLst>
           </p:cNvPr>
@@ -8308,7 +8308,7 @@
           <p:cNvPr id="9" name="">
             <a:extLst xmlns:a="http://schemas.openxmlformats.org/drawingml/2006/main">
               <a:ext uri="{FF2B5EF4-FFF2-40B4-BE49-F238E27FC236}">
-                <a16:creationId xmlns:a16="http://schemas.microsoft.com/office/drawing/2014/main" id="{EA230424-5308-41C6-B294-5EFABDEFD572}"/>
+                <a16:creationId xmlns:a16="http://schemas.microsoft.com/office/drawing/2014/main" id="{0BCABA34-D040-4DC0-A0E4-10DCFA9AA302}"/>
               </a:ext>
             </a:extLst>
           </p:cNvPr>
@@ -8375,7 +8375,7 @@
           <p:cNvPr id="10" name="">
             <a:extLst xmlns:a="http://schemas.openxmlformats.org/drawingml/2006/main">
               <a:ext uri="{FF2B5EF4-FFF2-40B4-BE49-F238E27FC236}">
-                <a16:creationId xmlns:a16="http://schemas.microsoft.com/office/drawing/2014/main" id="{D344E6B8-C3AF-415D-9B9E-567CBC23A6BA}"/>
+                <a16:creationId xmlns:a16="http://schemas.microsoft.com/office/drawing/2014/main" id="{962B5A3E-0A2C-456F-9E04-BD1CE20EF63E}"/>
               </a:ext>
             </a:extLst>
           </p:cNvPr>
@@ -8410,7 +8410,7 @@
           <p:cNvPr id="11" name="">
             <a:extLst xmlns:a="http://schemas.openxmlformats.org/drawingml/2006/main">
               <a:ext uri="{FF2B5EF4-FFF2-40B4-BE49-F238E27FC236}">
-                <a16:creationId xmlns:a16="http://schemas.microsoft.com/office/drawing/2014/main" id="{6876F310-F8C4-4803-95F9-BD135CBD7D84}"/>
+                <a16:creationId xmlns:a16="http://schemas.microsoft.com/office/drawing/2014/main" id="{D0FF56BA-9038-4C3A-A904-2D713EA66B8D}"/>
               </a:ext>
             </a:extLst>
           </p:cNvPr>
@@ -8477,7 +8477,7 @@
           <p:cNvPr id="12" name="">
             <a:extLst xmlns:a="http://schemas.openxmlformats.org/drawingml/2006/main">
               <a:ext uri="{FF2B5EF4-FFF2-40B4-BE49-F238E27FC236}">
-                <a16:creationId xmlns:a16="http://schemas.microsoft.com/office/drawing/2014/main" id="{E072DDE9-A25E-459B-9D94-9DB4877330D6}"/>
+                <a16:creationId xmlns:a16="http://schemas.microsoft.com/office/drawing/2014/main" id="{3A6493D8-3618-4498-95F8-36B4663B3FFF}"/>
               </a:ext>
             </a:extLst>
           </p:cNvPr>
@@ -8544,7 +8544,7 @@
           <p:cNvPr id="13" name="">
             <a:extLst xmlns:a="http://schemas.openxmlformats.org/drawingml/2006/main">
               <a:ext uri="{FF2B5EF4-FFF2-40B4-BE49-F238E27FC236}">
-                <a16:creationId xmlns:a16="http://schemas.microsoft.com/office/drawing/2014/main" id="{126839F6-EE12-461E-ACEE-3D25E94EDB2F}"/>
+                <a16:creationId xmlns:a16="http://schemas.microsoft.com/office/drawing/2014/main" id="{E86522D4-22B4-4A21-B403-5B0D857DDA3B}"/>
               </a:ext>
             </a:extLst>
           </p:cNvPr>
@@ -8579,7 +8579,7 @@
           <p:cNvPr id="14" name="">
             <a:extLst xmlns:a="http://schemas.openxmlformats.org/drawingml/2006/main">
               <a:ext uri="{FF2B5EF4-FFF2-40B4-BE49-F238E27FC236}">
-                <a16:creationId xmlns:a16="http://schemas.microsoft.com/office/drawing/2014/main" id="{2CA46755-1A7E-480B-B5D9-AECD28D64399}"/>
+                <a16:creationId xmlns:a16="http://schemas.microsoft.com/office/drawing/2014/main" id="{BABE0FD4-42F8-4184-8135-5B54E76A04CA}"/>
               </a:ext>
             </a:extLst>
           </p:cNvPr>
@@ -8646,7 +8646,7 @@
           <p:cNvPr id="15" name="">
             <a:extLst xmlns:a="http://schemas.openxmlformats.org/drawingml/2006/main">
               <a:ext uri="{FF2B5EF4-FFF2-40B4-BE49-F238E27FC236}">
-                <a16:creationId xmlns:a16="http://schemas.microsoft.com/office/drawing/2014/main" id="{1DDE6C87-5B75-4F02-9366-98A3CC636450}"/>
+                <a16:creationId xmlns:a16="http://schemas.microsoft.com/office/drawing/2014/main" id="{32B64822-4131-49A0-A7D0-4D9274735814}"/>
               </a:ext>
             </a:extLst>
           </p:cNvPr>
@@ -8713,7 +8713,7 @@
           <p:cNvPr id="16" name="">
             <a:extLst xmlns:a="http://schemas.openxmlformats.org/drawingml/2006/main">
               <a:ext uri="{FF2B5EF4-FFF2-40B4-BE49-F238E27FC236}">
-                <a16:creationId xmlns:a16="http://schemas.microsoft.com/office/drawing/2014/main" id="{61B5C5BC-2C18-49B6-B4F2-FD3C53C279EF}"/>
+                <a16:creationId xmlns:a16="http://schemas.microsoft.com/office/drawing/2014/main" id="{8AD726D3-6191-4BF0-AAD0-5C5DFAB54F8B}"/>
               </a:ext>
             </a:extLst>
           </p:cNvPr>
@@ -8748,7 +8748,7 @@
           <p:cNvPr id="17" name="">
             <a:extLst xmlns:a="http://schemas.openxmlformats.org/drawingml/2006/main">
               <a:ext uri="{FF2B5EF4-FFF2-40B4-BE49-F238E27FC236}">
-                <a16:creationId xmlns:a16="http://schemas.microsoft.com/office/drawing/2014/main" id="{B76935F2-EB66-422A-B1DA-16C0CB7F7D49}"/>
+                <a16:creationId xmlns:a16="http://schemas.microsoft.com/office/drawing/2014/main" id="{1B40FAC3-FBC0-42A2-A3C8-FBA8D3BAFB91}"/>
               </a:ext>
             </a:extLst>
           </p:cNvPr>
@@ -8815,7 +8815,7 @@
           <p:cNvPr id="18" name="">
             <a:extLst xmlns:a="http://schemas.openxmlformats.org/drawingml/2006/main">
               <a:ext uri="{FF2B5EF4-FFF2-40B4-BE49-F238E27FC236}">
-                <a16:creationId xmlns:a16="http://schemas.microsoft.com/office/drawing/2014/main" id="{9CD8BAC8-E457-4113-B9DE-572CDA218274}"/>
+                <a16:creationId xmlns:a16="http://schemas.microsoft.com/office/drawing/2014/main" id="{AF43076C-FA37-4513-9D0E-2C7B487FA5AE}"/>
               </a:ext>
             </a:extLst>
           </p:cNvPr>
@@ -8882,7 +8882,7 @@
           <p:cNvPr id="19" name="">
             <a:extLst xmlns:a="http://schemas.openxmlformats.org/drawingml/2006/main">
               <a:ext uri="{FF2B5EF4-FFF2-40B4-BE49-F238E27FC236}">
-                <a16:creationId xmlns:a16="http://schemas.microsoft.com/office/drawing/2014/main" id="{AEB8A50B-EDC0-4C75-A90D-B451D54CB50C}"/>
+                <a16:creationId xmlns:a16="http://schemas.microsoft.com/office/drawing/2014/main" id="{BEC6913B-6E66-43AB-B5DD-899D4D20458E}"/>
               </a:ext>
             </a:extLst>
           </p:cNvPr>
@@ -8949,7 +8949,7 @@
           <p:cNvPr id="20" name="">
             <a:extLst xmlns:a="http://schemas.openxmlformats.org/drawingml/2006/main">
               <a:ext uri="{FF2B5EF4-FFF2-40B4-BE49-F238E27FC236}">
-                <a16:creationId xmlns:a16="http://schemas.microsoft.com/office/drawing/2014/main" id="{D8FA845E-5335-46E5-ADE8-DB435603EBE6}"/>
+                <a16:creationId xmlns:a16="http://schemas.microsoft.com/office/drawing/2014/main" id="{46A69ED5-3BD3-4E1E-91C1-97C7D5E00662}"/>
               </a:ext>
             </a:extLst>
           </p:cNvPr>
@@ -9016,7 +9016,7 @@
           <p:cNvPr id="21" name="">
             <a:extLst xmlns:a="http://schemas.openxmlformats.org/drawingml/2006/main">
               <a:ext uri="{FF2B5EF4-FFF2-40B4-BE49-F238E27FC236}">
-                <a16:creationId xmlns:a16="http://schemas.microsoft.com/office/drawing/2014/main" id="{3C1780F4-57FD-45A1-9939-2B6DC7F938CC}"/>
+                <a16:creationId xmlns:a16="http://schemas.microsoft.com/office/drawing/2014/main" id="{CAB10016-C06B-413D-A706-020302AFA589}"/>
               </a:ext>
             </a:extLst>
           </p:cNvPr>
@@ -9083,7 +9083,7 @@
           <p:cNvPr id="22" name="">
             <a:extLst xmlns:a="http://schemas.openxmlformats.org/drawingml/2006/main">
               <a:ext uri="{FF2B5EF4-FFF2-40B4-BE49-F238E27FC236}">
-                <a16:creationId xmlns:a16="http://schemas.microsoft.com/office/drawing/2014/main" id="{5DB84AA0-BBF6-4290-816F-CEF0590C134F}"/>
+                <a16:creationId xmlns:a16="http://schemas.microsoft.com/office/drawing/2014/main" id="{C34978A3-CDDC-4E85-B055-AA8E50748BB4}"/>
               </a:ext>
             </a:extLst>
           </p:cNvPr>
@@ -9150,7 +9150,7 @@
           <p:cNvPr id="23" name="">
             <a:extLst xmlns:a="http://schemas.openxmlformats.org/drawingml/2006/main">
               <a:ext uri="{FF2B5EF4-FFF2-40B4-BE49-F238E27FC236}">
-                <a16:creationId xmlns:a16="http://schemas.microsoft.com/office/drawing/2014/main" id="{A55A4C61-71A6-47E3-81C5-37FB1E595582}"/>
+                <a16:creationId xmlns:a16="http://schemas.microsoft.com/office/drawing/2014/main" id="{12679131-2179-4AAA-AE29-2D6C37746CBB}"/>
               </a:ext>
             </a:extLst>
           </p:cNvPr>
@@ -9217,7 +9217,7 @@
           <p:cNvPr id="24" name="">
             <a:extLst xmlns:a="http://schemas.openxmlformats.org/drawingml/2006/main">
               <a:ext uri="{FF2B5EF4-FFF2-40B4-BE49-F238E27FC236}">
-                <a16:creationId xmlns:a16="http://schemas.microsoft.com/office/drawing/2014/main" id="{9A647239-5DD5-41AC-9688-85C3D88CE0E9}"/>
+                <a16:creationId xmlns:a16="http://schemas.microsoft.com/office/drawing/2014/main" id="{1E0B23DE-7D85-4A37-AA03-917FB10DCF44}"/>
               </a:ext>
             </a:extLst>
           </p:cNvPr>
@@ -9284,7 +9284,7 @@
           <p:cNvPr id="25" name="">
             <a:extLst xmlns:a="http://schemas.openxmlformats.org/drawingml/2006/main">
               <a:ext uri="{FF2B5EF4-FFF2-40B4-BE49-F238E27FC236}">
-                <a16:creationId xmlns:a16="http://schemas.microsoft.com/office/drawing/2014/main" id="{BE8889B1-FFE8-44CF-B983-A5B2EDA7972B}"/>
+                <a16:creationId xmlns:a16="http://schemas.microsoft.com/office/drawing/2014/main" id="{5EDB9ABC-9A61-4303-9554-97C2E4FC37BC}"/>
               </a:ext>
             </a:extLst>
           </p:cNvPr>
@@ -9349,7 +9349,7 @@
     </p:spTree>
     <p:extLst>
       <p:ext uri="{BB962C8B-B14F-4D97-AF65-F5344CB8AC3E}">
-        <p14:creationId xmlns:p14="http://schemas.microsoft.com/office/powerpoint/2010/main" val="1741813340"/>
+        <p14:creationId xmlns:p14="http://schemas.microsoft.com/office/powerpoint/2010/main" val="702801521"/>
       </p:ext>
     </p:extLst>
   </p:cSld>

</xml_diff>